<commit_message>
Include local demo logins and complete reviewer documentation
</commit_message>
<xml_diff>
--- a/docs/presentation/QuizNova-Review-1.pptx
+++ b/docs/presentation/QuizNova-Review-1.pptx
@@ -2,28 +2,29 @@
 <file path=ppt/presentation.xml><?xml version="1.0" encoding="utf-8"?>
 <p:presentation xmlns:p="http://schemas.openxmlformats.org/presentationml/2006/main">
   <p:sldMasterIdLst>
-    <p:sldMasterId xmlns:r="http://schemas.openxmlformats.org/officeDocument/2006/relationships" id="2147483648" r:id="R9c118fd95e744e47"/>
+    <p:sldMasterId xmlns:r="http://schemas.openxmlformats.org/officeDocument/2006/relationships" id="2147483648" r:id="R7c82ed5dacdf4ee2"/>
   </p:sldMasterIdLst>
   <p:notesMasterIdLst>
-    <p:notesMasterId xmlns:r="http://schemas.openxmlformats.org/officeDocument/2006/relationships" r:id="R9c0bcbd3081a4972"/>
+    <p:notesMasterId xmlns:r="http://schemas.openxmlformats.org/officeDocument/2006/relationships" r:id="Rc6491179baac4731"/>
   </p:notesMasterIdLst>
   <p:sldIdLst>
-    <p:sldId xmlns:r="http://schemas.openxmlformats.org/officeDocument/2006/relationships" id="256" r:id="R82f45df399834a4c"/>
-    <p:sldId xmlns:r="http://schemas.openxmlformats.org/officeDocument/2006/relationships" id="257" r:id="R4568185dceca4f60"/>
-    <p:sldId xmlns:r="http://schemas.openxmlformats.org/officeDocument/2006/relationships" id="258" r:id="Rc299ab422d844a83"/>
-    <p:sldId xmlns:r="http://schemas.openxmlformats.org/officeDocument/2006/relationships" id="259" r:id="Ra3525b974fae405b"/>
-    <p:sldId xmlns:r="http://schemas.openxmlformats.org/officeDocument/2006/relationships" id="260" r:id="R4d1357eb24374c57"/>
-    <p:sldId xmlns:r="http://schemas.openxmlformats.org/officeDocument/2006/relationships" id="261" r:id="Re45d088eee134af8"/>
-    <p:sldId xmlns:r="http://schemas.openxmlformats.org/officeDocument/2006/relationships" id="262" r:id="R1ec30383227146f8"/>
-    <p:sldId xmlns:r="http://schemas.openxmlformats.org/officeDocument/2006/relationships" id="263" r:id="R143fada0062f4101"/>
-    <p:sldId xmlns:r="http://schemas.openxmlformats.org/officeDocument/2006/relationships" id="264" r:id="R49667277fce64854"/>
-    <p:sldId xmlns:r="http://schemas.openxmlformats.org/officeDocument/2006/relationships" id="265" r:id="R40f34e4e65dc4cf2"/>
-    <p:sldId xmlns:r="http://schemas.openxmlformats.org/officeDocument/2006/relationships" id="266" r:id="R7a3e36f7050f4313"/>
-    <p:sldId xmlns:r="http://schemas.openxmlformats.org/officeDocument/2006/relationships" id="267" r:id="R262a85aaa5bd42b8"/>
-    <p:sldId xmlns:r="http://schemas.openxmlformats.org/officeDocument/2006/relationships" id="268" r:id="R2d5a30fe895e4b24"/>
-    <p:sldId xmlns:r="http://schemas.openxmlformats.org/officeDocument/2006/relationships" id="269" r:id="Rc1a6d5a8f62b486f"/>
-    <p:sldId xmlns:r="http://schemas.openxmlformats.org/officeDocument/2006/relationships" id="270" r:id="R00cbe3f00dac4413"/>
-    <p:sldId xmlns:r="http://schemas.openxmlformats.org/officeDocument/2006/relationships" id="271" r:id="R89d1acb533cb4b7b"/>
+    <p:sldId xmlns:r="http://schemas.openxmlformats.org/officeDocument/2006/relationships" id="256" r:id="R96a71879de0243be"/>
+    <p:sldId xmlns:r="http://schemas.openxmlformats.org/officeDocument/2006/relationships" id="257" r:id="R358d82fa986d4322"/>
+    <p:sldId xmlns:r="http://schemas.openxmlformats.org/officeDocument/2006/relationships" id="258" r:id="R58766a31063c40ff"/>
+    <p:sldId xmlns:r="http://schemas.openxmlformats.org/officeDocument/2006/relationships" id="259" r:id="R0d66ab0ee85f4f27"/>
+    <p:sldId xmlns:r="http://schemas.openxmlformats.org/officeDocument/2006/relationships" id="260" r:id="R3e1caf0ee30e4a38"/>
+    <p:sldId xmlns:r="http://schemas.openxmlformats.org/officeDocument/2006/relationships" id="261" r:id="Rc9e2d17ea23d49f2"/>
+    <p:sldId xmlns:r="http://schemas.openxmlformats.org/officeDocument/2006/relationships" id="262" r:id="R104ec6ee9c334a97"/>
+    <p:sldId xmlns:r="http://schemas.openxmlformats.org/officeDocument/2006/relationships" id="263" r:id="R56668e4b537b492d"/>
+    <p:sldId xmlns:r="http://schemas.openxmlformats.org/officeDocument/2006/relationships" id="264" r:id="Rc0d8d6e012f94a70"/>
+    <p:sldId xmlns:r="http://schemas.openxmlformats.org/officeDocument/2006/relationships" id="265" r:id="Rd6beabbfda5e4bb7"/>
+    <p:sldId xmlns:r="http://schemas.openxmlformats.org/officeDocument/2006/relationships" id="266" r:id="Rc841613697d34c55"/>
+    <p:sldId xmlns:r="http://schemas.openxmlformats.org/officeDocument/2006/relationships" id="267" r:id="R05edc500e2ec4183"/>
+    <p:sldId xmlns:r="http://schemas.openxmlformats.org/officeDocument/2006/relationships" id="268" r:id="R16a03d6e0e514513"/>
+    <p:sldId xmlns:r="http://schemas.openxmlformats.org/officeDocument/2006/relationships" id="269" r:id="R175c89a7b43542df"/>
+    <p:sldId xmlns:r="http://schemas.openxmlformats.org/officeDocument/2006/relationships" id="270" r:id="Rda449a5bfd214e89"/>
+    <p:sldId xmlns:r="http://schemas.openxmlformats.org/officeDocument/2006/relationships" id="271" r:id="R817de379c2424859"/>
+    <p:sldId xmlns:r="http://schemas.openxmlformats.org/officeDocument/2006/relationships" id="272" r:id="Rc431ee77e5ed4d33"/>
   </p:sldIdLst>
   <p:sldSz cx="12192000" cy="6858000"/>
   <p:notesSz cx="6858000" cy="9144000"/>
@@ -947,6 +948,76 @@
           <a:lstStyle xmlns:a="http://schemas.openxmlformats.org/drawingml/2006/main"/>
           <a:p xmlns:a="http://schemas.openxmlformats.org/drawingml/2006/main">
             <a:r>
+              <a:t>These are optional local sample accounts only. Open http://127.0.0.1:8080/ and use Sign in. Sample credentials are documented in README and are disabled by default in the cloud profile. Real deployment credentials must be privately configured; do not reuse these demo passwords for a public deployment.</a:t>
+            </a:r>
+          </a:p>
+        </p:txBody>
+      </p:sp>
+      <p:sp>
+        <p:nvSpPr>
+          <p:cNvPr id="4" name="Slide Number Placeholder 3"/>
+          <p:cNvSpPr>
+            <a:spLocks xmlns:a="http://schemas.openxmlformats.org/drawingml/2006/main" noGrp="1"/>
+          </p:cNvSpPr>
+          <p:nvPr>
+            <p:ph type="sldNum" idx="5"/>
+          </p:nvPr>
+        </p:nvSpPr>
+        <p:spPr/>
+        <p:txBody>
+          <a:bodyPr xmlns:a="http://schemas.openxmlformats.org/drawingml/2006/main"/>
+          <a:lstStyle xmlns:a="http://schemas.openxmlformats.org/drawingml/2006/main"/>
+          <a:p xmlns:a="http://schemas.openxmlformats.org/drawingml/2006/main"/>
+        </p:txBody>
+      </p:sp>
+    </p:spTree>
+  </p:cSld>
+  <p:clrMapOvr>
+    <a:masterClrMapping xmlns:a="http://schemas.openxmlformats.org/drawingml/2006/main"/>
+  </p:clrMapOvr>
+</p:notes>
+</file>
+
+<file path=ppt/notesSlides/notesSlide17.xml><?xml version="1.0" encoding="utf-8"?>
+<p:notes xmlns:p="http://schemas.openxmlformats.org/presentationml/2006/main">
+  <p:cSld>
+    <p:spTree>
+      <p:nvGrpSpPr>
+        <p:cNvPr id="1" name=""/>
+        <p:cNvGrpSpPr/>
+        <p:nvPr/>
+      </p:nvGrpSpPr>
+      <p:grpSpPr>
+        <a:xfrm xmlns:a="http://schemas.openxmlformats.org/drawingml/2006/main"/>
+      </p:grpSpPr>
+      <p:sp>
+        <p:nvSpPr>
+          <p:cNvPr id="2" name="Slide Image Placeholder 1"/>
+          <p:cNvSpPr>
+            <a:spLocks xmlns:a="http://schemas.openxmlformats.org/drawingml/2006/main" noGrp="1"/>
+          </p:cNvSpPr>
+          <p:nvPr>
+            <p:ph type="sldImg" idx="0"/>
+          </p:nvPr>
+        </p:nvSpPr>
+        <p:spPr/>
+      </p:sp>
+      <p:sp>
+        <p:nvSpPr>
+          <p:cNvPr id="3" name="Notes Placeholder 2"/>
+          <p:cNvSpPr>
+            <a:spLocks xmlns:a="http://schemas.openxmlformats.org/drawingml/2006/main" noGrp="1"/>
+          </p:cNvSpPr>
+          <p:nvPr>
+            <p:ph type="body" idx="1"/>
+          </p:nvPr>
+        </p:nvSpPr>
+        <p:spPr/>
+        <p:txBody>
+          <a:bodyPr xmlns:a="http://schemas.openxmlformats.org/drawingml/2006/main"/>
+          <a:lstStyle xmlns:a="http://schemas.openxmlformats.org/drawingml/2006/main"/>
+          <a:p xmlns:a="http://schemas.openxmlformats.org/drawingml/2006/main">
+            <a:r>
               <a:t>Live URL intentionally blank. Free hosting research: https://render.com/docs/free and https://neon.com/pricing . Render free web services can sleep after inactivity and have ephemeral local storage; use external PostgreSQL instead of H2 files. Free services have usage limits and are suitable for a project demonstration. Do not claim this project is hosted until a deployment succeeds. See docs/DEPLOYMENT.md.</a:t>
             </a:r>
           </a:p>
@@ -1554,7 +1625,7 @@
           <p:cNvPr id="3" name="Title">
             <a:extLst xmlns:a="http://schemas.openxmlformats.org/drawingml/2006/main">
               <a:ext uri="{FF2B5EF4-FFF2-40B4-BE49-F238E27FC236}">
-                <a16:creationId xmlns:a16="http://schemas.microsoft.com/office/drawing/2014/main" id="{CC836A70-D959-44A4-ADE0-761A5FDEE5DE}"/>
+                <a16:creationId xmlns:a16="http://schemas.microsoft.com/office/drawing/2014/main" id="{B24DD062-AF33-4B01-8733-EA08218A172C}"/>
               </a:ext>
             </a:extLst>
           </p:cNvPr>
@@ -1711,7 +1782,7 @@
           <p:cNvPr id="2" name="Subtitle">
             <a:extLst xmlns:a="http://schemas.openxmlformats.org/drawingml/2006/main">
               <a:ext uri="{FF2B5EF4-FFF2-40B4-BE49-F238E27FC236}">
-                <a16:creationId xmlns:a16="http://schemas.microsoft.com/office/drawing/2014/main" id="{1EDE8F52-4CFC-4F7F-99F6-E6318FFE441B}"/>
+                <a16:creationId xmlns:a16="http://schemas.microsoft.com/office/drawing/2014/main" id="{32EA105C-3CAC-47D3-B533-A7538F21F5AF}"/>
               </a:ext>
             </a:extLst>
           </p:cNvPr>
@@ -1885,7 +1956,7 @@
           <p:cNvPr id="2" name="Section title">
             <a:extLst xmlns:a="http://schemas.openxmlformats.org/drawingml/2006/main">
               <a:ext uri="{FF2B5EF4-FFF2-40B4-BE49-F238E27FC236}">
-                <a16:creationId xmlns:a16="http://schemas.microsoft.com/office/drawing/2014/main" id="{BF033FA0-E96F-4A25-BCC4-B6FDBFA6D11E}"/>
+                <a16:creationId xmlns:a16="http://schemas.microsoft.com/office/drawing/2014/main" id="{DC628B9A-977B-4B3F-9D73-C4AA3D2B5E97}"/>
               </a:ext>
             </a:extLst>
           </p:cNvPr>
@@ -2059,7 +2130,7 @@
           <p:cNvPr id="3" name="Title">
             <a:extLst xmlns:a="http://schemas.openxmlformats.org/drawingml/2006/main">
               <a:ext uri="{FF2B5EF4-FFF2-40B4-BE49-F238E27FC236}">
-                <a16:creationId xmlns:a16="http://schemas.microsoft.com/office/drawing/2014/main" id="{1D91D1E7-B5A8-4CE9-8A75-83F494BE0DAA}"/>
+                <a16:creationId xmlns:a16="http://schemas.microsoft.com/office/drawing/2014/main" id="{83FA8844-1C42-4AE7-9F21-D016550E92F3}"/>
               </a:ext>
             </a:extLst>
           </p:cNvPr>
@@ -2216,7 +2287,7 @@
           <p:cNvPr id="2" name="Body">
             <a:extLst xmlns:a="http://schemas.openxmlformats.org/drawingml/2006/main">
               <a:ext uri="{FF2B5EF4-FFF2-40B4-BE49-F238E27FC236}">
-                <a16:creationId xmlns:a16="http://schemas.microsoft.com/office/drawing/2014/main" id="{F0F82ED6-5920-4491-AC18-0FF56B1B35EB}"/>
+                <a16:creationId xmlns:a16="http://schemas.microsoft.com/office/drawing/2014/main" id="{FD0ED68A-BCA5-4E64-BB01-BBEC22BAC7CB}"/>
               </a:ext>
             </a:extLst>
           </p:cNvPr>
@@ -2390,7 +2461,7 @@
           <p:cNvPr id="4" name="Title">
             <a:extLst xmlns:a="http://schemas.openxmlformats.org/drawingml/2006/main">
               <a:ext uri="{FF2B5EF4-FFF2-40B4-BE49-F238E27FC236}">
-                <a16:creationId xmlns:a16="http://schemas.microsoft.com/office/drawing/2014/main" id="{F72F9396-A92D-4FF4-8BAA-28EA6395B600}"/>
+                <a16:creationId xmlns:a16="http://schemas.microsoft.com/office/drawing/2014/main" id="{1B3185B9-7AC7-408A-B36B-17F1207D8BF5}"/>
               </a:ext>
             </a:extLst>
           </p:cNvPr>
@@ -2547,7 +2618,7 @@
           <p:cNvPr id="2" name="Left column">
             <a:extLst xmlns:a="http://schemas.openxmlformats.org/drawingml/2006/main">
               <a:ext uri="{FF2B5EF4-FFF2-40B4-BE49-F238E27FC236}">
-                <a16:creationId xmlns:a16="http://schemas.microsoft.com/office/drawing/2014/main" id="{7B18FDCE-72F7-46F8-B755-965A736E05CD}"/>
+                <a16:creationId xmlns:a16="http://schemas.microsoft.com/office/drawing/2014/main" id="{D1695CBF-C045-44AD-A024-3680EFBB1961}"/>
               </a:ext>
             </a:extLst>
           </p:cNvPr>
@@ -2704,7 +2775,7 @@
           <p:cNvPr id="3" name="Right column">
             <a:extLst xmlns:a="http://schemas.openxmlformats.org/drawingml/2006/main">
               <a:ext uri="{FF2B5EF4-FFF2-40B4-BE49-F238E27FC236}">
-                <a16:creationId xmlns:a16="http://schemas.microsoft.com/office/drawing/2014/main" id="{A0A07C25-19E1-4B60-969D-7007D5824081}"/>
+                <a16:creationId xmlns:a16="http://schemas.microsoft.com/office/drawing/2014/main" id="{6796BF7E-2907-41B4-8365-DFA112B4975B}"/>
               </a:ext>
             </a:extLst>
           </p:cNvPr>
@@ -2878,7 +2949,7 @@
           <p:cNvPr id="3" name="Title">
             <a:extLst xmlns:a="http://schemas.openxmlformats.org/drawingml/2006/main">
               <a:ext uri="{FF2B5EF4-FFF2-40B4-BE49-F238E27FC236}">
-                <a16:creationId xmlns:a16="http://schemas.microsoft.com/office/drawing/2014/main" id="{57F1F685-52CF-4AC5-A989-56AF697FCE93}"/>
+                <a16:creationId xmlns:a16="http://schemas.microsoft.com/office/drawing/2014/main" id="{C52749D7-BC6B-4111-BC4B-1141429A5602}"/>
               </a:ext>
             </a:extLst>
           </p:cNvPr>
@@ -3035,7 +3106,7 @@
           <p:cNvPr id="2" name="Left column">
             <a:extLst xmlns:a="http://schemas.openxmlformats.org/drawingml/2006/main">
               <a:ext uri="{FF2B5EF4-FFF2-40B4-BE49-F238E27FC236}">
-                <a16:creationId xmlns:a16="http://schemas.microsoft.com/office/drawing/2014/main" id="{FA8346F0-FF06-4D7B-A3E7-78FA6D6BB2E5}"/>
+                <a16:creationId xmlns:a16="http://schemas.microsoft.com/office/drawing/2014/main" id="{1B3E5165-CEDB-4298-99B4-3A34F63D2F4F}"/>
               </a:ext>
             </a:extLst>
           </p:cNvPr>
@@ -3230,12 +3301,12 @@
   </p:cSld>
   <p:clrMap bg1="lt1" tx1="dk1" bg2="lt2" tx2="dk2" accent1="accent1" accent2="accent2" accent3="accent3" accent4="accent4" accent5="accent5" accent6="accent6" hlink="hlink" folHlink="folHlink"/>
   <p:sldLayoutIdLst>
-    <p:sldLayoutId xmlns:r="http://schemas.openxmlformats.org/officeDocument/2006/relationships" id="2147483649" r:id="R9f5ecdb6fdf8434e"/>
-    <p:sldLayoutId xmlns:r="http://schemas.openxmlformats.org/officeDocument/2006/relationships" id="2147483650" r:id="Re2bf8b3b098d43b8"/>
-    <p:sldLayoutId xmlns:r="http://schemas.openxmlformats.org/officeDocument/2006/relationships" id="2147483651" r:id="R0caee0cf0d6f4951"/>
-    <p:sldLayoutId xmlns:r="http://schemas.openxmlformats.org/officeDocument/2006/relationships" id="2147483652" r:id="R371b47b75a6e45cc"/>
-    <p:sldLayoutId xmlns:r="http://schemas.openxmlformats.org/officeDocument/2006/relationships" id="2147483653" r:id="Ra4c60a2fcb2a4f83"/>
-    <p:sldLayoutId xmlns:r="http://schemas.openxmlformats.org/officeDocument/2006/relationships" id="2147483654" r:id="R780fd4a5c5e442f3"/>
+    <p:sldLayoutId xmlns:r="http://schemas.openxmlformats.org/officeDocument/2006/relationships" id="2147483649" r:id="R6886aa3a559e4284"/>
+    <p:sldLayoutId xmlns:r="http://schemas.openxmlformats.org/officeDocument/2006/relationships" id="2147483650" r:id="Re9de69a3e4874d31"/>
+    <p:sldLayoutId xmlns:r="http://schemas.openxmlformats.org/officeDocument/2006/relationships" id="2147483651" r:id="R81ecece9debe4d6c"/>
+    <p:sldLayoutId xmlns:r="http://schemas.openxmlformats.org/officeDocument/2006/relationships" id="2147483652" r:id="Ra5897eaff16341b7"/>
+    <p:sldLayoutId xmlns:r="http://schemas.openxmlformats.org/officeDocument/2006/relationships" id="2147483653" r:id="R777995d81e864783"/>
+    <p:sldLayoutId xmlns:r="http://schemas.openxmlformats.org/officeDocument/2006/relationships" id="2147483654" r:id="R2767ade4d7164fb0"/>
   </p:sldLayoutIdLst>
   <p:txStyles>
     <p:titleStyle>
@@ -3786,7 +3857,7 @@
           <p:cNvPr id="9" name="">
             <a:extLst xmlns:a="http://schemas.openxmlformats.org/drawingml/2006/main">
               <a:ext uri="{FF2B5EF4-FFF2-40B4-BE49-F238E27FC236}">
-                <a16:creationId xmlns:a16="http://schemas.microsoft.com/office/drawing/2014/main" id="{4315B5B1-76CF-4B9E-B0C0-FE7CA06E8816}"/>
+                <a16:creationId xmlns:a16="http://schemas.microsoft.com/office/drawing/2014/main" id="{31B26374-FF7B-4544-AF7D-15FE17DC6F36}"/>
               </a:ext>
             </a:extLst>
           </p:cNvPr>
@@ -3852,7 +3923,7 @@
           <p:cNvPr id="2" name="">
             <a:extLst xmlns:a="http://schemas.openxmlformats.org/drawingml/2006/main">
               <a:ext uri="{FF2B5EF4-FFF2-40B4-BE49-F238E27FC236}">
-                <a16:creationId xmlns:a16="http://schemas.microsoft.com/office/drawing/2014/main" id="{EE8A0260-EEA2-4070-944D-6C8059586035}"/>
+                <a16:creationId xmlns:a16="http://schemas.microsoft.com/office/drawing/2014/main" id="{68DEE4CF-89C1-4221-8499-1F5ABBFD8612}"/>
               </a:ext>
             </a:extLst>
           </p:cNvPr>
@@ -3918,7 +3989,7 @@
           <p:cNvPr id="3" name="">
             <a:extLst xmlns:a="http://schemas.openxmlformats.org/drawingml/2006/main">
               <a:ext uri="{FF2B5EF4-FFF2-40B4-BE49-F238E27FC236}">
-                <a16:creationId xmlns:a16="http://schemas.microsoft.com/office/drawing/2014/main" id="{CD9F539E-EAFB-402C-8E79-DCAF3650F1C9}"/>
+                <a16:creationId xmlns:a16="http://schemas.microsoft.com/office/drawing/2014/main" id="{30897945-0268-4A6E-BEA8-0C63066E8A41}"/>
               </a:ext>
             </a:extLst>
           </p:cNvPr>
@@ -3984,7 +4055,7 @@
           <p:cNvPr id="4" name="">
             <a:extLst xmlns:a="http://schemas.openxmlformats.org/drawingml/2006/main">
               <a:ext uri="{FF2B5EF4-FFF2-40B4-BE49-F238E27FC236}">
-                <a16:creationId xmlns:a16="http://schemas.microsoft.com/office/drawing/2014/main" id="{8FF09D65-23B9-41FC-A0F4-59B139E704CD}"/>
+                <a16:creationId xmlns:a16="http://schemas.microsoft.com/office/drawing/2014/main" id="{C14C56DA-1B27-456E-91F8-B26814CF4FE9}"/>
               </a:ext>
             </a:extLst>
           </p:cNvPr>
@@ -4050,7 +4121,7 @@
           <p:cNvPr id="5" name="">
             <a:extLst xmlns:a="http://schemas.openxmlformats.org/drawingml/2006/main">
               <a:ext uri="{FF2B5EF4-FFF2-40B4-BE49-F238E27FC236}">
-                <a16:creationId xmlns:a16="http://schemas.microsoft.com/office/drawing/2014/main" id="{1FEB42E3-5A72-47A1-B784-A77B994EDD64}"/>
+                <a16:creationId xmlns:a16="http://schemas.microsoft.com/office/drawing/2014/main" id="{1B5CE880-C1DD-4557-976C-2A5201FDEAFE}"/>
               </a:ext>
             </a:extLst>
           </p:cNvPr>
@@ -4139,7 +4210,7 @@
           <p:cNvPr id="6" name="">
             <a:extLst xmlns:a="http://schemas.openxmlformats.org/drawingml/2006/main">
               <a:ext uri="{FF2B5EF4-FFF2-40B4-BE49-F238E27FC236}">
-                <a16:creationId xmlns:a16="http://schemas.microsoft.com/office/drawing/2014/main" id="{03B61B8E-85E7-48E1-8B3E-432D4F364891}"/>
+                <a16:creationId xmlns:a16="http://schemas.microsoft.com/office/drawing/2014/main" id="{E0B4DB1E-4712-4216-B539-4D897C8671B9}"/>
               </a:ext>
             </a:extLst>
           </p:cNvPr>
@@ -4205,7 +4276,7 @@
           <p:cNvPr id="7" name="">
             <a:extLst xmlns:a="http://schemas.openxmlformats.org/drawingml/2006/main">
               <a:ext uri="{FF2B5EF4-FFF2-40B4-BE49-F238E27FC236}">
-                <a16:creationId xmlns:a16="http://schemas.microsoft.com/office/drawing/2014/main" id="{A0369FC1-B1F2-4658-A92C-597D7007A64D}"/>
+                <a16:creationId xmlns:a16="http://schemas.microsoft.com/office/drawing/2014/main" id="{98574446-6BF6-47DC-9A54-F2EDC4CD5E7F}"/>
               </a:ext>
             </a:extLst>
           </p:cNvPr>
@@ -4271,7 +4342,7 @@
           <p:cNvPr id="8" name="">
             <a:extLst xmlns:a="http://schemas.openxmlformats.org/drawingml/2006/main">
               <a:ext uri="{FF2B5EF4-FFF2-40B4-BE49-F238E27FC236}">
-                <a16:creationId xmlns:a16="http://schemas.microsoft.com/office/drawing/2014/main" id="{DE96B44D-AAF2-4E8E-A39B-B49E1E5C4764}"/>
+                <a16:creationId xmlns:a16="http://schemas.microsoft.com/office/drawing/2014/main" id="{2D2021EE-6D5B-4CE2-9D9D-8C466E6EFE38}"/>
               </a:ext>
             </a:extLst>
           </p:cNvPr>
@@ -4335,7 +4406,7 @@
     </p:spTree>
     <p:extLst>
       <p:ext uri="{BB962C8B-B14F-4D97-AF65-F5344CB8AC3E}">
-        <p14:creationId xmlns:p14="http://schemas.microsoft.com/office/powerpoint/2010/main" val="383585665"/>
+        <p14:creationId xmlns:p14="http://schemas.microsoft.com/office/powerpoint/2010/main" val="924175461"/>
       </p:ext>
     </p:extLst>
   </p:cSld>
@@ -4366,7 +4437,7 @@
           <p:cNvPr id="8" name="">
             <a:extLst xmlns:a="http://schemas.openxmlformats.org/drawingml/2006/main">
               <a:ext uri="{FF2B5EF4-FFF2-40B4-BE49-F238E27FC236}">
-                <a16:creationId xmlns:a16="http://schemas.microsoft.com/office/drawing/2014/main" id="{6E7E1F87-1482-40D4-BBD4-797D8EAA51ED}"/>
+                <a16:creationId xmlns:a16="http://schemas.microsoft.com/office/drawing/2014/main" id="{A1C8FB5D-61A6-4604-B4BD-4E2301F40237}"/>
               </a:ext>
             </a:extLst>
           </p:cNvPr>
@@ -4432,7 +4503,7 @@
           <p:cNvPr id="2" name="">
             <a:extLst xmlns:a="http://schemas.openxmlformats.org/drawingml/2006/main">
               <a:ext uri="{FF2B5EF4-FFF2-40B4-BE49-F238E27FC236}">
-                <a16:creationId xmlns:a16="http://schemas.microsoft.com/office/drawing/2014/main" id="{655F8D73-A749-49FF-8840-871C755E99EE}"/>
+                <a16:creationId xmlns:a16="http://schemas.microsoft.com/office/drawing/2014/main" id="{5BCECA04-9E53-4405-8BB5-CD058C092AFA}"/>
               </a:ext>
             </a:extLst>
           </p:cNvPr>
@@ -4498,7 +4569,7 @@
           <p:cNvPr id="3" name="">
             <a:extLst xmlns:a="http://schemas.openxmlformats.org/drawingml/2006/main">
               <a:ext uri="{FF2B5EF4-FFF2-40B4-BE49-F238E27FC236}">
-                <a16:creationId xmlns:a16="http://schemas.microsoft.com/office/drawing/2014/main" id="{ACA49C21-81BD-4896-B25A-778E7BB8BA88}"/>
+                <a16:creationId xmlns:a16="http://schemas.microsoft.com/office/drawing/2014/main" id="{84B71978-504E-4C15-8FF5-AD6F316FD0F0}"/>
               </a:ext>
             </a:extLst>
           </p:cNvPr>
@@ -4564,7 +4635,7 @@
           <p:cNvPr id="4" name="">
             <a:extLst xmlns:a="http://schemas.openxmlformats.org/drawingml/2006/main">
               <a:ext uri="{FF2B5EF4-FFF2-40B4-BE49-F238E27FC236}">
-                <a16:creationId xmlns:a16="http://schemas.microsoft.com/office/drawing/2014/main" id="{5B115B39-B845-4DF5-B04A-03CBE071CB59}"/>
+                <a16:creationId xmlns:a16="http://schemas.microsoft.com/office/drawing/2014/main" id="{5B1FDDD5-9F3B-4F34-A89C-2B211A330DE5}"/>
               </a:ext>
             </a:extLst>
           </p:cNvPr>
@@ -4630,7 +4701,7 @@
           <p:cNvPr id="5" name="">
             <a:extLst xmlns:a="http://schemas.openxmlformats.org/drawingml/2006/main">
               <a:ext uri="{FF2B5EF4-FFF2-40B4-BE49-F238E27FC236}">
-                <a16:creationId xmlns:a16="http://schemas.microsoft.com/office/drawing/2014/main" id="{AB4A886F-D741-422C-852A-A7AF382AEA1A}"/>
+                <a16:creationId xmlns:a16="http://schemas.microsoft.com/office/drawing/2014/main" id="{31213927-0781-4B4C-9A0F-B0F10AE32E7E}"/>
               </a:ext>
             </a:extLst>
           </p:cNvPr>
@@ -4640,7 +4711,7 @@
           <p:nvPr/>
         </p:nvPicPr>
         <p:blipFill>
-          <a:blip xmlns:r="http://schemas.openxmlformats.org/officeDocument/2006/relationships" xmlns:a="http://schemas.openxmlformats.org/drawingml/2006/main" r:embed="R6f05bf66f5d947f1"/>
+          <a:blip xmlns:r="http://schemas.openxmlformats.org/officeDocument/2006/relationships" xmlns:a="http://schemas.openxmlformats.org/drawingml/2006/main" r:embed="Rcce83117c56f4d19"/>
           <a:stretch xmlns:a="http://schemas.openxmlformats.org/drawingml/2006/main"/>
         </p:blipFill>
         <p:spPr>
@@ -4658,7 +4729,7 @@
           <p:cNvPr id="6" name="">
             <a:extLst xmlns:a="http://schemas.openxmlformats.org/drawingml/2006/main">
               <a:ext uri="{FF2B5EF4-FFF2-40B4-BE49-F238E27FC236}">
-                <a16:creationId xmlns:a16="http://schemas.microsoft.com/office/drawing/2014/main" id="{3BE57448-B73C-4C6B-99E9-D34D72BE3064}"/>
+                <a16:creationId xmlns:a16="http://schemas.microsoft.com/office/drawing/2014/main" id="{7C8F742A-5154-4879-8E89-BDE68EF005E2}"/>
               </a:ext>
             </a:extLst>
           </p:cNvPr>
@@ -4816,7 +4887,7 @@
           <p:cNvPr id="7" name="">
             <a:extLst xmlns:a="http://schemas.openxmlformats.org/drawingml/2006/main">
               <a:ext uri="{FF2B5EF4-FFF2-40B4-BE49-F238E27FC236}">
-                <a16:creationId xmlns:a16="http://schemas.microsoft.com/office/drawing/2014/main" id="{868D65A6-D9F4-4FDE-8645-C1A465BCD9F4}"/>
+                <a16:creationId xmlns:a16="http://schemas.microsoft.com/office/drawing/2014/main" id="{ED836DCF-3E1E-41EA-9446-D0500D5BEB0B}"/>
               </a:ext>
             </a:extLst>
           </p:cNvPr>
@@ -4880,7 +4951,7 @@
     </p:spTree>
     <p:extLst>
       <p:ext uri="{BB962C8B-B14F-4D97-AF65-F5344CB8AC3E}">
-        <p14:creationId xmlns:p14="http://schemas.microsoft.com/office/powerpoint/2010/main" val="569313121"/>
+        <p14:creationId xmlns:p14="http://schemas.microsoft.com/office/powerpoint/2010/main" val="84163190"/>
       </p:ext>
     </p:extLst>
   </p:cSld>
@@ -4911,7 +4982,7 @@
           <p:cNvPr id="10" name="">
             <a:extLst xmlns:a="http://schemas.openxmlformats.org/drawingml/2006/main">
               <a:ext uri="{FF2B5EF4-FFF2-40B4-BE49-F238E27FC236}">
-                <a16:creationId xmlns:a16="http://schemas.microsoft.com/office/drawing/2014/main" id="{154D81C5-74B9-4C5C-B9B9-9542B3E00A81}"/>
+                <a16:creationId xmlns:a16="http://schemas.microsoft.com/office/drawing/2014/main" id="{6DFA75AF-5689-44FC-A606-E8CFD9AF4F01}"/>
               </a:ext>
             </a:extLst>
           </p:cNvPr>
@@ -4977,7 +5048,7 @@
           <p:cNvPr id="2" name="">
             <a:extLst xmlns:a="http://schemas.openxmlformats.org/drawingml/2006/main">
               <a:ext uri="{FF2B5EF4-FFF2-40B4-BE49-F238E27FC236}">
-                <a16:creationId xmlns:a16="http://schemas.microsoft.com/office/drawing/2014/main" id="{EABA320D-888D-4FE1-B515-FF7CDAE08CF3}"/>
+                <a16:creationId xmlns:a16="http://schemas.microsoft.com/office/drawing/2014/main" id="{F09924CC-AF93-4B8A-8F34-ED9852F3055A}"/>
               </a:ext>
             </a:extLst>
           </p:cNvPr>
@@ -5043,7 +5114,7 @@
           <p:cNvPr id="3" name="">
             <a:extLst xmlns:a="http://schemas.openxmlformats.org/drawingml/2006/main">
               <a:ext uri="{FF2B5EF4-FFF2-40B4-BE49-F238E27FC236}">
-                <a16:creationId xmlns:a16="http://schemas.microsoft.com/office/drawing/2014/main" id="{40EA8DED-0684-4AEF-A414-EE5ABDE9A8C5}"/>
+                <a16:creationId xmlns:a16="http://schemas.microsoft.com/office/drawing/2014/main" id="{E1ADEA92-997A-4172-ADF0-E1D9F9885B44}"/>
               </a:ext>
             </a:extLst>
           </p:cNvPr>
@@ -5109,7 +5180,7 @@
           <p:cNvPr id="4" name="">
             <a:extLst xmlns:a="http://schemas.openxmlformats.org/drawingml/2006/main">
               <a:ext uri="{FF2B5EF4-FFF2-40B4-BE49-F238E27FC236}">
-                <a16:creationId xmlns:a16="http://schemas.microsoft.com/office/drawing/2014/main" id="{B054869E-76E5-4E0F-AB41-24C22813309B}"/>
+                <a16:creationId xmlns:a16="http://schemas.microsoft.com/office/drawing/2014/main" id="{A830DE37-81A8-47AB-AB55-877DCD9BEA0C}"/>
               </a:ext>
             </a:extLst>
           </p:cNvPr>
@@ -5175,7 +5246,7 @@
           <p:cNvPr id="5" name="">
             <a:extLst xmlns:a="http://schemas.openxmlformats.org/drawingml/2006/main">
               <a:ext uri="{FF2B5EF4-FFF2-40B4-BE49-F238E27FC236}">
-                <a16:creationId xmlns:a16="http://schemas.microsoft.com/office/drawing/2014/main" id="{EFCB5344-DA63-4FA1-8797-CB25B756C321}"/>
+                <a16:creationId xmlns:a16="http://schemas.microsoft.com/office/drawing/2014/main" id="{34D69190-3880-4454-8C63-3BCD6E79CA1B}"/>
               </a:ext>
             </a:extLst>
           </p:cNvPr>
@@ -5185,7 +5256,7 @@
           <p:nvPr/>
         </p:nvPicPr>
         <p:blipFill>
-          <a:blip xmlns:r="http://schemas.openxmlformats.org/officeDocument/2006/relationships" xmlns:a="http://schemas.openxmlformats.org/drawingml/2006/main" r:embed="R1f4eea7088dd44d7"/>
+          <a:blip xmlns:r="http://schemas.openxmlformats.org/officeDocument/2006/relationships" xmlns:a="http://schemas.openxmlformats.org/drawingml/2006/main" r:embed="Rda7c6a3fe30b4869"/>
           <a:stretch xmlns:a="http://schemas.openxmlformats.org/drawingml/2006/main"/>
         </p:blipFill>
         <p:spPr>
@@ -5203,7 +5274,7 @@
           <p:cNvPr id="6" name="">
             <a:extLst xmlns:a="http://schemas.openxmlformats.org/drawingml/2006/main">
               <a:ext uri="{FF2B5EF4-FFF2-40B4-BE49-F238E27FC236}">
-                <a16:creationId xmlns:a16="http://schemas.microsoft.com/office/drawing/2014/main" id="{3B09F3E0-A78E-463D-98B2-24292A6587B0}"/>
+                <a16:creationId xmlns:a16="http://schemas.microsoft.com/office/drawing/2014/main" id="{962E3BD2-2BA7-4F61-946F-BE52B166B468}"/>
               </a:ext>
             </a:extLst>
           </p:cNvPr>
@@ -5269,7 +5340,7 @@
           <p:cNvPr id="7" name="">
             <a:extLst xmlns:a="http://schemas.openxmlformats.org/drawingml/2006/main">
               <a:ext uri="{FF2B5EF4-FFF2-40B4-BE49-F238E27FC236}">
-                <a16:creationId xmlns:a16="http://schemas.microsoft.com/office/drawing/2014/main" id="{AB6EECF8-2141-4408-9AD1-FA87498E8D5A}"/>
+                <a16:creationId xmlns:a16="http://schemas.microsoft.com/office/drawing/2014/main" id="{8C2DDBA5-7754-442A-9FC7-0AB468BA235C}"/>
               </a:ext>
             </a:extLst>
           </p:cNvPr>
@@ -5335,7 +5406,7 @@
           <p:cNvPr id="8" name="">
             <a:extLst xmlns:a="http://schemas.openxmlformats.org/drawingml/2006/main">
               <a:ext uri="{FF2B5EF4-FFF2-40B4-BE49-F238E27FC236}">
-                <a16:creationId xmlns:a16="http://schemas.microsoft.com/office/drawing/2014/main" id="{353015E8-C954-40DB-9E42-3D92C872DFA0}"/>
+                <a16:creationId xmlns:a16="http://schemas.microsoft.com/office/drawing/2014/main" id="{438F389A-B66E-418A-8577-3C0EE3237720}"/>
               </a:ext>
             </a:extLst>
           </p:cNvPr>
@@ -5401,7 +5472,7 @@
           <p:cNvPr id="9" name="">
             <a:extLst xmlns:a="http://schemas.openxmlformats.org/drawingml/2006/main">
               <a:ext uri="{FF2B5EF4-FFF2-40B4-BE49-F238E27FC236}">
-                <a16:creationId xmlns:a16="http://schemas.microsoft.com/office/drawing/2014/main" id="{D9C58655-2104-41B9-B961-FC84913C389A}"/>
+                <a16:creationId xmlns:a16="http://schemas.microsoft.com/office/drawing/2014/main" id="{4241CA44-8856-45F3-AD7D-8ECBE9F663C2}"/>
               </a:ext>
             </a:extLst>
           </p:cNvPr>
@@ -5465,7 +5536,7 @@
     </p:spTree>
     <p:extLst>
       <p:ext uri="{BB962C8B-B14F-4D97-AF65-F5344CB8AC3E}">
-        <p14:creationId xmlns:p14="http://schemas.microsoft.com/office/powerpoint/2010/main" val="142347203"/>
+        <p14:creationId xmlns:p14="http://schemas.microsoft.com/office/powerpoint/2010/main" val="708870536"/>
       </p:ext>
     </p:extLst>
   </p:cSld>
@@ -5496,7 +5567,7 @@
           <p:cNvPr id="7" name="">
             <a:extLst xmlns:a="http://schemas.openxmlformats.org/drawingml/2006/main">
               <a:ext uri="{FF2B5EF4-FFF2-40B4-BE49-F238E27FC236}">
-                <a16:creationId xmlns:a16="http://schemas.microsoft.com/office/drawing/2014/main" id="{B9F11F8C-EBD0-4482-823E-36DF735B27C0}"/>
+                <a16:creationId xmlns:a16="http://schemas.microsoft.com/office/drawing/2014/main" id="{2C15CEC1-A743-4137-BFE7-03636C3A85F2}"/>
               </a:ext>
             </a:extLst>
           </p:cNvPr>
@@ -5562,7 +5633,7 @@
           <p:cNvPr id="2" name="">
             <a:extLst xmlns:a="http://schemas.openxmlformats.org/drawingml/2006/main">
               <a:ext uri="{FF2B5EF4-FFF2-40B4-BE49-F238E27FC236}">
-                <a16:creationId xmlns:a16="http://schemas.microsoft.com/office/drawing/2014/main" id="{53FD139B-D13E-42D2-8F1C-185EB322F6B5}"/>
+                <a16:creationId xmlns:a16="http://schemas.microsoft.com/office/drawing/2014/main" id="{3B9FE56D-23B5-4A98-9AC7-F47A7D838213}"/>
               </a:ext>
             </a:extLst>
           </p:cNvPr>
@@ -5628,7 +5699,7 @@
           <p:cNvPr id="3" name="">
             <a:extLst xmlns:a="http://schemas.openxmlformats.org/drawingml/2006/main">
               <a:ext uri="{FF2B5EF4-FFF2-40B4-BE49-F238E27FC236}">
-                <a16:creationId xmlns:a16="http://schemas.microsoft.com/office/drawing/2014/main" id="{820AAC81-1971-4C6C-82A7-8A1E902DBE67}"/>
+                <a16:creationId xmlns:a16="http://schemas.microsoft.com/office/drawing/2014/main" id="{A41C5172-A7A9-47BF-8724-F8CFA5B4CB29}"/>
               </a:ext>
             </a:extLst>
           </p:cNvPr>
@@ -5694,7 +5765,7 @@
           <p:cNvPr id="4" name="">
             <a:extLst xmlns:a="http://schemas.openxmlformats.org/drawingml/2006/main">
               <a:ext uri="{FF2B5EF4-FFF2-40B4-BE49-F238E27FC236}">
-                <a16:creationId xmlns:a16="http://schemas.microsoft.com/office/drawing/2014/main" id="{BD1C7CE0-79DE-418A-867A-D9608526F65B}"/>
+                <a16:creationId xmlns:a16="http://schemas.microsoft.com/office/drawing/2014/main" id="{CE5307F0-F11F-41B5-BD01-AF465EBC88D7}"/>
               </a:ext>
             </a:extLst>
           </p:cNvPr>
@@ -5760,7 +5831,7 @@
           <p:cNvPr id="5" name="">
             <a:extLst xmlns:a="http://schemas.openxmlformats.org/drawingml/2006/main">
               <a:ext uri="{FF2B5EF4-FFF2-40B4-BE49-F238E27FC236}">
-                <a16:creationId xmlns:a16="http://schemas.microsoft.com/office/drawing/2014/main" id="{679962E3-75DB-41A7-93EA-ADE4728976AB}"/>
+                <a16:creationId xmlns:a16="http://schemas.microsoft.com/office/drawing/2014/main" id="{EBEAEF73-5885-4E33-AFC7-C1C7A6B2B5FB}"/>
               </a:ext>
             </a:extLst>
           </p:cNvPr>
@@ -5770,7 +5841,7 @@
           <p:nvPr/>
         </p:nvPicPr>
         <p:blipFill>
-          <a:blip xmlns:r="http://schemas.openxmlformats.org/officeDocument/2006/relationships" xmlns:a="http://schemas.openxmlformats.org/drawingml/2006/main" r:embed="R03628b295e124c40"/>
+          <a:blip xmlns:r="http://schemas.openxmlformats.org/officeDocument/2006/relationships" xmlns:a="http://schemas.openxmlformats.org/drawingml/2006/main" r:embed="R6b53e39edb91492e"/>
           <a:stretch xmlns:a="http://schemas.openxmlformats.org/drawingml/2006/main"/>
         </p:blipFill>
         <p:spPr>
@@ -5788,7 +5859,7 @@
           <p:cNvPr id="6" name="">
             <a:extLst xmlns:a="http://schemas.openxmlformats.org/drawingml/2006/main">
               <a:ext uri="{FF2B5EF4-FFF2-40B4-BE49-F238E27FC236}">
-                <a16:creationId xmlns:a16="http://schemas.microsoft.com/office/drawing/2014/main" id="{DC9133CB-AA20-4D20-B7AC-6050E515062A}"/>
+                <a16:creationId xmlns:a16="http://schemas.microsoft.com/office/drawing/2014/main" id="{5CEBC2EB-F1BF-4285-8657-3D4509D0282C}"/>
               </a:ext>
             </a:extLst>
           </p:cNvPr>
@@ -5964,7 +6035,7 @@
     </p:spTree>
     <p:extLst>
       <p:ext uri="{BB962C8B-B14F-4D97-AF65-F5344CB8AC3E}">
-        <p14:creationId xmlns:p14="http://schemas.microsoft.com/office/powerpoint/2010/main" val="1029704489"/>
+        <p14:creationId xmlns:p14="http://schemas.microsoft.com/office/powerpoint/2010/main" val="2110020772"/>
       </p:ext>
     </p:extLst>
   </p:cSld>
@@ -5995,7 +6066,7 @@
           <p:cNvPr id="13" name="">
             <a:extLst xmlns:a="http://schemas.openxmlformats.org/drawingml/2006/main">
               <a:ext uri="{FF2B5EF4-FFF2-40B4-BE49-F238E27FC236}">
-                <a16:creationId xmlns:a16="http://schemas.microsoft.com/office/drawing/2014/main" id="{14538D7A-B0CA-49AC-AAB5-FD9B0742B00E}"/>
+                <a16:creationId xmlns:a16="http://schemas.microsoft.com/office/drawing/2014/main" id="{A346D2F1-EBDC-473B-9E36-30F264A6853F}"/>
               </a:ext>
             </a:extLst>
           </p:cNvPr>
@@ -6061,7 +6132,7 @@
           <p:cNvPr id="2" name="">
             <a:extLst xmlns:a="http://schemas.openxmlformats.org/drawingml/2006/main">
               <a:ext uri="{FF2B5EF4-FFF2-40B4-BE49-F238E27FC236}">
-                <a16:creationId xmlns:a16="http://schemas.microsoft.com/office/drawing/2014/main" id="{A79D667B-116F-49F8-822A-A79C85998F0B}"/>
+                <a16:creationId xmlns:a16="http://schemas.microsoft.com/office/drawing/2014/main" id="{7220451A-DA55-4D07-A0CD-8D0AFB015276}"/>
               </a:ext>
             </a:extLst>
           </p:cNvPr>
@@ -6127,7 +6198,7 @@
           <p:cNvPr id="3" name="">
             <a:extLst xmlns:a="http://schemas.openxmlformats.org/drawingml/2006/main">
               <a:ext uri="{FF2B5EF4-FFF2-40B4-BE49-F238E27FC236}">
-                <a16:creationId xmlns:a16="http://schemas.microsoft.com/office/drawing/2014/main" id="{6F2DD6B2-B3EA-46C8-AE5E-D0C57609C2C5}"/>
+                <a16:creationId xmlns:a16="http://schemas.microsoft.com/office/drawing/2014/main" id="{1680548F-710B-4AE9-A42A-368811346F91}"/>
               </a:ext>
             </a:extLst>
           </p:cNvPr>
@@ -6193,7 +6264,7 @@
           <p:cNvPr id="4" name="">
             <a:extLst xmlns:a="http://schemas.openxmlformats.org/drawingml/2006/main">
               <a:ext uri="{FF2B5EF4-FFF2-40B4-BE49-F238E27FC236}">
-                <a16:creationId xmlns:a16="http://schemas.microsoft.com/office/drawing/2014/main" id="{8D0E06E4-C67E-4BC3-8AE4-20A28FB9FE82}"/>
+                <a16:creationId xmlns:a16="http://schemas.microsoft.com/office/drawing/2014/main" id="{6B04CD3B-A29D-4B49-9732-D33CE3879ACC}"/>
               </a:ext>
             </a:extLst>
           </p:cNvPr>
@@ -6259,7 +6330,7 @@
           <p:cNvPr id="5" name="">
             <a:extLst xmlns:a="http://schemas.openxmlformats.org/drawingml/2006/main">
               <a:ext uri="{FF2B5EF4-FFF2-40B4-BE49-F238E27FC236}">
-                <a16:creationId xmlns:a16="http://schemas.microsoft.com/office/drawing/2014/main" id="{791A048A-D2E0-4724-ABAB-D3DBF9213685}"/>
+                <a16:creationId xmlns:a16="http://schemas.microsoft.com/office/drawing/2014/main" id="{289EF506-8BE0-43A2-A063-9D36971C7C1E}"/>
               </a:ext>
             </a:extLst>
           </p:cNvPr>
@@ -6325,7 +6396,7 @@
           <p:cNvPr id="6" name="">
             <a:extLst xmlns:a="http://schemas.openxmlformats.org/drawingml/2006/main">
               <a:ext uri="{FF2B5EF4-FFF2-40B4-BE49-F238E27FC236}">
-                <a16:creationId xmlns:a16="http://schemas.microsoft.com/office/drawing/2014/main" id="{485BD634-3F8A-46E8-8893-C1D95F1FA1ED}"/>
+                <a16:creationId xmlns:a16="http://schemas.microsoft.com/office/drawing/2014/main" id="{6280D198-AC57-46E2-B744-909EA24B3832}"/>
               </a:ext>
             </a:extLst>
           </p:cNvPr>
@@ -6391,7 +6462,7 @@
           <p:cNvPr id="7" name="">
             <a:extLst xmlns:a="http://schemas.openxmlformats.org/drawingml/2006/main">
               <a:ext uri="{FF2B5EF4-FFF2-40B4-BE49-F238E27FC236}">
-                <a16:creationId xmlns:a16="http://schemas.microsoft.com/office/drawing/2014/main" id="{9C40C00A-0B08-486B-BD54-B74FEF6E56D5}"/>
+                <a16:creationId xmlns:a16="http://schemas.microsoft.com/office/drawing/2014/main" id="{8CBE901F-F3AE-4753-9756-1A2BFE1EF924}"/>
               </a:ext>
             </a:extLst>
           </p:cNvPr>
@@ -6457,7 +6528,7 @@
           <p:cNvPr id="8" name="">
             <a:extLst xmlns:a="http://schemas.openxmlformats.org/drawingml/2006/main">
               <a:ext uri="{FF2B5EF4-FFF2-40B4-BE49-F238E27FC236}">
-                <a16:creationId xmlns:a16="http://schemas.microsoft.com/office/drawing/2014/main" id="{A26CCFB0-97CF-46EE-ADE0-F4581587CF58}"/>
+                <a16:creationId xmlns:a16="http://schemas.microsoft.com/office/drawing/2014/main" id="{4AEBAD44-6818-42F8-8AB5-DD61605F9B6B}"/>
               </a:ext>
             </a:extLst>
           </p:cNvPr>
@@ -6523,7 +6594,7 @@
           <p:cNvPr id="9" name="">
             <a:extLst xmlns:a="http://schemas.openxmlformats.org/drawingml/2006/main">
               <a:ext uri="{FF2B5EF4-FFF2-40B4-BE49-F238E27FC236}">
-                <a16:creationId xmlns:a16="http://schemas.microsoft.com/office/drawing/2014/main" id="{3EB8D103-F7EB-492C-BF28-17C5D675BBC3}"/>
+                <a16:creationId xmlns:a16="http://schemas.microsoft.com/office/drawing/2014/main" id="{FD460BD7-6F6B-4328-B6CB-513B179D4FE3}"/>
               </a:ext>
             </a:extLst>
           </p:cNvPr>
@@ -6589,7 +6660,7 @@
           <p:cNvPr id="10" name="">
             <a:extLst xmlns:a="http://schemas.openxmlformats.org/drawingml/2006/main">
               <a:ext uri="{FF2B5EF4-FFF2-40B4-BE49-F238E27FC236}">
-                <a16:creationId xmlns:a16="http://schemas.microsoft.com/office/drawing/2014/main" id="{FA14E102-D840-46FF-BD61-111629B3F8AB}"/>
+                <a16:creationId xmlns:a16="http://schemas.microsoft.com/office/drawing/2014/main" id="{746DBF9F-3300-48C0-B384-9BCE1EAAF471}"/>
               </a:ext>
             </a:extLst>
           </p:cNvPr>
@@ -6655,7 +6726,7 @@
           <p:cNvPr id="11" name="">
             <a:extLst xmlns:a="http://schemas.openxmlformats.org/drawingml/2006/main">
               <a:ext uri="{FF2B5EF4-FFF2-40B4-BE49-F238E27FC236}">
-                <a16:creationId xmlns:a16="http://schemas.microsoft.com/office/drawing/2014/main" id="{0EAF2A70-F4A5-4BC9-984C-016F894994F6}"/>
+                <a16:creationId xmlns:a16="http://schemas.microsoft.com/office/drawing/2014/main" id="{48E8DAAD-8711-4582-B510-B4534758B7DA}"/>
               </a:ext>
             </a:extLst>
           </p:cNvPr>
@@ -6721,7 +6792,7 @@
           <p:cNvPr id="12" name="">
             <a:extLst xmlns:a="http://schemas.openxmlformats.org/drawingml/2006/main">
               <a:ext uri="{FF2B5EF4-FFF2-40B4-BE49-F238E27FC236}">
-                <a16:creationId xmlns:a16="http://schemas.microsoft.com/office/drawing/2014/main" id="{A82DC386-1FC1-4073-9BDE-B15C12ED6F64}"/>
+                <a16:creationId xmlns:a16="http://schemas.microsoft.com/office/drawing/2014/main" id="{A976BEF3-7FD6-47B0-944A-23A48CA90F90}"/>
               </a:ext>
             </a:extLst>
           </p:cNvPr>
@@ -6785,7 +6856,7 @@
     </p:spTree>
     <p:extLst>
       <p:ext uri="{BB962C8B-B14F-4D97-AF65-F5344CB8AC3E}">
-        <p14:creationId xmlns:p14="http://schemas.microsoft.com/office/powerpoint/2010/main" val="489278032"/>
+        <p14:creationId xmlns:p14="http://schemas.microsoft.com/office/powerpoint/2010/main" val="1701341541"/>
       </p:ext>
     </p:extLst>
   </p:cSld>
@@ -6816,7 +6887,7 @@
           <p:cNvPr id="7" name="">
             <a:extLst xmlns:a="http://schemas.openxmlformats.org/drawingml/2006/main">
               <a:ext uri="{FF2B5EF4-FFF2-40B4-BE49-F238E27FC236}">
-                <a16:creationId xmlns:a16="http://schemas.microsoft.com/office/drawing/2014/main" id="{EB5E23FC-0BD0-42C1-A918-82648F72482D}"/>
+                <a16:creationId xmlns:a16="http://schemas.microsoft.com/office/drawing/2014/main" id="{B982E21F-4980-45EE-94DB-DB7DE0E4108C}"/>
               </a:ext>
             </a:extLst>
           </p:cNvPr>
@@ -6882,7 +6953,7 @@
           <p:cNvPr id="2" name="">
             <a:extLst xmlns:a="http://schemas.openxmlformats.org/drawingml/2006/main">
               <a:ext uri="{FF2B5EF4-FFF2-40B4-BE49-F238E27FC236}">
-                <a16:creationId xmlns:a16="http://schemas.microsoft.com/office/drawing/2014/main" id="{296EA669-93F2-4742-9FF1-9C548B9BF1B7}"/>
+                <a16:creationId xmlns:a16="http://schemas.microsoft.com/office/drawing/2014/main" id="{CAC24CE4-AFFF-4CCC-B12D-61F46D5625DF}"/>
               </a:ext>
             </a:extLst>
           </p:cNvPr>
@@ -6948,7 +7019,7 @@
           <p:cNvPr id="3" name="">
             <a:extLst xmlns:a="http://schemas.openxmlformats.org/drawingml/2006/main">
               <a:ext uri="{FF2B5EF4-FFF2-40B4-BE49-F238E27FC236}">
-                <a16:creationId xmlns:a16="http://schemas.microsoft.com/office/drawing/2014/main" id="{624F31D8-D1E2-4D93-88FD-2C085676FB75}"/>
+                <a16:creationId xmlns:a16="http://schemas.microsoft.com/office/drawing/2014/main" id="{8281FE29-0C4B-4B95-B015-E44FC92C7882}"/>
               </a:ext>
             </a:extLst>
           </p:cNvPr>
@@ -7014,7 +7085,7 @@
           <p:cNvPr id="4" name="">
             <a:extLst xmlns:a="http://schemas.openxmlformats.org/drawingml/2006/main">
               <a:ext uri="{FF2B5EF4-FFF2-40B4-BE49-F238E27FC236}">
-                <a16:creationId xmlns:a16="http://schemas.microsoft.com/office/drawing/2014/main" id="{8E36B46B-CEA2-488F-AB1B-736DB0122E5A}"/>
+                <a16:creationId xmlns:a16="http://schemas.microsoft.com/office/drawing/2014/main" id="{A3AF94FE-A780-40C2-9BD3-17666A6552D7}"/>
               </a:ext>
             </a:extLst>
           </p:cNvPr>
@@ -7080,7 +7151,7 @@
           <p:cNvPr id="5" name="">
             <a:extLst xmlns:a="http://schemas.openxmlformats.org/drawingml/2006/main">
               <a:ext uri="{FF2B5EF4-FFF2-40B4-BE49-F238E27FC236}">
-                <a16:creationId xmlns:a16="http://schemas.microsoft.com/office/drawing/2014/main" id="{FBB0B28B-923D-4EE2-A01C-935F449B1F14}"/>
+                <a16:creationId xmlns:a16="http://schemas.microsoft.com/office/drawing/2014/main" id="{E561092D-DB50-4A05-9493-3322324DBA36}"/>
               </a:ext>
             </a:extLst>
           </p:cNvPr>
@@ -7097,8 +7168,8 @@
               <a:tblPr/>
               <a:tblGrid>
                 <a:gridCol w="3952875"/>
-                <a:gridCol w="1238250"/>
-                <a:gridCol w="5781675"/>
+                <a:gridCol w="1571625"/>
+                <a:gridCol w="5448300"/>
               </a:tblGrid>
               <a:tr h="638175">
                 <a:tc>
@@ -7778,7 +7849,7 @@
           <p:cNvPr id="6" name="">
             <a:extLst xmlns:a="http://schemas.openxmlformats.org/drawingml/2006/main">
               <a:ext uri="{FF2B5EF4-FFF2-40B4-BE49-F238E27FC236}">
-                <a16:creationId xmlns:a16="http://schemas.microsoft.com/office/drawing/2014/main" id="{B4BE0658-5924-4429-BA25-ECADE9784F22}"/>
+                <a16:creationId xmlns:a16="http://schemas.microsoft.com/office/drawing/2014/main" id="{5B94FF71-575E-48C3-99F4-81993E61E972}"/>
               </a:ext>
             </a:extLst>
           </p:cNvPr>
@@ -7842,7 +7913,7 @@
     </p:spTree>
     <p:extLst>
       <p:ext uri="{BB962C8B-B14F-4D97-AF65-F5344CB8AC3E}">
-        <p14:creationId xmlns:p14="http://schemas.microsoft.com/office/powerpoint/2010/main" val="1345551840"/>
+        <p14:creationId xmlns:p14="http://schemas.microsoft.com/office/powerpoint/2010/main" val="165124130"/>
       </p:ext>
     </p:extLst>
   </p:cSld>
@@ -7873,7 +7944,7 @@
           <p:cNvPr id="12" name="">
             <a:extLst xmlns:a="http://schemas.openxmlformats.org/drawingml/2006/main">
               <a:ext uri="{FF2B5EF4-FFF2-40B4-BE49-F238E27FC236}">
-                <a16:creationId xmlns:a16="http://schemas.microsoft.com/office/drawing/2014/main" id="{2D2D33DC-2066-4EF0-B1AA-248D84B86697}"/>
+                <a16:creationId xmlns:a16="http://schemas.microsoft.com/office/drawing/2014/main" id="{39EDD26C-B616-4795-B82C-846AD4AECEEA}"/>
               </a:ext>
             </a:extLst>
           </p:cNvPr>
@@ -7939,7 +8010,7 @@
           <p:cNvPr id="2" name="">
             <a:extLst xmlns:a="http://schemas.openxmlformats.org/drawingml/2006/main">
               <a:ext uri="{FF2B5EF4-FFF2-40B4-BE49-F238E27FC236}">
-                <a16:creationId xmlns:a16="http://schemas.microsoft.com/office/drawing/2014/main" id="{DCC0CB75-CFD1-4957-877A-DB031FDDB409}"/>
+                <a16:creationId xmlns:a16="http://schemas.microsoft.com/office/drawing/2014/main" id="{8C5F6484-0C44-4462-A196-8BA42C2EEA87}"/>
               </a:ext>
             </a:extLst>
           </p:cNvPr>
@@ -8005,7 +8076,7 @@
           <p:cNvPr id="3" name="">
             <a:extLst xmlns:a="http://schemas.openxmlformats.org/drawingml/2006/main">
               <a:ext uri="{FF2B5EF4-FFF2-40B4-BE49-F238E27FC236}">
-                <a16:creationId xmlns:a16="http://schemas.microsoft.com/office/drawing/2014/main" id="{B2D07C64-4357-490F-9F6C-08F51DB890EC}"/>
+                <a16:creationId xmlns:a16="http://schemas.microsoft.com/office/drawing/2014/main" id="{8C068DA1-11A9-4EE6-8DD8-B10CC00D706E}"/>
               </a:ext>
             </a:extLst>
           </p:cNvPr>
@@ -8071,7 +8142,7 @@
           <p:cNvPr id="4" name="">
             <a:extLst xmlns:a="http://schemas.openxmlformats.org/drawingml/2006/main">
               <a:ext uri="{FF2B5EF4-FFF2-40B4-BE49-F238E27FC236}">
-                <a16:creationId xmlns:a16="http://schemas.microsoft.com/office/drawing/2014/main" id="{330F7784-8E17-4E90-8E1E-A5A4A6FE916A}"/>
+                <a16:creationId xmlns:a16="http://schemas.microsoft.com/office/drawing/2014/main" id="{D0278FA4-FD90-41F2-81B3-AAA6BBF419D0}"/>
               </a:ext>
             </a:extLst>
           </p:cNvPr>
@@ -8137,7 +8208,7 @@
           <p:cNvPr id="5" name="">
             <a:extLst xmlns:a="http://schemas.openxmlformats.org/drawingml/2006/main">
               <a:ext uri="{FF2B5EF4-FFF2-40B4-BE49-F238E27FC236}">
-                <a16:creationId xmlns:a16="http://schemas.microsoft.com/office/drawing/2014/main" id="{AEA0FF46-B577-4E93-8A32-56EB94858B09}"/>
+                <a16:creationId xmlns:a16="http://schemas.microsoft.com/office/drawing/2014/main" id="{5A9454A6-2193-45AF-848F-41C6A907100E}"/>
               </a:ext>
             </a:extLst>
           </p:cNvPr>
@@ -8203,7 +8274,7 @@
           <p:cNvPr id="6" name="">
             <a:extLst xmlns:a="http://schemas.openxmlformats.org/drawingml/2006/main">
               <a:ext uri="{FF2B5EF4-FFF2-40B4-BE49-F238E27FC236}">
-                <a16:creationId xmlns:a16="http://schemas.microsoft.com/office/drawing/2014/main" id="{0B675204-4141-45BD-BCA4-5FDAD7571A67}"/>
+                <a16:creationId xmlns:a16="http://schemas.microsoft.com/office/drawing/2014/main" id="{EFB5573F-26AE-48DF-BB32-5674D3904871}"/>
               </a:ext>
             </a:extLst>
           </p:cNvPr>
@@ -8269,7 +8340,7 @@
           <p:cNvPr id="7" name="">
             <a:extLst xmlns:a="http://schemas.openxmlformats.org/drawingml/2006/main">
               <a:ext uri="{FF2B5EF4-FFF2-40B4-BE49-F238E27FC236}">
-                <a16:creationId xmlns:a16="http://schemas.microsoft.com/office/drawing/2014/main" id="{CD9D2E4C-73A6-4371-8213-A8FF627A23D7}"/>
+                <a16:creationId xmlns:a16="http://schemas.microsoft.com/office/drawing/2014/main" id="{0895C5D5-BB4F-44C0-B3AF-141EBCE83186}"/>
               </a:ext>
             </a:extLst>
           </p:cNvPr>
@@ -8335,7 +8406,7 @@
           <p:cNvPr id="8" name="">
             <a:extLst xmlns:a="http://schemas.openxmlformats.org/drawingml/2006/main">
               <a:ext uri="{FF2B5EF4-FFF2-40B4-BE49-F238E27FC236}">
-                <a16:creationId xmlns:a16="http://schemas.microsoft.com/office/drawing/2014/main" id="{E7995FBB-920D-4194-BB0A-2227A617A0C9}"/>
+                <a16:creationId xmlns:a16="http://schemas.microsoft.com/office/drawing/2014/main" id="{93AC1E00-7544-4E47-A075-2EADA441A82F}"/>
               </a:ext>
             </a:extLst>
           </p:cNvPr>
@@ -8401,7 +8472,7 @@
           <p:cNvPr id="9" name="">
             <a:extLst xmlns:a="http://schemas.openxmlformats.org/drawingml/2006/main">
               <a:ext uri="{FF2B5EF4-FFF2-40B4-BE49-F238E27FC236}">
-                <a16:creationId xmlns:a16="http://schemas.microsoft.com/office/drawing/2014/main" id="{874B3215-BDFF-498A-9D65-84F334E98221}"/>
+                <a16:creationId xmlns:a16="http://schemas.microsoft.com/office/drawing/2014/main" id="{CAD1925E-3E52-44DF-BD74-19923FF1140D}"/>
               </a:ext>
             </a:extLst>
           </p:cNvPr>
@@ -8467,7 +8538,7 @@
           <p:cNvPr id="10" name="">
             <a:extLst xmlns:a="http://schemas.openxmlformats.org/drawingml/2006/main">
               <a:ext uri="{FF2B5EF4-FFF2-40B4-BE49-F238E27FC236}">
-                <a16:creationId xmlns:a16="http://schemas.microsoft.com/office/drawing/2014/main" id="{9C508667-0940-4975-8BCB-7CF59D3027B2}"/>
+                <a16:creationId xmlns:a16="http://schemas.microsoft.com/office/drawing/2014/main" id="{555C2F76-FDA9-4E2C-BC45-40D9186BDD85}"/>
               </a:ext>
             </a:extLst>
           </p:cNvPr>
@@ -8533,7 +8604,7 @@
           <p:cNvPr id="11" name="">
             <a:extLst xmlns:a="http://schemas.openxmlformats.org/drawingml/2006/main">
               <a:ext uri="{FF2B5EF4-FFF2-40B4-BE49-F238E27FC236}">
-                <a16:creationId xmlns:a16="http://schemas.microsoft.com/office/drawing/2014/main" id="{F5A41CFE-6E5E-47B7-B9FC-6EE6DF1FEE5B}"/>
+                <a16:creationId xmlns:a16="http://schemas.microsoft.com/office/drawing/2014/main" id="{1704729A-30BA-4652-8854-64CF3E655230}"/>
               </a:ext>
             </a:extLst>
           </p:cNvPr>
@@ -8620,7 +8691,7 @@
     </p:spTree>
     <p:extLst>
       <p:ext uri="{BB962C8B-B14F-4D97-AF65-F5344CB8AC3E}">
-        <p14:creationId xmlns:p14="http://schemas.microsoft.com/office/powerpoint/2010/main" val="2081179745"/>
+        <p14:creationId xmlns:p14="http://schemas.microsoft.com/office/powerpoint/2010/main" val="683904136"/>
       </p:ext>
     </p:extLst>
   </p:cSld>
@@ -8648,10 +8719,10 @@
       </p:grpSpPr>
       <p:sp>
         <p:nvSpPr>
-          <p:cNvPr id="12" name="">
-            <a:extLst xmlns:a="http://schemas.openxmlformats.org/drawingml/2006/main">
-              <a:ext uri="{FF2B5EF4-FFF2-40B4-BE49-F238E27FC236}">
-                <a16:creationId xmlns:a16="http://schemas.microsoft.com/office/drawing/2014/main" id="{3EF75751-9202-411A-9DA3-E28B8B562178}"/>
+          <p:cNvPr id="8" name="">
+            <a:extLst xmlns:a="http://schemas.openxmlformats.org/drawingml/2006/main">
+              <a:ext uri="{FF2B5EF4-FFF2-40B4-BE49-F238E27FC236}">
+                <a16:creationId xmlns:a16="http://schemas.microsoft.com/office/drawing/2014/main" id="{86CD7216-35E1-4780-BD9D-62078D67521B}"/>
               </a:ext>
             </a:extLst>
           </p:cNvPr>
@@ -8707,7 +8778,7 @@
                 <a:ea typeface="Arial"/>
                 <a:cs typeface="Arial"/>
               </a:rPr>
-              <a:t>HOSTING</a:t>
+              <a:t>DEMONSTRATION ACCESS</a:t>
             </a:r>
           </a:p>
         </p:txBody>
@@ -8717,7 +8788,7 @@
           <p:cNvPr id="2" name="">
             <a:extLst xmlns:a="http://schemas.openxmlformats.org/drawingml/2006/main">
               <a:ext uri="{FF2B5EF4-FFF2-40B4-BE49-F238E27FC236}">
-                <a16:creationId xmlns:a16="http://schemas.microsoft.com/office/drawing/2014/main" id="{8767CE5D-5C37-4A8B-A4A5-29B089D0C302}"/>
+                <a16:creationId xmlns:a16="http://schemas.microsoft.com/office/drawing/2014/main" id="{EF96B717-FAD7-4A23-8F71-6CFA4C864BC4}"/>
               </a:ext>
             </a:extLst>
           </p:cNvPr>
@@ -8773,7 +8844,7 @@
                 <a:ea typeface="Georgia"/>
                 <a:cs typeface="Georgia"/>
               </a:rPr>
-              <a:t>Cloud deployment plan</a:t>
+              <a:t>Local demo login credentials</a:t>
             </a:r>
           </a:p>
         </p:txBody>
@@ -8783,7 +8854,7 @@
           <p:cNvPr id="3" name="">
             <a:extLst xmlns:a="http://schemas.openxmlformats.org/drawingml/2006/main">
               <a:ext uri="{FF2B5EF4-FFF2-40B4-BE49-F238E27FC236}">
-                <a16:creationId xmlns:a16="http://schemas.microsoft.com/office/drawing/2014/main" id="{001F3BA5-DA94-4076-A39F-6E581D855B47}"/>
+                <a16:creationId xmlns:a16="http://schemas.microsoft.com/office/drawing/2014/main" id="{42231240-1252-4917-92BF-A5A29340E5C2}"/>
               </a:ext>
             </a:extLst>
           </p:cNvPr>
@@ -8849,7 +8920,7 @@
           <p:cNvPr id="4" name="">
             <a:extLst xmlns:a="http://schemas.openxmlformats.org/drawingml/2006/main">
               <a:ext uri="{FF2B5EF4-FFF2-40B4-BE49-F238E27FC236}">
-                <a16:creationId xmlns:a16="http://schemas.microsoft.com/office/drawing/2014/main" id="{CFE1FB7B-645B-4878-BF07-3841805363F6}"/>
+                <a16:creationId xmlns:a16="http://schemas.microsoft.com/office/drawing/2014/main" id="{BB3C7932-1AD1-4F3C-8973-A26E0AA6A892}"/>
               </a:ext>
             </a:extLst>
           </p:cNvPr>
@@ -8910,24 +8981,362 @@
           </a:p>
         </p:txBody>
       </p:sp>
-      <p:sp>
-        <p:nvSpPr>
+      <p:graphicFrame>
+        <p:nvGraphicFramePr>
           <p:cNvPr id="5" name="">
             <a:extLst xmlns:a="http://schemas.openxmlformats.org/drawingml/2006/main">
               <a:ext uri="{FF2B5EF4-FFF2-40B4-BE49-F238E27FC236}">
-                <a16:creationId xmlns:a16="http://schemas.microsoft.com/office/drawing/2014/main" id="{EA8473D8-48FB-4DFB-85A5-438BFEA8CD00}"/>
-              </a:ext>
-            </a:extLst>
-          </p:cNvPr>
-          <p:cNvSpPr>
-            <a:spLocks xmlns:a="http://schemas.openxmlformats.org/drawingml/2006/main" noGrp="1"/>
-          </p:cNvSpPr>
-          <p:nvPr/>
-        </p:nvSpPr>
-        <p:spPr>
-          <a:xfrm xmlns:a="http://schemas.openxmlformats.org/drawingml/2006/main">
-            <a:off x="609600" y="1714500"/>
-            <a:ext cx="10668000" cy="361950"/>
+                <a16:creationId xmlns:a16="http://schemas.microsoft.com/office/drawing/2014/main" id="{DF3FA346-E453-435B-8C97-BF7A7E421F34}"/>
+              </a:ext>
+            </a:extLst>
+          </p:cNvPr>
+          <p:cNvGraphicFramePr/>
+          <p:nvPr/>
+        </p:nvGraphicFramePr>
+        <p:xfrm>
+          <a:off xmlns:a="http://schemas.openxmlformats.org/drawingml/2006/main" x="609600" y="1743075"/>
+          <a:ext xmlns:a="http://schemas.openxmlformats.org/drawingml/2006/main" cx="10972800" cy="2857500"/>
+        </p:xfrm>
+        <a:graphic xmlns:a="http://schemas.openxmlformats.org/drawingml/2006/main">
+          <a:graphicData uri="http://schemas.openxmlformats.org/drawingml/2006/table">
+            <a:tbl>
+              <a:tblPr/>
+              <a:tblGrid>
+                <a:gridCol w="4000500"/>
+                <a:gridCol w="6972300"/>
+              </a:tblGrid>
+              <a:tr h="714375">
+                <a:tc>
+                  <a:txBody>
+                    <a:bodyPr/>
+                    <a:lstStyle/>
+                    <a:p>
+                      <a:r>
+                        <a:rPr sz="2175" b="1">
+                          <a:solidFill>
+                            <a:srgbClr val="F5F2E9"/>
+                          </a:solidFill>
+                          <a:latin typeface="Arial"/>
+                          <a:ea typeface="Arial"/>
+                          <a:cs typeface="Arial"/>
+                        </a:rPr>
+                        <a:t>Role</a:t>
+                      </a:r>
+                    </a:p>
+                  </a:txBody>
+                  <a:tcPr marL="171450" marR="171450" marT="161925" marB="161925">
+                    <a:lnL w="9525">
+                      <a:solidFill>
+                        <a:srgbClr val="BBC5B6"/>
+                      </a:solidFill>
+                    </a:lnL>
+                    <a:lnR w="9525">
+                      <a:solidFill>
+                        <a:srgbClr val="BBC5B6"/>
+                      </a:solidFill>
+                    </a:lnR>
+                    <a:lnT w="9525">
+                      <a:solidFill>
+                        <a:srgbClr val="BBC5B6"/>
+                      </a:solidFill>
+                    </a:lnT>
+                    <a:lnB w="9525">
+                      <a:solidFill>
+                        <a:srgbClr val="BBC5B6"/>
+                      </a:solidFill>
+                    </a:lnB>
+                    <a:solidFill>
+                      <a:srgbClr val="253F33"/>
+                    </a:solidFill>
+                  </a:tcPr>
+                </a:tc>
+                <a:tc>
+                  <a:txBody>
+                    <a:bodyPr/>
+                    <a:lstStyle/>
+                    <a:p>
+                      <a:r>
+                        <a:rPr sz="2175" b="1">
+                          <a:solidFill>
+                            <a:srgbClr val="F5F2E9"/>
+                          </a:solidFill>
+                          <a:latin typeface="Arial"/>
+                          <a:ea typeface="Arial"/>
+                          <a:cs typeface="Arial"/>
+                        </a:rPr>
+                        <a:t>Email address</a:t>
+                      </a:r>
+                    </a:p>
+                  </a:txBody>
+                  <a:tcPr marL="171450" marR="171450" marT="161925" marB="161925">
+                    <a:lnR w="9525">
+                      <a:solidFill>
+                        <a:srgbClr val="BBC5B6"/>
+                      </a:solidFill>
+                    </a:lnR>
+                    <a:lnT w="9525">
+                      <a:solidFill>
+                        <a:srgbClr val="BBC5B6"/>
+                      </a:solidFill>
+                    </a:lnT>
+                    <a:lnB w="9525">
+                      <a:solidFill>
+                        <a:srgbClr val="BBC5B6"/>
+                      </a:solidFill>
+                    </a:lnB>
+                    <a:solidFill>
+                      <a:srgbClr val="253F33"/>
+                    </a:solidFill>
+                  </a:tcPr>
+                </a:tc>
+              </a:tr>
+              <a:tr h="714375">
+                <a:tc>
+                  <a:txBody>
+                    <a:bodyPr/>
+                    <a:lstStyle/>
+                    <a:p>
+                      <a:r>
+                        <a:rPr sz="2175">
+                          <a:solidFill>
+                            <a:srgbClr val="253F33"/>
+                          </a:solidFill>
+                          <a:latin typeface="Arial"/>
+                          <a:ea typeface="Arial"/>
+                          <a:cs typeface="Arial"/>
+                        </a:rPr>
+                        <a:t>Administrator</a:t>
+                      </a:r>
+                    </a:p>
+                  </a:txBody>
+                  <a:tcPr marL="171450" marR="171450" marT="161925" marB="161925">
+                    <a:lnL w="9525">
+                      <a:solidFill>
+                        <a:srgbClr val="BBC5B6"/>
+                      </a:solidFill>
+                    </a:lnL>
+                    <a:lnR w="9525">
+                      <a:solidFill>
+                        <a:srgbClr val="BBC5B6"/>
+                      </a:solidFill>
+                    </a:lnR>
+                    <a:lnB w="9525">
+                      <a:solidFill>
+                        <a:srgbClr val="BBC5B6"/>
+                      </a:solidFill>
+                    </a:lnB>
+                    <a:solidFill>
+                      <a:srgbClr val="F5F2E9"/>
+                    </a:solidFill>
+                  </a:tcPr>
+                </a:tc>
+                <a:tc>
+                  <a:txBody>
+                    <a:bodyPr/>
+                    <a:lstStyle/>
+                    <a:p>
+                      <a:r>
+                        <a:rPr sz="2175">
+                          <a:solidFill>
+                            <a:srgbClr val="253F33"/>
+                          </a:solidFill>
+                          <a:latin typeface="Arial"/>
+                          <a:ea typeface="Arial"/>
+                          <a:cs typeface="Arial"/>
+                        </a:rPr>
+                        <a:t>admin@quizcraft.dev</a:t>
+                      </a:r>
+                    </a:p>
+                  </a:txBody>
+                  <a:tcPr marL="171450" marR="171450" marT="161925" marB="161925">
+                    <a:lnR w="9525">
+                      <a:solidFill>
+                        <a:srgbClr val="BBC5B6"/>
+                      </a:solidFill>
+                    </a:lnR>
+                    <a:lnB w="9525">
+                      <a:solidFill>
+                        <a:srgbClr val="BBC5B6"/>
+                      </a:solidFill>
+                    </a:lnB>
+                    <a:solidFill>
+                      <a:srgbClr val="F5F2E9"/>
+                    </a:solidFill>
+                  </a:tcPr>
+                </a:tc>
+              </a:tr>
+              <a:tr h="714375">
+                <a:tc>
+                  <a:txBody>
+                    <a:bodyPr/>
+                    <a:lstStyle/>
+                    <a:p>
+                      <a:r>
+                        <a:rPr sz="2175">
+                          <a:solidFill>
+                            <a:srgbClr val="253F33"/>
+                          </a:solidFill>
+                          <a:latin typeface="Arial"/>
+                          <a:ea typeface="Arial"/>
+                          <a:cs typeface="Arial"/>
+                        </a:rPr>
+                        <a:t>Quiz creator</a:t>
+                      </a:r>
+                    </a:p>
+                  </a:txBody>
+                  <a:tcPr marL="171450" marR="171450" marT="161925" marB="161925">
+                    <a:lnL w="9525">
+                      <a:solidFill>
+                        <a:srgbClr val="BBC5B6"/>
+                      </a:solidFill>
+                    </a:lnL>
+                    <a:lnR w="9525">
+                      <a:solidFill>
+                        <a:srgbClr val="BBC5B6"/>
+                      </a:solidFill>
+                    </a:lnR>
+                    <a:lnB w="9525">
+                      <a:solidFill>
+                        <a:srgbClr val="BBC5B6"/>
+                      </a:solidFill>
+                    </a:lnB>
+                    <a:solidFill>
+                      <a:srgbClr val="F5F2E9"/>
+                    </a:solidFill>
+                  </a:tcPr>
+                </a:tc>
+                <a:tc>
+                  <a:txBody>
+                    <a:bodyPr/>
+                    <a:lstStyle/>
+                    <a:p>
+                      <a:r>
+                        <a:rPr sz="2175">
+                          <a:solidFill>
+                            <a:srgbClr val="253F33"/>
+                          </a:solidFill>
+                          <a:latin typeface="Arial"/>
+                          <a:ea typeface="Arial"/>
+                          <a:cs typeface="Arial"/>
+                        </a:rPr>
+                        <a:t>creator@quizcraft.dev</a:t>
+                      </a:r>
+                    </a:p>
+                  </a:txBody>
+                  <a:tcPr marL="171450" marR="171450" marT="161925" marB="161925">
+                    <a:lnR w="9525">
+                      <a:solidFill>
+                        <a:srgbClr val="BBC5B6"/>
+                      </a:solidFill>
+                    </a:lnR>
+                    <a:lnB w="9525">
+                      <a:solidFill>
+                        <a:srgbClr val="BBC5B6"/>
+                      </a:solidFill>
+                    </a:lnB>
+                    <a:solidFill>
+                      <a:srgbClr val="F5F2E9"/>
+                    </a:solidFill>
+                  </a:tcPr>
+                </a:tc>
+              </a:tr>
+              <a:tr h="714375">
+                <a:tc>
+                  <a:txBody>
+                    <a:bodyPr/>
+                    <a:lstStyle/>
+                    <a:p>
+                      <a:r>
+                        <a:rPr sz="2175">
+                          <a:solidFill>
+                            <a:srgbClr val="253F33"/>
+                          </a:solidFill>
+                          <a:latin typeface="Arial"/>
+                          <a:ea typeface="Arial"/>
+                          <a:cs typeface="Arial"/>
+                        </a:rPr>
+                        <a:t>Participant</a:t>
+                      </a:r>
+                    </a:p>
+                  </a:txBody>
+                  <a:tcPr marL="171450" marR="171450" marT="161925" marB="161925">
+                    <a:lnL w="9525">
+                      <a:solidFill>
+                        <a:srgbClr val="BBC5B6"/>
+                      </a:solidFill>
+                    </a:lnL>
+                    <a:lnR w="9525">
+                      <a:solidFill>
+                        <a:srgbClr val="BBC5B6"/>
+                      </a:solidFill>
+                    </a:lnR>
+                    <a:lnB w="9525">
+                      <a:solidFill>
+                        <a:srgbClr val="BBC5B6"/>
+                      </a:solidFill>
+                    </a:lnB>
+                    <a:solidFill>
+                      <a:srgbClr val="F5F2E9"/>
+                    </a:solidFill>
+                  </a:tcPr>
+                </a:tc>
+                <a:tc>
+                  <a:txBody>
+                    <a:bodyPr/>
+                    <a:lstStyle/>
+                    <a:p>
+                      <a:r>
+                        <a:rPr sz="2175">
+                          <a:solidFill>
+                            <a:srgbClr val="253F33"/>
+                          </a:solidFill>
+                          <a:latin typeface="Arial"/>
+                          <a:ea typeface="Arial"/>
+                          <a:cs typeface="Arial"/>
+                        </a:rPr>
+                        <a:t>participant@quizcraft.dev</a:t>
+                      </a:r>
+                    </a:p>
+                  </a:txBody>
+                  <a:tcPr marL="171450" marR="171450" marT="161925" marB="161925">
+                    <a:lnR w="9525">
+                      <a:solidFill>
+                        <a:srgbClr val="BBC5B6"/>
+                      </a:solidFill>
+                    </a:lnR>
+                    <a:lnB w="9525">
+                      <a:solidFill>
+                        <a:srgbClr val="BBC5B6"/>
+                      </a:solidFill>
+                    </a:lnB>
+                    <a:solidFill>
+                      <a:srgbClr val="F5F2E9"/>
+                    </a:solidFill>
+                  </a:tcPr>
+                </a:tc>
+              </a:tr>
+            </a:tbl>
+          </a:graphicData>
+        </a:graphic>
+      </p:graphicFrame>
+      <p:sp>
+        <p:nvSpPr>
+          <p:cNvPr id="6" name="">
+            <a:extLst xmlns:a="http://schemas.openxmlformats.org/drawingml/2006/main">
+              <a:ext uri="{FF2B5EF4-FFF2-40B4-BE49-F238E27FC236}">
+                <a16:creationId xmlns:a16="http://schemas.microsoft.com/office/drawing/2014/main" id="{7D5B8C17-9D6E-4D3A-9007-9F313CB34FEF}"/>
+              </a:ext>
+            </a:extLst>
+          </p:cNvPr>
+          <p:cNvSpPr>
+            <a:spLocks xmlns:a="http://schemas.openxmlformats.org/drawingml/2006/main" noGrp="1"/>
+          </p:cNvSpPr>
+          <p:nvPr/>
+        </p:nvSpPr>
+        <p:spPr>
+          <a:xfrm xmlns:a="http://schemas.openxmlformats.org/drawingml/2006/main">
+            <a:off x="609600" y="4953000"/>
+            <a:ext cx="10668000" cy="571500"/>
           </a:xfrm>
           <a:prstGeom xmlns:a="http://schemas.openxmlformats.org/drawingml/2006/main" prst="rect">
             <a:avLst/>
@@ -8941,7 +9350,7 @@
           <a:bodyPr xmlns:a="http://schemas.openxmlformats.org/drawingml/2006/main"/>
           <a:lstStyle xmlns:a="http://schemas.openxmlformats.org/drawingml/2006/main">
             <a:defPPr>
-              <a:defRPr sz="2100" b="1">
+              <a:defRPr sz="2550" b="1">
                 <a:solidFill>
                   <a:srgbClr val="AD583D"/>
                 </a:solidFill>
@@ -8953,7 +9362,7 @@
           </a:lstStyle>
           <a:p xmlns:a="http://schemas.openxmlformats.org/drawingml/2006/main">
             <a:pPr>
-              <a:defRPr sz="2100" b="1">
+              <a:defRPr sz="2550" b="1">
                 <a:solidFill>
                   <a:srgbClr val="AD583D"/>
                 </a:solidFill>
@@ -8963,7 +9372,7 @@
               </a:defRPr>
             </a:pPr>
             <a:r>
-              <a:rPr sz="2100" b="1">
+              <a:rPr sz="2550" b="1">
                 <a:solidFill>
                   <a:srgbClr val="AD583D"/>
                 </a:solidFill>
@@ -8971,29 +9380,29 @@
                 <a:ea typeface="Arial"/>
                 <a:cs typeface="Arial"/>
               </a:rPr>
-              <a:t>Render web service + Neon PostgreSQL</a:t>
-            </a:r>
-          </a:p>
-        </p:txBody>
-      </p:sp>
-      <p:sp>
-        <p:nvSpPr>
-          <p:cNvPr id="6" name="">
-            <a:extLst xmlns:a="http://schemas.openxmlformats.org/drawingml/2006/main">
-              <a:ext uri="{FF2B5EF4-FFF2-40B4-BE49-F238E27FC236}">
-                <a16:creationId xmlns:a16="http://schemas.microsoft.com/office/drawing/2014/main" id="{B0F59A64-233C-409F-8823-AA5DA1A2DA45}"/>
-              </a:ext>
-            </a:extLst>
-          </p:cNvPr>
-          <p:cNvSpPr>
-            <a:spLocks xmlns:a="http://schemas.openxmlformats.org/drawingml/2006/main" noGrp="1"/>
-          </p:cNvSpPr>
-          <p:nvPr/>
-        </p:nvSpPr>
-        <p:spPr>
-          <a:xfrm xmlns:a="http://schemas.openxmlformats.org/drawingml/2006/main">
-            <a:off x="609600" y="2095500"/>
-            <a:ext cx="10668000" cy="723900"/>
+              <a:t>Password for all three: JavaLab@123</a:t>
+            </a:r>
+          </a:p>
+        </p:txBody>
+      </p:sp>
+      <p:sp>
+        <p:nvSpPr>
+          <p:cNvPr id="7" name="">
+            <a:extLst xmlns:a="http://schemas.openxmlformats.org/drawingml/2006/main">
+              <a:ext uri="{FF2B5EF4-FFF2-40B4-BE49-F238E27FC236}">
+                <a16:creationId xmlns:a16="http://schemas.microsoft.com/office/drawing/2014/main" id="{CC3FF7D6-4E06-44F5-A2BC-631258ACA789}"/>
+              </a:ext>
+            </a:extLst>
+          </p:cNvPr>
+          <p:cNvSpPr>
+            <a:spLocks xmlns:a="http://schemas.openxmlformats.org/drawingml/2006/main" noGrp="1"/>
+          </p:cNvSpPr>
+          <p:nvPr/>
+        </p:nvSpPr>
+        <p:spPr>
+          <a:xfrm xmlns:a="http://schemas.openxmlformats.org/drawingml/2006/main">
+            <a:off x="609600" y="5772150"/>
+            <a:ext cx="10763250" cy="457200"/>
           </a:xfrm>
           <a:prstGeom xmlns:a="http://schemas.openxmlformats.org/drawingml/2006/main" prst="rect">
             <a:avLst/>
@@ -9037,29 +9446,58 @@
                 <a:ea typeface="Arial"/>
                 <a:cs typeface="Arial"/>
               </a:rPr>
-              <a:t>Dockerfile, render.yaml and a PostgreSQL cloud profile are included.</a:t>
-            </a:r>
-          </a:p>
-        </p:txBody>
-      </p:sp>
-      <p:sp>
-        <p:nvSpPr>
-          <p:cNvPr id="7" name="">
-            <a:extLst xmlns:a="http://schemas.openxmlformats.org/drawingml/2006/main">
-              <a:ext uri="{FF2B5EF4-FFF2-40B4-BE49-F238E27FC236}">
-                <a16:creationId xmlns:a16="http://schemas.microsoft.com/office/drawing/2014/main" id="{B71BC651-1162-467E-B49E-985A804F18ED}"/>
-              </a:ext>
-            </a:extLst>
-          </p:cNvPr>
-          <p:cNvSpPr>
-            <a:spLocks xmlns:a="http://schemas.openxmlformats.org/drawingml/2006/main" noGrp="1"/>
-          </p:cNvSpPr>
-          <p:nvPr/>
-        </p:nvSpPr>
-        <p:spPr>
-          <a:xfrm xmlns:a="http://schemas.openxmlformats.org/drawingml/2006/main">
-            <a:off x="609600" y="2819400"/>
-            <a:ext cx="10668000" cy="361950"/>
+              <a:t>Normal users create an account first. Admin creates creator accounts.</a:t>
+            </a:r>
+          </a:p>
+        </p:txBody>
+      </p:sp>
+    </p:spTree>
+    <p:extLst>
+      <p:ext uri="{BB962C8B-B14F-4D97-AF65-F5344CB8AC3E}">
+        <p14:creationId xmlns:p14="http://schemas.microsoft.com/office/powerpoint/2010/main" val="517612899"/>
+      </p:ext>
+    </p:extLst>
+  </p:cSld>
+</p:sld>
+</file>
+
+<file path=ppt/slides/slide17.xml><?xml version="1.0" encoding="utf-8"?>
+<p:sld xmlns:p="http://schemas.openxmlformats.org/presentationml/2006/main">
+  <p:cSld>
+    <p:bg>
+      <p:bgPr>
+        <a:solidFill xmlns:a="http://schemas.openxmlformats.org/drawingml/2006/main">
+          <a:srgbClr val="F5F2E9"/>
+        </a:solidFill>
+      </p:bgPr>
+    </p:bg>
+    <p:spTree>
+      <p:nvGrpSpPr>
+        <p:cNvPr id="1" name=""/>
+        <p:cNvGrpSpPr/>
+        <p:nvPr/>
+      </p:nvGrpSpPr>
+      <p:grpSpPr>
+        <a:xfrm xmlns:a="http://schemas.openxmlformats.org/drawingml/2006/main"/>
+      </p:grpSpPr>
+      <p:sp>
+        <p:nvSpPr>
+          <p:cNvPr id="12" name="">
+            <a:extLst xmlns:a="http://schemas.openxmlformats.org/drawingml/2006/main">
+              <a:ext uri="{FF2B5EF4-FFF2-40B4-BE49-F238E27FC236}">
+                <a16:creationId xmlns:a16="http://schemas.microsoft.com/office/drawing/2014/main" id="{0D9AA5E4-3B4F-4FCC-9647-B5EE21D6FE1D}"/>
+              </a:ext>
+            </a:extLst>
+          </p:cNvPr>
+          <p:cNvSpPr>
+            <a:spLocks xmlns:a="http://schemas.openxmlformats.org/drawingml/2006/main" noGrp="1"/>
+          </p:cNvSpPr>
+          <p:nvPr/>
+        </p:nvSpPr>
+        <p:spPr>
+          <a:xfrm xmlns:a="http://schemas.openxmlformats.org/drawingml/2006/main">
+            <a:off x="609600" y="323850"/>
+            <a:ext cx="10477500" cy="285750"/>
           </a:xfrm>
           <a:prstGeom xmlns:a="http://schemas.openxmlformats.org/drawingml/2006/main" prst="rect">
             <a:avLst/>
@@ -9073,7 +9511,7 @@
           <a:bodyPr xmlns:a="http://schemas.openxmlformats.org/drawingml/2006/main"/>
           <a:lstStyle xmlns:a="http://schemas.openxmlformats.org/drawingml/2006/main">
             <a:defPPr>
-              <a:defRPr sz="2100" b="1">
+              <a:defRPr sz="1425" b="1">
                 <a:solidFill>
                   <a:srgbClr val="AD583D"/>
                 </a:solidFill>
@@ -9085,7 +9523,7 @@
           </a:lstStyle>
           <a:p xmlns:a="http://schemas.openxmlformats.org/drawingml/2006/main">
             <a:pPr>
-              <a:defRPr sz="2100" b="1">
+              <a:defRPr sz="1425" b="1">
                 <a:solidFill>
                   <a:srgbClr val="AD583D"/>
                 </a:solidFill>
@@ -9095,7 +9533,7 @@
               </a:defRPr>
             </a:pPr>
             <a:r>
-              <a:rPr sz="2100" b="1">
+              <a:rPr sz="1425" b="1">
                 <a:solidFill>
                   <a:srgbClr val="AD583D"/>
                 </a:solidFill>
@@ -9103,29 +9541,29 @@
                 <a:ea typeface="Arial"/>
                 <a:cs typeface="Arial"/>
               </a:rPr>
-              <a:t>Private deployment configuration</a:t>
-            </a:r>
-          </a:p>
-        </p:txBody>
-      </p:sp>
-      <p:sp>
-        <p:nvSpPr>
-          <p:cNvPr id="8" name="">
-            <a:extLst xmlns:a="http://schemas.openxmlformats.org/drawingml/2006/main">
-              <a:ext uri="{FF2B5EF4-FFF2-40B4-BE49-F238E27FC236}">
-                <a16:creationId xmlns:a16="http://schemas.microsoft.com/office/drawing/2014/main" id="{94556C7C-5669-47B8-BEFE-2E26110132E7}"/>
-              </a:ext>
-            </a:extLst>
-          </p:cNvPr>
-          <p:cNvSpPr>
-            <a:spLocks xmlns:a="http://schemas.openxmlformats.org/drawingml/2006/main" noGrp="1"/>
-          </p:cNvSpPr>
-          <p:nvPr/>
-        </p:nvSpPr>
-        <p:spPr>
-          <a:xfrm xmlns:a="http://schemas.openxmlformats.org/drawingml/2006/main">
-            <a:off x="609600" y="3200400"/>
-            <a:ext cx="10668000" cy="723900"/>
+              <a:t>HOSTING</a:t>
+            </a:r>
+          </a:p>
+        </p:txBody>
+      </p:sp>
+      <p:sp>
+        <p:nvSpPr>
+          <p:cNvPr id="2" name="">
+            <a:extLst xmlns:a="http://schemas.openxmlformats.org/drawingml/2006/main">
+              <a:ext uri="{FF2B5EF4-FFF2-40B4-BE49-F238E27FC236}">
+                <a16:creationId xmlns:a16="http://schemas.microsoft.com/office/drawing/2014/main" id="{59751387-FC36-4225-A48F-A01E2D1E5862}"/>
+              </a:ext>
+            </a:extLst>
+          </p:cNvPr>
+          <p:cNvSpPr>
+            <a:spLocks xmlns:a="http://schemas.openxmlformats.org/drawingml/2006/main" noGrp="1"/>
+          </p:cNvSpPr>
+          <p:nvPr/>
+        </p:nvSpPr>
+        <p:spPr>
+          <a:xfrm xmlns:a="http://schemas.openxmlformats.org/drawingml/2006/main">
+            <a:off x="609600" y="790575"/>
+            <a:ext cx="10972800" cy="666750"/>
           </a:xfrm>
           <a:prstGeom xmlns:a="http://schemas.openxmlformats.org/drawingml/2006/main" prst="rect">
             <a:avLst/>
@@ -9139,59 +9577,59 @@
           <a:bodyPr xmlns:a="http://schemas.openxmlformats.org/drawingml/2006/main"/>
           <a:lstStyle xmlns:a="http://schemas.openxmlformats.org/drawingml/2006/main">
             <a:defPPr>
-              <a:defRPr sz="1800" b="0">
-                <a:solidFill>
-                  <a:srgbClr val="253F33"/>
-                </a:solidFill>
-                <a:latin typeface="Arial"/>
-                <a:ea typeface="Arial"/>
-                <a:cs typeface="Arial"/>
+              <a:defRPr sz="3450" b="0">
+                <a:solidFill>
+                  <a:srgbClr val="253F33"/>
+                </a:solidFill>
+                <a:latin typeface="Georgia"/>
+                <a:ea typeface="Georgia"/>
+                <a:cs typeface="Georgia"/>
               </a:defRPr>
             </a:defPPr>
           </a:lstStyle>
           <a:p xmlns:a="http://schemas.openxmlformats.org/drawingml/2006/main">
             <a:pPr>
-              <a:defRPr sz="1800" b="0">
-                <a:solidFill>
-                  <a:srgbClr val="253F33"/>
-                </a:solidFill>
-                <a:latin typeface="Arial"/>
-                <a:ea typeface="Arial"/>
-                <a:cs typeface="Arial"/>
-              </a:defRPr>
-            </a:pPr>
-            <a:r>
-              <a:rPr sz="1800" b="0">
-                <a:solidFill>
-                  <a:srgbClr val="253F33"/>
-                </a:solidFill>
-                <a:latin typeface="Arial"/>
-                <a:ea typeface="Arial"/>
-                <a:cs typeface="Arial"/>
-              </a:rPr>
-              <a:t>Set database credentials and an initial admin through environment variables.</a:t>
-            </a:r>
-          </a:p>
-        </p:txBody>
-      </p:sp>
-      <p:sp>
-        <p:nvSpPr>
-          <p:cNvPr id="9" name="">
-            <a:extLst xmlns:a="http://schemas.openxmlformats.org/drawingml/2006/main">
-              <a:ext uri="{FF2B5EF4-FFF2-40B4-BE49-F238E27FC236}">
-                <a16:creationId xmlns:a16="http://schemas.microsoft.com/office/drawing/2014/main" id="{F34D1E2F-C090-4AEA-8D4F-C96D895362D1}"/>
-              </a:ext>
-            </a:extLst>
-          </p:cNvPr>
-          <p:cNvSpPr>
-            <a:spLocks xmlns:a="http://schemas.openxmlformats.org/drawingml/2006/main" noGrp="1"/>
-          </p:cNvSpPr>
-          <p:nvPr/>
-        </p:nvSpPr>
-        <p:spPr>
-          <a:xfrm xmlns:a="http://schemas.openxmlformats.org/drawingml/2006/main">
-            <a:off x="609600" y="3924300"/>
-            <a:ext cx="10668000" cy="361950"/>
+              <a:defRPr sz="3450" b="0">
+                <a:solidFill>
+                  <a:srgbClr val="253F33"/>
+                </a:solidFill>
+                <a:latin typeface="Georgia"/>
+                <a:ea typeface="Georgia"/>
+                <a:cs typeface="Georgia"/>
+              </a:defRPr>
+            </a:pPr>
+            <a:r>
+              <a:rPr sz="3450" b="0">
+                <a:solidFill>
+                  <a:srgbClr val="253F33"/>
+                </a:solidFill>
+                <a:latin typeface="Georgia"/>
+                <a:ea typeface="Georgia"/>
+                <a:cs typeface="Georgia"/>
+              </a:rPr>
+              <a:t>Cloud deployment plan</a:t>
+            </a:r>
+          </a:p>
+        </p:txBody>
+      </p:sp>
+      <p:sp>
+        <p:nvSpPr>
+          <p:cNvPr id="3" name="">
+            <a:extLst xmlns:a="http://schemas.openxmlformats.org/drawingml/2006/main">
+              <a:ext uri="{FF2B5EF4-FFF2-40B4-BE49-F238E27FC236}">
+                <a16:creationId xmlns:a16="http://schemas.microsoft.com/office/drawing/2014/main" id="{4AA8A1E2-6545-4EE2-805E-AF8272B576AD}"/>
+              </a:ext>
+            </a:extLst>
+          </p:cNvPr>
+          <p:cNvSpPr>
+            <a:spLocks xmlns:a="http://schemas.openxmlformats.org/drawingml/2006/main" noGrp="1"/>
+          </p:cNvSpPr>
+          <p:nvPr/>
+        </p:nvSpPr>
+        <p:spPr>
+          <a:xfrm xmlns:a="http://schemas.openxmlformats.org/drawingml/2006/main">
+            <a:off x="609600" y="6457950"/>
+            <a:ext cx="9620250" cy="238125"/>
           </a:xfrm>
           <a:prstGeom xmlns:a="http://schemas.openxmlformats.org/drawingml/2006/main" prst="rect">
             <a:avLst/>
@@ -9205,9 +9643,9 @@
           <a:bodyPr xmlns:a="http://schemas.openxmlformats.org/drawingml/2006/main"/>
           <a:lstStyle xmlns:a="http://schemas.openxmlformats.org/drawingml/2006/main">
             <a:defPPr>
-              <a:defRPr sz="2100" b="1">
-                <a:solidFill>
-                  <a:srgbClr val="AD583D"/>
+              <a:defRPr sz="1200" b="0">
+                <a:solidFill>
+                  <a:srgbClr val="5E695F"/>
                 </a:solidFill>
                 <a:latin typeface="Arial"/>
                 <a:ea typeface="Arial"/>
@@ -9217,47 +9655,47 @@
           </a:lstStyle>
           <a:p xmlns:a="http://schemas.openxmlformats.org/drawingml/2006/main">
             <a:pPr>
-              <a:defRPr sz="2100" b="1">
-                <a:solidFill>
-                  <a:srgbClr val="AD583D"/>
-                </a:solidFill>
-                <a:latin typeface="Arial"/>
-                <a:ea typeface="Arial"/>
-                <a:cs typeface="Arial"/>
-              </a:defRPr>
-            </a:pPr>
-            <a:r>
-              <a:rPr sz="2100" b="1">
-                <a:solidFill>
-                  <a:srgbClr val="AD583D"/>
-                </a:solidFill>
-                <a:latin typeface="Arial"/>
-                <a:ea typeface="Arial"/>
-                <a:cs typeface="Arial"/>
-              </a:rPr>
-              <a:t>Current deployment status</a:t>
-            </a:r>
-          </a:p>
-        </p:txBody>
-      </p:sp>
-      <p:sp>
-        <p:nvSpPr>
-          <p:cNvPr id="10" name="">
-            <a:extLst xmlns:a="http://schemas.openxmlformats.org/drawingml/2006/main">
-              <a:ext uri="{FF2B5EF4-FFF2-40B4-BE49-F238E27FC236}">
-                <a16:creationId xmlns:a16="http://schemas.microsoft.com/office/drawing/2014/main" id="{917D98B9-343D-4E47-AADE-1A98F46CE6E6}"/>
-              </a:ext>
-            </a:extLst>
-          </p:cNvPr>
-          <p:cNvSpPr>
-            <a:spLocks xmlns:a="http://schemas.openxmlformats.org/drawingml/2006/main" noGrp="1"/>
-          </p:cNvSpPr>
-          <p:nvPr/>
-        </p:nvSpPr>
-        <p:spPr>
-          <a:xfrm xmlns:a="http://schemas.openxmlformats.org/drawingml/2006/main">
-            <a:off x="609600" y="4305300"/>
-            <a:ext cx="10668000" cy="723900"/>
+              <a:defRPr sz="1200" b="0">
+                <a:solidFill>
+                  <a:srgbClr val="5E695F"/>
+                </a:solidFill>
+                <a:latin typeface="Arial"/>
+                <a:ea typeface="Arial"/>
+                <a:cs typeface="Arial"/>
+              </a:defRPr>
+            </a:pPr>
+            <a:r>
+              <a:rPr sz="1200" b="0">
+                <a:solidFill>
+                  <a:srgbClr val="5E695F"/>
+                </a:solidFill>
+                <a:latin typeface="Arial"/>
+                <a:ea typeface="Arial"/>
+                <a:cs typeface="Arial"/>
+              </a:rPr>
+              <a:t>QUIZNOVA  /  JAVA PRACTICE STUDIO</a:t>
+            </a:r>
+          </a:p>
+        </p:txBody>
+      </p:sp>
+      <p:sp>
+        <p:nvSpPr>
+          <p:cNvPr id="4" name="">
+            <a:extLst xmlns:a="http://schemas.openxmlformats.org/drawingml/2006/main">
+              <a:ext uri="{FF2B5EF4-FFF2-40B4-BE49-F238E27FC236}">
+                <a16:creationId xmlns:a16="http://schemas.microsoft.com/office/drawing/2014/main" id="{0E0463AD-07F3-4CC0-9CB3-377C64409A6D}"/>
+              </a:ext>
+            </a:extLst>
+          </p:cNvPr>
+          <p:cNvSpPr>
+            <a:spLocks xmlns:a="http://schemas.openxmlformats.org/drawingml/2006/main" noGrp="1"/>
+          </p:cNvSpPr>
+          <p:nvPr/>
+        </p:nvSpPr>
+        <p:spPr>
+          <a:xfrm xmlns:a="http://schemas.openxmlformats.org/drawingml/2006/main">
+            <a:off x="11049000" y="6457950"/>
+            <a:ext cx="523875" cy="238125"/>
           </a:xfrm>
           <a:prstGeom xmlns:a="http://schemas.openxmlformats.org/drawingml/2006/main" prst="rect">
             <a:avLst/>
@@ -9271,9 +9709,9 @@
           <a:bodyPr xmlns:a="http://schemas.openxmlformats.org/drawingml/2006/main"/>
           <a:lstStyle xmlns:a="http://schemas.openxmlformats.org/drawingml/2006/main">
             <a:defPPr>
-              <a:defRPr sz="1800" b="0">
-                <a:solidFill>
-                  <a:srgbClr val="253F33"/>
+              <a:defRPr sz="1200" b="0">
+                <a:solidFill>
+                  <a:srgbClr val="5E695F"/>
                 </a:solidFill>
                 <a:latin typeface="Arial"/>
                 <a:ea typeface="Arial"/>
@@ -9283,47 +9721,47 @@
           </a:lstStyle>
           <a:p xmlns:a="http://schemas.openxmlformats.org/drawingml/2006/main">
             <a:pPr>
-              <a:defRPr sz="1800" b="0">
-                <a:solidFill>
-                  <a:srgbClr val="253F33"/>
-                </a:solidFill>
-                <a:latin typeface="Arial"/>
-                <a:ea typeface="Arial"/>
-                <a:cs typeface="Arial"/>
-              </a:defRPr>
-            </a:pPr>
-            <a:r>
-              <a:rPr sz="1800" b="0">
-                <a:solidFill>
-                  <a:srgbClr val="253F33"/>
-                </a:solidFill>
-                <a:latin typeface="Arial"/>
-                <a:ea typeface="Arial"/>
-                <a:cs typeface="Arial"/>
-              </a:rPr>
-              <a:t>Configuration is ready; provider setup and a live deployment are pending.</a:t>
-            </a:r>
-          </a:p>
-        </p:txBody>
-      </p:sp>
-      <p:sp>
-        <p:nvSpPr>
-          <p:cNvPr id="11" name="">
-            <a:extLst xmlns:a="http://schemas.openxmlformats.org/drawingml/2006/main">
-              <a:ext uri="{FF2B5EF4-FFF2-40B4-BE49-F238E27FC236}">
-                <a16:creationId xmlns:a16="http://schemas.microsoft.com/office/drawing/2014/main" id="{69B2886F-3624-4270-B0B1-985BDDD1414D}"/>
-              </a:ext>
-            </a:extLst>
-          </p:cNvPr>
-          <p:cNvSpPr>
-            <a:spLocks xmlns:a="http://schemas.openxmlformats.org/drawingml/2006/main" noGrp="1"/>
-          </p:cNvSpPr>
-          <p:nvPr/>
-        </p:nvSpPr>
-        <p:spPr>
-          <a:xfrm xmlns:a="http://schemas.openxmlformats.org/drawingml/2006/main">
-            <a:off x="609600" y="5410200"/>
-            <a:ext cx="10477500" cy="457200"/>
+              <a:defRPr sz="1200" b="0">
+                <a:solidFill>
+                  <a:srgbClr val="5E695F"/>
+                </a:solidFill>
+                <a:latin typeface="Arial"/>
+                <a:ea typeface="Arial"/>
+                <a:cs typeface="Arial"/>
+              </a:defRPr>
+            </a:pPr>
+            <a:r>
+              <a:rPr sz="1200" b="0">
+                <a:solidFill>
+                  <a:srgbClr val="5E695F"/>
+                </a:solidFill>
+                <a:latin typeface="Arial"/>
+                <a:ea typeface="Arial"/>
+                <a:cs typeface="Arial"/>
+              </a:rPr>
+              <a:t>17</a:t>
+            </a:r>
+          </a:p>
+        </p:txBody>
+      </p:sp>
+      <p:sp>
+        <p:nvSpPr>
+          <p:cNvPr id="5" name="">
+            <a:extLst xmlns:a="http://schemas.openxmlformats.org/drawingml/2006/main">
+              <a:ext uri="{FF2B5EF4-FFF2-40B4-BE49-F238E27FC236}">
+                <a16:creationId xmlns:a16="http://schemas.microsoft.com/office/drawing/2014/main" id="{0CF1CDC6-FFC0-494E-8EE4-2C2F66D4A805}"/>
+              </a:ext>
+            </a:extLst>
+          </p:cNvPr>
+          <p:cNvSpPr>
+            <a:spLocks xmlns:a="http://schemas.openxmlformats.org/drawingml/2006/main" noGrp="1"/>
+          </p:cNvSpPr>
+          <p:nvPr/>
+        </p:nvSpPr>
+        <p:spPr>
+          <a:xfrm xmlns:a="http://schemas.openxmlformats.org/drawingml/2006/main">
+            <a:off x="609600" y="1714500"/>
+            <a:ext cx="10668000" cy="361950"/>
           </a:xfrm>
           <a:prstGeom xmlns:a="http://schemas.openxmlformats.org/drawingml/2006/main" prst="rect">
             <a:avLst/>
@@ -9367,6 +9805,402 @@
                 <a:ea typeface="Arial"/>
                 <a:cs typeface="Arial"/>
               </a:rPr>
+              <a:t>Render web service + Neon PostgreSQL</a:t>
+            </a:r>
+          </a:p>
+        </p:txBody>
+      </p:sp>
+      <p:sp>
+        <p:nvSpPr>
+          <p:cNvPr id="6" name="">
+            <a:extLst xmlns:a="http://schemas.openxmlformats.org/drawingml/2006/main">
+              <a:ext uri="{FF2B5EF4-FFF2-40B4-BE49-F238E27FC236}">
+                <a16:creationId xmlns:a16="http://schemas.microsoft.com/office/drawing/2014/main" id="{02FB5EEF-33A2-4DE7-9AA2-A97B05A02C8B}"/>
+              </a:ext>
+            </a:extLst>
+          </p:cNvPr>
+          <p:cNvSpPr>
+            <a:spLocks xmlns:a="http://schemas.openxmlformats.org/drawingml/2006/main" noGrp="1"/>
+          </p:cNvSpPr>
+          <p:nvPr/>
+        </p:nvSpPr>
+        <p:spPr>
+          <a:xfrm xmlns:a="http://schemas.openxmlformats.org/drawingml/2006/main">
+            <a:off x="609600" y="2095500"/>
+            <a:ext cx="10668000" cy="723900"/>
+          </a:xfrm>
+          <a:prstGeom xmlns:a="http://schemas.openxmlformats.org/drawingml/2006/main" prst="rect">
+            <a:avLst/>
+          </a:prstGeom>
+          <a:noFill xmlns:a="http://schemas.openxmlformats.org/drawingml/2006/main"/>
+          <a:ln xmlns:a="http://schemas.openxmlformats.org/drawingml/2006/main" w="0">
+            <a:noFill/>
+          </a:ln>
+        </p:spPr>
+        <p:txBody>
+          <a:bodyPr xmlns:a="http://schemas.openxmlformats.org/drawingml/2006/main"/>
+          <a:lstStyle xmlns:a="http://schemas.openxmlformats.org/drawingml/2006/main">
+            <a:defPPr>
+              <a:defRPr sz="1800" b="0">
+                <a:solidFill>
+                  <a:srgbClr val="253F33"/>
+                </a:solidFill>
+                <a:latin typeface="Arial"/>
+                <a:ea typeface="Arial"/>
+                <a:cs typeface="Arial"/>
+              </a:defRPr>
+            </a:defPPr>
+          </a:lstStyle>
+          <a:p xmlns:a="http://schemas.openxmlformats.org/drawingml/2006/main">
+            <a:pPr>
+              <a:defRPr sz="1800" b="0">
+                <a:solidFill>
+                  <a:srgbClr val="253F33"/>
+                </a:solidFill>
+                <a:latin typeface="Arial"/>
+                <a:ea typeface="Arial"/>
+                <a:cs typeface="Arial"/>
+              </a:defRPr>
+            </a:pPr>
+            <a:r>
+              <a:rPr sz="1800" b="0">
+                <a:solidFill>
+                  <a:srgbClr val="253F33"/>
+                </a:solidFill>
+                <a:latin typeface="Arial"/>
+                <a:ea typeface="Arial"/>
+                <a:cs typeface="Arial"/>
+              </a:rPr>
+              <a:t>Dockerfile, render.yaml and a PostgreSQL cloud profile are included.</a:t>
+            </a:r>
+          </a:p>
+        </p:txBody>
+      </p:sp>
+      <p:sp>
+        <p:nvSpPr>
+          <p:cNvPr id="7" name="">
+            <a:extLst xmlns:a="http://schemas.openxmlformats.org/drawingml/2006/main">
+              <a:ext uri="{FF2B5EF4-FFF2-40B4-BE49-F238E27FC236}">
+                <a16:creationId xmlns:a16="http://schemas.microsoft.com/office/drawing/2014/main" id="{2F067613-5BCA-4D11-ACEF-767BDC76D73C}"/>
+              </a:ext>
+            </a:extLst>
+          </p:cNvPr>
+          <p:cNvSpPr>
+            <a:spLocks xmlns:a="http://schemas.openxmlformats.org/drawingml/2006/main" noGrp="1"/>
+          </p:cNvSpPr>
+          <p:nvPr/>
+        </p:nvSpPr>
+        <p:spPr>
+          <a:xfrm xmlns:a="http://schemas.openxmlformats.org/drawingml/2006/main">
+            <a:off x="609600" y="2819400"/>
+            <a:ext cx="10668000" cy="361950"/>
+          </a:xfrm>
+          <a:prstGeom xmlns:a="http://schemas.openxmlformats.org/drawingml/2006/main" prst="rect">
+            <a:avLst/>
+          </a:prstGeom>
+          <a:noFill xmlns:a="http://schemas.openxmlformats.org/drawingml/2006/main"/>
+          <a:ln xmlns:a="http://schemas.openxmlformats.org/drawingml/2006/main" w="0">
+            <a:noFill/>
+          </a:ln>
+        </p:spPr>
+        <p:txBody>
+          <a:bodyPr xmlns:a="http://schemas.openxmlformats.org/drawingml/2006/main"/>
+          <a:lstStyle xmlns:a="http://schemas.openxmlformats.org/drawingml/2006/main">
+            <a:defPPr>
+              <a:defRPr sz="2100" b="1">
+                <a:solidFill>
+                  <a:srgbClr val="AD583D"/>
+                </a:solidFill>
+                <a:latin typeface="Arial"/>
+                <a:ea typeface="Arial"/>
+                <a:cs typeface="Arial"/>
+              </a:defRPr>
+            </a:defPPr>
+          </a:lstStyle>
+          <a:p xmlns:a="http://schemas.openxmlformats.org/drawingml/2006/main">
+            <a:pPr>
+              <a:defRPr sz="2100" b="1">
+                <a:solidFill>
+                  <a:srgbClr val="AD583D"/>
+                </a:solidFill>
+                <a:latin typeface="Arial"/>
+                <a:ea typeface="Arial"/>
+                <a:cs typeface="Arial"/>
+              </a:defRPr>
+            </a:pPr>
+            <a:r>
+              <a:rPr sz="2100" b="1">
+                <a:solidFill>
+                  <a:srgbClr val="AD583D"/>
+                </a:solidFill>
+                <a:latin typeface="Arial"/>
+                <a:ea typeface="Arial"/>
+                <a:cs typeface="Arial"/>
+              </a:rPr>
+              <a:t>Private deployment configuration</a:t>
+            </a:r>
+          </a:p>
+        </p:txBody>
+      </p:sp>
+      <p:sp>
+        <p:nvSpPr>
+          <p:cNvPr id="8" name="">
+            <a:extLst xmlns:a="http://schemas.openxmlformats.org/drawingml/2006/main">
+              <a:ext uri="{FF2B5EF4-FFF2-40B4-BE49-F238E27FC236}">
+                <a16:creationId xmlns:a16="http://schemas.microsoft.com/office/drawing/2014/main" id="{5BCF72E0-C10D-4502-8CAF-158B08ED196A}"/>
+              </a:ext>
+            </a:extLst>
+          </p:cNvPr>
+          <p:cNvSpPr>
+            <a:spLocks xmlns:a="http://schemas.openxmlformats.org/drawingml/2006/main" noGrp="1"/>
+          </p:cNvSpPr>
+          <p:nvPr/>
+        </p:nvSpPr>
+        <p:spPr>
+          <a:xfrm xmlns:a="http://schemas.openxmlformats.org/drawingml/2006/main">
+            <a:off x="609600" y="3200400"/>
+            <a:ext cx="10668000" cy="723900"/>
+          </a:xfrm>
+          <a:prstGeom xmlns:a="http://schemas.openxmlformats.org/drawingml/2006/main" prst="rect">
+            <a:avLst/>
+          </a:prstGeom>
+          <a:noFill xmlns:a="http://schemas.openxmlformats.org/drawingml/2006/main"/>
+          <a:ln xmlns:a="http://schemas.openxmlformats.org/drawingml/2006/main" w="0">
+            <a:noFill/>
+          </a:ln>
+        </p:spPr>
+        <p:txBody>
+          <a:bodyPr xmlns:a="http://schemas.openxmlformats.org/drawingml/2006/main"/>
+          <a:lstStyle xmlns:a="http://schemas.openxmlformats.org/drawingml/2006/main">
+            <a:defPPr>
+              <a:defRPr sz="1800" b="0">
+                <a:solidFill>
+                  <a:srgbClr val="253F33"/>
+                </a:solidFill>
+                <a:latin typeface="Arial"/>
+                <a:ea typeface="Arial"/>
+                <a:cs typeface="Arial"/>
+              </a:defRPr>
+            </a:defPPr>
+          </a:lstStyle>
+          <a:p xmlns:a="http://schemas.openxmlformats.org/drawingml/2006/main">
+            <a:pPr>
+              <a:defRPr sz="1800" b="0">
+                <a:solidFill>
+                  <a:srgbClr val="253F33"/>
+                </a:solidFill>
+                <a:latin typeface="Arial"/>
+                <a:ea typeface="Arial"/>
+                <a:cs typeface="Arial"/>
+              </a:defRPr>
+            </a:pPr>
+            <a:r>
+              <a:rPr sz="1800" b="0">
+                <a:solidFill>
+                  <a:srgbClr val="253F33"/>
+                </a:solidFill>
+                <a:latin typeface="Arial"/>
+                <a:ea typeface="Arial"/>
+                <a:cs typeface="Arial"/>
+              </a:rPr>
+              <a:t>Set database credentials and an initial admin through environment variables.</a:t>
+            </a:r>
+          </a:p>
+        </p:txBody>
+      </p:sp>
+      <p:sp>
+        <p:nvSpPr>
+          <p:cNvPr id="9" name="">
+            <a:extLst xmlns:a="http://schemas.openxmlformats.org/drawingml/2006/main">
+              <a:ext uri="{FF2B5EF4-FFF2-40B4-BE49-F238E27FC236}">
+                <a16:creationId xmlns:a16="http://schemas.microsoft.com/office/drawing/2014/main" id="{DE1CEB6D-7434-4CC7-B084-97A82CBA008B}"/>
+              </a:ext>
+            </a:extLst>
+          </p:cNvPr>
+          <p:cNvSpPr>
+            <a:spLocks xmlns:a="http://schemas.openxmlformats.org/drawingml/2006/main" noGrp="1"/>
+          </p:cNvSpPr>
+          <p:nvPr/>
+        </p:nvSpPr>
+        <p:spPr>
+          <a:xfrm xmlns:a="http://schemas.openxmlformats.org/drawingml/2006/main">
+            <a:off x="609600" y="3924300"/>
+            <a:ext cx="10668000" cy="361950"/>
+          </a:xfrm>
+          <a:prstGeom xmlns:a="http://schemas.openxmlformats.org/drawingml/2006/main" prst="rect">
+            <a:avLst/>
+          </a:prstGeom>
+          <a:noFill xmlns:a="http://schemas.openxmlformats.org/drawingml/2006/main"/>
+          <a:ln xmlns:a="http://schemas.openxmlformats.org/drawingml/2006/main" w="0">
+            <a:noFill/>
+          </a:ln>
+        </p:spPr>
+        <p:txBody>
+          <a:bodyPr xmlns:a="http://schemas.openxmlformats.org/drawingml/2006/main"/>
+          <a:lstStyle xmlns:a="http://schemas.openxmlformats.org/drawingml/2006/main">
+            <a:defPPr>
+              <a:defRPr sz="2100" b="1">
+                <a:solidFill>
+                  <a:srgbClr val="AD583D"/>
+                </a:solidFill>
+                <a:latin typeface="Arial"/>
+                <a:ea typeface="Arial"/>
+                <a:cs typeface="Arial"/>
+              </a:defRPr>
+            </a:defPPr>
+          </a:lstStyle>
+          <a:p xmlns:a="http://schemas.openxmlformats.org/drawingml/2006/main">
+            <a:pPr>
+              <a:defRPr sz="2100" b="1">
+                <a:solidFill>
+                  <a:srgbClr val="AD583D"/>
+                </a:solidFill>
+                <a:latin typeface="Arial"/>
+                <a:ea typeface="Arial"/>
+                <a:cs typeface="Arial"/>
+              </a:defRPr>
+            </a:pPr>
+            <a:r>
+              <a:rPr sz="2100" b="1">
+                <a:solidFill>
+                  <a:srgbClr val="AD583D"/>
+                </a:solidFill>
+                <a:latin typeface="Arial"/>
+                <a:ea typeface="Arial"/>
+                <a:cs typeface="Arial"/>
+              </a:rPr>
+              <a:t>Current deployment status</a:t>
+            </a:r>
+          </a:p>
+        </p:txBody>
+      </p:sp>
+      <p:sp>
+        <p:nvSpPr>
+          <p:cNvPr id="10" name="">
+            <a:extLst xmlns:a="http://schemas.openxmlformats.org/drawingml/2006/main">
+              <a:ext uri="{FF2B5EF4-FFF2-40B4-BE49-F238E27FC236}">
+                <a16:creationId xmlns:a16="http://schemas.microsoft.com/office/drawing/2014/main" id="{35B0EFEF-4EDE-40A2-8968-0F03FE1C3AA5}"/>
+              </a:ext>
+            </a:extLst>
+          </p:cNvPr>
+          <p:cNvSpPr>
+            <a:spLocks xmlns:a="http://schemas.openxmlformats.org/drawingml/2006/main" noGrp="1"/>
+          </p:cNvSpPr>
+          <p:nvPr/>
+        </p:nvSpPr>
+        <p:spPr>
+          <a:xfrm xmlns:a="http://schemas.openxmlformats.org/drawingml/2006/main">
+            <a:off x="609600" y="4305300"/>
+            <a:ext cx="10668000" cy="723900"/>
+          </a:xfrm>
+          <a:prstGeom xmlns:a="http://schemas.openxmlformats.org/drawingml/2006/main" prst="rect">
+            <a:avLst/>
+          </a:prstGeom>
+          <a:noFill xmlns:a="http://schemas.openxmlformats.org/drawingml/2006/main"/>
+          <a:ln xmlns:a="http://schemas.openxmlformats.org/drawingml/2006/main" w="0">
+            <a:noFill/>
+          </a:ln>
+        </p:spPr>
+        <p:txBody>
+          <a:bodyPr xmlns:a="http://schemas.openxmlformats.org/drawingml/2006/main"/>
+          <a:lstStyle xmlns:a="http://schemas.openxmlformats.org/drawingml/2006/main">
+            <a:defPPr>
+              <a:defRPr sz="1800" b="0">
+                <a:solidFill>
+                  <a:srgbClr val="253F33"/>
+                </a:solidFill>
+                <a:latin typeface="Arial"/>
+                <a:ea typeface="Arial"/>
+                <a:cs typeface="Arial"/>
+              </a:defRPr>
+            </a:defPPr>
+          </a:lstStyle>
+          <a:p xmlns:a="http://schemas.openxmlformats.org/drawingml/2006/main">
+            <a:pPr>
+              <a:defRPr sz="1800" b="0">
+                <a:solidFill>
+                  <a:srgbClr val="253F33"/>
+                </a:solidFill>
+                <a:latin typeface="Arial"/>
+                <a:ea typeface="Arial"/>
+                <a:cs typeface="Arial"/>
+              </a:defRPr>
+            </a:pPr>
+            <a:r>
+              <a:rPr sz="1800" b="0">
+                <a:solidFill>
+                  <a:srgbClr val="253F33"/>
+                </a:solidFill>
+                <a:latin typeface="Arial"/>
+                <a:ea typeface="Arial"/>
+                <a:cs typeface="Arial"/>
+              </a:rPr>
+              <a:t>Configuration is ready; provider setup and a live deployment are pending.</a:t>
+            </a:r>
+          </a:p>
+        </p:txBody>
+      </p:sp>
+      <p:sp>
+        <p:nvSpPr>
+          <p:cNvPr id="11" name="">
+            <a:extLst xmlns:a="http://schemas.openxmlformats.org/drawingml/2006/main">
+              <a:ext uri="{FF2B5EF4-FFF2-40B4-BE49-F238E27FC236}">
+                <a16:creationId xmlns:a16="http://schemas.microsoft.com/office/drawing/2014/main" id="{55C66EE7-D273-4E6B-8A3D-3C80E81DEEA2}"/>
+              </a:ext>
+            </a:extLst>
+          </p:cNvPr>
+          <p:cNvSpPr>
+            <a:spLocks xmlns:a="http://schemas.openxmlformats.org/drawingml/2006/main" noGrp="1"/>
+          </p:cNvSpPr>
+          <p:nvPr/>
+        </p:nvSpPr>
+        <p:spPr>
+          <a:xfrm xmlns:a="http://schemas.openxmlformats.org/drawingml/2006/main">
+            <a:off x="609600" y="5410200"/>
+            <a:ext cx="10477500" cy="457200"/>
+          </a:xfrm>
+          <a:prstGeom xmlns:a="http://schemas.openxmlformats.org/drawingml/2006/main" prst="rect">
+            <a:avLst/>
+          </a:prstGeom>
+          <a:noFill xmlns:a="http://schemas.openxmlformats.org/drawingml/2006/main"/>
+          <a:ln xmlns:a="http://schemas.openxmlformats.org/drawingml/2006/main" w="0">
+            <a:noFill/>
+          </a:ln>
+        </p:spPr>
+        <p:txBody>
+          <a:bodyPr xmlns:a="http://schemas.openxmlformats.org/drawingml/2006/main"/>
+          <a:lstStyle xmlns:a="http://schemas.openxmlformats.org/drawingml/2006/main">
+            <a:defPPr>
+              <a:defRPr sz="2100" b="1">
+                <a:solidFill>
+                  <a:srgbClr val="AD583D"/>
+                </a:solidFill>
+                <a:latin typeface="Arial"/>
+                <a:ea typeface="Arial"/>
+                <a:cs typeface="Arial"/>
+              </a:defRPr>
+            </a:defPPr>
+          </a:lstStyle>
+          <a:p xmlns:a="http://schemas.openxmlformats.org/drawingml/2006/main">
+            <a:pPr>
+              <a:defRPr sz="2100" b="1">
+                <a:solidFill>
+                  <a:srgbClr val="AD583D"/>
+                </a:solidFill>
+                <a:latin typeface="Arial"/>
+                <a:ea typeface="Arial"/>
+                <a:cs typeface="Arial"/>
+              </a:defRPr>
+            </a:pPr>
+            <a:r>
+              <a:rPr sz="2100" b="1">
+                <a:solidFill>
+                  <a:srgbClr val="AD583D"/>
+                </a:solidFill>
+                <a:latin typeface="Arial"/>
+                <a:ea typeface="Arial"/>
+                <a:cs typeface="Arial"/>
+              </a:rPr>
               <a:t>Live URL:</a:t>
             </a:r>
           </a:p>
@@ -9375,7 +10209,7 @@
     </p:spTree>
     <p:extLst>
       <p:ext uri="{BB962C8B-B14F-4D97-AF65-F5344CB8AC3E}">
-        <p14:creationId xmlns:p14="http://schemas.microsoft.com/office/powerpoint/2010/main" val="338423377"/>
+        <p14:creationId xmlns:p14="http://schemas.microsoft.com/office/powerpoint/2010/main" val="272259728"/>
       </p:ext>
     </p:extLst>
   </p:cSld>
@@ -9406,7 +10240,7 @@
           <p:cNvPr id="12" name="">
             <a:extLst xmlns:a="http://schemas.openxmlformats.org/drawingml/2006/main">
               <a:ext uri="{FF2B5EF4-FFF2-40B4-BE49-F238E27FC236}">
-                <a16:creationId xmlns:a16="http://schemas.microsoft.com/office/drawing/2014/main" id="{2CDCB4D9-E747-4152-8331-D50DE66E5DF3}"/>
+                <a16:creationId xmlns:a16="http://schemas.microsoft.com/office/drawing/2014/main" id="{3F47EDBD-62AB-412A-8870-7D7D2D9FBF3F}"/>
               </a:ext>
             </a:extLst>
           </p:cNvPr>
@@ -9472,7 +10306,7 @@
           <p:cNvPr id="2" name="">
             <a:extLst xmlns:a="http://schemas.openxmlformats.org/drawingml/2006/main">
               <a:ext uri="{FF2B5EF4-FFF2-40B4-BE49-F238E27FC236}">
-                <a16:creationId xmlns:a16="http://schemas.microsoft.com/office/drawing/2014/main" id="{00FA1011-462C-4D25-B000-5619AB0DBBF8}"/>
+                <a16:creationId xmlns:a16="http://schemas.microsoft.com/office/drawing/2014/main" id="{F939950D-8136-40C0-9FDE-96C63EFE0868}"/>
               </a:ext>
             </a:extLst>
           </p:cNvPr>
@@ -9538,7 +10372,7 @@
           <p:cNvPr id="3" name="">
             <a:extLst xmlns:a="http://schemas.openxmlformats.org/drawingml/2006/main">
               <a:ext uri="{FF2B5EF4-FFF2-40B4-BE49-F238E27FC236}">
-                <a16:creationId xmlns:a16="http://schemas.microsoft.com/office/drawing/2014/main" id="{F56EBCC2-1227-4860-816C-242988F47A00}"/>
+                <a16:creationId xmlns:a16="http://schemas.microsoft.com/office/drawing/2014/main" id="{822B5EF6-2960-4682-B8C4-74D4EC986F47}"/>
               </a:ext>
             </a:extLst>
           </p:cNvPr>
@@ -9604,7 +10438,7 @@
           <p:cNvPr id="4" name="">
             <a:extLst xmlns:a="http://schemas.openxmlformats.org/drawingml/2006/main">
               <a:ext uri="{FF2B5EF4-FFF2-40B4-BE49-F238E27FC236}">
-                <a16:creationId xmlns:a16="http://schemas.microsoft.com/office/drawing/2014/main" id="{075803ED-2E2A-4058-9983-3EA4CA2600E0}"/>
+                <a16:creationId xmlns:a16="http://schemas.microsoft.com/office/drawing/2014/main" id="{709E6F6D-EDAF-4B25-B537-8DFE31202E8A}"/>
               </a:ext>
             </a:extLst>
           </p:cNvPr>
@@ -9670,7 +10504,7 @@
           <p:cNvPr id="5" name="">
             <a:extLst xmlns:a="http://schemas.openxmlformats.org/drawingml/2006/main">
               <a:ext uri="{FF2B5EF4-FFF2-40B4-BE49-F238E27FC236}">
-                <a16:creationId xmlns:a16="http://schemas.microsoft.com/office/drawing/2014/main" id="{7CDC6965-58D0-4588-8540-C5581D5F2956}"/>
+                <a16:creationId xmlns:a16="http://schemas.microsoft.com/office/drawing/2014/main" id="{B27B707D-E8E6-41D6-93AE-B129FBBE2593}"/>
               </a:ext>
             </a:extLst>
           </p:cNvPr>
@@ -9736,7 +10570,7 @@
           <p:cNvPr id="6" name="">
             <a:extLst xmlns:a="http://schemas.openxmlformats.org/drawingml/2006/main">
               <a:ext uri="{FF2B5EF4-FFF2-40B4-BE49-F238E27FC236}">
-                <a16:creationId xmlns:a16="http://schemas.microsoft.com/office/drawing/2014/main" id="{79339BBD-F7CD-47A4-9A79-E6B0FEF501DF}"/>
+                <a16:creationId xmlns:a16="http://schemas.microsoft.com/office/drawing/2014/main" id="{DBDB057B-61B4-4CAE-B260-F4D058DB4043}"/>
               </a:ext>
             </a:extLst>
           </p:cNvPr>
@@ -9802,7 +10636,7 @@
           <p:cNvPr id="7" name="">
             <a:extLst xmlns:a="http://schemas.openxmlformats.org/drawingml/2006/main">
               <a:ext uri="{FF2B5EF4-FFF2-40B4-BE49-F238E27FC236}">
-                <a16:creationId xmlns:a16="http://schemas.microsoft.com/office/drawing/2014/main" id="{0081F2F3-0FB7-4AA7-9F4F-1ECDB51F49E5}"/>
+                <a16:creationId xmlns:a16="http://schemas.microsoft.com/office/drawing/2014/main" id="{7ACB29D9-414A-4B30-817D-2B74EC2DAFAB}"/>
               </a:ext>
             </a:extLst>
           </p:cNvPr>
@@ -9868,7 +10702,7 @@
           <p:cNvPr id="8" name="">
             <a:extLst xmlns:a="http://schemas.openxmlformats.org/drawingml/2006/main">
               <a:ext uri="{FF2B5EF4-FFF2-40B4-BE49-F238E27FC236}">
-                <a16:creationId xmlns:a16="http://schemas.microsoft.com/office/drawing/2014/main" id="{B83549EA-B1F8-4B6B-9231-FC9B579F8E05}"/>
+                <a16:creationId xmlns:a16="http://schemas.microsoft.com/office/drawing/2014/main" id="{AD0590D6-416A-414E-B4CC-CBC2B27640E3}"/>
               </a:ext>
             </a:extLst>
           </p:cNvPr>
@@ -9934,7 +10768,7 @@
           <p:cNvPr id="9" name="">
             <a:extLst xmlns:a="http://schemas.openxmlformats.org/drawingml/2006/main">
               <a:ext uri="{FF2B5EF4-FFF2-40B4-BE49-F238E27FC236}">
-                <a16:creationId xmlns:a16="http://schemas.microsoft.com/office/drawing/2014/main" id="{6D59AFC2-04B5-485D-8F71-8726A06E8AB7}"/>
+                <a16:creationId xmlns:a16="http://schemas.microsoft.com/office/drawing/2014/main" id="{71347DBD-DCB6-4D69-839C-F23BA1C6DD75}"/>
               </a:ext>
             </a:extLst>
           </p:cNvPr>
@@ -10000,7 +10834,7 @@
           <p:cNvPr id="10" name="">
             <a:extLst xmlns:a="http://schemas.openxmlformats.org/drawingml/2006/main">
               <a:ext uri="{FF2B5EF4-FFF2-40B4-BE49-F238E27FC236}">
-                <a16:creationId xmlns:a16="http://schemas.microsoft.com/office/drawing/2014/main" id="{B14B4B6E-E290-4F3E-A0CE-EB6BDBAD49BA}"/>
+                <a16:creationId xmlns:a16="http://schemas.microsoft.com/office/drawing/2014/main" id="{B4CBE94B-B12B-4545-8CD3-0D5EE401FA3B}"/>
               </a:ext>
             </a:extLst>
           </p:cNvPr>
@@ -10066,7 +10900,7 @@
           <p:cNvPr id="11" name="">
             <a:extLst xmlns:a="http://schemas.openxmlformats.org/drawingml/2006/main">
               <a:ext uri="{FF2B5EF4-FFF2-40B4-BE49-F238E27FC236}">
-                <a16:creationId xmlns:a16="http://schemas.microsoft.com/office/drawing/2014/main" id="{9416193F-1554-4812-A35E-B5B12B4F69EC}"/>
+                <a16:creationId xmlns:a16="http://schemas.microsoft.com/office/drawing/2014/main" id="{4489CA5A-90CD-4524-8EC7-2E0EE300BA2B}"/>
               </a:ext>
             </a:extLst>
           </p:cNvPr>
@@ -10130,7 +10964,7 @@
     </p:spTree>
     <p:extLst>
       <p:ext uri="{BB962C8B-B14F-4D97-AF65-F5344CB8AC3E}">
-        <p14:creationId xmlns:p14="http://schemas.microsoft.com/office/powerpoint/2010/main" val="449520069"/>
+        <p14:creationId xmlns:p14="http://schemas.microsoft.com/office/powerpoint/2010/main" val="1687105784"/>
       </p:ext>
     </p:extLst>
   </p:cSld>
@@ -10161,7 +10995,7 @@
           <p:cNvPr id="16" name="">
             <a:extLst xmlns:a="http://schemas.openxmlformats.org/drawingml/2006/main">
               <a:ext uri="{FF2B5EF4-FFF2-40B4-BE49-F238E27FC236}">
-                <a16:creationId xmlns:a16="http://schemas.microsoft.com/office/drawing/2014/main" id="{084ACA76-707F-4736-B371-4777655A3620}"/>
+                <a16:creationId xmlns:a16="http://schemas.microsoft.com/office/drawing/2014/main" id="{19701E96-7C63-4A11-9F0D-7DA94D7ECE7C}"/>
               </a:ext>
             </a:extLst>
           </p:cNvPr>
@@ -10173,8 +11007,8 @@
         </p:nvCxnSpPr>
         <p:spPr>
           <a:xfrm xmlns:a="http://schemas.openxmlformats.org/drawingml/2006/main">
-            <a:off x="5467350" y="5095875"/>
-            <a:ext cx="723900" cy="0"/>
+            <a:off x="5372100" y="5143500"/>
+            <a:ext cx="1447800" cy="0"/>
           </a:xfrm>
           <a:prstGeom xmlns:a="http://schemas.openxmlformats.org/drawingml/2006/main" prst="straightConnector1">
             <a:avLst/>
@@ -10183,7 +11017,7 @@
             <a:solidFill>
               <a:srgbClr val="5E695F"/>
             </a:solidFill>
-            <a:headEnd type="arrow" w="med" len="med"/>
+            <a:tailEnd type="arrow" w="med" len="med"/>
           </a:ln>
         </p:spPr>
       </p:cxnSp>
@@ -10192,20 +11026,20 @@
           <p:cNvPr id="15" name="">
             <a:extLst xmlns:a="http://schemas.openxmlformats.org/drawingml/2006/main">
               <a:ext uri="{FF2B5EF4-FFF2-40B4-BE49-F238E27FC236}">
-                <a16:creationId xmlns:a16="http://schemas.microsoft.com/office/drawing/2014/main" id="{0FE00CE2-B095-4B1D-8DE0-DE28C029668B}"/>
+                <a16:creationId xmlns:a16="http://schemas.microsoft.com/office/drawing/2014/main" id="{32239288-4B83-4065-A0C2-42E1B532C130}"/>
               </a:ext>
             </a:extLst>
           </p:cNvPr>
           <p:cNvCxnSpPr>
-            <a:stCxn xmlns:a="http://schemas.openxmlformats.org/drawingml/2006/main" id="8" idx="2"/>
+            <a:stCxn xmlns:a="http://schemas.openxmlformats.org/drawingml/2006/main" id="8" idx="1"/>
             <a:endCxn xmlns:a="http://schemas.openxmlformats.org/drawingml/2006/main" id="9" idx="3"/>
           </p:cNvCxnSpPr>
           <p:nvPr/>
         </p:nvCxnSpPr>
         <p:spPr>
           <a:xfrm xmlns:a="http://schemas.openxmlformats.org/drawingml/2006/main" flipH="1">
-            <a:off x="5467350" y="3971925"/>
-            <a:ext cx="3319463" cy="1123950"/>
+            <a:off x="5372100" y="3619500"/>
+            <a:ext cx="1447800" cy="1524000"/>
           </a:xfrm>
           <a:prstGeom xmlns:a="http://schemas.openxmlformats.org/drawingml/2006/main" prst="straightConnector1">
             <a:avLst/>
@@ -10214,7 +11048,7 @@
             <a:solidFill>
               <a:srgbClr val="5E695F"/>
             </a:solidFill>
-            <a:headEnd type="arrow" w="med" len="med"/>
+            <a:tailEnd type="arrow" w="med" len="med"/>
           </a:ln>
         </p:spPr>
       </p:cxnSp>
@@ -10223,20 +11057,20 @@
           <p:cNvPr id="14" name="">
             <a:extLst xmlns:a="http://schemas.openxmlformats.org/drawingml/2006/main">
               <a:ext uri="{FF2B5EF4-FFF2-40B4-BE49-F238E27FC236}">
-                <a16:creationId xmlns:a16="http://schemas.microsoft.com/office/drawing/2014/main" id="{135DB7E3-5A0D-4C50-BF4A-9D39F5829F84}"/>
+                <a16:creationId xmlns:a16="http://schemas.microsoft.com/office/drawing/2014/main" id="{B36155F0-2135-41D5-A4F5-226582A40F56}"/>
               </a:ext>
             </a:extLst>
           </p:cNvPr>
           <p:cNvCxnSpPr>
             <a:stCxn xmlns:a="http://schemas.openxmlformats.org/drawingml/2006/main" id="7" idx="2"/>
-            <a:endCxn xmlns:a="http://schemas.openxmlformats.org/drawingml/2006/main" id="9" idx="3"/>
+            <a:endCxn xmlns:a="http://schemas.openxmlformats.org/drawingml/2006/main" id="9" idx="0"/>
           </p:cNvCxnSpPr>
           <p:nvPr/>
         </p:nvCxnSpPr>
         <p:spPr>
-          <a:xfrm xmlns:a="http://schemas.openxmlformats.org/drawingml/2006/main" flipH="1">
-            <a:off x="5467350" y="2638425"/>
-            <a:ext cx="3319463" cy="2457450"/>
+          <a:xfrm xmlns:a="http://schemas.openxmlformats.org/drawingml/2006/main">
+            <a:off x="2990850" y="4000500"/>
+            <a:ext cx="0" cy="714375"/>
           </a:xfrm>
           <a:prstGeom xmlns:a="http://schemas.openxmlformats.org/drawingml/2006/main" prst="straightConnector1">
             <a:avLst/>
@@ -10245,7 +11079,7 @@
             <a:solidFill>
               <a:srgbClr val="5E695F"/>
             </a:solidFill>
-            <a:headEnd type="arrow" w="med" len="med"/>
+            <a:tailEnd type="arrow" w="med" len="med"/>
           </a:ln>
         </p:spPr>
       </p:cxnSp>
@@ -10254,20 +11088,20 @@
           <p:cNvPr id="13" name="">
             <a:extLst xmlns:a="http://schemas.openxmlformats.org/drawingml/2006/main">
               <a:ext uri="{FF2B5EF4-FFF2-40B4-BE49-F238E27FC236}">
-                <a16:creationId xmlns:a16="http://schemas.microsoft.com/office/drawing/2014/main" id="{1EE75516-BD17-42A5-BEE8-BC2CDFEC5135}"/>
+                <a16:creationId xmlns:a16="http://schemas.microsoft.com/office/drawing/2014/main" id="{A85DA14F-CD12-4A9A-9B64-7AE726621A8E}"/>
               </a:ext>
             </a:extLst>
           </p:cNvPr>
           <p:cNvCxnSpPr>
-            <a:stCxn xmlns:a="http://schemas.openxmlformats.org/drawingml/2006/main" id="6" idx="3"/>
-            <a:endCxn xmlns:a="http://schemas.openxmlformats.org/drawingml/2006/main" id="8" idx="1"/>
+            <a:stCxn xmlns:a="http://schemas.openxmlformats.org/drawingml/2006/main" id="6" idx="2"/>
+            <a:endCxn xmlns:a="http://schemas.openxmlformats.org/drawingml/2006/main" id="8" idx="0"/>
           </p:cNvCxnSpPr>
           <p:nvPr/>
         </p:nvCxnSpPr>
         <p:spPr>
           <a:xfrm xmlns:a="http://schemas.openxmlformats.org/drawingml/2006/main">
-            <a:off x="5467350" y="3533775"/>
-            <a:ext cx="723900" cy="0"/>
+            <a:off x="9201150" y="2524125"/>
+            <a:ext cx="0" cy="714375"/>
           </a:xfrm>
           <a:prstGeom xmlns:a="http://schemas.openxmlformats.org/drawingml/2006/main" prst="straightConnector1">
             <a:avLst/>
@@ -10276,7 +11110,7 @@
             <a:solidFill>
               <a:srgbClr val="5E695F"/>
             </a:solidFill>
-            <a:headEnd type="arrow" w="med" len="med"/>
+            <a:tailEnd type="arrow" w="med" len="med"/>
           </a:ln>
         </p:spPr>
       </p:cxnSp>
@@ -10285,20 +11119,20 @@
           <p:cNvPr id="12" name="">
             <a:extLst xmlns:a="http://schemas.openxmlformats.org/drawingml/2006/main">
               <a:ext uri="{FF2B5EF4-FFF2-40B4-BE49-F238E27FC236}">
-                <a16:creationId xmlns:a16="http://schemas.microsoft.com/office/drawing/2014/main" id="{7E842FAC-670B-4131-A219-838D8AEA1B19}"/>
+                <a16:creationId xmlns:a16="http://schemas.microsoft.com/office/drawing/2014/main" id="{174048FD-FB74-40FD-9F89-892087EA813F}"/>
               </a:ext>
             </a:extLst>
           </p:cNvPr>
           <p:cNvCxnSpPr>
-            <a:stCxn xmlns:a="http://schemas.openxmlformats.org/drawingml/2006/main" id="6" idx="3"/>
-            <a:endCxn xmlns:a="http://schemas.openxmlformats.org/drawingml/2006/main" id="7" idx="1"/>
+            <a:stCxn xmlns:a="http://schemas.openxmlformats.org/drawingml/2006/main" id="6" idx="1"/>
+            <a:endCxn xmlns:a="http://schemas.openxmlformats.org/drawingml/2006/main" id="7" idx="0"/>
           </p:cNvCxnSpPr>
           <p:nvPr/>
         </p:nvCxnSpPr>
         <p:spPr>
-          <a:xfrm xmlns:a="http://schemas.openxmlformats.org/drawingml/2006/main" flipV="1">
-            <a:off x="5467350" y="2200275"/>
-            <a:ext cx="723900" cy="1333500"/>
+          <a:xfrm xmlns:a="http://schemas.openxmlformats.org/drawingml/2006/main" flipH="1">
+            <a:off x="2990850" y="2143125"/>
+            <a:ext cx="3829050" cy="1095375"/>
           </a:xfrm>
           <a:prstGeom xmlns:a="http://schemas.openxmlformats.org/drawingml/2006/main" prst="straightConnector1">
             <a:avLst/>
@@ -10307,7 +11141,7 @@
             <a:solidFill>
               <a:srgbClr val="5E695F"/>
             </a:solidFill>
-            <a:headEnd type="arrow" w="med" len="med"/>
+            <a:tailEnd type="arrow" w="med" len="med"/>
           </a:ln>
         </p:spPr>
       </p:cxnSp>
@@ -10316,20 +11150,20 @@
           <p:cNvPr id="11" name="">
             <a:extLst xmlns:a="http://schemas.openxmlformats.org/drawingml/2006/main">
               <a:ext uri="{FF2B5EF4-FFF2-40B4-BE49-F238E27FC236}">
-                <a16:creationId xmlns:a16="http://schemas.microsoft.com/office/drawing/2014/main" id="{E944FE95-E301-4FDA-BB83-B72A2AB5DA0A}"/>
+                <a16:creationId xmlns:a16="http://schemas.microsoft.com/office/drawing/2014/main" id="{8B722F6E-7991-497D-BD55-9B6A66118419}"/>
               </a:ext>
             </a:extLst>
           </p:cNvPr>
           <p:cNvCxnSpPr>
-            <a:stCxn xmlns:a="http://schemas.openxmlformats.org/drawingml/2006/main" id="5" idx="2"/>
-            <a:endCxn xmlns:a="http://schemas.openxmlformats.org/drawingml/2006/main" id="6" idx="0"/>
+            <a:stCxn xmlns:a="http://schemas.openxmlformats.org/drawingml/2006/main" id="5" idx="3"/>
+            <a:endCxn xmlns:a="http://schemas.openxmlformats.org/drawingml/2006/main" id="6" idx="1"/>
           </p:cNvCxnSpPr>
           <p:nvPr/>
         </p:nvCxnSpPr>
         <p:spPr>
           <a:xfrm xmlns:a="http://schemas.openxmlformats.org/drawingml/2006/main">
-            <a:off x="3038475" y="2638425"/>
-            <a:ext cx="0" cy="457200"/>
+            <a:off x="5372100" y="2143125"/>
+            <a:ext cx="1447800" cy="0"/>
           </a:xfrm>
           <a:prstGeom xmlns:a="http://schemas.openxmlformats.org/drawingml/2006/main" prst="straightConnector1">
             <a:avLst/>
@@ -10338,7 +11172,7 @@
             <a:solidFill>
               <a:srgbClr val="5E695F"/>
             </a:solidFill>
-            <a:headEnd type="arrow" w="med" len="med"/>
+            <a:tailEnd type="arrow" w="med" len="med"/>
           </a:ln>
         </p:spPr>
       </p:cxnSp>
@@ -10347,7 +11181,7 @@
           <p:cNvPr id="17" name="">
             <a:extLst xmlns:a="http://schemas.openxmlformats.org/drawingml/2006/main">
               <a:ext uri="{FF2B5EF4-FFF2-40B4-BE49-F238E27FC236}">
-                <a16:creationId xmlns:a16="http://schemas.microsoft.com/office/drawing/2014/main" id="{C33C79BA-A7DB-46EA-9A49-0C7A7BBDF431}"/>
+                <a16:creationId xmlns:a16="http://schemas.microsoft.com/office/drawing/2014/main" id="{9CA3B858-B337-4D55-8FB7-85BBD155B0D8}"/>
               </a:ext>
             </a:extLst>
           </p:cNvPr>
@@ -10413,7 +11247,7 @@
           <p:cNvPr id="2" name="">
             <a:extLst xmlns:a="http://schemas.openxmlformats.org/drawingml/2006/main">
               <a:ext uri="{FF2B5EF4-FFF2-40B4-BE49-F238E27FC236}">
-                <a16:creationId xmlns:a16="http://schemas.microsoft.com/office/drawing/2014/main" id="{87ABDB44-2638-4D71-B4B9-D208C8F02219}"/>
+                <a16:creationId xmlns:a16="http://schemas.microsoft.com/office/drawing/2014/main" id="{6E0B9825-909A-4119-8D91-316401588565}"/>
               </a:ext>
             </a:extLst>
           </p:cNvPr>
@@ -10479,7 +11313,7 @@
           <p:cNvPr id="3" name="">
             <a:extLst xmlns:a="http://schemas.openxmlformats.org/drawingml/2006/main">
               <a:ext uri="{FF2B5EF4-FFF2-40B4-BE49-F238E27FC236}">
-                <a16:creationId xmlns:a16="http://schemas.microsoft.com/office/drawing/2014/main" id="{573EA632-BED8-4EFB-87F0-DDC6E786FD99}"/>
+                <a16:creationId xmlns:a16="http://schemas.microsoft.com/office/drawing/2014/main" id="{21A7DEA3-A69D-4531-BF71-622D89071D63}"/>
               </a:ext>
             </a:extLst>
           </p:cNvPr>
@@ -10545,7 +11379,7 @@
           <p:cNvPr id="4" name="">
             <a:extLst xmlns:a="http://schemas.openxmlformats.org/drawingml/2006/main">
               <a:ext uri="{FF2B5EF4-FFF2-40B4-BE49-F238E27FC236}">
-                <a16:creationId xmlns:a16="http://schemas.microsoft.com/office/drawing/2014/main" id="{05FEABEB-B97A-49A5-968D-1555CC978B18}"/>
+                <a16:creationId xmlns:a16="http://schemas.microsoft.com/office/drawing/2014/main" id="{4AB750B9-B491-4EE4-B124-F794735B87B9}"/>
               </a:ext>
             </a:extLst>
           </p:cNvPr>
@@ -10611,7 +11445,7 @@
           <p:cNvPr id="5" name="">
             <a:extLst xmlns:a="http://schemas.openxmlformats.org/drawingml/2006/main">
               <a:ext uri="{FF2B5EF4-FFF2-40B4-BE49-F238E27FC236}">
-                <a16:creationId xmlns:a16="http://schemas.microsoft.com/office/drawing/2014/main" id="{8E551848-9C33-4596-9B42-8E0401EBC5EF}"/>
+                <a16:creationId xmlns:a16="http://schemas.microsoft.com/office/drawing/2014/main" id="{4C084FA2-3B6C-43BF-B6DF-ECCB48157942}"/>
               </a:ext>
             </a:extLst>
           </p:cNvPr>
@@ -10623,7 +11457,7 @@
         <p:spPr>
           <a:xfrm xmlns:a="http://schemas.openxmlformats.org/drawingml/2006/main">
             <a:off x="609600" y="1762125"/>
-            <a:ext cx="4857750" cy="876300"/>
+            <a:ext cx="4762500" cy="762000"/>
           </a:xfrm>
           <a:prstGeom xmlns:a="http://schemas.openxmlformats.org/drawingml/2006/main" prst="rect">
             <a:avLst/>
@@ -10704,19 +11538,19 @@
           <p:cNvPr id="6" name="">
             <a:extLst xmlns:a="http://schemas.openxmlformats.org/drawingml/2006/main">
               <a:ext uri="{FF2B5EF4-FFF2-40B4-BE49-F238E27FC236}">
-                <a16:creationId xmlns:a16="http://schemas.microsoft.com/office/drawing/2014/main" id="{D43871D2-3A0C-4A91-9052-E4AFA5FA9062}"/>
-              </a:ext>
-            </a:extLst>
-          </p:cNvPr>
-          <p:cNvSpPr>
-            <a:spLocks xmlns:a="http://schemas.openxmlformats.org/drawingml/2006/main" noGrp="1"/>
-          </p:cNvSpPr>
-          <p:nvPr/>
-        </p:nvSpPr>
-        <p:spPr>
-          <a:xfrm xmlns:a="http://schemas.openxmlformats.org/drawingml/2006/main">
-            <a:off x="609600" y="3095625"/>
-            <a:ext cx="4857750" cy="876300"/>
+                <a16:creationId xmlns:a16="http://schemas.microsoft.com/office/drawing/2014/main" id="{D25E672B-960D-4581-B746-012C9C3DBA02}"/>
+              </a:ext>
+            </a:extLst>
+          </p:cNvPr>
+          <p:cNvSpPr>
+            <a:spLocks xmlns:a="http://schemas.openxmlformats.org/drawingml/2006/main" noGrp="1"/>
+          </p:cNvSpPr>
+          <p:nvPr/>
+        </p:nvSpPr>
+        <p:spPr>
+          <a:xfrm xmlns:a="http://schemas.openxmlformats.org/drawingml/2006/main">
+            <a:off x="6819900" y="1762125"/>
+            <a:ext cx="4762500" cy="762000"/>
           </a:xfrm>
           <a:prstGeom xmlns:a="http://schemas.openxmlformats.org/drawingml/2006/main" prst="rect">
             <a:avLst/>
@@ -10797,19 +11631,19 @@
           <p:cNvPr id="7" name="">
             <a:extLst xmlns:a="http://schemas.openxmlformats.org/drawingml/2006/main">
               <a:ext uri="{FF2B5EF4-FFF2-40B4-BE49-F238E27FC236}">
-                <a16:creationId xmlns:a16="http://schemas.microsoft.com/office/drawing/2014/main" id="{C1B7EB22-2CE2-4701-8520-709EC2E4C71B}"/>
-              </a:ext>
-            </a:extLst>
-          </p:cNvPr>
-          <p:cNvSpPr>
-            <a:spLocks xmlns:a="http://schemas.openxmlformats.org/drawingml/2006/main" noGrp="1"/>
-          </p:cNvSpPr>
-          <p:nvPr/>
-        </p:nvSpPr>
-        <p:spPr>
-          <a:xfrm xmlns:a="http://schemas.openxmlformats.org/drawingml/2006/main">
-            <a:off x="6191250" y="1762125"/>
-            <a:ext cx="5191125" cy="876300"/>
+                <a16:creationId xmlns:a16="http://schemas.microsoft.com/office/drawing/2014/main" id="{831A7ED7-E60D-44BD-A5C7-233BF049F1B6}"/>
+              </a:ext>
+            </a:extLst>
+          </p:cNvPr>
+          <p:cNvSpPr>
+            <a:spLocks xmlns:a="http://schemas.openxmlformats.org/drawingml/2006/main" noGrp="1"/>
+          </p:cNvSpPr>
+          <p:nvPr/>
+        </p:nvSpPr>
+        <p:spPr>
+          <a:xfrm xmlns:a="http://schemas.openxmlformats.org/drawingml/2006/main">
+            <a:off x="609600" y="3238500"/>
+            <a:ext cx="4762500" cy="762000"/>
           </a:xfrm>
           <a:prstGeom xmlns:a="http://schemas.openxmlformats.org/drawingml/2006/main" prst="rect">
             <a:avLst/>
@@ -10890,19 +11724,19 @@
           <p:cNvPr id="8" name="">
             <a:extLst xmlns:a="http://schemas.openxmlformats.org/drawingml/2006/main">
               <a:ext uri="{FF2B5EF4-FFF2-40B4-BE49-F238E27FC236}">
-                <a16:creationId xmlns:a16="http://schemas.microsoft.com/office/drawing/2014/main" id="{A4FF8FAD-AAAE-4C30-88C8-3D3973CC7117}"/>
-              </a:ext>
-            </a:extLst>
-          </p:cNvPr>
-          <p:cNvSpPr>
-            <a:spLocks xmlns:a="http://schemas.openxmlformats.org/drawingml/2006/main" noGrp="1"/>
-          </p:cNvSpPr>
-          <p:nvPr/>
-        </p:nvSpPr>
-        <p:spPr>
-          <a:xfrm xmlns:a="http://schemas.openxmlformats.org/drawingml/2006/main">
-            <a:off x="6191250" y="3095625"/>
-            <a:ext cx="5191125" cy="876300"/>
+                <a16:creationId xmlns:a16="http://schemas.microsoft.com/office/drawing/2014/main" id="{8DA79A66-9B3A-4958-8648-EE04B8E328D4}"/>
+              </a:ext>
+            </a:extLst>
+          </p:cNvPr>
+          <p:cNvSpPr>
+            <a:spLocks xmlns:a="http://schemas.openxmlformats.org/drawingml/2006/main" noGrp="1"/>
+          </p:cNvSpPr>
+          <p:nvPr/>
+        </p:nvSpPr>
+        <p:spPr>
+          <a:xfrm xmlns:a="http://schemas.openxmlformats.org/drawingml/2006/main">
+            <a:off x="6819900" y="3238500"/>
+            <a:ext cx="4762500" cy="762000"/>
           </a:xfrm>
           <a:prstGeom xmlns:a="http://schemas.openxmlformats.org/drawingml/2006/main" prst="rect">
             <a:avLst/>
@@ -10983,19 +11817,19 @@
           <p:cNvPr id="9" name="">
             <a:extLst xmlns:a="http://schemas.openxmlformats.org/drawingml/2006/main">
               <a:ext uri="{FF2B5EF4-FFF2-40B4-BE49-F238E27FC236}">
-                <a16:creationId xmlns:a16="http://schemas.microsoft.com/office/drawing/2014/main" id="{52B4A848-C025-47BF-920E-8FC74230DF60}"/>
-              </a:ext>
-            </a:extLst>
-          </p:cNvPr>
-          <p:cNvSpPr>
-            <a:spLocks xmlns:a="http://schemas.openxmlformats.org/drawingml/2006/main" noGrp="1"/>
-          </p:cNvSpPr>
-          <p:nvPr/>
-        </p:nvSpPr>
-        <p:spPr>
-          <a:xfrm xmlns:a="http://schemas.openxmlformats.org/drawingml/2006/main">
-            <a:off x="609600" y="4619625"/>
-            <a:ext cx="4857750" cy="952500"/>
+                <a16:creationId xmlns:a16="http://schemas.microsoft.com/office/drawing/2014/main" id="{14D49347-4688-45E6-841C-E93BFB4C3731}"/>
+              </a:ext>
+            </a:extLst>
+          </p:cNvPr>
+          <p:cNvSpPr>
+            <a:spLocks xmlns:a="http://schemas.openxmlformats.org/drawingml/2006/main" noGrp="1"/>
+          </p:cNvSpPr>
+          <p:nvPr/>
+        </p:nvSpPr>
+        <p:spPr>
+          <a:xfrm xmlns:a="http://schemas.openxmlformats.org/drawingml/2006/main">
+            <a:off x="609600" y="4714875"/>
+            <a:ext cx="4762500" cy="857250"/>
           </a:xfrm>
           <a:prstGeom xmlns:a="http://schemas.openxmlformats.org/drawingml/2006/main" prst="rect">
             <a:avLst/>
@@ -11076,19 +11910,19 @@
           <p:cNvPr id="10" name="">
             <a:extLst xmlns:a="http://schemas.openxmlformats.org/drawingml/2006/main">
               <a:ext uri="{FF2B5EF4-FFF2-40B4-BE49-F238E27FC236}">
-                <a16:creationId xmlns:a16="http://schemas.microsoft.com/office/drawing/2014/main" id="{73B75688-E5F2-4077-89BF-6B911CB58520}"/>
-              </a:ext>
-            </a:extLst>
-          </p:cNvPr>
-          <p:cNvSpPr>
-            <a:spLocks xmlns:a="http://schemas.openxmlformats.org/drawingml/2006/main" noGrp="1"/>
-          </p:cNvSpPr>
-          <p:nvPr/>
-        </p:nvSpPr>
-        <p:spPr>
-          <a:xfrm xmlns:a="http://schemas.openxmlformats.org/drawingml/2006/main">
-            <a:off x="6191250" y="4619625"/>
-            <a:ext cx="5191125" cy="952500"/>
+                <a16:creationId xmlns:a16="http://schemas.microsoft.com/office/drawing/2014/main" id="{951EAF6B-B18D-4227-87BB-D0CAB00A3CEC}"/>
+              </a:ext>
+            </a:extLst>
+          </p:cNvPr>
+          <p:cNvSpPr>
+            <a:spLocks xmlns:a="http://schemas.openxmlformats.org/drawingml/2006/main" noGrp="1"/>
+          </p:cNvSpPr>
+          <p:nvPr/>
+        </p:nvSpPr>
+        <p:spPr>
+          <a:xfrm xmlns:a="http://schemas.openxmlformats.org/drawingml/2006/main">
+            <a:off x="6819900" y="4714875"/>
+            <a:ext cx="4762500" cy="857250"/>
           </a:xfrm>
           <a:prstGeom xmlns:a="http://schemas.openxmlformats.org/drawingml/2006/main" prst="rect">
             <a:avLst/>
@@ -11167,7 +12001,7 @@
     </p:spTree>
     <p:extLst>
       <p:ext uri="{BB962C8B-B14F-4D97-AF65-F5344CB8AC3E}">
-        <p14:creationId xmlns:p14="http://schemas.microsoft.com/office/powerpoint/2010/main" val="1317170820"/>
+        <p14:creationId xmlns:p14="http://schemas.microsoft.com/office/powerpoint/2010/main" val="2102242652"/>
       </p:ext>
     </p:extLst>
   </p:cSld>
@@ -11198,7 +12032,7 @@
           <p:cNvPr id="19" name="">
             <a:extLst xmlns:a="http://schemas.openxmlformats.org/drawingml/2006/main">
               <a:ext uri="{FF2B5EF4-FFF2-40B4-BE49-F238E27FC236}">
-                <a16:creationId xmlns:a16="http://schemas.microsoft.com/office/drawing/2014/main" id="{0135137D-B27C-4D46-B4E6-5A6B24555AAB}"/>
+                <a16:creationId xmlns:a16="http://schemas.microsoft.com/office/drawing/2014/main" id="{D652B94A-F07F-417D-AB02-6C5FE184A282}"/>
               </a:ext>
             </a:extLst>
           </p:cNvPr>
@@ -11220,7 +12054,7 @@
             <a:solidFill>
               <a:srgbClr val="5E695F"/>
             </a:solidFill>
-            <a:headEnd type="arrow" w="med" len="med"/>
+            <a:tailEnd type="arrow" w="med" len="med"/>
           </a:ln>
         </p:spPr>
       </p:cxnSp>
@@ -11229,7 +12063,7 @@
           <p:cNvPr id="18" name="">
             <a:extLst xmlns:a="http://schemas.openxmlformats.org/drawingml/2006/main">
               <a:ext uri="{FF2B5EF4-FFF2-40B4-BE49-F238E27FC236}">
-                <a16:creationId xmlns:a16="http://schemas.microsoft.com/office/drawing/2014/main" id="{5D5BA54D-6B6A-4B12-98F9-CFAB7097EFE0}"/>
+                <a16:creationId xmlns:a16="http://schemas.microsoft.com/office/drawing/2014/main" id="{020EAE63-9EF4-4515-B2C2-42FDD0E501DD}"/>
               </a:ext>
             </a:extLst>
           </p:cNvPr>
@@ -11251,7 +12085,7 @@
             <a:solidFill>
               <a:srgbClr val="5E695F"/>
             </a:solidFill>
-            <a:headEnd type="arrow" w="med" len="med"/>
+            <a:tailEnd type="arrow" w="med" len="med"/>
           </a:ln>
         </p:spPr>
       </p:cxnSp>
@@ -11260,7 +12094,7 @@
           <p:cNvPr id="17" name="">
             <a:extLst xmlns:a="http://schemas.openxmlformats.org/drawingml/2006/main">
               <a:ext uri="{FF2B5EF4-FFF2-40B4-BE49-F238E27FC236}">
-                <a16:creationId xmlns:a16="http://schemas.microsoft.com/office/drawing/2014/main" id="{EA370CBB-90CA-446C-BC61-39E458D7E457}"/>
+                <a16:creationId xmlns:a16="http://schemas.microsoft.com/office/drawing/2014/main" id="{A677AF46-0825-4063-97E9-104B307B042A}"/>
               </a:ext>
             </a:extLst>
           </p:cNvPr>
@@ -11282,7 +12116,7 @@
             <a:solidFill>
               <a:srgbClr val="5E695F"/>
             </a:solidFill>
-            <a:headEnd type="arrow" w="med" len="med"/>
+            <a:tailEnd type="arrow" w="med" len="med"/>
           </a:ln>
         </p:spPr>
       </p:cxnSp>
@@ -11291,7 +12125,7 @@
           <p:cNvPr id="16" name="">
             <a:extLst xmlns:a="http://schemas.openxmlformats.org/drawingml/2006/main">
               <a:ext uri="{FF2B5EF4-FFF2-40B4-BE49-F238E27FC236}">
-                <a16:creationId xmlns:a16="http://schemas.microsoft.com/office/drawing/2014/main" id="{E5639E00-845F-46B5-A6AC-A33717862D8E}"/>
+                <a16:creationId xmlns:a16="http://schemas.microsoft.com/office/drawing/2014/main" id="{1601B8A8-38B8-40BC-BB91-BBCA26B92B54}"/>
               </a:ext>
             </a:extLst>
           </p:cNvPr>
@@ -11313,7 +12147,7 @@
             <a:solidFill>
               <a:srgbClr val="5E695F"/>
             </a:solidFill>
-            <a:headEnd type="arrow" w="med" len="med"/>
+            <a:tailEnd type="arrow" w="med" len="med"/>
           </a:ln>
         </p:spPr>
       </p:cxnSp>
@@ -11322,7 +12156,7 @@
           <p:cNvPr id="15" name="">
             <a:extLst xmlns:a="http://schemas.openxmlformats.org/drawingml/2006/main">
               <a:ext uri="{FF2B5EF4-FFF2-40B4-BE49-F238E27FC236}">
-                <a16:creationId xmlns:a16="http://schemas.microsoft.com/office/drawing/2014/main" id="{F89807AC-C616-4EC4-8542-38F76DC44901}"/>
+                <a16:creationId xmlns:a16="http://schemas.microsoft.com/office/drawing/2014/main" id="{7451C75B-2C99-455F-98A7-6C0B415E1BFF}"/>
               </a:ext>
             </a:extLst>
           </p:cNvPr>
@@ -11344,7 +12178,7 @@
             <a:solidFill>
               <a:srgbClr val="5E695F"/>
             </a:solidFill>
-            <a:headEnd type="arrow" w="med" len="med"/>
+            <a:tailEnd type="arrow" w="med" len="med"/>
           </a:ln>
         </p:spPr>
       </p:cxnSp>
@@ -11353,7 +12187,7 @@
           <p:cNvPr id="14" name="">
             <a:extLst xmlns:a="http://schemas.openxmlformats.org/drawingml/2006/main">
               <a:ext uri="{FF2B5EF4-FFF2-40B4-BE49-F238E27FC236}">
-                <a16:creationId xmlns:a16="http://schemas.microsoft.com/office/drawing/2014/main" id="{201FB5E1-E323-4CEA-B188-711C62AC1417}"/>
+                <a16:creationId xmlns:a16="http://schemas.microsoft.com/office/drawing/2014/main" id="{CF9426D3-3858-461B-8870-6866E8282DDB}"/>
               </a:ext>
             </a:extLst>
           </p:cNvPr>
@@ -11375,7 +12209,7 @@
             <a:solidFill>
               <a:srgbClr val="5E695F"/>
             </a:solidFill>
-            <a:headEnd type="arrow" w="med" len="med"/>
+            <a:tailEnd type="arrow" w="med" len="med"/>
           </a:ln>
         </p:spPr>
       </p:cxnSp>
@@ -11384,7 +12218,7 @@
           <p:cNvPr id="13" name="">
             <a:extLst xmlns:a="http://schemas.openxmlformats.org/drawingml/2006/main">
               <a:ext uri="{FF2B5EF4-FFF2-40B4-BE49-F238E27FC236}">
-                <a16:creationId xmlns:a16="http://schemas.microsoft.com/office/drawing/2014/main" id="{E6692585-748A-4246-9D10-A05E4A184E35}"/>
+                <a16:creationId xmlns:a16="http://schemas.microsoft.com/office/drawing/2014/main" id="{1E07372F-C1AA-450D-BC9A-1DD340208AA0}"/>
               </a:ext>
             </a:extLst>
           </p:cNvPr>
@@ -11406,7 +12240,7 @@
             <a:solidFill>
               <a:srgbClr val="5E695F"/>
             </a:solidFill>
-            <a:headEnd type="arrow" w="med" len="med"/>
+            <a:tailEnd type="arrow" w="med" len="med"/>
           </a:ln>
         </p:spPr>
       </p:cxnSp>
@@ -11415,7 +12249,7 @@
           <p:cNvPr id="21" name="">
             <a:extLst xmlns:a="http://schemas.openxmlformats.org/drawingml/2006/main">
               <a:ext uri="{FF2B5EF4-FFF2-40B4-BE49-F238E27FC236}">
-                <a16:creationId xmlns:a16="http://schemas.microsoft.com/office/drawing/2014/main" id="{8F2D9A68-DA47-4ADB-9D04-D151B71FA74C}"/>
+                <a16:creationId xmlns:a16="http://schemas.microsoft.com/office/drawing/2014/main" id="{4EF69A2E-5545-4811-9FED-ECFAE8A98251}"/>
               </a:ext>
             </a:extLst>
           </p:cNvPr>
@@ -11481,7 +12315,7 @@
           <p:cNvPr id="2" name="">
             <a:extLst xmlns:a="http://schemas.openxmlformats.org/drawingml/2006/main">
               <a:ext uri="{FF2B5EF4-FFF2-40B4-BE49-F238E27FC236}">
-                <a16:creationId xmlns:a16="http://schemas.microsoft.com/office/drawing/2014/main" id="{0C955618-6282-4C13-8062-4B07532BC32B}"/>
+                <a16:creationId xmlns:a16="http://schemas.microsoft.com/office/drawing/2014/main" id="{379B7D99-9DAE-44FA-97BF-09A243896C94}"/>
               </a:ext>
             </a:extLst>
           </p:cNvPr>
@@ -11547,7 +12381,7 @@
           <p:cNvPr id="3" name="">
             <a:extLst xmlns:a="http://schemas.openxmlformats.org/drawingml/2006/main">
               <a:ext uri="{FF2B5EF4-FFF2-40B4-BE49-F238E27FC236}">
-                <a16:creationId xmlns:a16="http://schemas.microsoft.com/office/drawing/2014/main" id="{BD6638F3-F7EA-4197-B0E1-A15DF785F66D}"/>
+                <a16:creationId xmlns:a16="http://schemas.microsoft.com/office/drawing/2014/main" id="{0DCB0A56-A821-44BE-A0EF-8265536F7BF6}"/>
               </a:ext>
             </a:extLst>
           </p:cNvPr>
@@ -11613,7 +12447,7 @@
           <p:cNvPr id="4" name="">
             <a:extLst xmlns:a="http://schemas.openxmlformats.org/drawingml/2006/main">
               <a:ext uri="{FF2B5EF4-FFF2-40B4-BE49-F238E27FC236}">
-                <a16:creationId xmlns:a16="http://schemas.microsoft.com/office/drawing/2014/main" id="{3DA14D57-B19F-40E1-89A0-286060EDA097}"/>
+                <a16:creationId xmlns:a16="http://schemas.microsoft.com/office/drawing/2014/main" id="{5DF6C542-0697-4C54-B3F2-AB073CB45190}"/>
               </a:ext>
             </a:extLst>
           </p:cNvPr>
@@ -11679,7 +12513,7 @@
           <p:cNvPr id="5" name="">
             <a:extLst xmlns:a="http://schemas.openxmlformats.org/drawingml/2006/main">
               <a:ext uri="{FF2B5EF4-FFF2-40B4-BE49-F238E27FC236}">
-                <a16:creationId xmlns:a16="http://schemas.microsoft.com/office/drawing/2014/main" id="{526B8F58-A914-41CD-ACDC-F2378E6D2AB1}"/>
+                <a16:creationId xmlns:a16="http://schemas.microsoft.com/office/drawing/2014/main" id="{266EC22D-2E4E-4C31-A6C1-1F8D0E7A8E3D}"/>
               </a:ext>
             </a:extLst>
           </p:cNvPr>
@@ -11772,7 +12606,7 @@
           <p:cNvPr id="6" name="">
             <a:extLst xmlns:a="http://schemas.openxmlformats.org/drawingml/2006/main">
               <a:ext uri="{FF2B5EF4-FFF2-40B4-BE49-F238E27FC236}">
-                <a16:creationId xmlns:a16="http://schemas.microsoft.com/office/drawing/2014/main" id="{DB8B8971-F140-4903-9B01-37F651BD441D}"/>
+                <a16:creationId xmlns:a16="http://schemas.microsoft.com/office/drawing/2014/main" id="{97730043-8E3D-452E-8CFD-C5B5E8A1A27E}"/>
               </a:ext>
             </a:extLst>
           </p:cNvPr>
@@ -11865,7 +12699,7 @@
           <p:cNvPr id="7" name="">
             <a:extLst xmlns:a="http://schemas.openxmlformats.org/drawingml/2006/main">
               <a:ext uri="{FF2B5EF4-FFF2-40B4-BE49-F238E27FC236}">
-                <a16:creationId xmlns:a16="http://schemas.microsoft.com/office/drawing/2014/main" id="{1C182C19-43F4-483B-A430-8B76E603A67F}"/>
+                <a16:creationId xmlns:a16="http://schemas.microsoft.com/office/drawing/2014/main" id="{6F6429F5-8037-45AB-8AAA-FC31A682D22E}"/>
               </a:ext>
             </a:extLst>
           </p:cNvPr>
@@ -11958,7 +12792,7 @@
           <p:cNvPr id="8" name="">
             <a:extLst xmlns:a="http://schemas.openxmlformats.org/drawingml/2006/main">
               <a:ext uri="{FF2B5EF4-FFF2-40B4-BE49-F238E27FC236}">
-                <a16:creationId xmlns:a16="http://schemas.microsoft.com/office/drawing/2014/main" id="{F6C3E686-C06A-4907-A105-1D9521DB22A5}"/>
+                <a16:creationId xmlns:a16="http://schemas.microsoft.com/office/drawing/2014/main" id="{8D50A499-CC59-4008-852B-42C30A2DFC40}"/>
               </a:ext>
             </a:extLst>
           </p:cNvPr>
@@ -12051,7 +12885,7 @@
           <p:cNvPr id="9" name="">
             <a:extLst xmlns:a="http://schemas.openxmlformats.org/drawingml/2006/main">
               <a:ext uri="{FF2B5EF4-FFF2-40B4-BE49-F238E27FC236}">
-                <a16:creationId xmlns:a16="http://schemas.microsoft.com/office/drawing/2014/main" id="{C11B471B-0187-44EC-A642-10F54B4B4977}"/>
+                <a16:creationId xmlns:a16="http://schemas.microsoft.com/office/drawing/2014/main" id="{8C44B5FA-5FCF-4670-B998-87A8954E7368}"/>
               </a:ext>
             </a:extLst>
           </p:cNvPr>
@@ -12144,7 +12978,7 @@
           <p:cNvPr id="10" name="">
             <a:extLst xmlns:a="http://schemas.openxmlformats.org/drawingml/2006/main">
               <a:ext uri="{FF2B5EF4-FFF2-40B4-BE49-F238E27FC236}">
-                <a16:creationId xmlns:a16="http://schemas.microsoft.com/office/drawing/2014/main" id="{20B8CB85-64DC-4A86-A024-38154AC15354}"/>
+                <a16:creationId xmlns:a16="http://schemas.microsoft.com/office/drawing/2014/main" id="{EE4C8D79-0AF6-48F3-A4EA-D831EAF5F352}"/>
               </a:ext>
             </a:extLst>
           </p:cNvPr>
@@ -12237,7 +13071,7 @@
           <p:cNvPr id="11" name="">
             <a:extLst xmlns:a="http://schemas.openxmlformats.org/drawingml/2006/main">
               <a:ext uri="{FF2B5EF4-FFF2-40B4-BE49-F238E27FC236}">
-                <a16:creationId xmlns:a16="http://schemas.microsoft.com/office/drawing/2014/main" id="{87EC6974-972F-4A2C-816B-E8ACE9B5DF87}"/>
+                <a16:creationId xmlns:a16="http://schemas.microsoft.com/office/drawing/2014/main" id="{FB0351CC-CCC9-4176-9231-EAFAC2B77394}"/>
               </a:ext>
             </a:extLst>
           </p:cNvPr>
@@ -12330,7 +13164,7 @@
           <p:cNvPr id="12" name="">
             <a:extLst xmlns:a="http://schemas.openxmlformats.org/drawingml/2006/main">
               <a:ext uri="{FF2B5EF4-FFF2-40B4-BE49-F238E27FC236}">
-                <a16:creationId xmlns:a16="http://schemas.microsoft.com/office/drawing/2014/main" id="{6E68EE72-D3F2-47D9-AEF8-0BA1A3760491}"/>
+                <a16:creationId xmlns:a16="http://schemas.microsoft.com/office/drawing/2014/main" id="{57548EB2-D863-494B-A9BA-F2931C6603D8}"/>
               </a:ext>
             </a:extLst>
           </p:cNvPr>
@@ -12423,7 +13257,7 @@
           <p:cNvPr id="20" name="">
             <a:extLst xmlns:a="http://schemas.openxmlformats.org/drawingml/2006/main">
               <a:ext uri="{FF2B5EF4-FFF2-40B4-BE49-F238E27FC236}">
-                <a16:creationId xmlns:a16="http://schemas.microsoft.com/office/drawing/2014/main" id="{9506E676-2F37-4C83-92C5-5C86FFD13136}"/>
+                <a16:creationId xmlns:a16="http://schemas.microsoft.com/office/drawing/2014/main" id="{52740842-A85B-4E31-BFD1-2AADB4F0904E}"/>
               </a:ext>
             </a:extLst>
           </p:cNvPr>
@@ -12479,7 +13313,7 @@
                 <a:ea typeface="Arial"/>
                 <a:cs typeface="Arial"/>
               </a:rPr>
-              <a:t>Arrows show parent/reference direction. Reminders reference users and quizzes.</a:t>
+              <a:t>Parent → referencing table. Reminders link users and quizzes.</a:t>
             </a:r>
           </a:p>
         </p:txBody>
@@ -12487,7 +13321,7 @@
     </p:spTree>
     <p:extLst>
       <p:ext uri="{BB962C8B-B14F-4D97-AF65-F5344CB8AC3E}">
-        <p14:creationId xmlns:p14="http://schemas.microsoft.com/office/powerpoint/2010/main" val="1890981705"/>
+        <p14:creationId xmlns:p14="http://schemas.microsoft.com/office/powerpoint/2010/main" val="1180085438"/>
       </p:ext>
     </p:extLst>
   </p:cSld>
@@ -12518,7 +13352,7 @@
           <p:cNvPr id="11" name="">
             <a:extLst xmlns:a="http://schemas.openxmlformats.org/drawingml/2006/main">
               <a:ext uri="{FF2B5EF4-FFF2-40B4-BE49-F238E27FC236}">
-                <a16:creationId xmlns:a16="http://schemas.microsoft.com/office/drawing/2014/main" id="{21E62184-FE4B-43EB-A9F7-A521BA9D4A55}"/>
+                <a16:creationId xmlns:a16="http://schemas.microsoft.com/office/drawing/2014/main" id="{E162586F-80AE-453F-8AA1-485E5D2F0D9C}"/>
               </a:ext>
             </a:extLst>
           </p:cNvPr>
@@ -12584,7 +13418,7 @@
           <p:cNvPr id="2" name="">
             <a:extLst xmlns:a="http://schemas.openxmlformats.org/drawingml/2006/main">
               <a:ext uri="{FF2B5EF4-FFF2-40B4-BE49-F238E27FC236}">
-                <a16:creationId xmlns:a16="http://schemas.microsoft.com/office/drawing/2014/main" id="{2D03372F-99D4-448F-838E-95B6F212DF30}"/>
+                <a16:creationId xmlns:a16="http://schemas.microsoft.com/office/drawing/2014/main" id="{5B3F3543-228D-4690-8EFA-16399DC6AF08}"/>
               </a:ext>
             </a:extLst>
           </p:cNvPr>
@@ -12650,7 +13484,7 @@
           <p:cNvPr id="3" name="">
             <a:extLst xmlns:a="http://schemas.openxmlformats.org/drawingml/2006/main">
               <a:ext uri="{FF2B5EF4-FFF2-40B4-BE49-F238E27FC236}">
-                <a16:creationId xmlns:a16="http://schemas.microsoft.com/office/drawing/2014/main" id="{0E5BE3A8-FBD0-4831-BD98-8BB38684B9B5}"/>
+                <a16:creationId xmlns:a16="http://schemas.microsoft.com/office/drawing/2014/main" id="{CDE636E4-6E25-40AC-8B80-367EC4412942}"/>
               </a:ext>
             </a:extLst>
           </p:cNvPr>
@@ -12716,7 +13550,7 @@
           <p:cNvPr id="4" name="">
             <a:extLst xmlns:a="http://schemas.openxmlformats.org/drawingml/2006/main">
               <a:ext uri="{FF2B5EF4-FFF2-40B4-BE49-F238E27FC236}">
-                <a16:creationId xmlns:a16="http://schemas.microsoft.com/office/drawing/2014/main" id="{710CDBCF-2B36-4B6D-A78F-A563ED7DEB53}"/>
+                <a16:creationId xmlns:a16="http://schemas.microsoft.com/office/drawing/2014/main" id="{2AEECD81-5D2D-4CD1-84C6-68034CBC3D14}"/>
               </a:ext>
             </a:extLst>
           </p:cNvPr>
@@ -12782,7 +13616,7 @@
           <p:cNvPr id="5" name="">
             <a:extLst xmlns:a="http://schemas.openxmlformats.org/drawingml/2006/main">
               <a:ext uri="{FF2B5EF4-FFF2-40B4-BE49-F238E27FC236}">
-                <a16:creationId xmlns:a16="http://schemas.microsoft.com/office/drawing/2014/main" id="{3EE37D0B-FF62-4A3B-B910-108A09D17B80}"/>
+                <a16:creationId xmlns:a16="http://schemas.microsoft.com/office/drawing/2014/main" id="{6426AB8F-B17F-43C5-84F7-AF389958CE6B}"/>
               </a:ext>
             </a:extLst>
           </p:cNvPr>
@@ -12848,7 +13682,7 @@
           <p:cNvPr id="6" name="">
             <a:extLst xmlns:a="http://schemas.openxmlformats.org/drawingml/2006/main">
               <a:ext uri="{FF2B5EF4-FFF2-40B4-BE49-F238E27FC236}">
-                <a16:creationId xmlns:a16="http://schemas.microsoft.com/office/drawing/2014/main" id="{8E5B6288-B1FA-41A9-B2DE-11801E82B25D}"/>
+                <a16:creationId xmlns:a16="http://schemas.microsoft.com/office/drawing/2014/main" id="{E254D9D9-2E15-4007-9982-1F4E84743014}"/>
               </a:ext>
             </a:extLst>
           </p:cNvPr>
@@ -12965,7 +13799,7 @@
           <p:cNvPr id="7" name="">
             <a:extLst xmlns:a="http://schemas.openxmlformats.org/drawingml/2006/main">
               <a:ext uri="{FF2B5EF4-FFF2-40B4-BE49-F238E27FC236}">
-                <a16:creationId xmlns:a16="http://schemas.microsoft.com/office/drawing/2014/main" id="{D810315B-4B70-4442-82EC-6D9D46B2E2D4}"/>
+                <a16:creationId xmlns:a16="http://schemas.microsoft.com/office/drawing/2014/main" id="{182D24E6-6046-4FF6-A0B7-EA5E5E6AD91D}"/>
               </a:ext>
             </a:extLst>
           </p:cNvPr>
@@ -13031,7 +13865,7 @@
           <p:cNvPr id="8" name="">
             <a:extLst xmlns:a="http://schemas.openxmlformats.org/drawingml/2006/main">
               <a:ext uri="{FF2B5EF4-FFF2-40B4-BE49-F238E27FC236}">
-                <a16:creationId xmlns:a16="http://schemas.microsoft.com/office/drawing/2014/main" id="{5749752F-2D7A-4E79-855E-CAB7FF4D4394}"/>
+                <a16:creationId xmlns:a16="http://schemas.microsoft.com/office/drawing/2014/main" id="{1ED192CA-A5E0-406C-891F-2344AEEA686C}"/>
               </a:ext>
             </a:extLst>
           </p:cNvPr>
@@ -13097,7 +13931,7 @@
           <p:cNvPr id="9" name="">
             <a:extLst xmlns:a="http://schemas.openxmlformats.org/drawingml/2006/main">
               <a:ext uri="{FF2B5EF4-FFF2-40B4-BE49-F238E27FC236}">
-                <a16:creationId xmlns:a16="http://schemas.microsoft.com/office/drawing/2014/main" id="{A29FC2C7-7F19-4824-9D8B-A360E2C03CD0}"/>
+                <a16:creationId xmlns:a16="http://schemas.microsoft.com/office/drawing/2014/main" id="{C99DDC28-EB1D-4CB0-AB98-28C37836CB0D}"/>
               </a:ext>
             </a:extLst>
           </p:cNvPr>
@@ -13163,7 +13997,7 @@
           <p:cNvPr id="10" name="">
             <a:extLst xmlns:a="http://schemas.openxmlformats.org/drawingml/2006/main">
               <a:ext uri="{FF2B5EF4-FFF2-40B4-BE49-F238E27FC236}">
-                <a16:creationId xmlns:a16="http://schemas.microsoft.com/office/drawing/2014/main" id="{500691A7-6E8D-448C-9DBD-BC6D3BCC34D3}"/>
+                <a16:creationId xmlns:a16="http://schemas.microsoft.com/office/drawing/2014/main" id="{9C7BD024-90D2-4D70-BDD0-76BDE6FCE506}"/>
               </a:ext>
             </a:extLst>
           </p:cNvPr>
@@ -13227,7 +14061,7 @@
     </p:spTree>
     <p:extLst>
       <p:ext uri="{BB962C8B-B14F-4D97-AF65-F5344CB8AC3E}">
-        <p14:creationId xmlns:p14="http://schemas.microsoft.com/office/powerpoint/2010/main" val="261988451"/>
+        <p14:creationId xmlns:p14="http://schemas.microsoft.com/office/powerpoint/2010/main" val="1682330557"/>
       </p:ext>
     </p:extLst>
   </p:cSld>
@@ -13258,7 +14092,7 @@
           <p:cNvPr id="13" name="">
             <a:extLst xmlns:a="http://schemas.openxmlformats.org/drawingml/2006/main">
               <a:ext uri="{FF2B5EF4-FFF2-40B4-BE49-F238E27FC236}">
-                <a16:creationId xmlns:a16="http://schemas.microsoft.com/office/drawing/2014/main" id="{3CF543D6-1FBE-4CB1-B359-BAC8A6E2E60E}"/>
+                <a16:creationId xmlns:a16="http://schemas.microsoft.com/office/drawing/2014/main" id="{3C056264-DB1E-4EA1-A228-D56538DB657D}"/>
               </a:ext>
             </a:extLst>
           </p:cNvPr>
@@ -13324,7 +14158,7 @@
           <p:cNvPr id="2" name="">
             <a:extLst xmlns:a="http://schemas.openxmlformats.org/drawingml/2006/main">
               <a:ext uri="{FF2B5EF4-FFF2-40B4-BE49-F238E27FC236}">
-                <a16:creationId xmlns:a16="http://schemas.microsoft.com/office/drawing/2014/main" id="{F9AC1818-793F-4A6F-A3BE-874A0C5030DC}"/>
+                <a16:creationId xmlns:a16="http://schemas.microsoft.com/office/drawing/2014/main" id="{E06D3084-E34B-4DE6-958E-F17C9AC891CD}"/>
               </a:ext>
             </a:extLst>
           </p:cNvPr>
@@ -13390,7 +14224,7 @@
           <p:cNvPr id="3" name="">
             <a:extLst xmlns:a="http://schemas.openxmlformats.org/drawingml/2006/main">
               <a:ext uri="{FF2B5EF4-FFF2-40B4-BE49-F238E27FC236}">
-                <a16:creationId xmlns:a16="http://schemas.microsoft.com/office/drawing/2014/main" id="{0A9BCD0D-159C-4AAE-B9D5-4D2553183D2A}"/>
+                <a16:creationId xmlns:a16="http://schemas.microsoft.com/office/drawing/2014/main" id="{737F4491-DDD8-4817-ADEA-619828C9BADB}"/>
               </a:ext>
             </a:extLst>
           </p:cNvPr>
@@ -13456,7 +14290,7 @@
           <p:cNvPr id="4" name="">
             <a:extLst xmlns:a="http://schemas.openxmlformats.org/drawingml/2006/main">
               <a:ext uri="{FF2B5EF4-FFF2-40B4-BE49-F238E27FC236}">
-                <a16:creationId xmlns:a16="http://schemas.microsoft.com/office/drawing/2014/main" id="{7DD2B8FC-F8A3-49B0-9D9A-4C5199EB9292}"/>
+                <a16:creationId xmlns:a16="http://schemas.microsoft.com/office/drawing/2014/main" id="{28784C21-7B3E-4F5A-B191-A13ED944E89B}"/>
               </a:ext>
             </a:extLst>
           </p:cNvPr>
@@ -13522,7 +14356,7 @@
           <p:cNvPr id="5" name="">
             <a:extLst xmlns:a="http://schemas.openxmlformats.org/drawingml/2006/main">
               <a:ext uri="{FF2B5EF4-FFF2-40B4-BE49-F238E27FC236}">
-                <a16:creationId xmlns:a16="http://schemas.microsoft.com/office/drawing/2014/main" id="{073DD0BF-9666-4175-A6E8-AB5D954B889D}"/>
+                <a16:creationId xmlns:a16="http://schemas.microsoft.com/office/drawing/2014/main" id="{B3918271-9A32-47B6-84A8-6D1C2DF30676}"/>
               </a:ext>
             </a:extLst>
           </p:cNvPr>
@@ -13588,7 +14422,7 @@
           <p:cNvPr id="6" name="">
             <a:extLst xmlns:a="http://schemas.openxmlformats.org/drawingml/2006/main">
               <a:ext uri="{FF2B5EF4-FFF2-40B4-BE49-F238E27FC236}">
-                <a16:creationId xmlns:a16="http://schemas.microsoft.com/office/drawing/2014/main" id="{D0DA55FF-4048-4A70-9F9B-8A5AEB065C87}"/>
+                <a16:creationId xmlns:a16="http://schemas.microsoft.com/office/drawing/2014/main" id="{56E05986-3638-4F9B-A829-2ECE0818CDDA}"/>
               </a:ext>
             </a:extLst>
           </p:cNvPr>
@@ -13654,7 +14488,7 @@
           <p:cNvPr id="7" name="">
             <a:extLst xmlns:a="http://schemas.openxmlformats.org/drawingml/2006/main">
               <a:ext uri="{FF2B5EF4-FFF2-40B4-BE49-F238E27FC236}">
-                <a16:creationId xmlns:a16="http://schemas.microsoft.com/office/drawing/2014/main" id="{50904EAA-956B-4A0D-B8D0-77BE358C2D60}"/>
+                <a16:creationId xmlns:a16="http://schemas.microsoft.com/office/drawing/2014/main" id="{DDE18EE1-9BD2-4186-BF92-BF3FC600C869}"/>
               </a:ext>
             </a:extLst>
           </p:cNvPr>
@@ -13720,7 +14554,7 @@
           <p:cNvPr id="8" name="">
             <a:extLst xmlns:a="http://schemas.openxmlformats.org/drawingml/2006/main">
               <a:ext uri="{FF2B5EF4-FFF2-40B4-BE49-F238E27FC236}">
-                <a16:creationId xmlns:a16="http://schemas.microsoft.com/office/drawing/2014/main" id="{0C231E04-419D-4D72-A54F-38A67E4E4A70}"/>
+                <a16:creationId xmlns:a16="http://schemas.microsoft.com/office/drawing/2014/main" id="{B4F998B1-4DD7-48FF-8A3C-6D47B8B69FDC}"/>
               </a:ext>
             </a:extLst>
           </p:cNvPr>
@@ -13786,7 +14620,7 @@
           <p:cNvPr id="9" name="">
             <a:extLst xmlns:a="http://schemas.openxmlformats.org/drawingml/2006/main">
               <a:ext uri="{FF2B5EF4-FFF2-40B4-BE49-F238E27FC236}">
-                <a16:creationId xmlns:a16="http://schemas.microsoft.com/office/drawing/2014/main" id="{A36BBC2D-3C07-4FC8-A51C-23FC5BAF2571}"/>
+                <a16:creationId xmlns:a16="http://schemas.microsoft.com/office/drawing/2014/main" id="{5DAE2B9E-5C4A-466F-AAAD-C8153C136AD9}"/>
               </a:ext>
             </a:extLst>
           </p:cNvPr>
@@ -13852,7 +14686,7 @@
           <p:cNvPr id="10" name="">
             <a:extLst xmlns:a="http://schemas.openxmlformats.org/drawingml/2006/main">
               <a:ext uri="{FF2B5EF4-FFF2-40B4-BE49-F238E27FC236}">
-                <a16:creationId xmlns:a16="http://schemas.microsoft.com/office/drawing/2014/main" id="{CD762038-BB3E-4D90-9212-07DF4C3D4321}"/>
+                <a16:creationId xmlns:a16="http://schemas.microsoft.com/office/drawing/2014/main" id="{3C7E8BE7-8A0A-40D1-A1B7-FE5E1605F250}"/>
               </a:ext>
             </a:extLst>
           </p:cNvPr>
@@ -13918,7 +14752,7 @@
           <p:cNvPr id="11" name="">
             <a:extLst xmlns:a="http://schemas.openxmlformats.org/drawingml/2006/main">
               <a:ext uri="{FF2B5EF4-FFF2-40B4-BE49-F238E27FC236}">
-                <a16:creationId xmlns:a16="http://schemas.microsoft.com/office/drawing/2014/main" id="{D5D1D732-4D72-47C7-9A18-66DF827765EF}"/>
+                <a16:creationId xmlns:a16="http://schemas.microsoft.com/office/drawing/2014/main" id="{0592A34F-F893-4A6E-BA4B-E89EFA0F695A}"/>
               </a:ext>
             </a:extLst>
           </p:cNvPr>
@@ -13984,7 +14818,7 @@
           <p:cNvPr id="12" name="">
             <a:extLst xmlns:a="http://schemas.openxmlformats.org/drawingml/2006/main">
               <a:ext uri="{FF2B5EF4-FFF2-40B4-BE49-F238E27FC236}">
-                <a16:creationId xmlns:a16="http://schemas.microsoft.com/office/drawing/2014/main" id="{217F7DCE-AB3D-4025-94FC-5CEE60022AC8}"/>
+                <a16:creationId xmlns:a16="http://schemas.microsoft.com/office/drawing/2014/main" id="{3D978AB2-1570-478D-B245-D66C66C09A5A}"/>
               </a:ext>
             </a:extLst>
           </p:cNvPr>
@@ -14048,7 +14882,7 @@
     </p:spTree>
     <p:extLst>
       <p:ext uri="{BB962C8B-B14F-4D97-AF65-F5344CB8AC3E}">
-        <p14:creationId xmlns:p14="http://schemas.microsoft.com/office/powerpoint/2010/main" val="2101348099"/>
+        <p14:creationId xmlns:p14="http://schemas.microsoft.com/office/powerpoint/2010/main" val="495497854"/>
       </p:ext>
     </p:extLst>
   </p:cSld>
@@ -14079,7 +14913,7 @@
           <p:cNvPr id="8" name="">
             <a:extLst xmlns:a="http://schemas.openxmlformats.org/drawingml/2006/main">
               <a:ext uri="{FF2B5EF4-FFF2-40B4-BE49-F238E27FC236}">
-                <a16:creationId xmlns:a16="http://schemas.microsoft.com/office/drawing/2014/main" id="{54414611-703E-465C-BBA3-26056F516B88}"/>
+                <a16:creationId xmlns:a16="http://schemas.microsoft.com/office/drawing/2014/main" id="{192EDF96-A629-4EA2-A846-67901D5CD87B}"/>
               </a:ext>
             </a:extLst>
           </p:cNvPr>
@@ -14145,7 +14979,7 @@
           <p:cNvPr id="2" name="">
             <a:extLst xmlns:a="http://schemas.openxmlformats.org/drawingml/2006/main">
               <a:ext uri="{FF2B5EF4-FFF2-40B4-BE49-F238E27FC236}">
-                <a16:creationId xmlns:a16="http://schemas.microsoft.com/office/drawing/2014/main" id="{3FAA5CAA-9B16-4219-A061-02E3FF52378B}"/>
+                <a16:creationId xmlns:a16="http://schemas.microsoft.com/office/drawing/2014/main" id="{F8C8E726-3F5A-4C9E-B938-ED3BE6F59141}"/>
               </a:ext>
             </a:extLst>
           </p:cNvPr>
@@ -14211,7 +15045,7 @@
           <p:cNvPr id="3" name="">
             <a:extLst xmlns:a="http://schemas.openxmlformats.org/drawingml/2006/main">
               <a:ext uri="{FF2B5EF4-FFF2-40B4-BE49-F238E27FC236}">
-                <a16:creationId xmlns:a16="http://schemas.microsoft.com/office/drawing/2014/main" id="{ADBCAB46-3BB5-4EF4-BDFD-0B7EC0E0D103}"/>
+                <a16:creationId xmlns:a16="http://schemas.microsoft.com/office/drawing/2014/main" id="{27DFA6F8-304C-43BB-BC30-EB7858C6709D}"/>
               </a:ext>
             </a:extLst>
           </p:cNvPr>
@@ -14277,7 +15111,7 @@
           <p:cNvPr id="4" name="">
             <a:extLst xmlns:a="http://schemas.openxmlformats.org/drawingml/2006/main">
               <a:ext uri="{FF2B5EF4-FFF2-40B4-BE49-F238E27FC236}">
-                <a16:creationId xmlns:a16="http://schemas.microsoft.com/office/drawing/2014/main" id="{EB7406E8-EB4D-4C6F-8450-20E5AFEE4C44}"/>
+                <a16:creationId xmlns:a16="http://schemas.microsoft.com/office/drawing/2014/main" id="{1946E148-92C9-496D-9D37-63CBC2188827}"/>
               </a:ext>
             </a:extLst>
           </p:cNvPr>
@@ -14343,7 +15177,7 @@
           <p:cNvPr id="5" name="">
             <a:extLst xmlns:a="http://schemas.openxmlformats.org/drawingml/2006/main">
               <a:ext uri="{FF2B5EF4-FFF2-40B4-BE49-F238E27FC236}">
-                <a16:creationId xmlns:a16="http://schemas.microsoft.com/office/drawing/2014/main" id="{1DECE867-FD46-4943-8C1F-FF630CEA2FF4}"/>
+                <a16:creationId xmlns:a16="http://schemas.microsoft.com/office/drawing/2014/main" id="{0DC34BD3-2A98-43D5-B8DD-20F57D5570FD}"/>
               </a:ext>
             </a:extLst>
           </p:cNvPr>
@@ -14409,7 +15243,7 @@
           <p:cNvPr id="6" name="">
             <a:extLst xmlns:a="http://schemas.openxmlformats.org/drawingml/2006/main">
               <a:ext uri="{FF2B5EF4-FFF2-40B4-BE49-F238E27FC236}">
-                <a16:creationId xmlns:a16="http://schemas.microsoft.com/office/drawing/2014/main" id="{ED252172-FBCB-4C1B-B766-49BDB89872FC}"/>
+                <a16:creationId xmlns:a16="http://schemas.microsoft.com/office/drawing/2014/main" id="{718A37EC-9336-4E7D-BA71-243505886B4D}"/>
               </a:ext>
             </a:extLst>
           </p:cNvPr>
@@ -14559,7 +15393,7 @@
           <p:cNvPr id="7" name="">
             <a:extLst xmlns:a="http://schemas.openxmlformats.org/drawingml/2006/main">
               <a:ext uri="{FF2B5EF4-FFF2-40B4-BE49-F238E27FC236}">
-                <a16:creationId xmlns:a16="http://schemas.microsoft.com/office/drawing/2014/main" id="{4D9FD2BC-6D0A-421F-B062-7E7F7B1B71DD}"/>
+                <a16:creationId xmlns:a16="http://schemas.microsoft.com/office/drawing/2014/main" id="{BE1382DF-8529-4E3D-A843-237AA0490154}"/>
               </a:ext>
             </a:extLst>
           </p:cNvPr>
@@ -14569,7 +15403,7 @@
           <p:nvPr/>
         </p:nvPicPr>
         <p:blipFill>
-          <a:blip xmlns:r="http://schemas.openxmlformats.org/officeDocument/2006/relationships" xmlns:a="http://schemas.openxmlformats.org/drawingml/2006/main" r:embed="R4d81b6fcbff24c79"/>
+          <a:blip xmlns:r="http://schemas.openxmlformats.org/officeDocument/2006/relationships" xmlns:a="http://schemas.openxmlformats.org/drawingml/2006/main" r:embed="Rf91d8290ef824420"/>
           <a:stretch xmlns:a="http://schemas.openxmlformats.org/drawingml/2006/main"/>
         </p:blipFill>
         <p:spPr>
@@ -14585,7 +15419,7 @@
     </p:spTree>
     <p:extLst>
       <p:ext uri="{BB962C8B-B14F-4D97-AF65-F5344CB8AC3E}">
-        <p14:creationId xmlns:p14="http://schemas.microsoft.com/office/powerpoint/2010/main" val="1108284001"/>
+        <p14:creationId xmlns:p14="http://schemas.microsoft.com/office/powerpoint/2010/main" val="702304415"/>
       </p:ext>
     </p:extLst>
   </p:cSld>
@@ -14616,7 +15450,7 @@
           <p:cNvPr id="8" name="">
             <a:extLst xmlns:a="http://schemas.openxmlformats.org/drawingml/2006/main">
               <a:ext uri="{FF2B5EF4-FFF2-40B4-BE49-F238E27FC236}">
-                <a16:creationId xmlns:a16="http://schemas.microsoft.com/office/drawing/2014/main" id="{D808C2F1-1C3C-4ECA-BB2D-69678AC9C516}"/>
+                <a16:creationId xmlns:a16="http://schemas.microsoft.com/office/drawing/2014/main" id="{D70181CF-6E56-44F3-86FE-DD66C08D48F1}"/>
               </a:ext>
             </a:extLst>
           </p:cNvPr>
@@ -14682,7 +15516,7 @@
           <p:cNvPr id="2" name="">
             <a:extLst xmlns:a="http://schemas.openxmlformats.org/drawingml/2006/main">
               <a:ext uri="{FF2B5EF4-FFF2-40B4-BE49-F238E27FC236}">
-                <a16:creationId xmlns:a16="http://schemas.microsoft.com/office/drawing/2014/main" id="{B6326E33-75FC-49BD-8B60-0CFCB147DEAE}"/>
+                <a16:creationId xmlns:a16="http://schemas.microsoft.com/office/drawing/2014/main" id="{2D6FFFE3-ECD0-4EF1-9172-96C4F06C0CA2}"/>
               </a:ext>
             </a:extLst>
           </p:cNvPr>
@@ -14748,7 +15582,7 @@
           <p:cNvPr id="3" name="">
             <a:extLst xmlns:a="http://schemas.openxmlformats.org/drawingml/2006/main">
               <a:ext uri="{FF2B5EF4-FFF2-40B4-BE49-F238E27FC236}">
-                <a16:creationId xmlns:a16="http://schemas.microsoft.com/office/drawing/2014/main" id="{791A0254-08D7-4CB7-9056-6E106FC49C82}"/>
+                <a16:creationId xmlns:a16="http://schemas.microsoft.com/office/drawing/2014/main" id="{95C46DFB-DD62-43FA-A3A7-1DFD45B89138}"/>
               </a:ext>
             </a:extLst>
           </p:cNvPr>
@@ -14814,7 +15648,7 @@
           <p:cNvPr id="4" name="">
             <a:extLst xmlns:a="http://schemas.openxmlformats.org/drawingml/2006/main">
               <a:ext uri="{FF2B5EF4-FFF2-40B4-BE49-F238E27FC236}">
-                <a16:creationId xmlns:a16="http://schemas.microsoft.com/office/drawing/2014/main" id="{11FA1489-1F6B-4E38-944E-08609CD964F9}"/>
+                <a16:creationId xmlns:a16="http://schemas.microsoft.com/office/drawing/2014/main" id="{3EA17DA1-F9DD-414D-B32A-C8B30462D00B}"/>
               </a:ext>
             </a:extLst>
           </p:cNvPr>
@@ -14880,7 +15714,7 @@
           <p:cNvPr id="5" name="">
             <a:extLst xmlns:a="http://schemas.openxmlformats.org/drawingml/2006/main">
               <a:ext uri="{FF2B5EF4-FFF2-40B4-BE49-F238E27FC236}">
-                <a16:creationId xmlns:a16="http://schemas.microsoft.com/office/drawing/2014/main" id="{FB552F16-1D18-4D9E-9017-BF6EA253AF5D}"/>
+                <a16:creationId xmlns:a16="http://schemas.microsoft.com/office/drawing/2014/main" id="{60DD3328-3751-4E22-86BC-EB9E592809C8}"/>
               </a:ext>
             </a:extLst>
           </p:cNvPr>
@@ -14890,7 +15724,7 @@
           <p:nvPr/>
         </p:nvPicPr>
         <p:blipFill>
-          <a:blip xmlns:r="http://schemas.openxmlformats.org/officeDocument/2006/relationships" xmlns:a="http://schemas.openxmlformats.org/drawingml/2006/main" r:embed="Rda8a2ef3a20841c3"/>
+          <a:blip xmlns:r="http://schemas.openxmlformats.org/officeDocument/2006/relationships" xmlns:a="http://schemas.openxmlformats.org/drawingml/2006/main" r:embed="Re43903f1247b4db1"/>
           <a:stretch xmlns:a="http://schemas.openxmlformats.org/drawingml/2006/main"/>
         </p:blipFill>
         <p:spPr>
@@ -14908,7 +15742,7 @@
           <p:cNvPr id="6" name="">
             <a:extLst xmlns:a="http://schemas.openxmlformats.org/drawingml/2006/main">
               <a:ext uri="{FF2B5EF4-FFF2-40B4-BE49-F238E27FC236}">
-                <a16:creationId xmlns:a16="http://schemas.microsoft.com/office/drawing/2014/main" id="{292081E9-EAB1-4BE6-B187-8FD40421682B}"/>
+                <a16:creationId xmlns:a16="http://schemas.microsoft.com/office/drawing/2014/main" id="{758562C3-0BAD-4F21-80E6-8B4547EE7C77}"/>
               </a:ext>
             </a:extLst>
           </p:cNvPr>
@@ -14918,7 +15752,7 @@
           <p:nvPr/>
         </p:nvPicPr>
         <p:blipFill>
-          <a:blip xmlns:r="http://schemas.openxmlformats.org/officeDocument/2006/relationships" xmlns:a="http://schemas.openxmlformats.org/drawingml/2006/main" r:embed="R07fe9b8b1ac64150"/>
+          <a:blip xmlns:r="http://schemas.openxmlformats.org/officeDocument/2006/relationships" xmlns:a="http://schemas.openxmlformats.org/drawingml/2006/main" r:embed="Rdec12de8444a465b"/>
           <a:stretch xmlns:a="http://schemas.openxmlformats.org/drawingml/2006/main"/>
         </p:blipFill>
         <p:spPr>
@@ -14936,7 +15770,7 @@
           <p:cNvPr id="7" name="">
             <a:extLst xmlns:a="http://schemas.openxmlformats.org/drawingml/2006/main">
               <a:ext uri="{FF2B5EF4-FFF2-40B4-BE49-F238E27FC236}">
-                <a16:creationId xmlns:a16="http://schemas.microsoft.com/office/drawing/2014/main" id="{2BE99C61-5F1C-41A8-A253-76436A53E994}"/>
+                <a16:creationId xmlns:a16="http://schemas.microsoft.com/office/drawing/2014/main" id="{70BF4469-6F87-4D4B-B950-E558CADA11FC}"/>
               </a:ext>
             </a:extLst>
           </p:cNvPr>
@@ -15000,7 +15834,7 @@
     </p:spTree>
     <p:extLst>
       <p:ext uri="{BB962C8B-B14F-4D97-AF65-F5344CB8AC3E}">
-        <p14:creationId xmlns:p14="http://schemas.microsoft.com/office/powerpoint/2010/main" val="1493811147"/>
+        <p14:creationId xmlns:p14="http://schemas.microsoft.com/office/powerpoint/2010/main" val="1429437634"/>
       </p:ext>
     </p:extLst>
   </p:cSld>
@@ -15031,7 +15865,7 @@
           <p:cNvPr id="8" name="">
             <a:extLst xmlns:a="http://schemas.openxmlformats.org/drawingml/2006/main">
               <a:ext uri="{FF2B5EF4-FFF2-40B4-BE49-F238E27FC236}">
-                <a16:creationId xmlns:a16="http://schemas.microsoft.com/office/drawing/2014/main" id="{83ACA070-B5E1-4D5D-B1EC-A5647EC20AFA}"/>
+                <a16:creationId xmlns:a16="http://schemas.microsoft.com/office/drawing/2014/main" id="{6428ED43-A0CE-4A27-9DC7-9CAC2E401092}"/>
               </a:ext>
             </a:extLst>
           </p:cNvPr>
@@ -15097,7 +15931,7 @@
           <p:cNvPr id="2" name="">
             <a:extLst xmlns:a="http://schemas.openxmlformats.org/drawingml/2006/main">
               <a:ext uri="{FF2B5EF4-FFF2-40B4-BE49-F238E27FC236}">
-                <a16:creationId xmlns:a16="http://schemas.microsoft.com/office/drawing/2014/main" id="{4B844EA4-F1FA-4D71-8956-F73B66FD477C}"/>
+                <a16:creationId xmlns:a16="http://schemas.microsoft.com/office/drawing/2014/main" id="{D7A8C445-97CF-4EAB-B4E1-4F10ED3F9B56}"/>
               </a:ext>
             </a:extLst>
           </p:cNvPr>
@@ -15163,7 +15997,7 @@
           <p:cNvPr id="3" name="">
             <a:extLst xmlns:a="http://schemas.openxmlformats.org/drawingml/2006/main">
               <a:ext uri="{FF2B5EF4-FFF2-40B4-BE49-F238E27FC236}">
-                <a16:creationId xmlns:a16="http://schemas.microsoft.com/office/drawing/2014/main" id="{C54D9856-D108-4618-937F-F6ECF561F8E3}"/>
+                <a16:creationId xmlns:a16="http://schemas.microsoft.com/office/drawing/2014/main" id="{7A74BFD7-C781-45C3-A2AB-3E9B75BE9505}"/>
               </a:ext>
             </a:extLst>
           </p:cNvPr>
@@ -15229,7 +16063,7 @@
           <p:cNvPr id="4" name="">
             <a:extLst xmlns:a="http://schemas.openxmlformats.org/drawingml/2006/main">
               <a:ext uri="{FF2B5EF4-FFF2-40B4-BE49-F238E27FC236}">
-                <a16:creationId xmlns:a16="http://schemas.microsoft.com/office/drawing/2014/main" id="{49AFADEB-D414-4D5D-BF35-0896E74B600B}"/>
+                <a16:creationId xmlns:a16="http://schemas.microsoft.com/office/drawing/2014/main" id="{9D049325-18F5-418F-BA9B-561C3AC8E5CC}"/>
               </a:ext>
             </a:extLst>
           </p:cNvPr>
@@ -15295,7 +16129,7 @@
           <p:cNvPr id="5" name="">
             <a:extLst xmlns:a="http://schemas.openxmlformats.org/drawingml/2006/main">
               <a:ext uri="{FF2B5EF4-FFF2-40B4-BE49-F238E27FC236}">
-                <a16:creationId xmlns:a16="http://schemas.microsoft.com/office/drawing/2014/main" id="{4F592E31-D427-4587-BC97-712168DF06D4}"/>
+                <a16:creationId xmlns:a16="http://schemas.microsoft.com/office/drawing/2014/main" id="{C60E86A0-EC88-4E5D-8C48-66C97FADC7FC}"/>
               </a:ext>
             </a:extLst>
           </p:cNvPr>
@@ -15305,7 +16139,7 @@
           <p:nvPr/>
         </p:nvPicPr>
         <p:blipFill>
-          <a:blip xmlns:r="http://schemas.openxmlformats.org/officeDocument/2006/relationships" xmlns:a="http://schemas.openxmlformats.org/drawingml/2006/main" r:embed="Rb4dfc949f4e84a91"/>
+          <a:blip xmlns:r="http://schemas.openxmlformats.org/officeDocument/2006/relationships" xmlns:a="http://schemas.openxmlformats.org/drawingml/2006/main" r:embed="Rb748791944844647"/>
           <a:stretch xmlns:a="http://schemas.openxmlformats.org/drawingml/2006/main"/>
         </p:blipFill>
         <p:spPr>
@@ -15323,7 +16157,7 @@
           <p:cNvPr id="6" name="">
             <a:extLst xmlns:a="http://schemas.openxmlformats.org/drawingml/2006/main">
               <a:ext uri="{FF2B5EF4-FFF2-40B4-BE49-F238E27FC236}">
-                <a16:creationId xmlns:a16="http://schemas.microsoft.com/office/drawing/2014/main" id="{74388F12-CD6B-4838-A014-5D4894D6ACB6}"/>
+                <a16:creationId xmlns:a16="http://schemas.microsoft.com/office/drawing/2014/main" id="{7428E1DC-A442-4AFF-B04E-EB8A2DF0F0EE}"/>
               </a:ext>
             </a:extLst>
           </p:cNvPr>
@@ -15333,13 +16167,13 @@
           <p:nvPr/>
         </p:nvPicPr>
         <p:blipFill>
-          <a:blip xmlns:r="http://schemas.openxmlformats.org/officeDocument/2006/relationships" xmlns:a="http://schemas.openxmlformats.org/drawingml/2006/main" r:embed="Re6932f0cc344448c"/>
+          <a:blip xmlns:r="http://schemas.openxmlformats.org/officeDocument/2006/relationships" xmlns:a="http://schemas.openxmlformats.org/drawingml/2006/main" r:embed="Rd980bfa5fe794789"/>
           <a:stretch xmlns:a="http://schemas.openxmlformats.org/drawingml/2006/main"/>
         </p:blipFill>
         <p:spPr>
           <a:xfrm xmlns:a="http://schemas.openxmlformats.org/drawingml/2006/main">
-            <a:off x="9239250" y="3005455"/>
-            <a:ext cx="2238375" cy="1551940"/>
+            <a:off x="9367473" y="1638300"/>
+            <a:ext cx="1981928" cy="4286250"/>
           </a:xfrm>
           <a:prstGeom xmlns:a="http://schemas.openxmlformats.org/drawingml/2006/main" prst="rect">
             <a:avLst/>
@@ -15351,7 +16185,7 @@
           <p:cNvPr id="7" name="">
             <a:extLst xmlns:a="http://schemas.openxmlformats.org/drawingml/2006/main">
               <a:ext uri="{FF2B5EF4-FFF2-40B4-BE49-F238E27FC236}">
-                <a16:creationId xmlns:a16="http://schemas.microsoft.com/office/drawing/2014/main" id="{9721788F-B3E6-4C97-9F5E-BC6E2525933F}"/>
+                <a16:creationId xmlns:a16="http://schemas.microsoft.com/office/drawing/2014/main" id="{0468FAED-138D-4848-902C-2BF593E84DEB}"/>
               </a:ext>
             </a:extLst>
           </p:cNvPr>
@@ -15415,7 +16249,7 @@
     </p:spTree>
     <p:extLst>
       <p:ext uri="{BB962C8B-B14F-4D97-AF65-F5344CB8AC3E}">
-        <p14:creationId xmlns:p14="http://schemas.microsoft.com/office/powerpoint/2010/main" val="1211162789"/>
+        <p14:creationId xmlns:p14="http://schemas.microsoft.com/office/powerpoint/2010/main" val="1796518959"/>
       </p:ext>
     </p:extLst>
   </p:cSld>

</xml_diff>

<commit_message>
Document live QuizNova deployment and update review slides
</commit_message>
<xml_diff>
--- a/docs/presentation/QuizNova-Review-1.pptx
+++ b/docs/presentation/QuizNova-Review-1.pptx
@@ -2,29 +2,29 @@
 <file path=ppt/presentation.xml><?xml version="1.0" encoding="utf-8"?>
 <p:presentation xmlns:p="http://schemas.openxmlformats.org/presentationml/2006/main">
   <p:sldMasterIdLst>
-    <p:sldMasterId xmlns:r="http://schemas.openxmlformats.org/officeDocument/2006/relationships" id="2147483648" r:id="R7c82ed5dacdf4ee2"/>
+    <p:sldMasterId xmlns:r="http://schemas.openxmlformats.org/officeDocument/2006/relationships" id="2147483648" r:id="Rfee24b6fe4a34770"/>
   </p:sldMasterIdLst>
   <p:notesMasterIdLst>
-    <p:notesMasterId xmlns:r="http://schemas.openxmlformats.org/officeDocument/2006/relationships" r:id="Rc6491179baac4731"/>
+    <p:notesMasterId xmlns:r="http://schemas.openxmlformats.org/officeDocument/2006/relationships" r:id="Rf5b23a840f854243"/>
   </p:notesMasterIdLst>
   <p:sldIdLst>
-    <p:sldId xmlns:r="http://schemas.openxmlformats.org/officeDocument/2006/relationships" id="256" r:id="R96a71879de0243be"/>
-    <p:sldId xmlns:r="http://schemas.openxmlformats.org/officeDocument/2006/relationships" id="257" r:id="R358d82fa986d4322"/>
-    <p:sldId xmlns:r="http://schemas.openxmlformats.org/officeDocument/2006/relationships" id="258" r:id="R58766a31063c40ff"/>
-    <p:sldId xmlns:r="http://schemas.openxmlformats.org/officeDocument/2006/relationships" id="259" r:id="R0d66ab0ee85f4f27"/>
-    <p:sldId xmlns:r="http://schemas.openxmlformats.org/officeDocument/2006/relationships" id="260" r:id="R3e1caf0ee30e4a38"/>
-    <p:sldId xmlns:r="http://schemas.openxmlformats.org/officeDocument/2006/relationships" id="261" r:id="Rc9e2d17ea23d49f2"/>
-    <p:sldId xmlns:r="http://schemas.openxmlformats.org/officeDocument/2006/relationships" id="262" r:id="R104ec6ee9c334a97"/>
-    <p:sldId xmlns:r="http://schemas.openxmlformats.org/officeDocument/2006/relationships" id="263" r:id="R56668e4b537b492d"/>
-    <p:sldId xmlns:r="http://schemas.openxmlformats.org/officeDocument/2006/relationships" id="264" r:id="Rc0d8d6e012f94a70"/>
-    <p:sldId xmlns:r="http://schemas.openxmlformats.org/officeDocument/2006/relationships" id="265" r:id="Rd6beabbfda5e4bb7"/>
-    <p:sldId xmlns:r="http://schemas.openxmlformats.org/officeDocument/2006/relationships" id="266" r:id="Rc841613697d34c55"/>
-    <p:sldId xmlns:r="http://schemas.openxmlformats.org/officeDocument/2006/relationships" id="267" r:id="R05edc500e2ec4183"/>
-    <p:sldId xmlns:r="http://schemas.openxmlformats.org/officeDocument/2006/relationships" id="268" r:id="R16a03d6e0e514513"/>
-    <p:sldId xmlns:r="http://schemas.openxmlformats.org/officeDocument/2006/relationships" id="269" r:id="R175c89a7b43542df"/>
-    <p:sldId xmlns:r="http://schemas.openxmlformats.org/officeDocument/2006/relationships" id="270" r:id="Rda449a5bfd214e89"/>
-    <p:sldId xmlns:r="http://schemas.openxmlformats.org/officeDocument/2006/relationships" id="271" r:id="R817de379c2424859"/>
-    <p:sldId xmlns:r="http://schemas.openxmlformats.org/officeDocument/2006/relationships" id="272" r:id="Rc431ee77e5ed4d33"/>
+    <p:sldId xmlns:r="http://schemas.openxmlformats.org/officeDocument/2006/relationships" id="256" r:id="Rebb15089ef094bd3"/>
+    <p:sldId xmlns:r="http://schemas.openxmlformats.org/officeDocument/2006/relationships" id="257" r:id="R9717923cae6f4986"/>
+    <p:sldId xmlns:r="http://schemas.openxmlformats.org/officeDocument/2006/relationships" id="258" r:id="R52ea58a78c50467e"/>
+    <p:sldId xmlns:r="http://schemas.openxmlformats.org/officeDocument/2006/relationships" id="259" r:id="R1ab2ae47a9ae4d19"/>
+    <p:sldId xmlns:r="http://schemas.openxmlformats.org/officeDocument/2006/relationships" id="260" r:id="R6e13164621304983"/>
+    <p:sldId xmlns:r="http://schemas.openxmlformats.org/officeDocument/2006/relationships" id="261" r:id="R4d771d5add444eec"/>
+    <p:sldId xmlns:r="http://schemas.openxmlformats.org/officeDocument/2006/relationships" id="262" r:id="Re5f93417f28f4180"/>
+    <p:sldId xmlns:r="http://schemas.openxmlformats.org/officeDocument/2006/relationships" id="263" r:id="Ra77f68187d034b89"/>
+    <p:sldId xmlns:r="http://schemas.openxmlformats.org/officeDocument/2006/relationships" id="264" r:id="Rc520d9a581be4656"/>
+    <p:sldId xmlns:r="http://schemas.openxmlformats.org/officeDocument/2006/relationships" id="265" r:id="R59be68b5f9114d39"/>
+    <p:sldId xmlns:r="http://schemas.openxmlformats.org/officeDocument/2006/relationships" id="266" r:id="R22db0696b8f640ec"/>
+    <p:sldId xmlns:r="http://schemas.openxmlformats.org/officeDocument/2006/relationships" id="267" r:id="R7348645f1f0641c0"/>
+    <p:sldId xmlns:r="http://schemas.openxmlformats.org/officeDocument/2006/relationships" id="268" r:id="Ra699b55d272243e4"/>
+    <p:sldId xmlns:r="http://schemas.openxmlformats.org/officeDocument/2006/relationships" id="269" r:id="Reb5f4e490eac485a"/>
+    <p:sldId xmlns:r="http://schemas.openxmlformats.org/officeDocument/2006/relationships" id="270" r:id="R0ff24806da7c4149"/>
+    <p:sldId xmlns:r="http://schemas.openxmlformats.org/officeDocument/2006/relationships" id="271" r:id="R26dbc76ac2344584"/>
+    <p:sldId xmlns:r="http://schemas.openxmlformats.org/officeDocument/2006/relationships" id="272" r:id="R02aaf3819d694595"/>
   </p:sldIdLst>
   <p:sldSz cx="12192000" cy="6858000"/>
   <p:notesSz cx="6858000" cy="9144000"/>
@@ -1018,7 +1018,7 @@
           <a:lstStyle xmlns:a="http://schemas.openxmlformats.org/drawingml/2006/main"/>
           <a:p xmlns:a="http://schemas.openxmlformats.org/drawingml/2006/main">
             <a:r>
-              <a:t>Live URL intentionally blank. Free hosting research: https://render.com/docs/free and https://neon.com/pricing . Render free web services can sleep after inactivity and have ephemeral local storage; use external PostgreSQL instead of H2 files. Free services have usage limits and are suitable for a project demonstration. Do not claim this project is hosted until a deployment succeeds. See docs/DEPLOYMENT.md.</a:t>
+              <a:t>Live deployment verified on 15 October 2026: https://quiznova-muskanbuilds11.onrender.com . Secrets stay in Render environment variables. Cloud demo accounts are disabled. Free hosting sources: https://render.com/docs/free and https://neon.com/pricing . Render free web services can sleep after inactivity and have ephemeral local storage; use external PostgreSQL instead of H2 files. Free services have usage limits and are suitable for a project demonstration. See docs/DEPLOYMENT.md.</a:t>
             </a:r>
           </a:p>
         </p:txBody>
@@ -1625,7 +1625,7 @@
           <p:cNvPr id="3" name="Title">
             <a:extLst xmlns:a="http://schemas.openxmlformats.org/drawingml/2006/main">
               <a:ext uri="{FF2B5EF4-FFF2-40B4-BE49-F238E27FC236}">
-                <a16:creationId xmlns:a16="http://schemas.microsoft.com/office/drawing/2014/main" id="{B24DD062-AF33-4B01-8733-EA08218A172C}"/>
+                <a16:creationId xmlns:a16="http://schemas.microsoft.com/office/drawing/2014/main" id="{54FC63F6-384D-41C9-BEB6-2F16905490AB}"/>
               </a:ext>
             </a:extLst>
           </p:cNvPr>
@@ -1782,7 +1782,7 @@
           <p:cNvPr id="2" name="Subtitle">
             <a:extLst xmlns:a="http://schemas.openxmlformats.org/drawingml/2006/main">
               <a:ext uri="{FF2B5EF4-FFF2-40B4-BE49-F238E27FC236}">
-                <a16:creationId xmlns:a16="http://schemas.microsoft.com/office/drawing/2014/main" id="{32EA105C-3CAC-47D3-B533-A7538F21F5AF}"/>
+                <a16:creationId xmlns:a16="http://schemas.microsoft.com/office/drawing/2014/main" id="{4D7A3C1D-5D52-4CDC-87AE-37475845283B}"/>
               </a:ext>
             </a:extLst>
           </p:cNvPr>
@@ -1956,7 +1956,7 @@
           <p:cNvPr id="2" name="Section title">
             <a:extLst xmlns:a="http://schemas.openxmlformats.org/drawingml/2006/main">
               <a:ext uri="{FF2B5EF4-FFF2-40B4-BE49-F238E27FC236}">
-                <a16:creationId xmlns:a16="http://schemas.microsoft.com/office/drawing/2014/main" id="{DC628B9A-977B-4B3F-9D73-C4AA3D2B5E97}"/>
+                <a16:creationId xmlns:a16="http://schemas.microsoft.com/office/drawing/2014/main" id="{FFFA048B-4B28-456B-B186-282A9E6963C3}"/>
               </a:ext>
             </a:extLst>
           </p:cNvPr>
@@ -2130,7 +2130,7 @@
           <p:cNvPr id="3" name="Title">
             <a:extLst xmlns:a="http://schemas.openxmlformats.org/drawingml/2006/main">
               <a:ext uri="{FF2B5EF4-FFF2-40B4-BE49-F238E27FC236}">
-                <a16:creationId xmlns:a16="http://schemas.microsoft.com/office/drawing/2014/main" id="{83FA8844-1C42-4AE7-9F21-D016550E92F3}"/>
+                <a16:creationId xmlns:a16="http://schemas.microsoft.com/office/drawing/2014/main" id="{02912E29-B39F-4F3D-8EAB-D20DCF4E3C4D}"/>
               </a:ext>
             </a:extLst>
           </p:cNvPr>
@@ -2287,7 +2287,7 @@
           <p:cNvPr id="2" name="Body">
             <a:extLst xmlns:a="http://schemas.openxmlformats.org/drawingml/2006/main">
               <a:ext uri="{FF2B5EF4-FFF2-40B4-BE49-F238E27FC236}">
-                <a16:creationId xmlns:a16="http://schemas.microsoft.com/office/drawing/2014/main" id="{FD0ED68A-BCA5-4E64-BB01-BBEC22BAC7CB}"/>
+                <a16:creationId xmlns:a16="http://schemas.microsoft.com/office/drawing/2014/main" id="{9B90B899-6944-42A1-ACFD-834B474365E7}"/>
               </a:ext>
             </a:extLst>
           </p:cNvPr>
@@ -2461,7 +2461,7 @@
           <p:cNvPr id="4" name="Title">
             <a:extLst xmlns:a="http://schemas.openxmlformats.org/drawingml/2006/main">
               <a:ext uri="{FF2B5EF4-FFF2-40B4-BE49-F238E27FC236}">
-                <a16:creationId xmlns:a16="http://schemas.microsoft.com/office/drawing/2014/main" id="{1B3185B9-7AC7-408A-B36B-17F1207D8BF5}"/>
+                <a16:creationId xmlns:a16="http://schemas.microsoft.com/office/drawing/2014/main" id="{087C9BE8-ECC3-4252-ADD2-20E273D6AA48}"/>
               </a:ext>
             </a:extLst>
           </p:cNvPr>
@@ -2618,7 +2618,7 @@
           <p:cNvPr id="2" name="Left column">
             <a:extLst xmlns:a="http://schemas.openxmlformats.org/drawingml/2006/main">
               <a:ext uri="{FF2B5EF4-FFF2-40B4-BE49-F238E27FC236}">
-                <a16:creationId xmlns:a16="http://schemas.microsoft.com/office/drawing/2014/main" id="{D1695CBF-C045-44AD-A024-3680EFBB1961}"/>
+                <a16:creationId xmlns:a16="http://schemas.microsoft.com/office/drawing/2014/main" id="{01CAFD4A-3184-499F-B673-DD651EFFFFB6}"/>
               </a:ext>
             </a:extLst>
           </p:cNvPr>
@@ -2775,7 +2775,7 @@
           <p:cNvPr id="3" name="Right column">
             <a:extLst xmlns:a="http://schemas.openxmlformats.org/drawingml/2006/main">
               <a:ext uri="{FF2B5EF4-FFF2-40B4-BE49-F238E27FC236}">
-                <a16:creationId xmlns:a16="http://schemas.microsoft.com/office/drawing/2014/main" id="{6796BF7E-2907-41B4-8365-DFA112B4975B}"/>
+                <a16:creationId xmlns:a16="http://schemas.microsoft.com/office/drawing/2014/main" id="{3439FAB9-CDC7-4289-B6D9-3DC30536E27A}"/>
               </a:ext>
             </a:extLst>
           </p:cNvPr>
@@ -2949,7 +2949,7 @@
           <p:cNvPr id="3" name="Title">
             <a:extLst xmlns:a="http://schemas.openxmlformats.org/drawingml/2006/main">
               <a:ext uri="{FF2B5EF4-FFF2-40B4-BE49-F238E27FC236}">
-                <a16:creationId xmlns:a16="http://schemas.microsoft.com/office/drawing/2014/main" id="{C52749D7-BC6B-4111-BC4B-1141429A5602}"/>
+                <a16:creationId xmlns:a16="http://schemas.microsoft.com/office/drawing/2014/main" id="{C5D71C99-299A-46E3-B98F-D76501A73EE4}"/>
               </a:ext>
             </a:extLst>
           </p:cNvPr>
@@ -3106,7 +3106,7 @@
           <p:cNvPr id="2" name="Left column">
             <a:extLst xmlns:a="http://schemas.openxmlformats.org/drawingml/2006/main">
               <a:ext uri="{FF2B5EF4-FFF2-40B4-BE49-F238E27FC236}">
-                <a16:creationId xmlns:a16="http://schemas.microsoft.com/office/drawing/2014/main" id="{1B3E5165-CEDB-4298-99B4-3A34F63D2F4F}"/>
+                <a16:creationId xmlns:a16="http://schemas.microsoft.com/office/drawing/2014/main" id="{38FDB67F-E165-4F6C-8D80-F1D433828B41}"/>
               </a:ext>
             </a:extLst>
           </p:cNvPr>
@@ -3301,12 +3301,12 @@
   </p:cSld>
   <p:clrMap bg1="lt1" tx1="dk1" bg2="lt2" tx2="dk2" accent1="accent1" accent2="accent2" accent3="accent3" accent4="accent4" accent5="accent5" accent6="accent6" hlink="hlink" folHlink="folHlink"/>
   <p:sldLayoutIdLst>
-    <p:sldLayoutId xmlns:r="http://schemas.openxmlformats.org/officeDocument/2006/relationships" id="2147483649" r:id="R6886aa3a559e4284"/>
-    <p:sldLayoutId xmlns:r="http://schemas.openxmlformats.org/officeDocument/2006/relationships" id="2147483650" r:id="Re9de69a3e4874d31"/>
-    <p:sldLayoutId xmlns:r="http://schemas.openxmlformats.org/officeDocument/2006/relationships" id="2147483651" r:id="R81ecece9debe4d6c"/>
-    <p:sldLayoutId xmlns:r="http://schemas.openxmlformats.org/officeDocument/2006/relationships" id="2147483652" r:id="Ra5897eaff16341b7"/>
-    <p:sldLayoutId xmlns:r="http://schemas.openxmlformats.org/officeDocument/2006/relationships" id="2147483653" r:id="R777995d81e864783"/>
-    <p:sldLayoutId xmlns:r="http://schemas.openxmlformats.org/officeDocument/2006/relationships" id="2147483654" r:id="R2767ade4d7164fb0"/>
+    <p:sldLayoutId xmlns:r="http://schemas.openxmlformats.org/officeDocument/2006/relationships" id="2147483649" r:id="Rcb68d0ed18634b5a"/>
+    <p:sldLayoutId xmlns:r="http://schemas.openxmlformats.org/officeDocument/2006/relationships" id="2147483650" r:id="R42d937818df3422a"/>
+    <p:sldLayoutId xmlns:r="http://schemas.openxmlformats.org/officeDocument/2006/relationships" id="2147483651" r:id="Racf26a435e174eb2"/>
+    <p:sldLayoutId xmlns:r="http://schemas.openxmlformats.org/officeDocument/2006/relationships" id="2147483652" r:id="Rdb49b6175d2a4763"/>
+    <p:sldLayoutId xmlns:r="http://schemas.openxmlformats.org/officeDocument/2006/relationships" id="2147483653" r:id="R14c4d5dccd154edf"/>
+    <p:sldLayoutId xmlns:r="http://schemas.openxmlformats.org/officeDocument/2006/relationships" id="2147483654" r:id="R462b7576d5484b2a"/>
   </p:sldLayoutIdLst>
   <p:txStyles>
     <p:titleStyle>
@@ -3857,7 +3857,7 @@
           <p:cNvPr id="9" name="">
             <a:extLst xmlns:a="http://schemas.openxmlformats.org/drawingml/2006/main">
               <a:ext uri="{FF2B5EF4-FFF2-40B4-BE49-F238E27FC236}">
-                <a16:creationId xmlns:a16="http://schemas.microsoft.com/office/drawing/2014/main" id="{31B26374-FF7B-4544-AF7D-15FE17DC6F36}"/>
+                <a16:creationId xmlns:a16="http://schemas.microsoft.com/office/drawing/2014/main" id="{7652E45E-765E-4C6D-A64E-262E3B778B89}"/>
               </a:ext>
             </a:extLst>
           </p:cNvPr>
@@ -3923,7 +3923,7 @@
           <p:cNvPr id="2" name="">
             <a:extLst xmlns:a="http://schemas.openxmlformats.org/drawingml/2006/main">
               <a:ext uri="{FF2B5EF4-FFF2-40B4-BE49-F238E27FC236}">
-                <a16:creationId xmlns:a16="http://schemas.microsoft.com/office/drawing/2014/main" id="{68DEE4CF-89C1-4221-8499-1F5ABBFD8612}"/>
+                <a16:creationId xmlns:a16="http://schemas.microsoft.com/office/drawing/2014/main" id="{D34003A3-CD09-46DC-B8E8-505DA1016C72}"/>
               </a:ext>
             </a:extLst>
           </p:cNvPr>
@@ -3989,7 +3989,7 @@
           <p:cNvPr id="3" name="">
             <a:extLst xmlns:a="http://schemas.openxmlformats.org/drawingml/2006/main">
               <a:ext uri="{FF2B5EF4-FFF2-40B4-BE49-F238E27FC236}">
-                <a16:creationId xmlns:a16="http://schemas.microsoft.com/office/drawing/2014/main" id="{30897945-0268-4A6E-BEA8-0C63066E8A41}"/>
+                <a16:creationId xmlns:a16="http://schemas.microsoft.com/office/drawing/2014/main" id="{25D87C7D-D27D-44EE-9DC8-0C467AD78C4B}"/>
               </a:ext>
             </a:extLst>
           </p:cNvPr>
@@ -4055,7 +4055,7 @@
           <p:cNvPr id="4" name="">
             <a:extLst xmlns:a="http://schemas.openxmlformats.org/drawingml/2006/main">
               <a:ext uri="{FF2B5EF4-FFF2-40B4-BE49-F238E27FC236}">
-                <a16:creationId xmlns:a16="http://schemas.microsoft.com/office/drawing/2014/main" id="{C14C56DA-1B27-456E-91F8-B26814CF4FE9}"/>
+                <a16:creationId xmlns:a16="http://schemas.microsoft.com/office/drawing/2014/main" id="{13958CA5-1500-44D1-9F8E-94C847AB2A9E}"/>
               </a:ext>
             </a:extLst>
           </p:cNvPr>
@@ -4121,7 +4121,7 @@
           <p:cNvPr id="5" name="">
             <a:extLst xmlns:a="http://schemas.openxmlformats.org/drawingml/2006/main">
               <a:ext uri="{FF2B5EF4-FFF2-40B4-BE49-F238E27FC236}">
-                <a16:creationId xmlns:a16="http://schemas.microsoft.com/office/drawing/2014/main" id="{1B5CE880-C1DD-4557-976C-2A5201FDEAFE}"/>
+                <a16:creationId xmlns:a16="http://schemas.microsoft.com/office/drawing/2014/main" id="{AFDC4D86-82A6-4240-AAE3-2B4ADF1E4290}"/>
               </a:ext>
             </a:extLst>
           </p:cNvPr>
@@ -4210,7 +4210,7 @@
           <p:cNvPr id="6" name="">
             <a:extLst xmlns:a="http://schemas.openxmlformats.org/drawingml/2006/main">
               <a:ext uri="{FF2B5EF4-FFF2-40B4-BE49-F238E27FC236}">
-                <a16:creationId xmlns:a16="http://schemas.microsoft.com/office/drawing/2014/main" id="{E0B4DB1E-4712-4216-B539-4D897C8671B9}"/>
+                <a16:creationId xmlns:a16="http://schemas.microsoft.com/office/drawing/2014/main" id="{FE967601-9669-4105-A998-098CB1866C50}"/>
               </a:ext>
             </a:extLst>
           </p:cNvPr>
@@ -4276,7 +4276,7 @@
           <p:cNvPr id="7" name="">
             <a:extLst xmlns:a="http://schemas.openxmlformats.org/drawingml/2006/main">
               <a:ext uri="{FF2B5EF4-FFF2-40B4-BE49-F238E27FC236}">
-                <a16:creationId xmlns:a16="http://schemas.microsoft.com/office/drawing/2014/main" id="{98574446-6BF6-47DC-9A54-F2EDC4CD5E7F}"/>
+                <a16:creationId xmlns:a16="http://schemas.microsoft.com/office/drawing/2014/main" id="{6D00D644-2E41-4F63-8412-3B40A629B62B}"/>
               </a:ext>
             </a:extLst>
           </p:cNvPr>
@@ -4342,7 +4342,7 @@
           <p:cNvPr id="8" name="">
             <a:extLst xmlns:a="http://schemas.openxmlformats.org/drawingml/2006/main">
               <a:ext uri="{FF2B5EF4-FFF2-40B4-BE49-F238E27FC236}">
-                <a16:creationId xmlns:a16="http://schemas.microsoft.com/office/drawing/2014/main" id="{2D2021EE-6D5B-4CE2-9D9D-8C466E6EFE38}"/>
+                <a16:creationId xmlns:a16="http://schemas.microsoft.com/office/drawing/2014/main" id="{826E268A-2A83-4726-9736-4D013F9C1257}"/>
               </a:ext>
             </a:extLst>
           </p:cNvPr>
@@ -4406,7 +4406,7 @@
     </p:spTree>
     <p:extLst>
       <p:ext uri="{BB962C8B-B14F-4D97-AF65-F5344CB8AC3E}">
-        <p14:creationId xmlns:p14="http://schemas.microsoft.com/office/powerpoint/2010/main" val="924175461"/>
+        <p14:creationId xmlns:p14="http://schemas.microsoft.com/office/powerpoint/2010/main" val="354681538"/>
       </p:ext>
     </p:extLst>
   </p:cSld>
@@ -4437,7 +4437,7 @@
           <p:cNvPr id="8" name="">
             <a:extLst xmlns:a="http://schemas.openxmlformats.org/drawingml/2006/main">
               <a:ext uri="{FF2B5EF4-FFF2-40B4-BE49-F238E27FC236}">
-                <a16:creationId xmlns:a16="http://schemas.microsoft.com/office/drawing/2014/main" id="{A1C8FB5D-61A6-4604-B4BD-4E2301F40237}"/>
+                <a16:creationId xmlns:a16="http://schemas.microsoft.com/office/drawing/2014/main" id="{B7008365-33E5-4DC0-8679-AF4F0755B16D}"/>
               </a:ext>
             </a:extLst>
           </p:cNvPr>
@@ -4503,7 +4503,7 @@
           <p:cNvPr id="2" name="">
             <a:extLst xmlns:a="http://schemas.openxmlformats.org/drawingml/2006/main">
               <a:ext uri="{FF2B5EF4-FFF2-40B4-BE49-F238E27FC236}">
-                <a16:creationId xmlns:a16="http://schemas.microsoft.com/office/drawing/2014/main" id="{5BCECA04-9E53-4405-8BB5-CD058C092AFA}"/>
+                <a16:creationId xmlns:a16="http://schemas.microsoft.com/office/drawing/2014/main" id="{BAD85004-1668-4473-85AC-E836D969429D}"/>
               </a:ext>
             </a:extLst>
           </p:cNvPr>
@@ -4569,7 +4569,7 @@
           <p:cNvPr id="3" name="">
             <a:extLst xmlns:a="http://schemas.openxmlformats.org/drawingml/2006/main">
               <a:ext uri="{FF2B5EF4-FFF2-40B4-BE49-F238E27FC236}">
-                <a16:creationId xmlns:a16="http://schemas.microsoft.com/office/drawing/2014/main" id="{84B71978-504E-4C15-8FF5-AD6F316FD0F0}"/>
+                <a16:creationId xmlns:a16="http://schemas.microsoft.com/office/drawing/2014/main" id="{90D76DA7-35F0-4FD0-AB87-F41FE7009C0F}"/>
               </a:ext>
             </a:extLst>
           </p:cNvPr>
@@ -4635,7 +4635,7 @@
           <p:cNvPr id="4" name="">
             <a:extLst xmlns:a="http://schemas.openxmlformats.org/drawingml/2006/main">
               <a:ext uri="{FF2B5EF4-FFF2-40B4-BE49-F238E27FC236}">
-                <a16:creationId xmlns:a16="http://schemas.microsoft.com/office/drawing/2014/main" id="{5B1FDDD5-9F3B-4F34-A89C-2B211A330DE5}"/>
+                <a16:creationId xmlns:a16="http://schemas.microsoft.com/office/drawing/2014/main" id="{D36900B8-543D-43AA-A46A-BC66F363F132}"/>
               </a:ext>
             </a:extLst>
           </p:cNvPr>
@@ -4701,7 +4701,7 @@
           <p:cNvPr id="5" name="">
             <a:extLst xmlns:a="http://schemas.openxmlformats.org/drawingml/2006/main">
               <a:ext uri="{FF2B5EF4-FFF2-40B4-BE49-F238E27FC236}">
-                <a16:creationId xmlns:a16="http://schemas.microsoft.com/office/drawing/2014/main" id="{31213927-0781-4B4C-9A0F-B0F10AE32E7E}"/>
+                <a16:creationId xmlns:a16="http://schemas.microsoft.com/office/drawing/2014/main" id="{B3C9A0AB-FC2F-4BE3-814E-03C611463461}"/>
               </a:ext>
             </a:extLst>
           </p:cNvPr>
@@ -4711,7 +4711,7 @@
           <p:nvPr/>
         </p:nvPicPr>
         <p:blipFill>
-          <a:blip xmlns:r="http://schemas.openxmlformats.org/officeDocument/2006/relationships" xmlns:a="http://schemas.openxmlformats.org/drawingml/2006/main" r:embed="Rcce83117c56f4d19"/>
+          <a:blip xmlns:r="http://schemas.openxmlformats.org/officeDocument/2006/relationships" xmlns:a="http://schemas.openxmlformats.org/drawingml/2006/main" r:embed="Refd5732d24f740c8"/>
           <a:stretch xmlns:a="http://schemas.openxmlformats.org/drawingml/2006/main"/>
         </p:blipFill>
         <p:spPr>
@@ -4729,7 +4729,7 @@
           <p:cNvPr id="6" name="">
             <a:extLst xmlns:a="http://schemas.openxmlformats.org/drawingml/2006/main">
               <a:ext uri="{FF2B5EF4-FFF2-40B4-BE49-F238E27FC236}">
-                <a16:creationId xmlns:a16="http://schemas.microsoft.com/office/drawing/2014/main" id="{7C8F742A-5154-4879-8E89-BDE68EF005E2}"/>
+                <a16:creationId xmlns:a16="http://schemas.microsoft.com/office/drawing/2014/main" id="{E8485680-15E8-49C8-9B5B-AFE1CA70B092}"/>
               </a:ext>
             </a:extLst>
           </p:cNvPr>
@@ -4887,7 +4887,7 @@
           <p:cNvPr id="7" name="">
             <a:extLst xmlns:a="http://schemas.openxmlformats.org/drawingml/2006/main">
               <a:ext uri="{FF2B5EF4-FFF2-40B4-BE49-F238E27FC236}">
-                <a16:creationId xmlns:a16="http://schemas.microsoft.com/office/drawing/2014/main" id="{ED836DCF-3E1E-41EA-9446-D0500D5BEB0B}"/>
+                <a16:creationId xmlns:a16="http://schemas.microsoft.com/office/drawing/2014/main" id="{27770F52-95BD-4BF4-98C4-DA9E22ACA7B8}"/>
               </a:ext>
             </a:extLst>
           </p:cNvPr>
@@ -4951,7 +4951,7 @@
     </p:spTree>
     <p:extLst>
       <p:ext uri="{BB962C8B-B14F-4D97-AF65-F5344CB8AC3E}">
-        <p14:creationId xmlns:p14="http://schemas.microsoft.com/office/powerpoint/2010/main" val="84163190"/>
+        <p14:creationId xmlns:p14="http://schemas.microsoft.com/office/powerpoint/2010/main" val="402189327"/>
       </p:ext>
     </p:extLst>
   </p:cSld>
@@ -4982,7 +4982,7 @@
           <p:cNvPr id="10" name="">
             <a:extLst xmlns:a="http://schemas.openxmlformats.org/drawingml/2006/main">
               <a:ext uri="{FF2B5EF4-FFF2-40B4-BE49-F238E27FC236}">
-                <a16:creationId xmlns:a16="http://schemas.microsoft.com/office/drawing/2014/main" id="{6DFA75AF-5689-44FC-A606-E8CFD9AF4F01}"/>
+                <a16:creationId xmlns:a16="http://schemas.microsoft.com/office/drawing/2014/main" id="{0733E233-AAC8-44F8-B40D-90F242D5C2DC}"/>
               </a:ext>
             </a:extLst>
           </p:cNvPr>
@@ -5048,7 +5048,7 @@
           <p:cNvPr id="2" name="">
             <a:extLst xmlns:a="http://schemas.openxmlformats.org/drawingml/2006/main">
               <a:ext uri="{FF2B5EF4-FFF2-40B4-BE49-F238E27FC236}">
-                <a16:creationId xmlns:a16="http://schemas.microsoft.com/office/drawing/2014/main" id="{F09924CC-AF93-4B8A-8F34-ED9852F3055A}"/>
+                <a16:creationId xmlns:a16="http://schemas.microsoft.com/office/drawing/2014/main" id="{7036EFD0-B10D-4653-8375-AB8EC25BF9F0}"/>
               </a:ext>
             </a:extLst>
           </p:cNvPr>
@@ -5114,7 +5114,7 @@
           <p:cNvPr id="3" name="">
             <a:extLst xmlns:a="http://schemas.openxmlformats.org/drawingml/2006/main">
               <a:ext uri="{FF2B5EF4-FFF2-40B4-BE49-F238E27FC236}">
-                <a16:creationId xmlns:a16="http://schemas.microsoft.com/office/drawing/2014/main" id="{E1ADEA92-997A-4172-ADF0-E1D9F9885B44}"/>
+                <a16:creationId xmlns:a16="http://schemas.microsoft.com/office/drawing/2014/main" id="{C15DDC6F-7CD3-401A-AA35-BD6165F41DB0}"/>
               </a:ext>
             </a:extLst>
           </p:cNvPr>
@@ -5180,7 +5180,7 @@
           <p:cNvPr id="4" name="">
             <a:extLst xmlns:a="http://schemas.openxmlformats.org/drawingml/2006/main">
               <a:ext uri="{FF2B5EF4-FFF2-40B4-BE49-F238E27FC236}">
-                <a16:creationId xmlns:a16="http://schemas.microsoft.com/office/drawing/2014/main" id="{A830DE37-81A8-47AB-AB55-877DCD9BEA0C}"/>
+                <a16:creationId xmlns:a16="http://schemas.microsoft.com/office/drawing/2014/main" id="{33CDA81D-4ABC-4BE0-8A60-63C266AB769C}"/>
               </a:ext>
             </a:extLst>
           </p:cNvPr>
@@ -5246,7 +5246,7 @@
           <p:cNvPr id="5" name="">
             <a:extLst xmlns:a="http://schemas.openxmlformats.org/drawingml/2006/main">
               <a:ext uri="{FF2B5EF4-FFF2-40B4-BE49-F238E27FC236}">
-                <a16:creationId xmlns:a16="http://schemas.microsoft.com/office/drawing/2014/main" id="{34D69190-3880-4454-8C63-3BCD6E79CA1B}"/>
+                <a16:creationId xmlns:a16="http://schemas.microsoft.com/office/drawing/2014/main" id="{8BD1A0C4-B1DD-456D-BD1C-C6C42C3E406F}"/>
               </a:ext>
             </a:extLst>
           </p:cNvPr>
@@ -5256,7 +5256,7 @@
           <p:nvPr/>
         </p:nvPicPr>
         <p:blipFill>
-          <a:blip xmlns:r="http://schemas.openxmlformats.org/officeDocument/2006/relationships" xmlns:a="http://schemas.openxmlformats.org/drawingml/2006/main" r:embed="Rda7c6a3fe30b4869"/>
+          <a:blip xmlns:r="http://schemas.openxmlformats.org/officeDocument/2006/relationships" xmlns:a="http://schemas.openxmlformats.org/drawingml/2006/main" r:embed="R82aa1fb7572542bd"/>
           <a:stretch xmlns:a="http://schemas.openxmlformats.org/drawingml/2006/main"/>
         </p:blipFill>
         <p:spPr>
@@ -5274,7 +5274,7 @@
           <p:cNvPr id="6" name="">
             <a:extLst xmlns:a="http://schemas.openxmlformats.org/drawingml/2006/main">
               <a:ext uri="{FF2B5EF4-FFF2-40B4-BE49-F238E27FC236}">
-                <a16:creationId xmlns:a16="http://schemas.microsoft.com/office/drawing/2014/main" id="{962E3BD2-2BA7-4F61-946F-BE52B166B468}"/>
+                <a16:creationId xmlns:a16="http://schemas.microsoft.com/office/drawing/2014/main" id="{37BF661E-68F9-4D09-8E1B-0F3656D5F06B}"/>
               </a:ext>
             </a:extLst>
           </p:cNvPr>
@@ -5340,7 +5340,7 @@
           <p:cNvPr id="7" name="">
             <a:extLst xmlns:a="http://schemas.openxmlformats.org/drawingml/2006/main">
               <a:ext uri="{FF2B5EF4-FFF2-40B4-BE49-F238E27FC236}">
-                <a16:creationId xmlns:a16="http://schemas.microsoft.com/office/drawing/2014/main" id="{8C2DDBA5-7754-442A-9FC7-0AB468BA235C}"/>
+                <a16:creationId xmlns:a16="http://schemas.microsoft.com/office/drawing/2014/main" id="{C958347F-8889-4A79-8979-9D72F538BD6D}"/>
               </a:ext>
             </a:extLst>
           </p:cNvPr>
@@ -5406,7 +5406,7 @@
           <p:cNvPr id="8" name="">
             <a:extLst xmlns:a="http://schemas.openxmlformats.org/drawingml/2006/main">
               <a:ext uri="{FF2B5EF4-FFF2-40B4-BE49-F238E27FC236}">
-                <a16:creationId xmlns:a16="http://schemas.microsoft.com/office/drawing/2014/main" id="{438F389A-B66E-418A-8577-3C0EE3237720}"/>
+                <a16:creationId xmlns:a16="http://schemas.microsoft.com/office/drawing/2014/main" id="{1FF4F931-5EF0-4B98-BE82-DA0EC08B8D5B}"/>
               </a:ext>
             </a:extLst>
           </p:cNvPr>
@@ -5472,7 +5472,7 @@
           <p:cNvPr id="9" name="">
             <a:extLst xmlns:a="http://schemas.openxmlformats.org/drawingml/2006/main">
               <a:ext uri="{FF2B5EF4-FFF2-40B4-BE49-F238E27FC236}">
-                <a16:creationId xmlns:a16="http://schemas.microsoft.com/office/drawing/2014/main" id="{4241CA44-8856-45F3-AD7D-8ECBE9F663C2}"/>
+                <a16:creationId xmlns:a16="http://schemas.microsoft.com/office/drawing/2014/main" id="{2AD69EA6-B1BC-4ED0-AF55-41D402A68951}"/>
               </a:ext>
             </a:extLst>
           </p:cNvPr>
@@ -5536,7 +5536,7 @@
     </p:spTree>
     <p:extLst>
       <p:ext uri="{BB962C8B-B14F-4D97-AF65-F5344CB8AC3E}">
-        <p14:creationId xmlns:p14="http://schemas.microsoft.com/office/powerpoint/2010/main" val="708870536"/>
+        <p14:creationId xmlns:p14="http://schemas.microsoft.com/office/powerpoint/2010/main" val="1928287995"/>
       </p:ext>
     </p:extLst>
   </p:cSld>
@@ -5567,7 +5567,7 @@
           <p:cNvPr id="7" name="">
             <a:extLst xmlns:a="http://schemas.openxmlformats.org/drawingml/2006/main">
               <a:ext uri="{FF2B5EF4-FFF2-40B4-BE49-F238E27FC236}">
-                <a16:creationId xmlns:a16="http://schemas.microsoft.com/office/drawing/2014/main" id="{2C15CEC1-A743-4137-BFE7-03636C3A85F2}"/>
+                <a16:creationId xmlns:a16="http://schemas.microsoft.com/office/drawing/2014/main" id="{8C775853-97CB-4B6E-9D8D-61EBBCC00AC2}"/>
               </a:ext>
             </a:extLst>
           </p:cNvPr>
@@ -5633,7 +5633,7 @@
           <p:cNvPr id="2" name="">
             <a:extLst xmlns:a="http://schemas.openxmlformats.org/drawingml/2006/main">
               <a:ext uri="{FF2B5EF4-FFF2-40B4-BE49-F238E27FC236}">
-                <a16:creationId xmlns:a16="http://schemas.microsoft.com/office/drawing/2014/main" id="{3B9FE56D-23B5-4A98-9AC7-F47A7D838213}"/>
+                <a16:creationId xmlns:a16="http://schemas.microsoft.com/office/drawing/2014/main" id="{8A0820C5-90AF-419F-8BA9-A2AD6BFD626F}"/>
               </a:ext>
             </a:extLst>
           </p:cNvPr>
@@ -5699,7 +5699,7 @@
           <p:cNvPr id="3" name="">
             <a:extLst xmlns:a="http://schemas.openxmlformats.org/drawingml/2006/main">
               <a:ext uri="{FF2B5EF4-FFF2-40B4-BE49-F238E27FC236}">
-                <a16:creationId xmlns:a16="http://schemas.microsoft.com/office/drawing/2014/main" id="{A41C5172-A7A9-47BF-8724-F8CFA5B4CB29}"/>
+                <a16:creationId xmlns:a16="http://schemas.microsoft.com/office/drawing/2014/main" id="{7526C55D-C75C-4628-98F6-BCC8E4FBC440}"/>
               </a:ext>
             </a:extLst>
           </p:cNvPr>
@@ -5765,7 +5765,7 @@
           <p:cNvPr id="4" name="">
             <a:extLst xmlns:a="http://schemas.openxmlformats.org/drawingml/2006/main">
               <a:ext uri="{FF2B5EF4-FFF2-40B4-BE49-F238E27FC236}">
-                <a16:creationId xmlns:a16="http://schemas.microsoft.com/office/drawing/2014/main" id="{CE5307F0-F11F-41B5-BD01-AF465EBC88D7}"/>
+                <a16:creationId xmlns:a16="http://schemas.microsoft.com/office/drawing/2014/main" id="{0BC74D24-B8FC-40DD-91D5-35B441FEDEA2}"/>
               </a:ext>
             </a:extLst>
           </p:cNvPr>
@@ -5831,7 +5831,7 @@
           <p:cNvPr id="5" name="">
             <a:extLst xmlns:a="http://schemas.openxmlformats.org/drawingml/2006/main">
               <a:ext uri="{FF2B5EF4-FFF2-40B4-BE49-F238E27FC236}">
-                <a16:creationId xmlns:a16="http://schemas.microsoft.com/office/drawing/2014/main" id="{EBEAEF73-5885-4E33-AFC7-C1C7A6B2B5FB}"/>
+                <a16:creationId xmlns:a16="http://schemas.microsoft.com/office/drawing/2014/main" id="{2E3FD07A-4649-42A2-BA34-CE40D3FDC6BC}"/>
               </a:ext>
             </a:extLst>
           </p:cNvPr>
@@ -5841,7 +5841,7 @@
           <p:nvPr/>
         </p:nvPicPr>
         <p:blipFill>
-          <a:blip xmlns:r="http://schemas.openxmlformats.org/officeDocument/2006/relationships" xmlns:a="http://schemas.openxmlformats.org/drawingml/2006/main" r:embed="R6b53e39edb91492e"/>
+          <a:blip xmlns:r="http://schemas.openxmlformats.org/officeDocument/2006/relationships" xmlns:a="http://schemas.openxmlformats.org/drawingml/2006/main" r:embed="R5441e4d06826401b"/>
           <a:stretch xmlns:a="http://schemas.openxmlformats.org/drawingml/2006/main"/>
         </p:blipFill>
         <p:spPr>
@@ -5859,7 +5859,7 @@
           <p:cNvPr id="6" name="">
             <a:extLst xmlns:a="http://schemas.openxmlformats.org/drawingml/2006/main">
               <a:ext uri="{FF2B5EF4-FFF2-40B4-BE49-F238E27FC236}">
-                <a16:creationId xmlns:a16="http://schemas.microsoft.com/office/drawing/2014/main" id="{5CEBC2EB-F1BF-4285-8657-3D4509D0282C}"/>
+                <a16:creationId xmlns:a16="http://schemas.microsoft.com/office/drawing/2014/main" id="{CF6AB562-8CEF-4466-86E0-77F3DE949322}"/>
               </a:ext>
             </a:extLst>
           </p:cNvPr>
@@ -6035,7 +6035,7 @@
     </p:spTree>
     <p:extLst>
       <p:ext uri="{BB962C8B-B14F-4D97-AF65-F5344CB8AC3E}">
-        <p14:creationId xmlns:p14="http://schemas.microsoft.com/office/powerpoint/2010/main" val="2110020772"/>
+        <p14:creationId xmlns:p14="http://schemas.microsoft.com/office/powerpoint/2010/main" val="1444049765"/>
       </p:ext>
     </p:extLst>
   </p:cSld>
@@ -6066,7 +6066,7 @@
           <p:cNvPr id="13" name="">
             <a:extLst xmlns:a="http://schemas.openxmlformats.org/drawingml/2006/main">
               <a:ext uri="{FF2B5EF4-FFF2-40B4-BE49-F238E27FC236}">
-                <a16:creationId xmlns:a16="http://schemas.microsoft.com/office/drawing/2014/main" id="{A346D2F1-EBDC-473B-9E36-30F264A6853F}"/>
+                <a16:creationId xmlns:a16="http://schemas.microsoft.com/office/drawing/2014/main" id="{DFF03A49-C633-41A1-B583-1AB75E2F4A4B}"/>
               </a:ext>
             </a:extLst>
           </p:cNvPr>
@@ -6132,7 +6132,7 @@
           <p:cNvPr id="2" name="">
             <a:extLst xmlns:a="http://schemas.openxmlformats.org/drawingml/2006/main">
               <a:ext uri="{FF2B5EF4-FFF2-40B4-BE49-F238E27FC236}">
-                <a16:creationId xmlns:a16="http://schemas.microsoft.com/office/drawing/2014/main" id="{7220451A-DA55-4D07-A0CD-8D0AFB015276}"/>
+                <a16:creationId xmlns:a16="http://schemas.microsoft.com/office/drawing/2014/main" id="{0432EE22-0C45-48E3-AB9D-2FE8B2E45AA6}"/>
               </a:ext>
             </a:extLst>
           </p:cNvPr>
@@ -6198,7 +6198,7 @@
           <p:cNvPr id="3" name="">
             <a:extLst xmlns:a="http://schemas.openxmlformats.org/drawingml/2006/main">
               <a:ext uri="{FF2B5EF4-FFF2-40B4-BE49-F238E27FC236}">
-                <a16:creationId xmlns:a16="http://schemas.microsoft.com/office/drawing/2014/main" id="{1680548F-710B-4AE9-A42A-368811346F91}"/>
+                <a16:creationId xmlns:a16="http://schemas.microsoft.com/office/drawing/2014/main" id="{787F7393-8CED-48DF-82E9-142C23844AD1}"/>
               </a:ext>
             </a:extLst>
           </p:cNvPr>
@@ -6264,7 +6264,7 @@
           <p:cNvPr id="4" name="">
             <a:extLst xmlns:a="http://schemas.openxmlformats.org/drawingml/2006/main">
               <a:ext uri="{FF2B5EF4-FFF2-40B4-BE49-F238E27FC236}">
-                <a16:creationId xmlns:a16="http://schemas.microsoft.com/office/drawing/2014/main" id="{6B04CD3B-A29D-4B49-9732-D33CE3879ACC}"/>
+                <a16:creationId xmlns:a16="http://schemas.microsoft.com/office/drawing/2014/main" id="{6A3F5DCF-CB79-41F0-A4B7-25BDA395D37A}"/>
               </a:ext>
             </a:extLst>
           </p:cNvPr>
@@ -6330,7 +6330,7 @@
           <p:cNvPr id="5" name="">
             <a:extLst xmlns:a="http://schemas.openxmlformats.org/drawingml/2006/main">
               <a:ext uri="{FF2B5EF4-FFF2-40B4-BE49-F238E27FC236}">
-                <a16:creationId xmlns:a16="http://schemas.microsoft.com/office/drawing/2014/main" id="{289EF506-8BE0-43A2-A063-9D36971C7C1E}"/>
+                <a16:creationId xmlns:a16="http://schemas.microsoft.com/office/drawing/2014/main" id="{119EDCD0-FED0-4B38-9E9A-A4DC74657D29}"/>
               </a:ext>
             </a:extLst>
           </p:cNvPr>
@@ -6396,7 +6396,7 @@
           <p:cNvPr id="6" name="">
             <a:extLst xmlns:a="http://schemas.openxmlformats.org/drawingml/2006/main">
               <a:ext uri="{FF2B5EF4-FFF2-40B4-BE49-F238E27FC236}">
-                <a16:creationId xmlns:a16="http://schemas.microsoft.com/office/drawing/2014/main" id="{6280D198-AC57-46E2-B744-909EA24B3832}"/>
+                <a16:creationId xmlns:a16="http://schemas.microsoft.com/office/drawing/2014/main" id="{8D0488E6-A674-4268-B1B8-01489369D47C}"/>
               </a:ext>
             </a:extLst>
           </p:cNvPr>
@@ -6462,7 +6462,7 @@
           <p:cNvPr id="7" name="">
             <a:extLst xmlns:a="http://schemas.openxmlformats.org/drawingml/2006/main">
               <a:ext uri="{FF2B5EF4-FFF2-40B4-BE49-F238E27FC236}">
-                <a16:creationId xmlns:a16="http://schemas.microsoft.com/office/drawing/2014/main" id="{8CBE901F-F3AE-4753-9756-1A2BFE1EF924}"/>
+                <a16:creationId xmlns:a16="http://schemas.microsoft.com/office/drawing/2014/main" id="{4C35A903-4901-4E00-95FB-9D370A37B864}"/>
               </a:ext>
             </a:extLst>
           </p:cNvPr>
@@ -6528,7 +6528,7 @@
           <p:cNvPr id="8" name="">
             <a:extLst xmlns:a="http://schemas.openxmlformats.org/drawingml/2006/main">
               <a:ext uri="{FF2B5EF4-FFF2-40B4-BE49-F238E27FC236}">
-                <a16:creationId xmlns:a16="http://schemas.microsoft.com/office/drawing/2014/main" id="{4AEBAD44-6818-42F8-8AB5-DD61605F9B6B}"/>
+                <a16:creationId xmlns:a16="http://schemas.microsoft.com/office/drawing/2014/main" id="{2E6C1082-3FA2-4EC6-80B1-32A17866428C}"/>
               </a:ext>
             </a:extLst>
           </p:cNvPr>
@@ -6594,7 +6594,7 @@
           <p:cNvPr id="9" name="">
             <a:extLst xmlns:a="http://schemas.openxmlformats.org/drawingml/2006/main">
               <a:ext uri="{FF2B5EF4-FFF2-40B4-BE49-F238E27FC236}">
-                <a16:creationId xmlns:a16="http://schemas.microsoft.com/office/drawing/2014/main" id="{FD460BD7-6F6B-4328-B6CB-513B179D4FE3}"/>
+                <a16:creationId xmlns:a16="http://schemas.microsoft.com/office/drawing/2014/main" id="{D43D48DF-F6D9-4559-928A-92A50B62C17D}"/>
               </a:ext>
             </a:extLst>
           </p:cNvPr>
@@ -6660,7 +6660,7 @@
           <p:cNvPr id="10" name="">
             <a:extLst xmlns:a="http://schemas.openxmlformats.org/drawingml/2006/main">
               <a:ext uri="{FF2B5EF4-FFF2-40B4-BE49-F238E27FC236}">
-                <a16:creationId xmlns:a16="http://schemas.microsoft.com/office/drawing/2014/main" id="{746DBF9F-3300-48C0-B384-9BCE1EAAF471}"/>
+                <a16:creationId xmlns:a16="http://schemas.microsoft.com/office/drawing/2014/main" id="{087402F6-A3BC-4AFD-A614-E75E55844759}"/>
               </a:ext>
             </a:extLst>
           </p:cNvPr>
@@ -6726,7 +6726,7 @@
           <p:cNvPr id="11" name="">
             <a:extLst xmlns:a="http://schemas.openxmlformats.org/drawingml/2006/main">
               <a:ext uri="{FF2B5EF4-FFF2-40B4-BE49-F238E27FC236}">
-                <a16:creationId xmlns:a16="http://schemas.microsoft.com/office/drawing/2014/main" id="{48E8DAAD-8711-4582-B510-B4534758B7DA}"/>
+                <a16:creationId xmlns:a16="http://schemas.microsoft.com/office/drawing/2014/main" id="{EC34402A-E6DA-4606-BF13-F58959225174}"/>
               </a:ext>
             </a:extLst>
           </p:cNvPr>
@@ -6792,7 +6792,7 @@
           <p:cNvPr id="12" name="">
             <a:extLst xmlns:a="http://schemas.openxmlformats.org/drawingml/2006/main">
               <a:ext uri="{FF2B5EF4-FFF2-40B4-BE49-F238E27FC236}">
-                <a16:creationId xmlns:a16="http://schemas.microsoft.com/office/drawing/2014/main" id="{A976BEF3-7FD6-47B0-944A-23A48CA90F90}"/>
+                <a16:creationId xmlns:a16="http://schemas.microsoft.com/office/drawing/2014/main" id="{6B3DBC32-354D-40F8-A7FC-30E63637C00B}"/>
               </a:ext>
             </a:extLst>
           </p:cNvPr>
@@ -6856,7 +6856,7 @@
     </p:spTree>
     <p:extLst>
       <p:ext uri="{BB962C8B-B14F-4D97-AF65-F5344CB8AC3E}">
-        <p14:creationId xmlns:p14="http://schemas.microsoft.com/office/powerpoint/2010/main" val="1701341541"/>
+        <p14:creationId xmlns:p14="http://schemas.microsoft.com/office/powerpoint/2010/main" val="1595144439"/>
       </p:ext>
     </p:extLst>
   </p:cSld>
@@ -6887,7 +6887,7 @@
           <p:cNvPr id="7" name="">
             <a:extLst xmlns:a="http://schemas.openxmlformats.org/drawingml/2006/main">
               <a:ext uri="{FF2B5EF4-FFF2-40B4-BE49-F238E27FC236}">
-                <a16:creationId xmlns:a16="http://schemas.microsoft.com/office/drawing/2014/main" id="{B982E21F-4980-45EE-94DB-DB7DE0E4108C}"/>
+                <a16:creationId xmlns:a16="http://schemas.microsoft.com/office/drawing/2014/main" id="{E89C330A-10E7-4B56-8826-2213918A706A}"/>
               </a:ext>
             </a:extLst>
           </p:cNvPr>
@@ -6953,7 +6953,7 @@
           <p:cNvPr id="2" name="">
             <a:extLst xmlns:a="http://schemas.openxmlformats.org/drawingml/2006/main">
               <a:ext uri="{FF2B5EF4-FFF2-40B4-BE49-F238E27FC236}">
-                <a16:creationId xmlns:a16="http://schemas.microsoft.com/office/drawing/2014/main" id="{CAC24CE4-AFFF-4CCC-B12D-61F46D5625DF}"/>
+                <a16:creationId xmlns:a16="http://schemas.microsoft.com/office/drawing/2014/main" id="{A87BC61A-2081-485C-B627-5250B6BF5D90}"/>
               </a:ext>
             </a:extLst>
           </p:cNvPr>
@@ -7019,7 +7019,7 @@
           <p:cNvPr id="3" name="">
             <a:extLst xmlns:a="http://schemas.openxmlformats.org/drawingml/2006/main">
               <a:ext uri="{FF2B5EF4-FFF2-40B4-BE49-F238E27FC236}">
-                <a16:creationId xmlns:a16="http://schemas.microsoft.com/office/drawing/2014/main" id="{8281FE29-0C4B-4B95-B015-E44FC92C7882}"/>
+                <a16:creationId xmlns:a16="http://schemas.microsoft.com/office/drawing/2014/main" id="{B3FD5A8C-4770-4AE6-9EB5-5D75E8EC5564}"/>
               </a:ext>
             </a:extLst>
           </p:cNvPr>
@@ -7085,7 +7085,7 @@
           <p:cNvPr id="4" name="">
             <a:extLst xmlns:a="http://schemas.openxmlformats.org/drawingml/2006/main">
               <a:ext uri="{FF2B5EF4-FFF2-40B4-BE49-F238E27FC236}">
-                <a16:creationId xmlns:a16="http://schemas.microsoft.com/office/drawing/2014/main" id="{A3AF94FE-A780-40C2-9BD3-17666A6552D7}"/>
+                <a16:creationId xmlns:a16="http://schemas.microsoft.com/office/drawing/2014/main" id="{68EA55A0-DCF9-44CA-83F0-4D59E0EB609A}"/>
               </a:ext>
             </a:extLst>
           </p:cNvPr>
@@ -7151,7 +7151,7 @@
           <p:cNvPr id="5" name="">
             <a:extLst xmlns:a="http://schemas.openxmlformats.org/drawingml/2006/main">
               <a:ext uri="{FF2B5EF4-FFF2-40B4-BE49-F238E27FC236}">
-                <a16:creationId xmlns:a16="http://schemas.microsoft.com/office/drawing/2014/main" id="{E561092D-DB50-4A05-9493-3322324DBA36}"/>
+                <a16:creationId xmlns:a16="http://schemas.microsoft.com/office/drawing/2014/main" id="{5C15AB6B-84D6-4825-9AA7-AD8706FAB11E}"/>
               </a:ext>
             </a:extLst>
           </p:cNvPr>
@@ -7849,7 +7849,7 @@
           <p:cNvPr id="6" name="">
             <a:extLst xmlns:a="http://schemas.openxmlformats.org/drawingml/2006/main">
               <a:ext uri="{FF2B5EF4-FFF2-40B4-BE49-F238E27FC236}">
-                <a16:creationId xmlns:a16="http://schemas.microsoft.com/office/drawing/2014/main" id="{5B94FF71-575E-48C3-99F4-81993E61E972}"/>
+                <a16:creationId xmlns:a16="http://schemas.microsoft.com/office/drawing/2014/main" id="{0FF34829-377D-44F8-96DA-F6AB16421EDD}"/>
               </a:ext>
             </a:extLst>
           </p:cNvPr>
@@ -7913,7 +7913,7 @@
     </p:spTree>
     <p:extLst>
       <p:ext uri="{BB962C8B-B14F-4D97-AF65-F5344CB8AC3E}">
-        <p14:creationId xmlns:p14="http://schemas.microsoft.com/office/powerpoint/2010/main" val="165124130"/>
+        <p14:creationId xmlns:p14="http://schemas.microsoft.com/office/powerpoint/2010/main" val="1571530152"/>
       </p:ext>
     </p:extLst>
   </p:cSld>
@@ -7944,7 +7944,7 @@
           <p:cNvPr id="12" name="">
             <a:extLst xmlns:a="http://schemas.openxmlformats.org/drawingml/2006/main">
               <a:ext uri="{FF2B5EF4-FFF2-40B4-BE49-F238E27FC236}">
-                <a16:creationId xmlns:a16="http://schemas.microsoft.com/office/drawing/2014/main" id="{39EDD26C-B616-4795-B82C-846AD4AECEEA}"/>
+                <a16:creationId xmlns:a16="http://schemas.microsoft.com/office/drawing/2014/main" id="{37C72842-50A2-4892-93E7-373C9D03C855}"/>
               </a:ext>
             </a:extLst>
           </p:cNvPr>
@@ -8010,7 +8010,7 @@
           <p:cNvPr id="2" name="">
             <a:extLst xmlns:a="http://schemas.openxmlformats.org/drawingml/2006/main">
               <a:ext uri="{FF2B5EF4-FFF2-40B4-BE49-F238E27FC236}">
-                <a16:creationId xmlns:a16="http://schemas.microsoft.com/office/drawing/2014/main" id="{8C5F6484-0C44-4462-A196-8BA42C2EEA87}"/>
+                <a16:creationId xmlns:a16="http://schemas.microsoft.com/office/drawing/2014/main" id="{30DBFB3F-E9F2-409E-9D68-DCBC8F945877}"/>
               </a:ext>
             </a:extLst>
           </p:cNvPr>
@@ -8076,7 +8076,7 @@
           <p:cNvPr id="3" name="">
             <a:extLst xmlns:a="http://schemas.openxmlformats.org/drawingml/2006/main">
               <a:ext uri="{FF2B5EF4-FFF2-40B4-BE49-F238E27FC236}">
-                <a16:creationId xmlns:a16="http://schemas.microsoft.com/office/drawing/2014/main" id="{8C068DA1-11A9-4EE6-8DD8-B10CC00D706E}"/>
+                <a16:creationId xmlns:a16="http://schemas.microsoft.com/office/drawing/2014/main" id="{BE2E6FA8-1FA1-4C42-9B1C-74A74307F696}"/>
               </a:ext>
             </a:extLst>
           </p:cNvPr>
@@ -8142,7 +8142,7 @@
           <p:cNvPr id="4" name="">
             <a:extLst xmlns:a="http://schemas.openxmlformats.org/drawingml/2006/main">
               <a:ext uri="{FF2B5EF4-FFF2-40B4-BE49-F238E27FC236}">
-                <a16:creationId xmlns:a16="http://schemas.microsoft.com/office/drawing/2014/main" id="{D0278FA4-FD90-41F2-81B3-AAA6BBF419D0}"/>
+                <a16:creationId xmlns:a16="http://schemas.microsoft.com/office/drawing/2014/main" id="{23816DBF-1127-4E4E-8ED1-078CE06ED40B}"/>
               </a:ext>
             </a:extLst>
           </p:cNvPr>
@@ -8208,7 +8208,7 @@
           <p:cNvPr id="5" name="">
             <a:extLst xmlns:a="http://schemas.openxmlformats.org/drawingml/2006/main">
               <a:ext uri="{FF2B5EF4-FFF2-40B4-BE49-F238E27FC236}">
-                <a16:creationId xmlns:a16="http://schemas.microsoft.com/office/drawing/2014/main" id="{5A9454A6-2193-45AF-848F-41C6A907100E}"/>
+                <a16:creationId xmlns:a16="http://schemas.microsoft.com/office/drawing/2014/main" id="{BA4B3F65-834E-413B-B568-E7B63F4DEA42}"/>
               </a:ext>
             </a:extLst>
           </p:cNvPr>
@@ -8274,7 +8274,7 @@
           <p:cNvPr id="6" name="">
             <a:extLst xmlns:a="http://schemas.openxmlformats.org/drawingml/2006/main">
               <a:ext uri="{FF2B5EF4-FFF2-40B4-BE49-F238E27FC236}">
-                <a16:creationId xmlns:a16="http://schemas.microsoft.com/office/drawing/2014/main" id="{EFB5573F-26AE-48DF-BB32-5674D3904871}"/>
+                <a16:creationId xmlns:a16="http://schemas.microsoft.com/office/drawing/2014/main" id="{A18BC4B3-6F6A-4909-97CA-3FF585A62C47}"/>
               </a:ext>
             </a:extLst>
           </p:cNvPr>
@@ -8340,7 +8340,7 @@
           <p:cNvPr id="7" name="">
             <a:extLst xmlns:a="http://schemas.openxmlformats.org/drawingml/2006/main">
               <a:ext uri="{FF2B5EF4-FFF2-40B4-BE49-F238E27FC236}">
-                <a16:creationId xmlns:a16="http://schemas.microsoft.com/office/drawing/2014/main" id="{0895C5D5-BB4F-44C0-B3AF-141EBCE83186}"/>
+                <a16:creationId xmlns:a16="http://schemas.microsoft.com/office/drawing/2014/main" id="{CAC895BF-3035-4A89-B305-806CD65963FB}"/>
               </a:ext>
             </a:extLst>
           </p:cNvPr>
@@ -8406,7 +8406,7 @@
           <p:cNvPr id="8" name="">
             <a:extLst xmlns:a="http://schemas.openxmlformats.org/drawingml/2006/main">
               <a:ext uri="{FF2B5EF4-FFF2-40B4-BE49-F238E27FC236}">
-                <a16:creationId xmlns:a16="http://schemas.microsoft.com/office/drawing/2014/main" id="{93AC1E00-7544-4E47-A075-2EADA441A82F}"/>
+                <a16:creationId xmlns:a16="http://schemas.microsoft.com/office/drawing/2014/main" id="{DA0D2AD1-4F7D-4C0E-9756-68D6FCE6ABCF}"/>
               </a:ext>
             </a:extLst>
           </p:cNvPr>
@@ -8472,7 +8472,7 @@
           <p:cNvPr id="9" name="">
             <a:extLst xmlns:a="http://schemas.openxmlformats.org/drawingml/2006/main">
               <a:ext uri="{FF2B5EF4-FFF2-40B4-BE49-F238E27FC236}">
-                <a16:creationId xmlns:a16="http://schemas.microsoft.com/office/drawing/2014/main" id="{CAD1925E-3E52-44DF-BD74-19923FF1140D}"/>
+                <a16:creationId xmlns:a16="http://schemas.microsoft.com/office/drawing/2014/main" id="{0634AFFB-9B0D-4FB2-BCFA-772B804801EF}"/>
               </a:ext>
             </a:extLst>
           </p:cNvPr>
@@ -8538,7 +8538,7 @@
           <p:cNvPr id="10" name="">
             <a:extLst xmlns:a="http://schemas.openxmlformats.org/drawingml/2006/main">
               <a:ext uri="{FF2B5EF4-FFF2-40B4-BE49-F238E27FC236}">
-                <a16:creationId xmlns:a16="http://schemas.microsoft.com/office/drawing/2014/main" id="{555C2F76-FDA9-4E2C-BC45-40D9186BDD85}"/>
+                <a16:creationId xmlns:a16="http://schemas.microsoft.com/office/drawing/2014/main" id="{DF2F7FFD-1466-4774-8A6B-9F4C60660CB8}"/>
               </a:ext>
             </a:extLst>
           </p:cNvPr>
@@ -8604,7 +8604,7 @@
           <p:cNvPr id="11" name="">
             <a:extLst xmlns:a="http://schemas.openxmlformats.org/drawingml/2006/main">
               <a:ext uri="{FF2B5EF4-FFF2-40B4-BE49-F238E27FC236}">
-                <a16:creationId xmlns:a16="http://schemas.microsoft.com/office/drawing/2014/main" id="{1704729A-30BA-4652-8854-64CF3E655230}"/>
+                <a16:creationId xmlns:a16="http://schemas.microsoft.com/office/drawing/2014/main" id="{06072862-851F-44FB-AA1E-D64FAD833A51}"/>
               </a:ext>
             </a:extLst>
           </p:cNvPr>
@@ -8691,7 +8691,7 @@
     </p:spTree>
     <p:extLst>
       <p:ext uri="{BB962C8B-B14F-4D97-AF65-F5344CB8AC3E}">
-        <p14:creationId xmlns:p14="http://schemas.microsoft.com/office/powerpoint/2010/main" val="683904136"/>
+        <p14:creationId xmlns:p14="http://schemas.microsoft.com/office/powerpoint/2010/main" val="1010739324"/>
       </p:ext>
     </p:extLst>
   </p:cSld>
@@ -8722,7 +8722,7 @@
           <p:cNvPr id="8" name="">
             <a:extLst xmlns:a="http://schemas.openxmlformats.org/drawingml/2006/main">
               <a:ext uri="{FF2B5EF4-FFF2-40B4-BE49-F238E27FC236}">
-                <a16:creationId xmlns:a16="http://schemas.microsoft.com/office/drawing/2014/main" id="{86CD7216-35E1-4780-BD9D-62078D67521B}"/>
+                <a16:creationId xmlns:a16="http://schemas.microsoft.com/office/drawing/2014/main" id="{5F75C5D9-8795-47E8-B8E1-B4F4E2EA9116}"/>
               </a:ext>
             </a:extLst>
           </p:cNvPr>
@@ -8788,7 +8788,7 @@
           <p:cNvPr id="2" name="">
             <a:extLst xmlns:a="http://schemas.openxmlformats.org/drawingml/2006/main">
               <a:ext uri="{FF2B5EF4-FFF2-40B4-BE49-F238E27FC236}">
-                <a16:creationId xmlns:a16="http://schemas.microsoft.com/office/drawing/2014/main" id="{EF96B717-FAD7-4A23-8F71-6CFA4C864BC4}"/>
+                <a16:creationId xmlns:a16="http://schemas.microsoft.com/office/drawing/2014/main" id="{FCC43C81-3ED7-4E94-9622-28B39AFC978A}"/>
               </a:ext>
             </a:extLst>
           </p:cNvPr>
@@ -8854,7 +8854,7 @@
           <p:cNvPr id="3" name="">
             <a:extLst xmlns:a="http://schemas.openxmlformats.org/drawingml/2006/main">
               <a:ext uri="{FF2B5EF4-FFF2-40B4-BE49-F238E27FC236}">
-                <a16:creationId xmlns:a16="http://schemas.microsoft.com/office/drawing/2014/main" id="{42231240-1252-4917-92BF-A5A29340E5C2}"/>
+                <a16:creationId xmlns:a16="http://schemas.microsoft.com/office/drawing/2014/main" id="{ABF26330-E5B2-4B36-A851-C81F633B0729}"/>
               </a:ext>
             </a:extLst>
           </p:cNvPr>
@@ -8920,7 +8920,7 @@
           <p:cNvPr id="4" name="">
             <a:extLst xmlns:a="http://schemas.openxmlformats.org/drawingml/2006/main">
               <a:ext uri="{FF2B5EF4-FFF2-40B4-BE49-F238E27FC236}">
-                <a16:creationId xmlns:a16="http://schemas.microsoft.com/office/drawing/2014/main" id="{BB3C7932-1AD1-4F3C-8973-A26E0AA6A892}"/>
+                <a16:creationId xmlns:a16="http://schemas.microsoft.com/office/drawing/2014/main" id="{17C82ED5-1D00-4E18-94CD-1F33E2E205E9}"/>
               </a:ext>
             </a:extLst>
           </p:cNvPr>
@@ -8986,7 +8986,7 @@
           <p:cNvPr id="5" name="">
             <a:extLst xmlns:a="http://schemas.openxmlformats.org/drawingml/2006/main">
               <a:ext uri="{FF2B5EF4-FFF2-40B4-BE49-F238E27FC236}">
-                <a16:creationId xmlns:a16="http://schemas.microsoft.com/office/drawing/2014/main" id="{DF3FA346-E453-435B-8C97-BF7A7E421F34}"/>
+                <a16:creationId xmlns:a16="http://schemas.microsoft.com/office/drawing/2014/main" id="{1EEDB10E-62B1-478F-B98E-5D8767AF1351}"/>
               </a:ext>
             </a:extLst>
           </p:cNvPr>
@@ -9324,7 +9324,7 @@
           <p:cNvPr id="6" name="">
             <a:extLst xmlns:a="http://schemas.openxmlformats.org/drawingml/2006/main">
               <a:ext uri="{FF2B5EF4-FFF2-40B4-BE49-F238E27FC236}">
-                <a16:creationId xmlns:a16="http://schemas.microsoft.com/office/drawing/2014/main" id="{7D5B8C17-9D6E-4D3A-9007-9F313CB34FEF}"/>
+                <a16:creationId xmlns:a16="http://schemas.microsoft.com/office/drawing/2014/main" id="{52B1193B-9709-4728-AE8E-F7575011A3D5}"/>
               </a:ext>
             </a:extLst>
           </p:cNvPr>
@@ -9390,7 +9390,7 @@
           <p:cNvPr id="7" name="">
             <a:extLst xmlns:a="http://schemas.openxmlformats.org/drawingml/2006/main">
               <a:ext uri="{FF2B5EF4-FFF2-40B4-BE49-F238E27FC236}">
-                <a16:creationId xmlns:a16="http://schemas.microsoft.com/office/drawing/2014/main" id="{CC3FF7D6-4E06-44F5-A2BC-631258ACA789}"/>
+                <a16:creationId xmlns:a16="http://schemas.microsoft.com/office/drawing/2014/main" id="{FE65C4FB-34F7-4095-BD1B-CD976CEBA85C}"/>
               </a:ext>
             </a:extLst>
           </p:cNvPr>
@@ -9454,7 +9454,7 @@
     </p:spTree>
     <p:extLst>
       <p:ext uri="{BB962C8B-B14F-4D97-AF65-F5344CB8AC3E}">
-        <p14:creationId xmlns:p14="http://schemas.microsoft.com/office/powerpoint/2010/main" val="517612899"/>
+        <p14:creationId xmlns:p14="http://schemas.microsoft.com/office/powerpoint/2010/main" val="1355623438"/>
       </p:ext>
     </p:extLst>
   </p:cSld>
@@ -9485,7 +9485,7 @@
           <p:cNvPr id="12" name="">
             <a:extLst xmlns:a="http://schemas.openxmlformats.org/drawingml/2006/main">
               <a:ext uri="{FF2B5EF4-FFF2-40B4-BE49-F238E27FC236}">
-                <a16:creationId xmlns:a16="http://schemas.microsoft.com/office/drawing/2014/main" id="{0D9AA5E4-3B4F-4FCC-9647-B5EE21D6FE1D}"/>
+                <a16:creationId xmlns:a16="http://schemas.microsoft.com/office/drawing/2014/main" id="{353B1A3A-A0E6-4039-A813-AB0D9FB28B3E}"/>
               </a:ext>
             </a:extLst>
           </p:cNvPr>
@@ -9551,7 +9551,7 @@
           <p:cNvPr id="2" name="">
             <a:extLst xmlns:a="http://schemas.openxmlformats.org/drawingml/2006/main">
               <a:ext uri="{FF2B5EF4-FFF2-40B4-BE49-F238E27FC236}">
-                <a16:creationId xmlns:a16="http://schemas.microsoft.com/office/drawing/2014/main" id="{59751387-FC36-4225-A48F-A01E2D1E5862}"/>
+                <a16:creationId xmlns:a16="http://schemas.microsoft.com/office/drawing/2014/main" id="{D604AD7B-9EAB-48AD-B31C-BDCA4672CB23}"/>
               </a:ext>
             </a:extLst>
           </p:cNvPr>
@@ -9607,7 +9607,7 @@
                 <a:ea typeface="Georgia"/>
                 <a:cs typeface="Georgia"/>
               </a:rPr>
-              <a:t>Cloud deployment plan</a:t>
+              <a:t>Cloud deployment</a:t>
             </a:r>
           </a:p>
         </p:txBody>
@@ -9617,7 +9617,7 @@
           <p:cNvPr id="3" name="">
             <a:extLst xmlns:a="http://schemas.openxmlformats.org/drawingml/2006/main">
               <a:ext uri="{FF2B5EF4-FFF2-40B4-BE49-F238E27FC236}">
-                <a16:creationId xmlns:a16="http://schemas.microsoft.com/office/drawing/2014/main" id="{4AA8A1E2-6545-4EE2-805E-AF8272B576AD}"/>
+                <a16:creationId xmlns:a16="http://schemas.microsoft.com/office/drawing/2014/main" id="{5255E50A-E22A-4CFB-BFC9-2DFB7CCC3DB7}"/>
               </a:ext>
             </a:extLst>
           </p:cNvPr>
@@ -9683,7 +9683,7 @@
           <p:cNvPr id="4" name="">
             <a:extLst xmlns:a="http://schemas.openxmlformats.org/drawingml/2006/main">
               <a:ext uri="{FF2B5EF4-FFF2-40B4-BE49-F238E27FC236}">
-                <a16:creationId xmlns:a16="http://schemas.microsoft.com/office/drawing/2014/main" id="{0E0463AD-07F3-4CC0-9CB3-377C64409A6D}"/>
+                <a16:creationId xmlns:a16="http://schemas.microsoft.com/office/drawing/2014/main" id="{8BB741FC-A07F-40D8-AD40-7593D8A67C7F}"/>
               </a:ext>
             </a:extLst>
           </p:cNvPr>
@@ -9749,7 +9749,7 @@
           <p:cNvPr id="5" name="">
             <a:extLst xmlns:a="http://schemas.openxmlformats.org/drawingml/2006/main">
               <a:ext uri="{FF2B5EF4-FFF2-40B4-BE49-F238E27FC236}">
-                <a16:creationId xmlns:a16="http://schemas.microsoft.com/office/drawing/2014/main" id="{0CF1CDC6-FFC0-494E-8EE4-2C2F66D4A805}"/>
+                <a16:creationId xmlns:a16="http://schemas.microsoft.com/office/drawing/2014/main" id="{EF3B05EF-3A26-4814-AD84-89ACBBA86846}"/>
               </a:ext>
             </a:extLst>
           </p:cNvPr>
@@ -9805,7 +9805,7 @@
                 <a:ea typeface="Arial"/>
                 <a:cs typeface="Arial"/>
               </a:rPr>
-              <a:t>Render web service + Neon PostgreSQL</a:t>
+              <a:t>Render Free + Neon PostgreSQL</a:t>
             </a:r>
           </a:p>
         </p:txBody>
@@ -9815,7 +9815,7 @@
           <p:cNvPr id="6" name="">
             <a:extLst xmlns:a="http://schemas.openxmlformats.org/drawingml/2006/main">
               <a:ext uri="{FF2B5EF4-FFF2-40B4-BE49-F238E27FC236}">
-                <a16:creationId xmlns:a16="http://schemas.microsoft.com/office/drawing/2014/main" id="{02FB5EEF-33A2-4DE7-9AA2-A97B05A02C8B}"/>
+                <a16:creationId xmlns:a16="http://schemas.microsoft.com/office/drawing/2014/main" id="{FBF13A5E-6A95-45ED-96B0-8B3CB9767829}"/>
               </a:ext>
             </a:extLst>
           </p:cNvPr>
@@ -9871,7 +9871,7 @@
                 <a:ea typeface="Arial"/>
                 <a:cs typeface="Arial"/>
               </a:rPr>
-              <a:t>Dockerfile, render.yaml and a PostgreSQL cloud profile are included.</a:t>
+              <a:t>Java Docker service and a persistent PostgreSQL database in Singapore.</a:t>
             </a:r>
           </a:p>
         </p:txBody>
@@ -9881,7 +9881,7 @@
           <p:cNvPr id="7" name="">
             <a:extLst xmlns:a="http://schemas.openxmlformats.org/drawingml/2006/main">
               <a:ext uri="{FF2B5EF4-FFF2-40B4-BE49-F238E27FC236}">
-                <a16:creationId xmlns:a16="http://schemas.microsoft.com/office/drawing/2014/main" id="{2F067613-5BCA-4D11-ACEF-767BDC76D73C}"/>
+                <a16:creationId xmlns:a16="http://schemas.microsoft.com/office/drawing/2014/main" id="{91712309-A384-4B57-8A70-FD3DF6E4F8BB}"/>
               </a:ext>
             </a:extLst>
           </p:cNvPr>
@@ -9937,7 +9937,7 @@
                 <a:ea typeface="Arial"/>
                 <a:cs typeface="Arial"/>
               </a:rPr>
-              <a:t>Private deployment configuration</a:t>
+              <a:t>Private administrator access</a:t>
             </a:r>
           </a:p>
         </p:txBody>
@@ -9947,7 +9947,7 @@
           <p:cNvPr id="8" name="">
             <a:extLst xmlns:a="http://schemas.openxmlformats.org/drawingml/2006/main">
               <a:ext uri="{FF2B5EF4-FFF2-40B4-BE49-F238E27FC236}">
-                <a16:creationId xmlns:a16="http://schemas.microsoft.com/office/drawing/2014/main" id="{5BCF72E0-C10D-4502-8CAF-158B08ED196A}"/>
+                <a16:creationId xmlns:a16="http://schemas.microsoft.com/office/drawing/2014/main" id="{A0F390AF-4DED-4DD1-96BF-1B5CFB5FC37D}"/>
               </a:ext>
             </a:extLst>
           </p:cNvPr>
@@ -10003,7 +10003,7 @@
                 <a:ea typeface="Arial"/>
                 <a:cs typeface="Arial"/>
               </a:rPr>
-              <a:t>Set database credentials and an initial admin through environment variables.</a:t>
+              <a:t>Use the configured admin email and private password. Local demo logins stay local.</a:t>
             </a:r>
           </a:p>
         </p:txBody>
@@ -10013,7 +10013,7 @@
           <p:cNvPr id="9" name="">
             <a:extLst xmlns:a="http://schemas.openxmlformats.org/drawingml/2006/main">
               <a:ext uri="{FF2B5EF4-FFF2-40B4-BE49-F238E27FC236}">
-                <a16:creationId xmlns:a16="http://schemas.microsoft.com/office/drawing/2014/main" id="{DE1CEB6D-7434-4CC7-B084-97A82CBA008B}"/>
+                <a16:creationId xmlns:a16="http://schemas.microsoft.com/office/drawing/2014/main" id="{598A8E44-C627-41E2-9C70-06DCF6B4EE9A}"/>
               </a:ext>
             </a:extLst>
           </p:cNvPr>
@@ -10069,7 +10069,7 @@
                 <a:ea typeface="Arial"/>
                 <a:cs typeface="Arial"/>
               </a:rPr>
-              <a:t>Current deployment status</a:t>
+              <a:t>Free hosting behavior</a:t>
             </a:r>
           </a:p>
         </p:txBody>
@@ -10079,7 +10079,7 @@
           <p:cNvPr id="10" name="">
             <a:extLst xmlns:a="http://schemas.openxmlformats.org/drawingml/2006/main">
               <a:ext uri="{FF2B5EF4-FFF2-40B4-BE49-F238E27FC236}">
-                <a16:creationId xmlns:a16="http://schemas.microsoft.com/office/drawing/2014/main" id="{35B0EFEF-4EDE-40A2-8968-0F03FE1C3AA5}"/>
+                <a16:creationId xmlns:a16="http://schemas.microsoft.com/office/drawing/2014/main" id="{B790AA26-A274-4220-A066-2F1F5EB9D9BE}"/>
               </a:ext>
             </a:extLst>
           </p:cNvPr>
@@ -10135,7 +10135,7 @@
                 <a:ea typeface="Arial"/>
                 <a:cs typeface="Arial"/>
               </a:rPr>
-              <a:t>Configuration is ready; provider setup and a live deployment are pending.</a:t>
+              <a:t>The service sleeps after inactivity. Allow 50 seconds or more for a cold start.</a:t>
             </a:r>
           </a:p>
         </p:txBody>
@@ -10145,7 +10145,7 @@
           <p:cNvPr id="11" name="">
             <a:extLst xmlns:a="http://schemas.openxmlformats.org/drawingml/2006/main">
               <a:ext uri="{FF2B5EF4-FFF2-40B4-BE49-F238E27FC236}">
-                <a16:creationId xmlns:a16="http://schemas.microsoft.com/office/drawing/2014/main" id="{55C66EE7-D273-4E6B-8A3D-3C80E81DEEA2}"/>
+                <a16:creationId xmlns:a16="http://schemas.microsoft.com/office/drawing/2014/main" id="{C72F0374-BA83-459E-92BA-4DDA43FA176A}"/>
               </a:ext>
             </a:extLst>
           </p:cNvPr>
@@ -10157,7 +10157,7 @@
         <p:spPr>
           <a:xfrm xmlns:a="http://schemas.openxmlformats.org/drawingml/2006/main">
             <a:off x="609600" y="5410200"/>
-            <a:ext cx="10477500" cy="457200"/>
+            <a:ext cx="10972800" cy="762000"/>
           </a:xfrm>
           <a:prstGeom xmlns:a="http://schemas.openxmlformats.org/drawingml/2006/main" prst="rect">
             <a:avLst/>
@@ -10201,7 +10201,7 @@
                 <a:ea typeface="Arial"/>
                 <a:cs typeface="Arial"/>
               </a:rPr>
-              <a:t>Live URL:</a:t>
+              <a:t>https://quiznova-muskanbuilds11.onrender.com</a:t>
             </a:r>
           </a:p>
         </p:txBody>
@@ -10209,7 +10209,7 @@
     </p:spTree>
     <p:extLst>
       <p:ext uri="{BB962C8B-B14F-4D97-AF65-F5344CB8AC3E}">
-        <p14:creationId xmlns:p14="http://schemas.microsoft.com/office/powerpoint/2010/main" val="272259728"/>
+        <p14:creationId xmlns:p14="http://schemas.microsoft.com/office/powerpoint/2010/main" val="1816796149"/>
       </p:ext>
     </p:extLst>
   </p:cSld>
@@ -10240,7 +10240,7 @@
           <p:cNvPr id="12" name="">
             <a:extLst xmlns:a="http://schemas.openxmlformats.org/drawingml/2006/main">
               <a:ext uri="{FF2B5EF4-FFF2-40B4-BE49-F238E27FC236}">
-                <a16:creationId xmlns:a16="http://schemas.microsoft.com/office/drawing/2014/main" id="{3F47EDBD-62AB-412A-8870-7D7D2D9FBF3F}"/>
+                <a16:creationId xmlns:a16="http://schemas.microsoft.com/office/drawing/2014/main" id="{7EC57283-04F4-4C30-BE70-BA11A57B90A6}"/>
               </a:ext>
             </a:extLst>
           </p:cNvPr>
@@ -10306,7 +10306,7 @@
           <p:cNvPr id="2" name="">
             <a:extLst xmlns:a="http://schemas.openxmlformats.org/drawingml/2006/main">
               <a:ext uri="{FF2B5EF4-FFF2-40B4-BE49-F238E27FC236}">
-                <a16:creationId xmlns:a16="http://schemas.microsoft.com/office/drawing/2014/main" id="{F939950D-8136-40C0-9FDE-96C63EFE0868}"/>
+                <a16:creationId xmlns:a16="http://schemas.microsoft.com/office/drawing/2014/main" id="{8ACCB7F6-3AF4-44AC-B7AE-96494731127A}"/>
               </a:ext>
             </a:extLst>
           </p:cNvPr>
@@ -10372,7 +10372,7 @@
           <p:cNvPr id="3" name="">
             <a:extLst xmlns:a="http://schemas.openxmlformats.org/drawingml/2006/main">
               <a:ext uri="{FF2B5EF4-FFF2-40B4-BE49-F238E27FC236}">
-                <a16:creationId xmlns:a16="http://schemas.microsoft.com/office/drawing/2014/main" id="{822B5EF6-2960-4682-B8C4-74D4EC986F47}"/>
+                <a16:creationId xmlns:a16="http://schemas.microsoft.com/office/drawing/2014/main" id="{894EC7DC-FFB1-416E-A887-903F680F8CF8}"/>
               </a:ext>
             </a:extLst>
           </p:cNvPr>
@@ -10438,7 +10438,7 @@
           <p:cNvPr id="4" name="">
             <a:extLst xmlns:a="http://schemas.openxmlformats.org/drawingml/2006/main">
               <a:ext uri="{FF2B5EF4-FFF2-40B4-BE49-F238E27FC236}">
-                <a16:creationId xmlns:a16="http://schemas.microsoft.com/office/drawing/2014/main" id="{709E6F6D-EDAF-4B25-B537-8DFE31202E8A}"/>
+                <a16:creationId xmlns:a16="http://schemas.microsoft.com/office/drawing/2014/main" id="{4354C36E-1640-43F9-9732-D245FC2BBEAD}"/>
               </a:ext>
             </a:extLst>
           </p:cNvPr>
@@ -10504,7 +10504,7 @@
           <p:cNvPr id="5" name="">
             <a:extLst xmlns:a="http://schemas.openxmlformats.org/drawingml/2006/main">
               <a:ext uri="{FF2B5EF4-FFF2-40B4-BE49-F238E27FC236}">
-                <a16:creationId xmlns:a16="http://schemas.microsoft.com/office/drawing/2014/main" id="{B27B707D-E8E6-41D6-93AE-B129FBBE2593}"/>
+                <a16:creationId xmlns:a16="http://schemas.microsoft.com/office/drawing/2014/main" id="{DEB32B90-5FB3-4FD5-87B6-B3F5C2BA3CC0}"/>
               </a:ext>
             </a:extLst>
           </p:cNvPr>
@@ -10570,7 +10570,7 @@
           <p:cNvPr id="6" name="">
             <a:extLst xmlns:a="http://schemas.openxmlformats.org/drawingml/2006/main">
               <a:ext uri="{FF2B5EF4-FFF2-40B4-BE49-F238E27FC236}">
-                <a16:creationId xmlns:a16="http://schemas.microsoft.com/office/drawing/2014/main" id="{DBDB057B-61B4-4CAE-B260-F4D058DB4043}"/>
+                <a16:creationId xmlns:a16="http://schemas.microsoft.com/office/drawing/2014/main" id="{A4F206D0-DE1C-4C72-9374-9EB289D12D82}"/>
               </a:ext>
             </a:extLst>
           </p:cNvPr>
@@ -10636,7 +10636,7 @@
           <p:cNvPr id="7" name="">
             <a:extLst xmlns:a="http://schemas.openxmlformats.org/drawingml/2006/main">
               <a:ext uri="{FF2B5EF4-FFF2-40B4-BE49-F238E27FC236}">
-                <a16:creationId xmlns:a16="http://schemas.microsoft.com/office/drawing/2014/main" id="{7ACB29D9-414A-4B30-817D-2B74EC2DAFAB}"/>
+                <a16:creationId xmlns:a16="http://schemas.microsoft.com/office/drawing/2014/main" id="{A5C53F2F-E025-49D6-BD47-A643397D8D94}"/>
               </a:ext>
             </a:extLst>
           </p:cNvPr>
@@ -10702,7 +10702,7 @@
           <p:cNvPr id="8" name="">
             <a:extLst xmlns:a="http://schemas.openxmlformats.org/drawingml/2006/main">
               <a:ext uri="{FF2B5EF4-FFF2-40B4-BE49-F238E27FC236}">
-                <a16:creationId xmlns:a16="http://schemas.microsoft.com/office/drawing/2014/main" id="{AD0590D6-416A-414E-B4CC-CBC2B27640E3}"/>
+                <a16:creationId xmlns:a16="http://schemas.microsoft.com/office/drawing/2014/main" id="{DF95FF0C-C56E-433D-80F6-9AE0F6E8419F}"/>
               </a:ext>
             </a:extLst>
           </p:cNvPr>
@@ -10768,7 +10768,7 @@
           <p:cNvPr id="9" name="">
             <a:extLst xmlns:a="http://schemas.openxmlformats.org/drawingml/2006/main">
               <a:ext uri="{FF2B5EF4-FFF2-40B4-BE49-F238E27FC236}">
-                <a16:creationId xmlns:a16="http://schemas.microsoft.com/office/drawing/2014/main" id="{71347DBD-DCB6-4D69-839C-F23BA1C6DD75}"/>
+                <a16:creationId xmlns:a16="http://schemas.microsoft.com/office/drawing/2014/main" id="{1D074E9E-F699-41F3-A6F3-B6C1C1BF3C66}"/>
               </a:ext>
             </a:extLst>
           </p:cNvPr>
@@ -10834,7 +10834,7 @@
           <p:cNvPr id="10" name="">
             <a:extLst xmlns:a="http://schemas.openxmlformats.org/drawingml/2006/main">
               <a:ext uri="{FF2B5EF4-FFF2-40B4-BE49-F238E27FC236}">
-                <a16:creationId xmlns:a16="http://schemas.microsoft.com/office/drawing/2014/main" id="{B4CBE94B-B12B-4545-8CD3-0D5EE401FA3B}"/>
+                <a16:creationId xmlns:a16="http://schemas.microsoft.com/office/drawing/2014/main" id="{A13A16E0-55F3-4011-B96C-8AB77708589A}"/>
               </a:ext>
             </a:extLst>
           </p:cNvPr>
@@ -10900,7 +10900,7 @@
           <p:cNvPr id="11" name="">
             <a:extLst xmlns:a="http://schemas.openxmlformats.org/drawingml/2006/main">
               <a:ext uri="{FF2B5EF4-FFF2-40B4-BE49-F238E27FC236}">
-                <a16:creationId xmlns:a16="http://schemas.microsoft.com/office/drawing/2014/main" id="{4489CA5A-90CD-4524-8EC7-2E0EE300BA2B}"/>
+                <a16:creationId xmlns:a16="http://schemas.microsoft.com/office/drawing/2014/main" id="{E36279AA-DDFB-4853-BEC0-B2D347BD2FED}"/>
               </a:ext>
             </a:extLst>
           </p:cNvPr>
@@ -10964,7 +10964,7 @@
     </p:spTree>
     <p:extLst>
       <p:ext uri="{BB962C8B-B14F-4D97-AF65-F5344CB8AC3E}">
-        <p14:creationId xmlns:p14="http://schemas.microsoft.com/office/powerpoint/2010/main" val="1687105784"/>
+        <p14:creationId xmlns:p14="http://schemas.microsoft.com/office/powerpoint/2010/main" val="1010940883"/>
       </p:ext>
     </p:extLst>
   </p:cSld>
@@ -10995,7 +10995,7 @@
           <p:cNvPr id="16" name="">
             <a:extLst xmlns:a="http://schemas.openxmlformats.org/drawingml/2006/main">
               <a:ext uri="{FF2B5EF4-FFF2-40B4-BE49-F238E27FC236}">
-                <a16:creationId xmlns:a16="http://schemas.microsoft.com/office/drawing/2014/main" id="{19701E96-7C63-4A11-9F0D-7DA94D7ECE7C}"/>
+                <a16:creationId xmlns:a16="http://schemas.microsoft.com/office/drawing/2014/main" id="{ECB4F049-E17E-4D9B-B10A-71F873B64778}"/>
               </a:ext>
             </a:extLst>
           </p:cNvPr>
@@ -11026,7 +11026,7 @@
           <p:cNvPr id="15" name="">
             <a:extLst xmlns:a="http://schemas.openxmlformats.org/drawingml/2006/main">
               <a:ext uri="{FF2B5EF4-FFF2-40B4-BE49-F238E27FC236}">
-                <a16:creationId xmlns:a16="http://schemas.microsoft.com/office/drawing/2014/main" id="{32239288-4B83-4065-A0C2-42E1B532C130}"/>
+                <a16:creationId xmlns:a16="http://schemas.microsoft.com/office/drawing/2014/main" id="{6F4F54C7-03A3-42FE-9760-5310A7BB06E8}"/>
               </a:ext>
             </a:extLst>
           </p:cNvPr>
@@ -11057,7 +11057,7 @@
           <p:cNvPr id="14" name="">
             <a:extLst xmlns:a="http://schemas.openxmlformats.org/drawingml/2006/main">
               <a:ext uri="{FF2B5EF4-FFF2-40B4-BE49-F238E27FC236}">
-                <a16:creationId xmlns:a16="http://schemas.microsoft.com/office/drawing/2014/main" id="{B36155F0-2135-41D5-A4F5-226582A40F56}"/>
+                <a16:creationId xmlns:a16="http://schemas.microsoft.com/office/drawing/2014/main" id="{7B12681F-59F1-4DA9-9F80-C83EEE2730D6}"/>
               </a:ext>
             </a:extLst>
           </p:cNvPr>
@@ -11088,7 +11088,7 @@
           <p:cNvPr id="13" name="">
             <a:extLst xmlns:a="http://schemas.openxmlformats.org/drawingml/2006/main">
               <a:ext uri="{FF2B5EF4-FFF2-40B4-BE49-F238E27FC236}">
-                <a16:creationId xmlns:a16="http://schemas.microsoft.com/office/drawing/2014/main" id="{A85DA14F-CD12-4A9A-9B64-7AE726621A8E}"/>
+                <a16:creationId xmlns:a16="http://schemas.microsoft.com/office/drawing/2014/main" id="{74C5D578-A436-4435-BF12-5C06C2F99872}"/>
               </a:ext>
             </a:extLst>
           </p:cNvPr>
@@ -11119,7 +11119,7 @@
           <p:cNvPr id="12" name="">
             <a:extLst xmlns:a="http://schemas.openxmlformats.org/drawingml/2006/main">
               <a:ext uri="{FF2B5EF4-FFF2-40B4-BE49-F238E27FC236}">
-                <a16:creationId xmlns:a16="http://schemas.microsoft.com/office/drawing/2014/main" id="{174048FD-FB74-40FD-9F89-892087EA813F}"/>
+                <a16:creationId xmlns:a16="http://schemas.microsoft.com/office/drawing/2014/main" id="{79E0937C-50E4-4F88-B570-6DD61F9A0082}"/>
               </a:ext>
             </a:extLst>
           </p:cNvPr>
@@ -11150,7 +11150,7 @@
           <p:cNvPr id="11" name="">
             <a:extLst xmlns:a="http://schemas.openxmlformats.org/drawingml/2006/main">
               <a:ext uri="{FF2B5EF4-FFF2-40B4-BE49-F238E27FC236}">
-                <a16:creationId xmlns:a16="http://schemas.microsoft.com/office/drawing/2014/main" id="{8B722F6E-7991-497D-BD55-9B6A66118419}"/>
+                <a16:creationId xmlns:a16="http://schemas.microsoft.com/office/drawing/2014/main" id="{6BE8A253-9342-4F24-A00E-B9428E032597}"/>
               </a:ext>
             </a:extLst>
           </p:cNvPr>
@@ -11181,7 +11181,7 @@
           <p:cNvPr id="17" name="">
             <a:extLst xmlns:a="http://schemas.openxmlformats.org/drawingml/2006/main">
               <a:ext uri="{FF2B5EF4-FFF2-40B4-BE49-F238E27FC236}">
-                <a16:creationId xmlns:a16="http://schemas.microsoft.com/office/drawing/2014/main" id="{9CA3B858-B337-4D55-8FB7-85BBD155B0D8}"/>
+                <a16:creationId xmlns:a16="http://schemas.microsoft.com/office/drawing/2014/main" id="{602E22E7-2571-4A88-9F7D-E69DB09718D3}"/>
               </a:ext>
             </a:extLst>
           </p:cNvPr>
@@ -11247,7 +11247,7 @@
           <p:cNvPr id="2" name="">
             <a:extLst xmlns:a="http://schemas.openxmlformats.org/drawingml/2006/main">
               <a:ext uri="{FF2B5EF4-FFF2-40B4-BE49-F238E27FC236}">
-                <a16:creationId xmlns:a16="http://schemas.microsoft.com/office/drawing/2014/main" id="{6E0B9825-909A-4119-8D91-316401588565}"/>
+                <a16:creationId xmlns:a16="http://schemas.microsoft.com/office/drawing/2014/main" id="{3467EA4E-6D4E-4D21-9B31-6AF1CB811A2B}"/>
               </a:ext>
             </a:extLst>
           </p:cNvPr>
@@ -11313,7 +11313,7 @@
           <p:cNvPr id="3" name="">
             <a:extLst xmlns:a="http://schemas.openxmlformats.org/drawingml/2006/main">
               <a:ext uri="{FF2B5EF4-FFF2-40B4-BE49-F238E27FC236}">
-                <a16:creationId xmlns:a16="http://schemas.microsoft.com/office/drawing/2014/main" id="{21A7DEA3-A69D-4531-BF71-622D89071D63}"/>
+                <a16:creationId xmlns:a16="http://schemas.microsoft.com/office/drawing/2014/main" id="{A09BAB1A-EA9F-43FE-A835-3E69340778AB}"/>
               </a:ext>
             </a:extLst>
           </p:cNvPr>
@@ -11379,7 +11379,7 @@
           <p:cNvPr id="4" name="">
             <a:extLst xmlns:a="http://schemas.openxmlformats.org/drawingml/2006/main">
               <a:ext uri="{FF2B5EF4-FFF2-40B4-BE49-F238E27FC236}">
-                <a16:creationId xmlns:a16="http://schemas.microsoft.com/office/drawing/2014/main" id="{4AB750B9-B491-4EE4-B124-F794735B87B9}"/>
+                <a16:creationId xmlns:a16="http://schemas.microsoft.com/office/drawing/2014/main" id="{68AA98C5-D54C-4DA0-989B-6B743BC81923}"/>
               </a:ext>
             </a:extLst>
           </p:cNvPr>
@@ -11445,7 +11445,7 @@
           <p:cNvPr id="5" name="">
             <a:extLst xmlns:a="http://schemas.openxmlformats.org/drawingml/2006/main">
               <a:ext uri="{FF2B5EF4-FFF2-40B4-BE49-F238E27FC236}">
-                <a16:creationId xmlns:a16="http://schemas.microsoft.com/office/drawing/2014/main" id="{4C084FA2-3B6C-43BF-B6DF-ECCB48157942}"/>
+                <a16:creationId xmlns:a16="http://schemas.microsoft.com/office/drawing/2014/main" id="{D2B7D90E-A96C-4A85-A324-D9B3F029C1AA}"/>
               </a:ext>
             </a:extLst>
           </p:cNvPr>
@@ -11538,7 +11538,7 @@
           <p:cNvPr id="6" name="">
             <a:extLst xmlns:a="http://schemas.openxmlformats.org/drawingml/2006/main">
               <a:ext uri="{FF2B5EF4-FFF2-40B4-BE49-F238E27FC236}">
-                <a16:creationId xmlns:a16="http://schemas.microsoft.com/office/drawing/2014/main" id="{D25E672B-960D-4581-B746-012C9C3DBA02}"/>
+                <a16:creationId xmlns:a16="http://schemas.microsoft.com/office/drawing/2014/main" id="{B4F3A3EE-A111-4FD2-9328-73B046A2BC4A}"/>
               </a:ext>
             </a:extLst>
           </p:cNvPr>
@@ -11631,7 +11631,7 @@
           <p:cNvPr id="7" name="">
             <a:extLst xmlns:a="http://schemas.openxmlformats.org/drawingml/2006/main">
               <a:ext uri="{FF2B5EF4-FFF2-40B4-BE49-F238E27FC236}">
-                <a16:creationId xmlns:a16="http://schemas.microsoft.com/office/drawing/2014/main" id="{831A7ED7-E60D-44BD-A5C7-233BF049F1B6}"/>
+                <a16:creationId xmlns:a16="http://schemas.microsoft.com/office/drawing/2014/main" id="{C743ED02-4B5D-448F-AA56-1F0595EC500A}"/>
               </a:ext>
             </a:extLst>
           </p:cNvPr>
@@ -11724,7 +11724,7 @@
           <p:cNvPr id="8" name="">
             <a:extLst xmlns:a="http://schemas.openxmlformats.org/drawingml/2006/main">
               <a:ext uri="{FF2B5EF4-FFF2-40B4-BE49-F238E27FC236}">
-                <a16:creationId xmlns:a16="http://schemas.microsoft.com/office/drawing/2014/main" id="{8DA79A66-9B3A-4958-8648-EE04B8E328D4}"/>
+                <a16:creationId xmlns:a16="http://schemas.microsoft.com/office/drawing/2014/main" id="{2EAB2326-1CBB-4CC9-94FC-C004F1C53E5F}"/>
               </a:ext>
             </a:extLst>
           </p:cNvPr>
@@ -11817,7 +11817,7 @@
           <p:cNvPr id="9" name="">
             <a:extLst xmlns:a="http://schemas.openxmlformats.org/drawingml/2006/main">
               <a:ext uri="{FF2B5EF4-FFF2-40B4-BE49-F238E27FC236}">
-                <a16:creationId xmlns:a16="http://schemas.microsoft.com/office/drawing/2014/main" id="{14D49347-4688-45E6-841C-E93BFB4C3731}"/>
+                <a16:creationId xmlns:a16="http://schemas.microsoft.com/office/drawing/2014/main" id="{FF453E35-237B-46CB-9FEF-D3F011665BF9}"/>
               </a:ext>
             </a:extLst>
           </p:cNvPr>
@@ -11910,7 +11910,7 @@
           <p:cNvPr id="10" name="">
             <a:extLst xmlns:a="http://schemas.openxmlformats.org/drawingml/2006/main">
               <a:ext uri="{FF2B5EF4-FFF2-40B4-BE49-F238E27FC236}">
-                <a16:creationId xmlns:a16="http://schemas.microsoft.com/office/drawing/2014/main" id="{951EAF6B-B18D-4227-87BB-D0CAB00A3CEC}"/>
+                <a16:creationId xmlns:a16="http://schemas.microsoft.com/office/drawing/2014/main" id="{2F0263F5-4356-4090-BA38-A212659F305E}"/>
               </a:ext>
             </a:extLst>
           </p:cNvPr>
@@ -12001,7 +12001,7 @@
     </p:spTree>
     <p:extLst>
       <p:ext uri="{BB962C8B-B14F-4D97-AF65-F5344CB8AC3E}">
-        <p14:creationId xmlns:p14="http://schemas.microsoft.com/office/powerpoint/2010/main" val="2102242652"/>
+        <p14:creationId xmlns:p14="http://schemas.microsoft.com/office/powerpoint/2010/main" val="1447635965"/>
       </p:ext>
     </p:extLst>
   </p:cSld>
@@ -12032,7 +12032,7 @@
           <p:cNvPr id="19" name="">
             <a:extLst xmlns:a="http://schemas.openxmlformats.org/drawingml/2006/main">
               <a:ext uri="{FF2B5EF4-FFF2-40B4-BE49-F238E27FC236}">
-                <a16:creationId xmlns:a16="http://schemas.microsoft.com/office/drawing/2014/main" id="{D652B94A-F07F-417D-AB02-6C5FE184A282}"/>
+                <a16:creationId xmlns:a16="http://schemas.microsoft.com/office/drawing/2014/main" id="{6BA5E1CF-3F43-4F54-8BA1-65566756C8CA}"/>
               </a:ext>
             </a:extLst>
           </p:cNvPr>
@@ -12063,7 +12063,7 @@
           <p:cNvPr id="18" name="">
             <a:extLst xmlns:a="http://schemas.openxmlformats.org/drawingml/2006/main">
               <a:ext uri="{FF2B5EF4-FFF2-40B4-BE49-F238E27FC236}">
-                <a16:creationId xmlns:a16="http://schemas.microsoft.com/office/drawing/2014/main" id="{020EAE63-9EF4-4515-B2C2-42FDD0E501DD}"/>
+                <a16:creationId xmlns:a16="http://schemas.microsoft.com/office/drawing/2014/main" id="{B5079D49-3A42-4328-BD73-22E1F71073C4}"/>
               </a:ext>
             </a:extLst>
           </p:cNvPr>
@@ -12094,7 +12094,7 @@
           <p:cNvPr id="17" name="">
             <a:extLst xmlns:a="http://schemas.openxmlformats.org/drawingml/2006/main">
               <a:ext uri="{FF2B5EF4-FFF2-40B4-BE49-F238E27FC236}">
-                <a16:creationId xmlns:a16="http://schemas.microsoft.com/office/drawing/2014/main" id="{A677AF46-0825-4063-97E9-104B307B042A}"/>
+                <a16:creationId xmlns:a16="http://schemas.microsoft.com/office/drawing/2014/main" id="{6C753D2C-760C-448B-A37C-E4F4ED1E6A9C}"/>
               </a:ext>
             </a:extLst>
           </p:cNvPr>
@@ -12125,7 +12125,7 @@
           <p:cNvPr id="16" name="">
             <a:extLst xmlns:a="http://schemas.openxmlformats.org/drawingml/2006/main">
               <a:ext uri="{FF2B5EF4-FFF2-40B4-BE49-F238E27FC236}">
-                <a16:creationId xmlns:a16="http://schemas.microsoft.com/office/drawing/2014/main" id="{1601B8A8-38B8-40BC-BB91-BBCA26B92B54}"/>
+                <a16:creationId xmlns:a16="http://schemas.microsoft.com/office/drawing/2014/main" id="{09B0F088-AC7C-4F13-A116-4543196AA5DF}"/>
               </a:ext>
             </a:extLst>
           </p:cNvPr>
@@ -12156,7 +12156,7 @@
           <p:cNvPr id="15" name="">
             <a:extLst xmlns:a="http://schemas.openxmlformats.org/drawingml/2006/main">
               <a:ext uri="{FF2B5EF4-FFF2-40B4-BE49-F238E27FC236}">
-                <a16:creationId xmlns:a16="http://schemas.microsoft.com/office/drawing/2014/main" id="{7451C75B-2C99-455F-98A7-6C0B415E1BFF}"/>
+                <a16:creationId xmlns:a16="http://schemas.microsoft.com/office/drawing/2014/main" id="{D9E11230-69F5-462A-9F30-177B6EFB80AF}"/>
               </a:ext>
             </a:extLst>
           </p:cNvPr>
@@ -12187,7 +12187,7 @@
           <p:cNvPr id="14" name="">
             <a:extLst xmlns:a="http://schemas.openxmlformats.org/drawingml/2006/main">
               <a:ext uri="{FF2B5EF4-FFF2-40B4-BE49-F238E27FC236}">
-                <a16:creationId xmlns:a16="http://schemas.microsoft.com/office/drawing/2014/main" id="{CF9426D3-3858-461B-8870-6866E8282DDB}"/>
+                <a16:creationId xmlns:a16="http://schemas.microsoft.com/office/drawing/2014/main" id="{59A919F6-AC5F-4930-B17C-B79265BC2575}"/>
               </a:ext>
             </a:extLst>
           </p:cNvPr>
@@ -12218,7 +12218,7 @@
           <p:cNvPr id="13" name="">
             <a:extLst xmlns:a="http://schemas.openxmlformats.org/drawingml/2006/main">
               <a:ext uri="{FF2B5EF4-FFF2-40B4-BE49-F238E27FC236}">
-                <a16:creationId xmlns:a16="http://schemas.microsoft.com/office/drawing/2014/main" id="{1E07372F-C1AA-450D-BC9A-1DD340208AA0}"/>
+                <a16:creationId xmlns:a16="http://schemas.microsoft.com/office/drawing/2014/main" id="{026ACE20-F709-44DE-8C55-F138A28A1B1F}"/>
               </a:ext>
             </a:extLst>
           </p:cNvPr>
@@ -12249,7 +12249,7 @@
           <p:cNvPr id="21" name="">
             <a:extLst xmlns:a="http://schemas.openxmlformats.org/drawingml/2006/main">
               <a:ext uri="{FF2B5EF4-FFF2-40B4-BE49-F238E27FC236}">
-                <a16:creationId xmlns:a16="http://schemas.microsoft.com/office/drawing/2014/main" id="{4EF69A2E-5545-4811-9FED-ECFAE8A98251}"/>
+                <a16:creationId xmlns:a16="http://schemas.microsoft.com/office/drawing/2014/main" id="{7454FCB4-94FC-4549-BDE5-764E0DB74D48}"/>
               </a:ext>
             </a:extLst>
           </p:cNvPr>
@@ -12315,7 +12315,7 @@
           <p:cNvPr id="2" name="">
             <a:extLst xmlns:a="http://schemas.openxmlformats.org/drawingml/2006/main">
               <a:ext uri="{FF2B5EF4-FFF2-40B4-BE49-F238E27FC236}">
-                <a16:creationId xmlns:a16="http://schemas.microsoft.com/office/drawing/2014/main" id="{379B7D99-9DAE-44FA-97BF-09A243896C94}"/>
+                <a16:creationId xmlns:a16="http://schemas.microsoft.com/office/drawing/2014/main" id="{63A3E537-2BD0-42A4-80E5-FA901CCCB39F}"/>
               </a:ext>
             </a:extLst>
           </p:cNvPr>
@@ -12381,7 +12381,7 @@
           <p:cNvPr id="3" name="">
             <a:extLst xmlns:a="http://schemas.openxmlformats.org/drawingml/2006/main">
               <a:ext uri="{FF2B5EF4-FFF2-40B4-BE49-F238E27FC236}">
-                <a16:creationId xmlns:a16="http://schemas.microsoft.com/office/drawing/2014/main" id="{0DCB0A56-A821-44BE-A0EF-8265536F7BF6}"/>
+                <a16:creationId xmlns:a16="http://schemas.microsoft.com/office/drawing/2014/main" id="{C4736573-AC0D-4F66-A293-1E2B52F34008}"/>
               </a:ext>
             </a:extLst>
           </p:cNvPr>
@@ -12447,7 +12447,7 @@
           <p:cNvPr id="4" name="">
             <a:extLst xmlns:a="http://schemas.openxmlformats.org/drawingml/2006/main">
               <a:ext uri="{FF2B5EF4-FFF2-40B4-BE49-F238E27FC236}">
-                <a16:creationId xmlns:a16="http://schemas.microsoft.com/office/drawing/2014/main" id="{5DF6C542-0697-4C54-B3F2-AB073CB45190}"/>
+                <a16:creationId xmlns:a16="http://schemas.microsoft.com/office/drawing/2014/main" id="{D209E5D9-43E1-4ADA-AD1F-D11B0F1C5E5E}"/>
               </a:ext>
             </a:extLst>
           </p:cNvPr>
@@ -12513,7 +12513,7 @@
           <p:cNvPr id="5" name="">
             <a:extLst xmlns:a="http://schemas.openxmlformats.org/drawingml/2006/main">
               <a:ext uri="{FF2B5EF4-FFF2-40B4-BE49-F238E27FC236}">
-                <a16:creationId xmlns:a16="http://schemas.microsoft.com/office/drawing/2014/main" id="{266EC22D-2E4E-4C31-A6C1-1F8D0E7A8E3D}"/>
+                <a16:creationId xmlns:a16="http://schemas.microsoft.com/office/drawing/2014/main" id="{BCAB8A8E-11B0-4D42-B378-3624806E888D}"/>
               </a:ext>
             </a:extLst>
           </p:cNvPr>
@@ -12606,7 +12606,7 @@
           <p:cNvPr id="6" name="">
             <a:extLst xmlns:a="http://schemas.openxmlformats.org/drawingml/2006/main">
               <a:ext uri="{FF2B5EF4-FFF2-40B4-BE49-F238E27FC236}">
-                <a16:creationId xmlns:a16="http://schemas.microsoft.com/office/drawing/2014/main" id="{97730043-8E3D-452E-8CFD-C5B5E8A1A27E}"/>
+                <a16:creationId xmlns:a16="http://schemas.microsoft.com/office/drawing/2014/main" id="{8E8C970B-3EE1-4997-AB71-79AE7CAB1414}"/>
               </a:ext>
             </a:extLst>
           </p:cNvPr>
@@ -12699,7 +12699,7 @@
           <p:cNvPr id="7" name="">
             <a:extLst xmlns:a="http://schemas.openxmlformats.org/drawingml/2006/main">
               <a:ext uri="{FF2B5EF4-FFF2-40B4-BE49-F238E27FC236}">
-                <a16:creationId xmlns:a16="http://schemas.microsoft.com/office/drawing/2014/main" id="{6F6429F5-8037-45AB-8AAA-FC31A682D22E}"/>
+                <a16:creationId xmlns:a16="http://schemas.microsoft.com/office/drawing/2014/main" id="{0D8BC9A2-B405-40BE-B60E-0F2ED72608FD}"/>
               </a:ext>
             </a:extLst>
           </p:cNvPr>
@@ -12792,7 +12792,7 @@
           <p:cNvPr id="8" name="">
             <a:extLst xmlns:a="http://schemas.openxmlformats.org/drawingml/2006/main">
               <a:ext uri="{FF2B5EF4-FFF2-40B4-BE49-F238E27FC236}">
-                <a16:creationId xmlns:a16="http://schemas.microsoft.com/office/drawing/2014/main" id="{8D50A499-CC59-4008-852B-42C30A2DFC40}"/>
+                <a16:creationId xmlns:a16="http://schemas.microsoft.com/office/drawing/2014/main" id="{3CFA2E7A-57C5-47E0-9B3A-8FE351753904}"/>
               </a:ext>
             </a:extLst>
           </p:cNvPr>
@@ -12885,7 +12885,7 @@
           <p:cNvPr id="9" name="">
             <a:extLst xmlns:a="http://schemas.openxmlformats.org/drawingml/2006/main">
               <a:ext uri="{FF2B5EF4-FFF2-40B4-BE49-F238E27FC236}">
-                <a16:creationId xmlns:a16="http://schemas.microsoft.com/office/drawing/2014/main" id="{8C44B5FA-5FCF-4670-B998-87A8954E7368}"/>
+                <a16:creationId xmlns:a16="http://schemas.microsoft.com/office/drawing/2014/main" id="{D242F453-F958-4B5D-B682-F8EB2E144D08}"/>
               </a:ext>
             </a:extLst>
           </p:cNvPr>
@@ -12978,7 +12978,7 @@
           <p:cNvPr id="10" name="">
             <a:extLst xmlns:a="http://schemas.openxmlformats.org/drawingml/2006/main">
               <a:ext uri="{FF2B5EF4-FFF2-40B4-BE49-F238E27FC236}">
-                <a16:creationId xmlns:a16="http://schemas.microsoft.com/office/drawing/2014/main" id="{EE4C8D79-0AF6-48F3-A4EA-D831EAF5F352}"/>
+                <a16:creationId xmlns:a16="http://schemas.microsoft.com/office/drawing/2014/main" id="{B9517BF6-07C5-49D8-972D-D6E2F15B9139}"/>
               </a:ext>
             </a:extLst>
           </p:cNvPr>
@@ -13071,7 +13071,7 @@
           <p:cNvPr id="11" name="">
             <a:extLst xmlns:a="http://schemas.openxmlformats.org/drawingml/2006/main">
               <a:ext uri="{FF2B5EF4-FFF2-40B4-BE49-F238E27FC236}">
-                <a16:creationId xmlns:a16="http://schemas.microsoft.com/office/drawing/2014/main" id="{FB0351CC-CCC9-4176-9231-EAFAC2B77394}"/>
+                <a16:creationId xmlns:a16="http://schemas.microsoft.com/office/drawing/2014/main" id="{135BBA48-C2E7-4401-9AB8-0DB0B319F4CF}"/>
               </a:ext>
             </a:extLst>
           </p:cNvPr>
@@ -13164,7 +13164,7 @@
           <p:cNvPr id="12" name="">
             <a:extLst xmlns:a="http://schemas.openxmlformats.org/drawingml/2006/main">
               <a:ext uri="{FF2B5EF4-FFF2-40B4-BE49-F238E27FC236}">
-                <a16:creationId xmlns:a16="http://schemas.microsoft.com/office/drawing/2014/main" id="{57548EB2-D863-494B-A9BA-F2931C6603D8}"/>
+                <a16:creationId xmlns:a16="http://schemas.microsoft.com/office/drawing/2014/main" id="{FF74F7D6-3E9D-430B-BABE-178EB8B776F1}"/>
               </a:ext>
             </a:extLst>
           </p:cNvPr>
@@ -13257,7 +13257,7 @@
           <p:cNvPr id="20" name="">
             <a:extLst xmlns:a="http://schemas.openxmlformats.org/drawingml/2006/main">
               <a:ext uri="{FF2B5EF4-FFF2-40B4-BE49-F238E27FC236}">
-                <a16:creationId xmlns:a16="http://schemas.microsoft.com/office/drawing/2014/main" id="{52740842-A85B-4E31-BFD1-2AADB4F0904E}"/>
+                <a16:creationId xmlns:a16="http://schemas.microsoft.com/office/drawing/2014/main" id="{FD53EE6B-9943-4223-BACD-D02CF7253FAC}"/>
               </a:ext>
             </a:extLst>
           </p:cNvPr>
@@ -13321,7 +13321,7 @@
     </p:spTree>
     <p:extLst>
       <p:ext uri="{BB962C8B-B14F-4D97-AF65-F5344CB8AC3E}">
-        <p14:creationId xmlns:p14="http://schemas.microsoft.com/office/powerpoint/2010/main" val="1180085438"/>
+        <p14:creationId xmlns:p14="http://schemas.microsoft.com/office/powerpoint/2010/main" val="1725932056"/>
       </p:ext>
     </p:extLst>
   </p:cSld>
@@ -13352,7 +13352,7 @@
           <p:cNvPr id="11" name="">
             <a:extLst xmlns:a="http://schemas.openxmlformats.org/drawingml/2006/main">
               <a:ext uri="{FF2B5EF4-FFF2-40B4-BE49-F238E27FC236}">
-                <a16:creationId xmlns:a16="http://schemas.microsoft.com/office/drawing/2014/main" id="{E162586F-80AE-453F-8AA1-485E5D2F0D9C}"/>
+                <a16:creationId xmlns:a16="http://schemas.microsoft.com/office/drawing/2014/main" id="{04FAA4F7-692E-4FDF-A70B-B6654E42667E}"/>
               </a:ext>
             </a:extLst>
           </p:cNvPr>
@@ -13418,7 +13418,7 @@
           <p:cNvPr id="2" name="">
             <a:extLst xmlns:a="http://schemas.openxmlformats.org/drawingml/2006/main">
               <a:ext uri="{FF2B5EF4-FFF2-40B4-BE49-F238E27FC236}">
-                <a16:creationId xmlns:a16="http://schemas.microsoft.com/office/drawing/2014/main" id="{5B3F3543-228D-4690-8EFA-16399DC6AF08}"/>
+                <a16:creationId xmlns:a16="http://schemas.microsoft.com/office/drawing/2014/main" id="{D9602E98-87A2-4F8A-904F-87B8526C9C08}"/>
               </a:ext>
             </a:extLst>
           </p:cNvPr>
@@ -13484,7 +13484,7 @@
           <p:cNvPr id="3" name="">
             <a:extLst xmlns:a="http://schemas.openxmlformats.org/drawingml/2006/main">
               <a:ext uri="{FF2B5EF4-FFF2-40B4-BE49-F238E27FC236}">
-                <a16:creationId xmlns:a16="http://schemas.microsoft.com/office/drawing/2014/main" id="{CDE636E4-6E25-40AC-8B80-367EC4412942}"/>
+                <a16:creationId xmlns:a16="http://schemas.microsoft.com/office/drawing/2014/main" id="{69959912-4419-4072-9D35-9CC8615F2DF5}"/>
               </a:ext>
             </a:extLst>
           </p:cNvPr>
@@ -13550,7 +13550,7 @@
           <p:cNvPr id="4" name="">
             <a:extLst xmlns:a="http://schemas.openxmlformats.org/drawingml/2006/main">
               <a:ext uri="{FF2B5EF4-FFF2-40B4-BE49-F238E27FC236}">
-                <a16:creationId xmlns:a16="http://schemas.microsoft.com/office/drawing/2014/main" id="{2AEECD81-5D2D-4CD1-84C6-68034CBC3D14}"/>
+                <a16:creationId xmlns:a16="http://schemas.microsoft.com/office/drawing/2014/main" id="{96579A74-101A-4B74-A233-196D43C7AAB3}"/>
               </a:ext>
             </a:extLst>
           </p:cNvPr>
@@ -13616,7 +13616,7 @@
           <p:cNvPr id="5" name="">
             <a:extLst xmlns:a="http://schemas.openxmlformats.org/drawingml/2006/main">
               <a:ext uri="{FF2B5EF4-FFF2-40B4-BE49-F238E27FC236}">
-                <a16:creationId xmlns:a16="http://schemas.microsoft.com/office/drawing/2014/main" id="{6426AB8F-B17F-43C5-84F7-AF389958CE6B}"/>
+                <a16:creationId xmlns:a16="http://schemas.microsoft.com/office/drawing/2014/main" id="{028478D7-87CC-49DE-800A-F8CA7A20BBA4}"/>
               </a:ext>
             </a:extLst>
           </p:cNvPr>
@@ -13682,7 +13682,7 @@
           <p:cNvPr id="6" name="">
             <a:extLst xmlns:a="http://schemas.openxmlformats.org/drawingml/2006/main">
               <a:ext uri="{FF2B5EF4-FFF2-40B4-BE49-F238E27FC236}">
-                <a16:creationId xmlns:a16="http://schemas.microsoft.com/office/drawing/2014/main" id="{E254D9D9-2E15-4007-9982-1F4E84743014}"/>
+                <a16:creationId xmlns:a16="http://schemas.microsoft.com/office/drawing/2014/main" id="{AADDBC94-3497-4E3A-A3A7-F1E8B1009CC3}"/>
               </a:ext>
             </a:extLst>
           </p:cNvPr>
@@ -13799,7 +13799,7 @@
           <p:cNvPr id="7" name="">
             <a:extLst xmlns:a="http://schemas.openxmlformats.org/drawingml/2006/main">
               <a:ext uri="{FF2B5EF4-FFF2-40B4-BE49-F238E27FC236}">
-                <a16:creationId xmlns:a16="http://schemas.microsoft.com/office/drawing/2014/main" id="{182D24E6-6046-4FF6-A0B7-EA5E5E6AD91D}"/>
+                <a16:creationId xmlns:a16="http://schemas.microsoft.com/office/drawing/2014/main" id="{BDE66234-10D8-47EA-806E-A3F8E9BB9AA5}"/>
               </a:ext>
             </a:extLst>
           </p:cNvPr>
@@ -13865,7 +13865,7 @@
           <p:cNvPr id="8" name="">
             <a:extLst xmlns:a="http://schemas.openxmlformats.org/drawingml/2006/main">
               <a:ext uri="{FF2B5EF4-FFF2-40B4-BE49-F238E27FC236}">
-                <a16:creationId xmlns:a16="http://schemas.microsoft.com/office/drawing/2014/main" id="{1ED192CA-A5E0-406C-891F-2344AEEA686C}"/>
+                <a16:creationId xmlns:a16="http://schemas.microsoft.com/office/drawing/2014/main" id="{4041D0A9-E420-4ACC-BBA4-354AB23057F6}"/>
               </a:ext>
             </a:extLst>
           </p:cNvPr>
@@ -13931,7 +13931,7 @@
           <p:cNvPr id="9" name="">
             <a:extLst xmlns:a="http://schemas.openxmlformats.org/drawingml/2006/main">
               <a:ext uri="{FF2B5EF4-FFF2-40B4-BE49-F238E27FC236}">
-                <a16:creationId xmlns:a16="http://schemas.microsoft.com/office/drawing/2014/main" id="{C99DDC28-EB1D-4CB0-AB98-28C37836CB0D}"/>
+                <a16:creationId xmlns:a16="http://schemas.microsoft.com/office/drawing/2014/main" id="{E4A3684C-CD77-472B-900E-96F58D091750}"/>
               </a:ext>
             </a:extLst>
           </p:cNvPr>
@@ -13997,7 +13997,7 @@
           <p:cNvPr id="10" name="">
             <a:extLst xmlns:a="http://schemas.openxmlformats.org/drawingml/2006/main">
               <a:ext uri="{FF2B5EF4-FFF2-40B4-BE49-F238E27FC236}">
-                <a16:creationId xmlns:a16="http://schemas.microsoft.com/office/drawing/2014/main" id="{9C7BD024-90D2-4D70-BDD0-76BDE6FCE506}"/>
+                <a16:creationId xmlns:a16="http://schemas.microsoft.com/office/drawing/2014/main" id="{8DB7FA04-4113-465D-83FB-D7902712A2CB}"/>
               </a:ext>
             </a:extLst>
           </p:cNvPr>
@@ -14061,7 +14061,7 @@
     </p:spTree>
     <p:extLst>
       <p:ext uri="{BB962C8B-B14F-4D97-AF65-F5344CB8AC3E}">
-        <p14:creationId xmlns:p14="http://schemas.microsoft.com/office/powerpoint/2010/main" val="1682330557"/>
+        <p14:creationId xmlns:p14="http://schemas.microsoft.com/office/powerpoint/2010/main" val="1362913730"/>
       </p:ext>
     </p:extLst>
   </p:cSld>
@@ -14092,7 +14092,7 @@
           <p:cNvPr id="13" name="">
             <a:extLst xmlns:a="http://schemas.openxmlformats.org/drawingml/2006/main">
               <a:ext uri="{FF2B5EF4-FFF2-40B4-BE49-F238E27FC236}">
-                <a16:creationId xmlns:a16="http://schemas.microsoft.com/office/drawing/2014/main" id="{3C056264-DB1E-4EA1-A228-D56538DB657D}"/>
+                <a16:creationId xmlns:a16="http://schemas.microsoft.com/office/drawing/2014/main" id="{A9152D53-E42B-47BC-B5AC-531D09EB7C80}"/>
               </a:ext>
             </a:extLst>
           </p:cNvPr>
@@ -14158,7 +14158,7 @@
           <p:cNvPr id="2" name="">
             <a:extLst xmlns:a="http://schemas.openxmlformats.org/drawingml/2006/main">
               <a:ext uri="{FF2B5EF4-FFF2-40B4-BE49-F238E27FC236}">
-                <a16:creationId xmlns:a16="http://schemas.microsoft.com/office/drawing/2014/main" id="{E06D3084-E34B-4DE6-958E-F17C9AC891CD}"/>
+                <a16:creationId xmlns:a16="http://schemas.microsoft.com/office/drawing/2014/main" id="{D38FCB1A-5A26-49B7-AFAB-2BCEDEEFDC90}"/>
               </a:ext>
             </a:extLst>
           </p:cNvPr>
@@ -14224,7 +14224,7 @@
           <p:cNvPr id="3" name="">
             <a:extLst xmlns:a="http://schemas.openxmlformats.org/drawingml/2006/main">
               <a:ext uri="{FF2B5EF4-FFF2-40B4-BE49-F238E27FC236}">
-                <a16:creationId xmlns:a16="http://schemas.microsoft.com/office/drawing/2014/main" id="{737F4491-DDD8-4817-ADEA-619828C9BADB}"/>
+                <a16:creationId xmlns:a16="http://schemas.microsoft.com/office/drawing/2014/main" id="{ADE7BA50-47ED-46F1-9088-D5838E8EF046}"/>
               </a:ext>
             </a:extLst>
           </p:cNvPr>
@@ -14290,7 +14290,7 @@
           <p:cNvPr id="4" name="">
             <a:extLst xmlns:a="http://schemas.openxmlformats.org/drawingml/2006/main">
               <a:ext uri="{FF2B5EF4-FFF2-40B4-BE49-F238E27FC236}">
-                <a16:creationId xmlns:a16="http://schemas.microsoft.com/office/drawing/2014/main" id="{28784C21-7B3E-4F5A-B191-A13ED944E89B}"/>
+                <a16:creationId xmlns:a16="http://schemas.microsoft.com/office/drawing/2014/main" id="{70D79545-FDB3-4C6C-842A-7F1F3659D8D3}"/>
               </a:ext>
             </a:extLst>
           </p:cNvPr>
@@ -14356,7 +14356,7 @@
           <p:cNvPr id="5" name="">
             <a:extLst xmlns:a="http://schemas.openxmlformats.org/drawingml/2006/main">
               <a:ext uri="{FF2B5EF4-FFF2-40B4-BE49-F238E27FC236}">
-                <a16:creationId xmlns:a16="http://schemas.microsoft.com/office/drawing/2014/main" id="{B3918271-9A32-47B6-84A8-6D1C2DF30676}"/>
+                <a16:creationId xmlns:a16="http://schemas.microsoft.com/office/drawing/2014/main" id="{4202AC86-C4FD-4E6B-B2B1-961EADE48C03}"/>
               </a:ext>
             </a:extLst>
           </p:cNvPr>
@@ -14422,7 +14422,7 @@
           <p:cNvPr id="6" name="">
             <a:extLst xmlns:a="http://schemas.openxmlformats.org/drawingml/2006/main">
               <a:ext uri="{FF2B5EF4-FFF2-40B4-BE49-F238E27FC236}">
-                <a16:creationId xmlns:a16="http://schemas.microsoft.com/office/drawing/2014/main" id="{56E05986-3638-4F9B-A829-2ECE0818CDDA}"/>
+                <a16:creationId xmlns:a16="http://schemas.microsoft.com/office/drawing/2014/main" id="{5784319E-8B41-4FC3-9588-6C14F5669D0B}"/>
               </a:ext>
             </a:extLst>
           </p:cNvPr>
@@ -14488,7 +14488,7 @@
           <p:cNvPr id="7" name="">
             <a:extLst xmlns:a="http://schemas.openxmlformats.org/drawingml/2006/main">
               <a:ext uri="{FF2B5EF4-FFF2-40B4-BE49-F238E27FC236}">
-                <a16:creationId xmlns:a16="http://schemas.microsoft.com/office/drawing/2014/main" id="{DDE18EE1-9BD2-4186-BF92-BF3FC600C869}"/>
+                <a16:creationId xmlns:a16="http://schemas.microsoft.com/office/drawing/2014/main" id="{96B10287-BB84-4849-8BFF-F4B28BB3B576}"/>
               </a:ext>
             </a:extLst>
           </p:cNvPr>
@@ -14554,7 +14554,7 @@
           <p:cNvPr id="8" name="">
             <a:extLst xmlns:a="http://schemas.openxmlformats.org/drawingml/2006/main">
               <a:ext uri="{FF2B5EF4-FFF2-40B4-BE49-F238E27FC236}">
-                <a16:creationId xmlns:a16="http://schemas.microsoft.com/office/drawing/2014/main" id="{B4F998B1-4DD7-48FF-8A3C-6D47B8B69FDC}"/>
+                <a16:creationId xmlns:a16="http://schemas.microsoft.com/office/drawing/2014/main" id="{8044581C-657E-4431-8C59-AE7961169CD6}"/>
               </a:ext>
             </a:extLst>
           </p:cNvPr>
@@ -14620,7 +14620,7 @@
           <p:cNvPr id="9" name="">
             <a:extLst xmlns:a="http://schemas.openxmlformats.org/drawingml/2006/main">
               <a:ext uri="{FF2B5EF4-FFF2-40B4-BE49-F238E27FC236}">
-                <a16:creationId xmlns:a16="http://schemas.microsoft.com/office/drawing/2014/main" id="{5DAE2B9E-5C4A-466F-AAAD-C8153C136AD9}"/>
+                <a16:creationId xmlns:a16="http://schemas.microsoft.com/office/drawing/2014/main" id="{E98F18F9-F5A0-4DC9-8576-0207EDA353B1}"/>
               </a:ext>
             </a:extLst>
           </p:cNvPr>
@@ -14686,7 +14686,7 @@
           <p:cNvPr id="10" name="">
             <a:extLst xmlns:a="http://schemas.openxmlformats.org/drawingml/2006/main">
               <a:ext uri="{FF2B5EF4-FFF2-40B4-BE49-F238E27FC236}">
-                <a16:creationId xmlns:a16="http://schemas.microsoft.com/office/drawing/2014/main" id="{3C7E8BE7-8A0A-40D1-A1B7-FE5E1605F250}"/>
+                <a16:creationId xmlns:a16="http://schemas.microsoft.com/office/drawing/2014/main" id="{86E15C1F-995B-4E2D-A751-99A016DA17E9}"/>
               </a:ext>
             </a:extLst>
           </p:cNvPr>
@@ -14752,7 +14752,7 @@
           <p:cNvPr id="11" name="">
             <a:extLst xmlns:a="http://schemas.openxmlformats.org/drawingml/2006/main">
               <a:ext uri="{FF2B5EF4-FFF2-40B4-BE49-F238E27FC236}">
-                <a16:creationId xmlns:a16="http://schemas.microsoft.com/office/drawing/2014/main" id="{0592A34F-F893-4A6E-BA4B-E89EFA0F695A}"/>
+                <a16:creationId xmlns:a16="http://schemas.microsoft.com/office/drawing/2014/main" id="{D4E6FA61-0590-41F2-B9A6-0F7855F33ED5}"/>
               </a:ext>
             </a:extLst>
           </p:cNvPr>
@@ -14818,7 +14818,7 @@
           <p:cNvPr id="12" name="">
             <a:extLst xmlns:a="http://schemas.openxmlformats.org/drawingml/2006/main">
               <a:ext uri="{FF2B5EF4-FFF2-40B4-BE49-F238E27FC236}">
-                <a16:creationId xmlns:a16="http://schemas.microsoft.com/office/drawing/2014/main" id="{3D978AB2-1570-478D-B245-D66C66C09A5A}"/>
+                <a16:creationId xmlns:a16="http://schemas.microsoft.com/office/drawing/2014/main" id="{A71EDCCD-7AFD-43C0-B33B-8516E136614B}"/>
               </a:ext>
             </a:extLst>
           </p:cNvPr>
@@ -14882,7 +14882,7 @@
     </p:spTree>
     <p:extLst>
       <p:ext uri="{BB962C8B-B14F-4D97-AF65-F5344CB8AC3E}">
-        <p14:creationId xmlns:p14="http://schemas.microsoft.com/office/powerpoint/2010/main" val="495497854"/>
+        <p14:creationId xmlns:p14="http://schemas.microsoft.com/office/powerpoint/2010/main" val="1982180738"/>
       </p:ext>
     </p:extLst>
   </p:cSld>
@@ -14913,7 +14913,7 @@
           <p:cNvPr id="8" name="">
             <a:extLst xmlns:a="http://schemas.openxmlformats.org/drawingml/2006/main">
               <a:ext uri="{FF2B5EF4-FFF2-40B4-BE49-F238E27FC236}">
-                <a16:creationId xmlns:a16="http://schemas.microsoft.com/office/drawing/2014/main" id="{192EDF96-A629-4EA2-A846-67901D5CD87B}"/>
+                <a16:creationId xmlns:a16="http://schemas.microsoft.com/office/drawing/2014/main" id="{63A1551E-D326-4516-BB8C-8CBCE5D258A8}"/>
               </a:ext>
             </a:extLst>
           </p:cNvPr>
@@ -14979,7 +14979,7 @@
           <p:cNvPr id="2" name="">
             <a:extLst xmlns:a="http://schemas.openxmlformats.org/drawingml/2006/main">
               <a:ext uri="{FF2B5EF4-FFF2-40B4-BE49-F238E27FC236}">
-                <a16:creationId xmlns:a16="http://schemas.microsoft.com/office/drawing/2014/main" id="{F8C8E726-3F5A-4C9E-B938-ED3BE6F59141}"/>
+                <a16:creationId xmlns:a16="http://schemas.microsoft.com/office/drawing/2014/main" id="{BC56D4B3-029E-4D36-A096-27EA8977ED71}"/>
               </a:ext>
             </a:extLst>
           </p:cNvPr>
@@ -15045,7 +15045,7 @@
           <p:cNvPr id="3" name="">
             <a:extLst xmlns:a="http://schemas.openxmlformats.org/drawingml/2006/main">
               <a:ext uri="{FF2B5EF4-FFF2-40B4-BE49-F238E27FC236}">
-                <a16:creationId xmlns:a16="http://schemas.microsoft.com/office/drawing/2014/main" id="{27DFA6F8-304C-43BB-BC30-EB7858C6709D}"/>
+                <a16:creationId xmlns:a16="http://schemas.microsoft.com/office/drawing/2014/main" id="{F2AF8D57-933E-4478-962C-FC52F3AEC969}"/>
               </a:ext>
             </a:extLst>
           </p:cNvPr>
@@ -15111,7 +15111,7 @@
           <p:cNvPr id="4" name="">
             <a:extLst xmlns:a="http://schemas.openxmlformats.org/drawingml/2006/main">
               <a:ext uri="{FF2B5EF4-FFF2-40B4-BE49-F238E27FC236}">
-                <a16:creationId xmlns:a16="http://schemas.microsoft.com/office/drawing/2014/main" id="{1946E148-92C9-496D-9D37-63CBC2188827}"/>
+                <a16:creationId xmlns:a16="http://schemas.microsoft.com/office/drawing/2014/main" id="{6DDDE0B7-4D5F-403F-AF48-E6E93FEC5F74}"/>
               </a:ext>
             </a:extLst>
           </p:cNvPr>
@@ -15177,7 +15177,7 @@
           <p:cNvPr id="5" name="">
             <a:extLst xmlns:a="http://schemas.openxmlformats.org/drawingml/2006/main">
               <a:ext uri="{FF2B5EF4-FFF2-40B4-BE49-F238E27FC236}">
-                <a16:creationId xmlns:a16="http://schemas.microsoft.com/office/drawing/2014/main" id="{0DC34BD3-2A98-43D5-B8DD-20F57D5570FD}"/>
+                <a16:creationId xmlns:a16="http://schemas.microsoft.com/office/drawing/2014/main" id="{703877D2-973C-48D4-96D9-2BF711862CAB}"/>
               </a:ext>
             </a:extLst>
           </p:cNvPr>
@@ -15243,7 +15243,7 @@
           <p:cNvPr id="6" name="">
             <a:extLst xmlns:a="http://schemas.openxmlformats.org/drawingml/2006/main">
               <a:ext uri="{FF2B5EF4-FFF2-40B4-BE49-F238E27FC236}">
-                <a16:creationId xmlns:a16="http://schemas.microsoft.com/office/drawing/2014/main" id="{718A37EC-9336-4E7D-BA71-243505886B4D}"/>
+                <a16:creationId xmlns:a16="http://schemas.microsoft.com/office/drawing/2014/main" id="{F2EE7ED1-5E3F-4D62-9CB7-03BE0C757F34}"/>
               </a:ext>
             </a:extLst>
           </p:cNvPr>
@@ -15393,7 +15393,7 @@
           <p:cNvPr id="7" name="">
             <a:extLst xmlns:a="http://schemas.openxmlformats.org/drawingml/2006/main">
               <a:ext uri="{FF2B5EF4-FFF2-40B4-BE49-F238E27FC236}">
-                <a16:creationId xmlns:a16="http://schemas.microsoft.com/office/drawing/2014/main" id="{BE1382DF-8529-4E3D-A843-237AA0490154}"/>
+                <a16:creationId xmlns:a16="http://schemas.microsoft.com/office/drawing/2014/main" id="{B3042F9C-A74B-49B0-86A3-91CFA4700CDC}"/>
               </a:ext>
             </a:extLst>
           </p:cNvPr>
@@ -15403,7 +15403,7 @@
           <p:nvPr/>
         </p:nvPicPr>
         <p:blipFill>
-          <a:blip xmlns:r="http://schemas.openxmlformats.org/officeDocument/2006/relationships" xmlns:a="http://schemas.openxmlformats.org/drawingml/2006/main" r:embed="Rf91d8290ef824420"/>
+          <a:blip xmlns:r="http://schemas.openxmlformats.org/officeDocument/2006/relationships" xmlns:a="http://schemas.openxmlformats.org/drawingml/2006/main" r:embed="R6e41881ede3940bf"/>
           <a:stretch xmlns:a="http://schemas.openxmlformats.org/drawingml/2006/main"/>
         </p:blipFill>
         <p:spPr>
@@ -15419,7 +15419,7 @@
     </p:spTree>
     <p:extLst>
       <p:ext uri="{BB962C8B-B14F-4D97-AF65-F5344CB8AC3E}">
-        <p14:creationId xmlns:p14="http://schemas.microsoft.com/office/powerpoint/2010/main" val="702304415"/>
+        <p14:creationId xmlns:p14="http://schemas.microsoft.com/office/powerpoint/2010/main" val="1170944965"/>
       </p:ext>
     </p:extLst>
   </p:cSld>
@@ -15450,7 +15450,7 @@
           <p:cNvPr id="8" name="">
             <a:extLst xmlns:a="http://schemas.openxmlformats.org/drawingml/2006/main">
               <a:ext uri="{FF2B5EF4-FFF2-40B4-BE49-F238E27FC236}">
-                <a16:creationId xmlns:a16="http://schemas.microsoft.com/office/drawing/2014/main" id="{D70181CF-6E56-44F3-86FE-DD66C08D48F1}"/>
+                <a16:creationId xmlns:a16="http://schemas.microsoft.com/office/drawing/2014/main" id="{13BF33EF-33D8-46EF-AA8A-3F949A16D1AF}"/>
               </a:ext>
             </a:extLst>
           </p:cNvPr>
@@ -15516,7 +15516,7 @@
           <p:cNvPr id="2" name="">
             <a:extLst xmlns:a="http://schemas.openxmlformats.org/drawingml/2006/main">
               <a:ext uri="{FF2B5EF4-FFF2-40B4-BE49-F238E27FC236}">
-                <a16:creationId xmlns:a16="http://schemas.microsoft.com/office/drawing/2014/main" id="{2D6FFFE3-ECD0-4EF1-9172-96C4F06C0CA2}"/>
+                <a16:creationId xmlns:a16="http://schemas.microsoft.com/office/drawing/2014/main" id="{DCB1A01F-B26C-4077-BC25-1670D90E1BD8}"/>
               </a:ext>
             </a:extLst>
           </p:cNvPr>
@@ -15582,7 +15582,7 @@
           <p:cNvPr id="3" name="">
             <a:extLst xmlns:a="http://schemas.openxmlformats.org/drawingml/2006/main">
               <a:ext uri="{FF2B5EF4-FFF2-40B4-BE49-F238E27FC236}">
-                <a16:creationId xmlns:a16="http://schemas.microsoft.com/office/drawing/2014/main" id="{95C46DFB-DD62-43FA-A3A7-1DFD45B89138}"/>
+                <a16:creationId xmlns:a16="http://schemas.microsoft.com/office/drawing/2014/main" id="{5C1F3D4B-8529-4559-9651-7864271901D5}"/>
               </a:ext>
             </a:extLst>
           </p:cNvPr>
@@ -15648,7 +15648,7 @@
           <p:cNvPr id="4" name="">
             <a:extLst xmlns:a="http://schemas.openxmlformats.org/drawingml/2006/main">
               <a:ext uri="{FF2B5EF4-FFF2-40B4-BE49-F238E27FC236}">
-                <a16:creationId xmlns:a16="http://schemas.microsoft.com/office/drawing/2014/main" id="{3EA17DA1-F9DD-414D-B32A-C8B30462D00B}"/>
+                <a16:creationId xmlns:a16="http://schemas.microsoft.com/office/drawing/2014/main" id="{80D64C62-3AD2-4C3A-8DDF-76C1D84FA641}"/>
               </a:ext>
             </a:extLst>
           </p:cNvPr>
@@ -15714,7 +15714,7 @@
           <p:cNvPr id="5" name="">
             <a:extLst xmlns:a="http://schemas.openxmlformats.org/drawingml/2006/main">
               <a:ext uri="{FF2B5EF4-FFF2-40B4-BE49-F238E27FC236}">
-                <a16:creationId xmlns:a16="http://schemas.microsoft.com/office/drawing/2014/main" id="{60DD3328-3751-4E22-86BC-EB9E592809C8}"/>
+                <a16:creationId xmlns:a16="http://schemas.microsoft.com/office/drawing/2014/main" id="{BC83C81A-3729-435D-97FD-FAF39E97ED7F}"/>
               </a:ext>
             </a:extLst>
           </p:cNvPr>
@@ -15724,7 +15724,7 @@
           <p:nvPr/>
         </p:nvPicPr>
         <p:blipFill>
-          <a:blip xmlns:r="http://schemas.openxmlformats.org/officeDocument/2006/relationships" xmlns:a="http://schemas.openxmlformats.org/drawingml/2006/main" r:embed="Re43903f1247b4db1"/>
+          <a:blip xmlns:r="http://schemas.openxmlformats.org/officeDocument/2006/relationships" xmlns:a="http://schemas.openxmlformats.org/drawingml/2006/main" r:embed="Ra0ccbf1734554dd8"/>
           <a:stretch xmlns:a="http://schemas.openxmlformats.org/drawingml/2006/main"/>
         </p:blipFill>
         <p:spPr>
@@ -15742,7 +15742,7 @@
           <p:cNvPr id="6" name="">
             <a:extLst xmlns:a="http://schemas.openxmlformats.org/drawingml/2006/main">
               <a:ext uri="{FF2B5EF4-FFF2-40B4-BE49-F238E27FC236}">
-                <a16:creationId xmlns:a16="http://schemas.microsoft.com/office/drawing/2014/main" id="{758562C3-0BAD-4F21-80E6-8B4547EE7C77}"/>
+                <a16:creationId xmlns:a16="http://schemas.microsoft.com/office/drawing/2014/main" id="{8063D66C-E577-4C4E-849C-6BF3A357D367}"/>
               </a:ext>
             </a:extLst>
           </p:cNvPr>
@@ -15752,7 +15752,7 @@
           <p:nvPr/>
         </p:nvPicPr>
         <p:blipFill>
-          <a:blip xmlns:r="http://schemas.openxmlformats.org/officeDocument/2006/relationships" xmlns:a="http://schemas.openxmlformats.org/drawingml/2006/main" r:embed="Rdec12de8444a465b"/>
+          <a:blip xmlns:r="http://schemas.openxmlformats.org/officeDocument/2006/relationships" xmlns:a="http://schemas.openxmlformats.org/drawingml/2006/main" r:embed="Re2d738a83e5b41a6"/>
           <a:stretch xmlns:a="http://schemas.openxmlformats.org/drawingml/2006/main"/>
         </p:blipFill>
         <p:spPr>
@@ -15770,7 +15770,7 @@
           <p:cNvPr id="7" name="">
             <a:extLst xmlns:a="http://schemas.openxmlformats.org/drawingml/2006/main">
               <a:ext uri="{FF2B5EF4-FFF2-40B4-BE49-F238E27FC236}">
-                <a16:creationId xmlns:a16="http://schemas.microsoft.com/office/drawing/2014/main" id="{70BF4469-6F87-4D4B-B950-E558CADA11FC}"/>
+                <a16:creationId xmlns:a16="http://schemas.microsoft.com/office/drawing/2014/main" id="{4112D853-B39B-42BB-8CE0-E1516893A8BA}"/>
               </a:ext>
             </a:extLst>
           </p:cNvPr>
@@ -15834,7 +15834,7 @@
     </p:spTree>
     <p:extLst>
       <p:ext uri="{BB962C8B-B14F-4D97-AF65-F5344CB8AC3E}">
-        <p14:creationId xmlns:p14="http://schemas.microsoft.com/office/powerpoint/2010/main" val="1429437634"/>
+        <p14:creationId xmlns:p14="http://schemas.microsoft.com/office/powerpoint/2010/main" val="148508790"/>
       </p:ext>
     </p:extLst>
   </p:cSld>
@@ -15865,7 +15865,7 @@
           <p:cNvPr id="8" name="">
             <a:extLst xmlns:a="http://schemas.openxmlformats.org/drawingml/2006/main">
               <a:ext uri="{FF2B5EF4-FFF2-40B4-BE49-F238E27FC236}">
-                <a16:creationId xmlns:a16="http://schemas.microsoft.com/office/drawing/2014/main" id="{6428ED43-A0CE-4A27-9DC7-9CAC2E401092}"/>
+                <a16:creationId xmlns:a16="http://schemas.microsoft.com/office/drawing/2014/main" id="{CD53D4C1-D427-4023-B83D-4C749B795ECE}"/>
               </a:ext>
             </a:extLst>
           </p:cNvPr>
@@ -15931,7 +15931,7 @@
           <p:cNvPr id="2" name="">
             <a:extLst xmlns:a="http://schemas.openxmlformats.org/drawingml/2006/main">
               <a:ext uri="{FF2B5EF4-FFF2-40B4-BE49-F238E27FC236}">
-                <a16:creationId xmlns:a16="http://schemas.microsoft.com/office/drawing/2014/main" id="{D7A8C445-97CF-4EAB-B4E1-4F10ED3F9B56}"/>
+                <a16:creationId xmlns:a16="http://schemas.microsoft.com/office/drawing/2014/main" id="{2FCCB202-5370-4F0E-A74D-763C8E8BCE89}"/>
               </a:ext>
             </a:extLst>
           </p:cNvPr>
@@ -15997,7 +15997,7 @@
           <p:cNvPr id="3" name="">
             <a:extLst xmlns:a="http://schemas.openxmlformats.org/drawingml/2006/main">
               <a:ext uri="{FF2B5EF4-FFF2-40B4-BE49-F238E27FC236}">
-                <a16:creationId xmlns:a16="http://schemas.microsoft.com/office/drawing/2014/main" id="{7A74BFD7-C781-45C3-A2AB-3E9B75BE9505}"/>
+                <a16:creationId xmlns:a16="http://schemas.microsoft.com/office/drawing/2014/main" id="{49DA53A5-3E28-41F6-818A-31377AC252C0}"/>
               </a:ext>
             </a:extLst>
           </p:cNvPr>
@@ -16063,7 +16063,7 @@
           <p:cNvPr id="4" name="">
             <a:extLst xmlns:a="http://schemas.openxmlformats.org/drawingml/2006/main">
               <a:ext uri="{FF2B5EF4-FFF2-40B4-BE49-F238E27FC236}">
-                <a16:creationId xmlns:a16="http://schemas.microsoft.com/office/drawing/2014/main" id="{9D049325-18F5-418F-BA9B-561C3AC8E5CC}"/>
+                <a16:creationId xmlns:a16="http://schemas.microsoft.com/office/drawing/2014/main" id="{6593A6DF-FD07-459B-BC1B-440BBEA253E5}"/>
               </a:ext>
             </a:extLst>
           </p:cNvPr>
@@ -16129,7 +16129,7 @@
           <p:cNvPr id="5" name="">
             <a:extLst xmlns:a="http://schemas.openxmlformats.org/drawingml/2006/main">
               <a:ext uri="{FF2B5EF4-FFF2-40B4-BE49-F238E27FC236}">
-                <a16:creationId xmlns:a16="http://schemas.microsoft.com/office/drawing/2014/main" id="{C60E86A0-EC88-4E5D-8C48-66C97FADC7FC}"/>
+                <a16:creationId xmlns:a16="http://schemas.microsoft.com/office/drawing/2014/main" id="{BAB372DA-C7BF-42B9-B203-579548395987}"/>
               </a:ext>
             </a:extLst>
           </p:cNvPr>
@@ -16139,7 +16139,7 @@
           <p:nvPr/>
         </p:nvPicPr>
         <p:blipFill>
-          <a:blip xmlns:r="http://schemas.openxmlformats.org/officeDocument/2006/relationships" xmlns:a="http://schemas.openxmlformats.org/drawingml/2006/main" r:embed="Rb748791944844647"/>
+          <a:blip xmlns:r="http://schemas.openxmlformats.org/officeDocument/2006/relationships" xmlns:a="http://schemas.openxmlformats.org/drawingml/2006/main" r:embed="R9a4d604e6c054ddf"/>
           <a:stretch xmlns:a="http://schemas.openxmlformats.org/drawingml/2006/main"/>
         </p:blipFill>
         <p:spPr>
@@ -16157,7 +16157,7 @@
           <p:cNvPr id="6" name="">
             <a:extLst xmlns:a="http://schemas.openxmlformats.org/drawingml/2006/main">
               <a:ext uri="{FF2B5EF4-FFF2-40B4-BE49-F238E27FC236}">
-                <a16:creationId xmlns:a16="http://schemas.microsoft.com/office/drawing/2014/main" id="{7428E1DC-A442-4AFF-B04E-EB8A2DF0F0EE}"/>
+                <a16:creationId xmlns:a16="http://schemas.microsoft.com/office/drawing/2014/main" id="{5C3FDA54-2ECC-419A-B6CA-8FBCF971A230}"/>
               </a:ext>
             </a:extLst>
           </p:cNvPr>
@@ -16167,7 +16167,7 @@
           <p:nvPr/>
         </p:nvPicPr>
         <p:blipFill>
-          <a:blip xmlns:r="http://schemas.openxmlformats.org/officeDocument/2006/relationships" xmlns:a="http://schemas.openxmlformats.org/drawingml/2006/main" r:embed="Rd980bfa5fe794789"/>
+          <a:blip xmlns:r="http://schemas.openxmlformats.org/officeDocument/2006/relationships" xmlns:a="http://schemas.openxmlformats.org/drawingml/2006/main" r:embed="R5c66a171a68d463a"/>
           <a:stretch xmlns:a="http://schemas.openxmlformats.org/drawingml/2006/main"/>
         </p:blipFill>
         <p:spPr>
@@ -16185,7 +16185,7 @@
           <p:cNvPr id="7" name="">
             <a:extLst xmlns:a="http://schemas.openxmlformats.org/drawingml/2006/main">
               <a:ext uri="{FF2B5EF4-FFF2-40B4-BE49-F238E27FC236}">
-                <a16:creationId xmlns:a16="http://schemas.microsoft.com/office/drawing/2014/main" id="{0468FAED-138D-4848-902C-2BF593E84DEB}"/>
+                <a16:creationId xmlns:a16="http://schemas.microsoft.com/office/drawing/2014/main" id="{15E32786-AC06-445C-AC2A-F3ACC575EA08}"/>
               </a:ext>
             </a:extLst>
           </p:cNvPr>
@@ -16249,7 +16249,7 @@
     </p:spTree>
     <p:extLst>
       <p:ext uri="{BB962C8B-B14F-4D97-AF65-F5344CB8AC3E}">
-        <p14:creationId xmlns:p14="http://schemas.microsoft.com/office/powerpoint/2010/main" val="1796518959"/>
+        <p14:creationId xmlns:p14="http://schemas.microsoft.com/office/powerpoint/2010/main" val="417577643"/>
       </p:ext>
     </p:extLst>
   </p:cSld>

</xml_diff>

<commit_message>
Publish Java starter quiz library and live reviewer access slide
</commit_message>
<xml_diff>
--- a/docs/presentation/QuizNova-Review-1.pptx
+++ b/docs/presentation/QuizNova-Review-1.pptx
@@ -2,29 +2,29 @@
 <file path=ppt/presentation.xml><?xml version="1.0" encoding="utf-8"?>
 <p:presentation xmlns:p="http://schemas.openxmlformats.org/presentationml/2006/main">
   <p:sldMasterIdLst>
-    <p:sldMasterId xmlns:r="http://schemas.openxmlformats.org/officeDocument/2006/relationships" id="2147483648" r:id="Rfee24b6fe4a34770"/>
+    <p:sldMasterId xmlns:r="http://schemas.openxmlformats.org/officeDocument/2006/relationships" id="2147483648" r:id="R288e8331c87e470f"/>
   </p:sldMasterIdLst>
   <p:notesMasterIdLst>
-    <p:notesMasterId xmlns:r="http://schemas.openxmlformats.org/officeDocument/2006/relationships" r:id="Rf5b23a840f854243"/>
+    <p:notesMasterId xmlns:r="http://schemas.openxmlformats.org/officeDocument/2006/relationships" r:id="R431247f8026649aa"/>
   </p:notesMasterIdLst>
   <p:sldIdLst>
-    <p:sldId xmlns:r="http://schemas.openxmlformats.org/officeDocument/2006/relationships" id="256" r:id="Rebb15089ef094bd3"/>
-    <p:sldId xmlns:r="http://schemas.openxmlformats.org/officeDocument/2006/relationships" id="257" r:id="R9717923cae6f4986"/>
-    <p:sldId xmlns:r="http://schemas.openxmlformats.org/officeDocument/2006/relationships" id="258" r:id="R52ea58a78c50467e"/>
-    <p:sldId xmlns:r="http://schemas.openxmlformats.org/officeDocument/2006/relationships" id="259" r:id="R1ab2ae47a9ae4d19"/>
-    <p:sldId xmlns:r="http://schemas.openxmlformats.org/officeDocument/2006/relationships" id="260" r:id="R6e13164621304983"/>
-    <p:sldId xmlns:r="http://schemas.openxmlformats.org/officeDocument/2006/relationships" id="261" r:id="R4d771d5add444eec"/>
-    <p:sldId xmlns:r="http://schemas.openxmlformats.org/officeDocument/2006/relationships" id="262" r:id="Re5f93417f28f4180"/>
-    <p:sldId xmlns:r="http://schemas.openxmlformats.org/officeDocument/2006/relationships" id="263" r:id="Ra77f68187d034b89"/>
-    <p:sldId xmlns:r="http://schemas.openxmlformats.org/officeDocument/2006/relationships" id="264" r:id="Rc520d9a581be4656"/>
-    <p:sldId xmlns:r="http://schemas.openxmlformats.org/officeDocument/2006/relationships" id="265" r:id="R59be68b5f9114d39"/>
-    <p:sldId xmlns:r="http://schemas.openxmlformats.org/officeDocument/2006/relationships" id="266" r:id="R22db0696b8f640ec"/>
-    <p:sldId xmlns:r="http://schemas.openxmlformats.org/officeDocument/2006/relationships" id="267" r:id="R7348645f1f0641c0"/>
-    <p:sldId xmlns:r="http://schemas.openxmlformats.org/officeDocument/2006/relationships" id="268" r:id="Ra699b55d272243e4"/>
-    <p:sldId xmlns:r="http://schemas.openxmlformats.org/officeDocument/2006/relationships" id="269" r:id="Reb5f4e490eac485a"/>
-    <p:sldId xmlns:r="http://schemas.openxmlformats.org/officeDocument/2006/relationships" id="270" r:id="R0ff24806da7c4149"/>
-    <p:sldId xmlns:r="http://schemas.openxmlformats.org/officeDocument/2006/relationships" id="271" r:id="R26dbc76ac2344584"/>
-    <p:sldId xmlns:r="http://schemas.openxmlformats.org/officeDocument/2006/relationships" id="272" r:id="R02aaf3819d694595"/>
+    <p:sldId xmlns:r="http://schemas.openxmlformats.org/officeDocument/2006/relationships" id="256" r:id="R4566e76028514856"/>
+    <p:sldId xmlns:r="http://schemas.openxmlformats.org/officeDocument/2006/relationships" id="257" r:id="Re9bb7d56884144e3"/>
+    <p:sldId xmlns:r="http://schemas.openxmlformats.org/officeDocument/2006/relationships" id="258" r:id="R3967a5a1d65b452d"/>
+    <p:sldId xmlns:r="http://schemas.openxmlformats.org/officeDocument/2006/relationships" id="259" r:id="R77ed05f6cbf14ce6"/>
+    <p:sldId xmlns:r="http://schemas.openxmlformats.org/officeDocument/2006/relationships" id="260" r:id="R125b4839811f48a3"/>
+    <p:sldId xmlns:r="http://schemas.openxmlformats.org/officeDocument/2006/relationships" id="261" r:id="R04b332bd40d24d33"/>
+    <p:sldId xmlns:r="http://schemas.openxmlformats.org/officeDocument/2006/relationships" id="262" r:id="R66ccb1eabaaa4872"/>
+    <p:sldId xmlns:r="http://schemas.openxmlformats.org/officeDocument/2006/relationships" id="263" r:id="R8a46711dedcc4fe2"/>
+    <p:sldId xmlns:r="http://schemas.openxmlformats.org/officeDocument/2006/relationships" id="264" r:id="Rb2b78e6c80bf4e51"/>
+    <p:sldId xmlns:r="http://schemas.openxmlformats.org/officeDocument/2006/relationships" id="265" r:id="Rf03ffa88b1864724"/>
+    <p:sldId xmlns:r="http://schemas.openxmlformats.org/officeDocument/2006/relationships" id="266" r:id="R64fb20f1d8f24c35"/>
+    <p:sldId xmlns:r="http://schemas.openxmlformats.org/officeDocument/2006/relationships" id="267" r:id="R26f4ff2ea42d445e"/>
+    <p:sldId xmlns:r="http://schemas.openxmlformats.org/officeDocument/2006/relationships" id="268" r:id="R00ffae7f9c5c403d"/>
+    <p:sldId xmlns:r="http://schemas.openxmlformats.org/officeDocument/2006/relationships" id="269" r:id="R5d6912bfb7d940dc"/>
+    <p:sldId xmlns:r="http://schemas.openxmlformats.org/officeDocument/2006/relationships" id="270" r:id="Rf85d45dc5d384a8a"/>
+    <p:sldId xmlns:r="http://schemas.openxmlformats.org/officeDocument/2006/relationships" id="271" r:id="Rad66677759db480f"/>
+    <p:sldId xmlns:r="http://schemas.openxmlformats.org/officeDocument/2006/relationships" id="272" r:id="Rae7b357c580a4637"/>
   </p:sldIdLst>
   <p:sldSz cx="12192000" cy="6858000"/>
   <p:notesSz cx="6858000" cy="9144000"/>
@@ -948,7 +948,7 @@
           <a:lstStyle xmlns:a="http://schemas.openxmlformats.org/drawingml/2006/main"/>
           <a:p xmlns:a="http://schemas.openxmlformats.org/drawingml/2006/main">
             <a:r>
-              <a:t>These are optional local sample accounts only. Open http://127.0.0.1:8080/ and use Sign in. Sample credentials are documented in README and are disabled by default in the cloud profile. Real deployment credentials must be privately configured; do not reuse these demo passwords for a public deployment.</a:t>
+              <a:t>Live participant reviewer account on https://quiznova-muskanbuilds11.onrender.com . This is a shared demonstration login with Participant permissions. Reviewers can instead register their own participant account for independent history. The live database contains six approved quizzes with six questions each. The private administrator password and database credentials are not included. The local-only sample logins have been replaced on this access slide.</a:t>
             </a:r>
           </a:p>
         </p:txBody>
@@ -1625,7 +1625,7 @@
           <p:cNvPr id="3" name="Title">
             <a:extLst xmlns:a="http://schemas.openxmlformats.org/drawingml/2006/main">
               <a:ext uri="{FF2B5EF4-FFF2-40B4-BE49-F238E27FC236}">
-                <a16:creationId xmlns:a16="http://schemas.microsoft.com/office/drawing/2014/main" id="{54FC63F6-384D-41C9-BEB6-2F16905490AB}"/>
+                <a16:creationId xmlns:a16="http://schemas.microsoft.com/office/drawing/2014/main" id="{D5913389-0334-4D36-B97C-A3318C06EEA4}"/>
               </a:ext>
             </a:extLst>
           </p:cNvPr>
@@ -1782,7 +1782,7 @@
           <p:cNvPr id="2" name="Subtitle">
             <a:extLst xmlns:a="http://schemas.openxmlformats.org/drawingml/2006/main">
               <a:ext uri="{FF2B5EF4-FFF2-40B4-BE49-F238E27FC236}">
-                <a16:creationId xmlns:a16="http://schemas.microsoft.com/office/drawing/2014/main" id="{4D7A3C1D-5D52-4CDC-87AE-37475845283B}"/>
+                <a16:creationId xmlns:a16="http://schemas.microsoft.com/office/drawing/2014/main" id="{B7ED4327-0EA0-4AE1-968D-20F8413F2B85}"/>
               </a:ext>
             </a:extLst>
           </p:cNvPr>
@@ -1956,7 +1956,7 @@
           <p:cNvPr id="2" name="Section title">
             <a:extLst xmlns:a="http://schemas.openxmlformats.org/drawingml/2006/main">
               <a:ext uri="{FF2B5EF4-FFF2-40B4-BE49-F238E27FC236}">
-                <a16:creationId xmlns:a16="http://schemas.microsoft.com/office/drawing/2014/main" id="{FFFA048B-4B28-456B-B186-282A9E6963C3}"/>
+                <a16:creationId xmlns:a16="http://schemas.microsoft.com/office/drawing/2014/main" id="{7ABE9A62-6648-497F-9D8B-00E540E7F97C}"/>
               </a:ext>
             </a:extLst>
           </p:cNvPr>
@@ -2130,7 +2130,7 @@
           <p:cNvPr id="3" name="Title">
             <a:extLst xmlns:a="http://schemas.openxmlformats.org/drawingml/2006/main">
               <a:ext uri="{FF2B5EF4-FFF2-40B4-BE49-F238E27FC236}">
-                <a16:creationId xmlns:a16="http://schemas.microsoft.com/office/drawing/2014/main" id="{02912E29-B39F-4F3D-8EAB-D20DCF4E3C4D}"/>
+                <a16:creationId xmlns:a16="http://schemas.microsoft.com/office/drawing/2014/main" id="{3D62B2D3-B723-42D8-A787-0847FC611125}"/>
               </a:ext>
             </a:extLst>
           </p:cNvPr>
@@ -2287,7 +2287,7 @@
           <p:cNvPr id="2" name="Body">
             <a:extLst xmlns:a="http://schemas.openxmlformats.org/drawingml/2006/main">
               <a:ext uri="{FF2B5EF4-FFF2-40B4-BE49-F238E27FC236}">
-                <a16:creationId xmlns:a16="http://schemas.microsoft.com/office/drawing/2014/main" id="{9B90B899-6944-42A1-ACFD-834B474365E7}"/>
+                <a16:creationId xmlns:a16="http://schemas.microsoft.com/office/drawing/2014/main" id="{A47A654F-AFC2-4E3E-825C-179D3046AAEA}"/>
               </a:ext>
             </a:extLst>
           </p:cNvPr>
@@ -2461,7 +2461,7 @@
           <p:cNvPr id="4" name="Title">
             <a:extLst xmlns:a="http://schemas.openxmlformats.org/drawingml/2006/main">
               <a:ext uri="{FF2B5EF4-FFF2-40B4-BE49-F238E27FC236}">
-                <a16:creationId xmlns:a16="http://schemas.microsoft.com/office/drawing/2014/main" id="{087C9BE8-ECC3-4252-ADD2-20E273D6AA48}"/>
+                <a16:creationId xmlns:a16="http://schemas.microsoft.com/office/drawing/2014/main" id="{52A0D7D7-184A-44B9-9F2E-8F9BD6EA49FA}"/>
               </a:ext>
             </a:extLst>
           </p:cNvPr>
@@ -2618,7 +2618,7 @@
           <p:cNvPr id="2" name="Left column">
             <a:extLst xmlns:a="http://schemas.openxmlformats.org/drawingml/2006/main">
               <a:ext uri="{FF2B5EF4-FFF2-40B4-BE49-F238E27FC236}">
-                <a16:creationId xmlns:a16="http://schemas.microsoft.com/office/drawing/2014/main" id="{01CAFD4A-3184-499F-B673-DD651EFFFFB6}"/>
+                <a16:creationId xmlns:a16="http://schemas.microsoft.com/office/drawing/2014/main" id="{579F1165-F0ED-415D-A456-10B12E3CC482}"/>
               </a:ext>
             </a:extLst>
           </p:cNvPr>
@@ -2775,7 +2775,7 @@
           <p:cNvPr id="3" name="Right column">
             <a:extLst xmlns:a="http://schemas.openxmlformats.org/drawingml/2006/main">
               <a:ext uri="{FF2B5EF4-FFF2-40B4-BE49-F238E27FC236}">
-                <a16:creationId xmlns:a16="http://schemas.microsoft.com/office/drawing/2014/main" id="{3439FAB9-CDC7-4289-B6D9-3DC30536E27A}"/>
+                <a16:creationId xmlns:a16="http://schemas.microsoft.com/office/drawing/2014/main" id="{02A3B431-B49C-49B4-BB14-409F48A96190}"/>
               </a:ext>
             </a:extLst>
           </p:cNvPr>
@@ -2949,7 +2949,7 @@
           <p:cNvPr id="3" name="Title">
             <a:extLst xmlns:a="http://schemas.openxmlformats.org/drawingml/2006/main">
               <a:ext uri="{FF2B5EF4-FFF2-40B4-BE49-F238E27FC236}">
-                <a16:creationId xmlns:a16="http://schemas.microsoft.com/office/drawing/2014/main" id="{C5D71C99-299A-46E3-B98F-D76501A73EE4}"/>
+                <a16:creationId xmlns:a16="http://schemas.microsoft.com/office/drawing/2014/main" id="{420CF134-3117-4A22-8707-766733449F87}"/>
               </a:ext>
             </a:extLst>
           </p:cNvPr>
@@ -3106,7 +3106,7 @@
           <p:cNvPr id="2" name="Left column">
             <a:extLst xmlns:a="http://schemas.openxmlformats.org/drawingml/2006/main">
               <a:ext uri="{FF2B5EF4-FFF2-40B4-BE49-F238E27FC236}">
-                <a16:creationId xmlns:a16="http://schemas.microsoft.com/office/drawing/2014/main" id="{38FDB67F-E165-4F6C-8D80-F1D433828B41}"/>
+                <a16:creationId xmlns:a16="http://schemas.microsoft.com/office/drawing/2014/main" id="{68BCB4EF-CA12-4785-9BB6-161D0F756A68}"/>
               </a:ext>
             </a:extLst>
           </p:cNvPr>
@@ -3301,12 +3301,12 @@
   </p:cSld>
   <p:clrMap bg1="lt1" tx1="dk1" bg2="lt2" tx2="dk2" accent1="accent1" accent2="accent2" accent3="accent3" accent4="accent4" accent5="accent5" accent6="accent6" hlink="hlink" folHlink="folHlink"/>
   <p:sldLayoutIdLst>
-    <p:sldLayoutId xmlns:r="http://schemas.openxmlformats.org/officeDocument/2006/relationships" id="2147483649" r:id="Rcb68d0ed18634b5a"/>
-    <p:sldLayoutId xmlns:r="http://schemas.openxmlformats.org/officeDocument/2006/relationships" id="2147483650" r:id="R42d937818df3422a"/>
-    <p:sldLayoutId xmlns:r="http://schemas.openxmlformats.org/officeDocument/2006/relationships" id="2147483651" r:id="Racf26a435e174eb2"/>
-    <p:sldLayoutId xmlns:r="http://schemas.openxmlformats.org/officeDocument/2006/relationships" id="2147483652" r:id="Rdb49b6175d2a4763"/>
-    <p:sldLayoutId xmlns:r="http://schemas.openxmlformats.org/officeDocument/2006/relationships" id="2147483653" r:id="R14c4d5dccd154edf"/>
-    <p:sldLayoutId xmlns:r="http://schemas.openxmlformats.org/officeDocument/2006/relationships" id="2147483654" r:id="R462b7576d5484b2a"/>
+    <p:sldLayoutId xmlns:r="http://schemas.openxmlformats.org/officeDocument/2006/relationships" id="2147483649" r:id="Re16ef79a633e4a05"/>
+    <p:sldLayoutId xmlns:r="http://schemas.openxmlformats.org/officeDocument/2006/relationships" id="2147483650" r:id="R65583c4bc4c547f7"/>
+    <p:sldLayoutId xmlns:r="http://schemas.openxmlformats.org/officeDocument/2006/relationships" id="2147483651" r:id="R30b3839a589e45ed"/>
+    <p:sldLayoutId xmlns:r="http://schemas.openxmlformats.org/officeDocument/2006/relationships" id="2147483652" r:id="Rab5fda82924b47e2"/>
+    <p:sldLayoutId xmlns:r="http://schemas.openxmlformats.org/officeDocument/2006/relationships" id="2147483653" r:id="Ra8e83730e23043b8"/>
+    <p:sldLayoutId xmlns:r="http://schemas.openxmlformats.org/officeDocument/2006/relationships" id="2147483654" r:id="R752a0b8e10ec4811"/>
   </p:sldLayoutIdLst>
   <p:txStyles>
     <p:titleStyle>
@@ -3857,7 +3857,7 @@
           <p:cNvPr id="9" name="">
             <a:extLst xmlns:a="http://schemas.openxmlformats.org/drawingml/2006/main">
               <a:ext uri="{FF2B5EF4-FFF2-40B4-BE49-F238E27FC236}">
-                <a16:creationId xmlns:a16="http://schemas.microsoft.com/office/drawing/2014/main" id="{7652E45E-765E-4C6D-A64E-262E3B778B89}"/>
+                <a16:creationId xmlns:a16="http://schemas.microsoft.com/office/drawing/2014/main" id="{0B33FF4D-7DD1-4EDF-A968-359CE6FDC11E}"/>
               </a:ext>
             </a:extLst>
           </p:cNvPr>
@@ -3923,7 +3923,7 @@
           <p:cNvPr id="2" name="">
             <a:extLst xmlns:a="http://schemas.openxmlformats.org/drawingml/2006/main">
               <a:ext uri="{FF2B5EF4-FFF2-40B4-BE49-F238E27FC236}">
-                <a16:creationId xmlns:a16="http://schemas.microsoft.com/office/drawing/2014/main" id="{D34003A3-CD09-46DC-B8E8-505DA1016C72}"/>
+                <a16:creationId xmlns:a16="http://schemas.microsoft.com/office/drawing/2014/main" id="{AEB854E7-5A4D-4784-ADA2-45960B5F29E8}"/>
               </a:ext>
             </a:extLst>
           </p:cNvPr>
@@ -3989,7 +3989,7 @@
           <p:cNvPr id="3" name="">
             <a:extLst xmlns:a="http://schemas.openxmlformats.org/drawingml/2006/main">
               <a:ext uri="{FF2B5EF4-FFF2-40B4-BE49-F238E27FC236}">
-                <a16:creationId xmlns:a16="http://schemas.microsoft.com/office/drawing/2014/main" id="{25D87C7D-D27D-44EE-9DC8-0C467AD78C4B}"/>
+                <a16:creationId xmlns:a16="http://schemas.microsoft.com/office/drawing/2014/main" id="{8C070406-749F-41CE-90C7-D567C2C96967}"/>
               </a:ext>
             </a:extLst>
           </p:cNvPr>
@@ -4055,7 +4055,7 @@
           <p:cNvPr id="4" name="">
             <a:extLst xmlns:a="http://schemas.openxmlformats.org/drawingml/2006/main">
               <a:ext uri="{FF2B5EF4-FFF2-40B4-BE49-F238E27FC236}">
-                <a16:creationId xmlns:a16="http://schemas.microsoft.com/office/drawing/2014/main" id="{13958CA5-1500-44D1-9F8E-94C847AB2A9E}"/>
+                <a16:creationId xmlns:a16="http://schemas.microsoft.com/office/drawing/2014/main" id="{FC2825E5-0D0E-47A5-BAC8-9A2BFB813723}"/>
               </a:ext>
             </a:extLst>
           </p:cNvPr>
@@ -4121,7 +4121,7 @@
           <p:cNvPr id="5" name="">
             <a:extLst xmlns:a="http://schemas.openxmlformats.org/drawingml/2006/main">
               <a:ext uri="{FF2B5EF4-FFF2-40B4-BE49-F238E27FC236}">
-                <a16:creationId xmlns:a16="http://schemas.microsoft.com/office/drawing/2014/main" id="{AFDC4D86-82A6-4240-AAE3-2B4ADF1E4290}"/>
+                <a16:creationId xmlns:a16="http://schemas.microsoft.com/office/drawing/2014/main" id="{861422A5-4616-4FB0-AAE8-DCBCC6C36104}"/>
               </a:ext>
             </a:extLst>
           </p:cNvPr>
@@ -4210,7 +4210,7 @@
           <p:cNvPr id="6" name="">
             <a:extLst xmlns:a="http://schemas.openxmlformats.org/drawingml/2006/main">
               <a:ext uri="{FF2B5EF4-FFF2-40B4-BE49-F238E27FC236}">
-                <a16:creationId xmlns:a16="http://schemas.microsoft.com/office/drawing/2014/main" id="{FE967601-9669-4105-A998-098CB1866C50}"/>
+                <a16:creationId xmlns:a16="http://schemas.microsoft.com/office/drawing/2014/main" id="{59F1872D-3FC7-4363-AD96-01D6448BF612}"/>
               </a:ext>
             </a:extLst>
           </p:cNvPr>
@@ -4276,7 +4276,7 @@
           <p:cNvPr id="7" name="">
             <a:extLst xmlns:a="http://schemas.openxmlformats.org/drawingml/2006/main">
               <a:ext uri="{FF2B5EF4-FFF2-40B4-BE49-F238E27FC236}">
-                <a16:creationId xmlns:a16="http://schemas.microsoft.com/office/drawing/2014/main" id="{6D00D644-2E41-4F63-8412-3B40A629B62B}"/>
+                <a16:creationId xmlns:a16="http://schemas.microsoft.com/office/drawing/2014/main" id="{1FDC43B7-9DCC-461C-8F12-C12001BE5E78}"/>
               </a:ext>
             </a:extLst>
           </p:cNvPr>
@@ -4342,7 +4342,7 @@
           <p:cNvPr id="8" name="">
             <a:extLst xmlns:a="http://schemas.openxmlformats.org/drawingml/2006/main">
               <a:ext uri="{FF2B5EF4-FFF2-40B4-BE49-F238E27FC236}">
-                <a16:creationId xmlns:a16="http://schemas.microsoft.com/office/drawing/2014/main" id="{826E268A-2A83-4726-9736-4D013F9C1257}"/>
+                <a16:creationId xmlns:a16="http://schemas.microsoft.com/office/drawing/2014/main" id="{CA1706E3-44FC-487C-B3A0-EE9BF687C2E1}"/>
               </a:ext>
             </a:extLst>
           </p:cNvPr>
@@ -4406,7 +4406,7 @@
     </p:spTree>
     <p:extLst>
       <p:ext uri="{BB962C8B-B14F-4D97-AF65-F5344CB8AC3E}">
-        <p14:creationId xmlns:p14="http://schemas.microsoft.com/office/powerpoint/2010/main" val="354681538"/>
+        <p14:creationId xmlns:p14="http://schemas.microsoft.com/office/powerpoint/2010/main" val="126208355"/>
       </p:ext>
     </p:extLst>
   </p:cSld>
@@ -4437,7 +4437,7 @@
           <p:cNvPr id="8" name="">
             <a:extLst xmlns:a="http://schemas.openxmlformats.org/drawingml/2006/main">
               <a:ext uri="{FF2B5EF4-FFF2-40B4-BE49-F238E27FC236}">
-                <a16:creationId xmlns:a16="http://schemas.microsoft.com/office/drawing/2014/main" id="{B7008365-33E5-4DC0-8679-AF4F0755B16D}"/>
+                <a16:creationId xmlns:a16="http://schemas.microsoft.com/office/drawing/2014/main" id="{1D4B0FE0-E811-4D3F-A3D1-7F0CFA443229}"/>
               </a:ext>
             </a:extLst>
           </p:cNvPr>
@@ -4503,7 +4503,7 @@
           <p:cNvPr id="2" name="">
             <a:extLst xmlns:a="http://schemas.openxmlformats.org/drawingml/2006/main">
               <a:ext uri="{FF2B5EF4-FFF2-40B4-BE49-F238E27FC236}">
-                <a16:creationId xmlns:a16="http://schemas.microsoft.com/office/drawing/2014/main" id="{BAD85004-1668-4473-85AC-E836D969429D}"/>
+                <a16:creationId xmlns:a16="http://schemas.microsoft.com/office/drawing/2014/main" id="{4C5F2C88-98C2-4AD2-B3C3-8016E82B0665}"/>
               </a:ext>
             </a:extLst>
           </p:cNvPr>
@@ -4569,7 +4569,7 @@
           <p:cNvPr id="3" name="">
             <a:extLst xmlns:a="http://schemas.openxmlformats.org/drawingml/2006/main">
               <a:ext uri="{FF2B5EF4-FFF2-40B4-BE49-F238E27FC236}">
-                <a16:creationId xmlns:a16="http://schemas.microsoft.com/office/drawing/2014/main" id="{90D76DA7-35F0-4FD0-AB87-F41FE7009C0F}"/>
+                <a16:creationId xmlns:a16="http://schemas.microsoft.com/office/drawing/2014/main" id="{A87B96A3-E6A3-4B4A-8498-874B45908C63}"/>
               </a:ext>
             </a:extLst>
           </p:cNvPr>
@@ -4635,7 +4635,7 @@
           <p:cNvPr id="4" name="">
             <a:extLst xmlns:a="http://schemas.openxmlformats.org/drawingml/2006/main">
               <a:ext uri="{FF2B5EF4-FFF2-40B4-BE49-F238E27FC236}">
-                <a16:creationId xmlns:a16="http://schemas.microsoft.com/office/drawing/2014/main" id="{D36900B8-543D-43AA-A46A-BC66F363F132}"/>
+                <a16:creationId xmlns:a16="http://schemas.microsoft.com/office/drawing/2014/main" id="{42F479A6-580E-47F7-9521-066FA4956121}"/>
               </a:ext>
             </a:extLst>
           </p:cNvPr>
@@ -4701,7 +4701,7 @@
           <p:cNvPr id="5" name="">
             <a:extLst xmlns:a="http://schemas.openxmlformats.org/drawingml/2006/main">
               <a:ext uri="{FF2B5EF4-FFF2-40B4-BE49-F238E27FC236}">
-                <a16:creationId xmlns:a16="http://schemas.microsoft.com/office/drawing/2014/main" id="{B3C9A0AB-FC2F-4BE3-814E-03C611463461}"/>
+                <a16:creationId xmlns:a16="http://schemas.microsoft.com/office/drawing/2014/main" id="{35CD215E-C6C7-4A76-9816-E887EDB3CA65}"/>
               </a:ext>
             </a:extLst>
           </p:cNvPr>
@@ -4711,7 +4711,7 @@
           <p:nvPr/>
         </p:nvPicPr>
         <p:blipFill>
-          <a:blip xmlns:r="http://schemas.openxmlformats.org/officeDocument/2006/relationships" xmlns:a="http://schemas.openxmlformats.org/drawingml/2006/main" r:embed="Refd5732d24f740c8"/>
+          <a:blip xmlns:r="http://schemas.openxmlformats.org/officeDocument/2006/relationships" xmlns:a="http://schemas.openxmlformats.org/drawingml/2006/main" r:embed="Rf434958cac2b4f90"/>
           <a:stretch xmlns:a="http://schemas.openxmlformats.org/drawingml/2006/main"/>
         </p:blipFill>
         <p:spPr>
@@ -4729,7 +4729,7 @@
           <p:cNvPr id="6" name="">
             <a:extLst xmlns:a="http://schemas.openxmlformats.org/drawingml/2006/main">
               <a:ext uri="{FF2B5EF4-FFF2-40B4-BE49-F238E27FC236}">
-                <a16:creationId xmlns:a16="http://schemas.microsoft.com/office/drawing/2014/main" id="{E8485680-15E8-49C8-9B5B-AFE1CA70B092}"/>
+                <a16:creationId xmlns:a16="http://schemas.microsoft.com/office/drawing/2014/main" id="{9E39597C-A1DC-4346-B823-5F146677CCF8}"/>
               </a:ext>
             </a:extLst>
           </p:cNvPr>
@@ -4887,7 +4887,7 @@
           <p:cNvPr id="7" name="">
             <a:extLst xmlns:a="http://schemas.openxmlformats.org/drawingml/2006/main">
               <a:ext uri="{FF2B5EF4-FFF2-40B4-BE49-F238E27FC236}">
-                <a16:creationId xmlns:a16="http://schemas.microsoft.com/office/drawing/2014/main" id="{27770F52-95BD-4BF4-98C4-DA9E22ACA7B8}"/>
+                <a16:creationId xmlns:a16="http://schemas.microsoft.com/office/drawing/2014/main" id="{7AD45F27-3B51-4C41-9DB1-414B8D7F7D55}"/>
               </a:ext>
             </a:extLst>
           </p:cNvPr>
@@ -4951,7 +4951,7 @@
     </p:spTree>
     <p:extLst>
       <p:ext uri="{BB962C8B-B14F-4D97-AF65-F5344CB8AC3E}">
-        <p14:creationId xmlns:p14="http://schemas.microsoft.com/office/powerpoint/2010/main" val="402189327"/>
+        <p14:creationId xmlns:p14="http://schemas.microsoft.com/office/powerpoint/2010/main" val="744470422"/>
       </p:ext>
     </p:extLst>
   </p:cSld>
@@ -4982,7 +4982,7 @@
           <p:cNvPr id="10" name="">
             <a:extLst xmlns:a="http://schemas.openxmlformats.org/drawingml/2006/main">
               <a:ext uri="{FF2B5EF4-FFF2-40B4-BE49-F238E27FC236}">
-                <a16:creationId xmlns:a16="http://schemas.microsoft.com/office/drawing/2014/main" id="{0733E233-AAC8-44F8-B40D-90F242D5C2DC}"/>
+                <a16:creationId xmlns:a16="http://schemas.microsoft.com/office/drawing/2014/main" id="{9D00A86D-232F-4218-A314-12801E370F05}"/>
               </a:ext>
             </a:extLst>
           </p:cNvPr>
@@ -5048,7 +5048,7 @@
           <p:cNvPr id="2" name="">
             <a:extLst xmlns:a="http://schemas.openxmlformats.org/drawingml/2006/main">
               <a:ext uri="{FF2B5EF4-FFF2-40B4-BE49-F238E27FC236}">
-                <a16:creationId xmlns:a16="http://schemas.microsoft.com/office/drawing/2014/main" id="{7036EFD0-B10D-4653-8375-AB8EC25BF9F0}"/>
+                <a16:creationId xmlns:a16="http://schemas.microsoft.com/office/drawing/2014/main" id="{CF7EBBF6-53F0-4BF8-9FEE-E2E6922BB717}"/>
               </a:ext>
             </a:extLst>
           </p:cNvPr>
@@ -5114,7 +5114,7 @@
           <p:cNvPr id="3" name="">
             <a:extLst xmlns:a="http://schemas.openxmlformats.org/drawingml/2006/main">
               <a:ext uri="{FF2B5EF4-FFF2-40B4-BE49-F238E27FC236}">
-                <a16:creationId xmlns:a16="http://schemas.microsoft.com/office/drawing/2014/main" id="{C15DDC6F-7CD3-401A-AA35-BD6165F41DB0}"/>
+                <a16:creationId xmlns:a16="http://schemas.microsoft.com/office/drawing/2014/main" id="{AA6C98CA-D310-463D-891D-72054058911C}"/>
               </a:ext>
             </a:extLst>
           </p:cNvPr>
@@ -5180,7 +5180,7 @@
           <p:cNvPr id="4" name="">
             <a:extLst xmlns:a="http://schemas.openxmlformats.org/drawingml/2006/main">
               <a:ext uri="{FF2B5EF4-FFF2-40B4-BE49-F238E27FC236}">
-                <a16:creationId xmlns:a16="http://schemas.microsoft.com/office/drawing/2014/main" id="{33CDA81D-4ABC-4BE0-8A60-63C266AB769C}"/>
+                <a16:creationId xmlns:a16="http://schemas.microsoft.com/office/drawing/2014/main" id="{6F053C87-BD0F-4FA3-BDD4-7EAFDD75F7D5}"/>
               </a:ext>
             </a:extLst>
           </p:cNvPr>
@@ -5246,7 +5246,7 @@
           <p:cNvPr id="5" name="">
             <a:extLst xmlns:a="http://schemas.openxmlformats.org/drawingml/2006/main">
               <a:ext uri="{FF2B5EF4-FFF2-40B4-BE49-F238E27FC236}">
-                <a16:creationId xmlns:a16="http://schemas.microsoft.com/office/drawing/2014/main" id="{8BD1A0C4-B1DD-456D-BD1C-C6C42C3E406F}"/>
+                <a16:creationId xmlns:a16="http://schemas.microsoft.com/office/drawing/2014/main" id="{87D35437-A266-4E16-828E-8C4F79AC0A37}"/>
               </a:ext>
             </a:extLst>
           </p:cNvPr>
@@ -5256,7 +5256,7 @@
           <p:nvPr/>
         </p:nvPicPr>
         <p:blipFill>
-          <a:blip xmlns:r="http://schemas.openxmlformats.org/officeDocument/2006/relationships" xmlns:a="http://schemas.openxmlformats.org/drawingml/2006/main" r:embed="R82aa1fb7572542bd"/>
+          <a:blip xmlns:r="http://schemas.openxmlformats.org/officeDocument/2006/relationships" xmlns:a="http://schemas.openxmlformats.org/drawingml/2006/main" r:embed="Rd05da8484b744344"/>
           <a:stretch xmlns:a="http://schemas.openxmlformats.org/drawingml/2006/main"/>
         </p:blipFill>
         <p:spPr>
@@ -5274,7 +5274,7 @@
           <p:cNvPr id="6" name="">
             <a:extLst xmlns:a="http://schemas.openxmlformats.org/drawingml/2006/main">
               <a:ext uri="{FF2B5EF4-FFF2-40B4-BE49-F238E27FC236}">
-                <a16:creationId xmlns:a16="http://schemas.microsoft.com/office/drawing/2014/main" id="{37BF661E-68F9-4D09-8E1B-0F3656D5F06B}"/>
+                <a16:creationId xmlns:a16="http://schemas.microsoft.com/office/drawing/2014/main" id="{86A82145-0CF5-436A-AD0B-48CB24F1BEFF}"/>
               </a:ext>
             </a:extLst>
           </p:cNvPr>
@@ -5340,7 +5340,7 @@
           <p:cNvPr id="7" name="">
             <a:extLst xmlns:a="http://schemas.openxmlformats.org/drawingml/2006/main">
               <a:ext uri="{FF2B5EF4-FFF2-40B4-BE49-F238E27FC236}">
-                <a16:creationId xmlns:a16="http://schemas.microsoft.com/office/drawing/2014/main" id="{C958347F-8889-4A79-8979-9D72F538BD6D}"/>
+                <a16:creationId xmlns:a16="http://schemas.microsoft.com/office/drawing/2014/main" id="{03E89C19-E075-46BA-A750-53DA87FEE1AC}"/>
               </a:ext>
             </a:extLst>
           </p:cNvPr>
@@ -5406,7 +5406,7 @@
           <p:cNvPr id="8" name="">
             <a:extLst xmlns:a="http://schemas.openxmlformats.org/drawingml/2006/main">
               <a:ext uri="{FF2B5EF4-FFF2-40B4-BE49-F238E27FC236}">
-                <a16:creationId xmlns:a16="http://schemas.microsoft.com/office/drawing/2014/main" id="{1FF4F931-5EF0-4B98-BE82-DA0EC08B8D5B}"/>
+                <a16:creationId xmlns:a16="http://schemas.microsoft.com/office/drawing/2014/main" id="{86AA87D0-2A92-4F36-A9C8-510078AD9D7A}"/>
               </a:ext>
             </a:extLst>
           </p:cNvPr>
@@ -5472,7 +5472,7 @@
           <p:cNvPr id="9" name="">
             <a:extLst xmlns:a="http://schemas.openxmlformats.org/drawingml/2006/main">
               <a:ext uri="{FF2B5EF4-FFF2-40B4-BE49-F238E27FC236}">
-                <a16:creationId xmlns:a16="http://schemas.microsoft.com/office/drawing/2014/main" id="{2AD69EA6-B1BC-4ED0-AF55-41D402A68951}"/>
+                <a16:creationId xmlns:a16="http://schemas.microsoft.com/office/drawing/2014/main" id="{880A2560-EF36-4900-B1BD-019E35DD35B1}"/>
               </a:ext>
             </a:extLst>
           </p:cNvPr>
@@ -5536,7 +5536,7 @@
     </p:spTree>
     <p:extLst>
       <p:ext uri="{BB962C8B-B14F-4D97-AF65-F5344CB8AC3E}">
-        <p14:creationId xmlns:p14="http://schemas.microsoft.com/office/powerpoint/2010/main" val="1928287995"/>
+        <p14:creationId xmlns:p14="http://schemas.microsoft.com/office/powerpoint/2010/main" val="2037342438"/>
       </p:ext>
     </p:extLst>
   </p:cSld>
@@ -5567,7 +5567,7 @@
           <p:cNvPr id="7" name="">
             <a:extLst xmlns:a="http://schemas.openxmlformats.org/drawingml/2006/main">
               <a:ext uri="{FF2B5EF4-FFF2-40B4-BE49-F238E27FC236}">
-                <a16:creationId xmlns:a16="http://schemas.microsoft.com/office/drawing/2014/main" id="{8C775853-97CB-4B6E-9D8D-61EBBCC00AC2}"/>
+                <a16:creationId xmlns:a16="http://schemas.microsoft.com/office/drawing/2014/main" id="{7D91943D-F696-4B8D-8598-3736A4719F91}"/>
               </a:ext>
             </a:extLst>
           </p:cNvPr>
@@ -5633,7 +5633,7 @@
           <p:cNvPr id="2" name="">
             <a:extLst xmlns:a="http://schemas.openxmlformats.org/drawingml/2006/main">
               <a:ext uri="{FF2B5EF4-FFF2-40B4-BE49-F238E27FC236}">
-                <a16:creationId xmlns:a16="http://schemas.microsoft.com/office/drawing/2014/main" id="{8A0820C5-90AF-419F-8BA9-A2AD6BFD626F}"/>
+                <a16:creationId xmlns:a16="http://schemas.microsoft.com/office/drawing/2014/main" id="{4639AFCB-20D6-49BB-B969-9D5B5DF95508}"/>
               </a:ext>
             </a:extLst>
           </p:cNvPr>
@@ -5699,7 +5699,7 @@
           <p:cNvPr id="3" name="">
             <a:extLst xmlns:a="http://schemas.openxmlformats.org/drawingml/2006/main">
               <a:ext uri="{FF2B5EF4-FFF2-40B4-BE49-F238E27FC236}">
-                <a16:creationId xmlns:a16="http://schemas.microsoft.com/office/drawing/2014/main" id="{7526C55D-C75C-4628-98F6-BCC8E4FBC440}"/>
+                <a16:creationId xmlns:a16="http://schemas.microsoft.com/office/drawing/2014/main" id="{141B3037-AE8D-40E0-BFA5-A378963C8EB0}"/>
               </a:ext>
             </a:extLst>
           </p:cNvPr>
@@ -5765,7 +5765,7 @@
           <p:cNvPr id="4" name="">
             <a:extLst xmlns:a="http://schemas.openxmlformats.org/drawingml/2006/main">
               <a:ext uri="{FF2B5EF4-FFF2-40B4-BE49-F238E27FC236}">
-                <a16:creationId xmlns:a16="http://schemas.microsoft.com/office/drawing/2014/main" id="{0BC74D24-B8FC-40DD-91D5-35B441FEDEA2}"/>
+                <a16:creationId xmlns:a16="http://schemas.microsoft.com/office/drawing/2014/main" id="{7FB0BA8B-1E55-4899-AB29-A211E8BF6BDC}"/>
               </a:ext>
             </a:extLst>
           </p:cNvPr>
@@ -5831,7 +5831,7 @@
           <p:cNvPr id="5" name="">
             <a:extLst xmlns:a="http://schemas.openxmlformats.org/drawingml/2006/main">
               <a:ext uri="{FF2B5EF4-FFF2-40B4-BE49-F238E27FC236}">
-                <a16:creationId xmlns:a16="http://schemas.microsoft.com/office/drawing/2014/main" id="{2E3FD07A-4649-42A2-BA34-CE40D3FDC6BC}"/>
+                <a16:creationId xmlns:a16="http://schemas.microsoft.com/office/drawing/2014/main" id="{30F63B44-48F5-42B3-A2B3-85ADB199B8BA}"/>
               </a:ext>
             </a:extLst>
           </p:cNvPr>
@@ -5841,7 +5841,7 @@
           <p:nvPr/>
         </p:nvPicPr>
         <p:blipFill>
-          <a:blip xmlns:r="http://schemas.openxmlformats.org/officeDocument/2006/relationships" xmlns:a="http://schemas.openxmlformats.org/drawingml/2006/main" r:embed="R5441e4d06826401b"/>
+          <a:blip xmlns:r="http://schemas.openxmlformats.org/officeDocument/2006/relationships" xmlns:a="http://schemas.openxmlformats.org/drawingml/2006/main" r:embed="R16bc5d5e554a4cf5"/>
           <a:stretch xmlns:a="http://schemas.openxmlformats.org/drawingml/2006/main"/>
         </p:blipFill>
         <p:spPr>
@@ -5859,7 +5859,7 @@
           <p:cNvPr id="6" name="">
             <a:extLst xmlns:a="http://schemas.openxmlformats.org/drawingml/2006/main">
               <a:ext uri="{FF2B5EF4-FFF2-40B4-BE49-F238E27FC236}">
-                <a16:creationId xmlns:a16="http://schemas.microsoft.com/office/drawing/2014/main" id="{CF6AB562-8CEF-4466-86E0-77F3DE949322}"/>
+                <a16:creationId xmlns:a16="http://schemas.microsoft.com/office/drawing/2014/main" id="{BB96F312-2580-4253-84CB-E5E58CDC9459}"/>
               </a:ext>
             </a:extLst>
           </p:cNvPr>
@@ -6035,7 +6035,7 @@
     </p:spTree>
     <p:extLst>
       <p:ext uri="{BB962C8B-B14F-4D97-AF65-F5344CB8AC3E}">
-        <p14:creationId xmlns:p14="http://schemas.microsoft.com/office/powerpoint/2010/main" val="1444049765"/>
+        <p14:creationId xmlns:p14="http://schemas.microsoft.com/office/powerpoint/2010/main" val="1364022024"/>
       </p:ext>
     </p:extLst>
   </p:cSld>
@@ -6066,7 +6066,7 @@
           <p:cNvPr id="13" name="">
             <a:extLst xmlns:a="http://schemas.openxmlformats.org/drawingml/2006/main">
               <a:ext uri="{FF2B5EF4-FFF2-40B4-BE49-F238E27FC236}">
-                <a16:creationId xmlns:a16="http://schemas.microsoft.com/office/drawing/2014/main" id="{DFF03A49-C633-41A1-B583-1AB75E2F4A4B}"/>
+                <a16:creationId xmlns:a16="http://schemas.microsoft.com/office/drawing/2014/main" id="{A1537DB9-9620-48B7-8884-C483E5113ED1}"/>
               </a:ext>
             </a:extLst>
           </p:cNvPr>
@@ -6132,7 +6132,7 @@
           <p:cNvPr id="2" name="">
             <a:extLst xmlns:a="http://schemas.openxmlformats.org/drawingml/2006/main">
               <a:ext uri="{FF2B5EF4-FFF2-40B4-BE49-F238E27FC236}">
-                <a16:creationId xmlns:a16="http://schemas.microsoft.com/office/drawing/2014/main" id="{0432EE22-0C45-48E3-AB9D-2FE8B2E45AA6}"/>
+                <a16:creationId xmlns:a16="http://schemas.microsoft.com/office/drawing/2014/main" id="{98E6FBCD-38F2-437F-9604-0A93777B41D7}"/>
               </a:ext>
             </a:extLst>
           </p:cNvPr>
@@ -6198,7 +6198,7 @@
           <p:cNvPr id="3" name="">
             <a:extLst xmlns:a="http://schemas.openxmlformats.org/drawingml/2006/main">
               <a:ext uri="{FF2B5EF4-FFF2-40B4-BE49-F238E27FC236}">
-                <a16:creationId xmlns:a16="http://schemas.microsoft.com/office/drawing/2014/main" id="{787F7393-8CED-48DF-82E9-142C23844AD1}"/>
+                <a16:creationId xmlns:a16="http://schemas.microsoft.com/office/drawing/2014/main" id="{92A65F0F-AF49-4B5D-8CE3-3EA2EDCB86E9}"/>
               </a:ext>
             </a:extLst>
           </p:cNvPr>
@@ -6264,7 +6264,7 @@
           <p:cNvPr id="4" name="">
             <a:extLst xmlns:a="http://schemas.openxmlformats.org/drawingml/2006/main">
               <a:ext uri="{FF2B5EF4-FFF2-40B4-BE49-F238E27FC236}">
-                <a16:creationId xmlns:a16="http://schemas.microsoft.com/office/drawing/2014/main" id="{6A3F5DCF-CB79-41F0-A4B7-25BDA395D37A}"/>
+                <a16:creationId xmlns:a16="http://schemas.microsoft.com/office/drawing/2014/main" id="{DA93D888-4956-4307-86A9-AD798CFBCBCF}"/>
               </a:ext>
             </a:extLst>
           </p:cNvPr>
@@ -6330,7 +6330,7 @@
           <p:cNvPr id="5" name="">
             <a:extLst xmlns:a="http://schemas.openxmlformats.org/drawingml/2006/main">
               <a:ext uri="{FF2B5EF4-FFF2-40B4-BE49-F238E27FC236}">
-                <a16:creationId xmlns:a16="http://schemas.microsoft.com/office/drawing/2014/main" id="{119EDCD0-FED0-4B38-9E9A-A4DC74657D29}"/>
+                <a16:creationId xmlns:a16="http://schemas.microsoft.com/office/drawing/2014/main" id="{C4803E62-0BAB-495B-9DA0-381C7B4AE892}"/>
               </a:ext>
             </a:extLst>
           </p:cNvPr>
@@ -6396,7 +6396,7 @@
           <p:cNvPr id="6" name="">
             <a:extLst xmlns:a="http://schemas.openxmlformats.org/drawingml/2006/main">
               <a:ext uri="{FF2B5EF4-FFF2-40B4-BE49-F238E27FC236}">
-                <a16:creationId xmlns:a16="http://schemas.microsoft.com/office/drawing/2014/main" id="{8D0488E6-A674-4268-B1B8-01489369D47C}"/>
+                <a16:creationId xmlns:a16="http://schemas.microsoft.com/office/drawing/2014/main" id="{86094195-4FD4-428A-B4EA-5C60C2E00AEF}"/>
               </a:ext>
             </a:extLst>
           </p:cNvPr>
@@ -6462,7 +6462,7 @@
           <p:cNvPr id="7" name="">
             <a:extLst xmlns:a="http://schemas.openxmlformats.org/drawingml/2006/main">
               <a:ext uri="{FF2B5EF4-FFF2-40B4-BE49-F238E27FC236}">
-                <a16:creationId xmlns:a16="http://schemas.microsoft.com/office/drawing/2014/main" id="{4C35A903-4901-4E00-95FB-9D370A37B864}"/>
+                <a16:creationId xmlns:a16="http://schemas.microsoft.com/office/drawing/2014/main" id="{8065139C-38B8-49A1-B2B5-AFA3A7B53AEA}"/>
               </a:ext>
             </a:extLst>
           </p:cNvPr>
@@ -6528,7 +6528,7 @@
           <p:cNvPr id="8" name="">
             <a:extLst xmlns:a="http://schemas.openxmlformats.org/drawingml/2006/main">
               <a:ext uri="{FF2B5EF4-FFF2-40B4-BE49-F238E27FC236}">
-                <a16:creationId xmlns:a16="http://schemas.microsoft.com/office/drawing/2014/main" id="{2E6C1082-3FA2-4EC6-80B1-32A17866428C}"/>
+                <a16:creationId xmlns:a16="http://schemas.microsoft.com/office/drawing/2014/main" id="{C58D9F01-5B4A-4000-9C76-11D6928FFF2C}"/>
               </a:ext>
             </a:extLst>
           </p:cNvPr>
@@ -6594,7 +6594,7 @@
           <p:cNvPr id="9" name="">
             <a:extLst xmlns:a="http://schemas.openxmlformats.org/drawingml/2006/main">
               <a:ext uri="{FF2B5EF4-FFF2-40B4-BE49-F238E27FC236}">
-                <a16:creationId xmlns:a16="http://schemas.microsoft.com/office/drawing/2014/main" id="{D43D48DF-F6D9-4559-928A-92A50B62C17D}"/>
+                <a16:creationId xmlns:a16="http://schemas.microsoft.com/office/drawing/2014/main" id="{4CC9CC86-0A54-4BC5-970C-A9D9DD0F1D28}"/>
               </a:ext>
             </a:extLst>
           </p:cNvPr>
@@ -6660,7 +6660,7 @@
           <p:cNvPr id="10" name="">
             <a:extLst xmlns:a="http://schemas.openxmlformats.org/drawingml/2006/main">
               <a:ext uri="{FF2B5EF4-FFF2-40B4-BE49-F238E27FC236}">
-                <a16:creationId xmlns:a16="http://schemas.microsoft.com/office/drawing/2014/main" id="{087402F6-A3BC-4AFD-A614-E75E55844759}"/>
+                <a16:creationId xmlns:a16="http://schemas.microsoft.com/office/drawing/2014/main" id="{38C0B4C3-5491-4BE8-BFFC-B3751FF430CD}"/>
               </a:ext>
             </a:extLst>
           </p:cNvPr>
@@ -6726,7 +6726,7 @@
           <p:cNvPr id="11" name="">
             <a:extLst xmlns:a="http://schemas.openxmlformats.org/drawingml/2006/main">
               <a:ext uri="{FF2B5EF4-FFF2-40B4-BE49-F238E27FC236}">
-                <a16:creationId xmlns:a16="http://schemas.microsoft.com/office/drawing/2014/main" id="{EC34402A-E6DA-4606-BF13-F58959225174}"/>
+                <a16:creationId xmlns:a16="http://schemas.microsoft.com/office/drawing/2014/main" id="{06194F0C-7BBC-4E75-85C6-5AD07A7826D9}"/>
               </a:ext>
             </a:extLst>
           </p:cNvPr>
@@ -6792,7 +6792,7 @@
           <p:cNvPr id="12" name="">
             <a:extLst xmlns:a="http://schemas.openxmlformats.org/drawingml/2006/main">
               <a:ext uri="{FF2B5EF4-FFF2-40B4-BE49-F238E27FC236}">
-                <a16:creationId xmlns:a16="http://schemas.microsoft.com/office/drawing/2014/main" id="{6B3DBC32-354D-40F8-A7FC-30E63637C00B}"/>
+                <a16:creationId xmlns:a16="http://schemas.microsoft.com/office/drawing/2014/main" id="{24F2746A-605B-4AB4-883D-26C0852DEA3F}"/>
               </a:ext>
             </a:extLst>
           </p:cNvPr>
@@ -6856,7 +6856,7 @@
     </p:spTree>
     <p:extLst>
       <p:ext uri="{BB962C8B-B14F-4D97-AF65-F5344CB8AC3E}">
-        <p14:creationId xmlns:p14="http://schemas.microsoft.com/office/powerpoint/2010/main" val="1595144439"/>
+        <p14:creationId xmlns:p14="http://schemas.microsoft.com/office/powerpoint/2010/main" val="1825684873"/>
       </p:ext>
     </p:extLst>
   </p:cSld>
@@ -6887,7 +6887,7 @@
           <p:cNvPr id="7" name="">
             <a:extLst xmlns:a="http://schemas.openxmlformats.org/drawingml/2006/main">
               <a:ext uri="{FF2B5EF4-FFF2-40B4-BE49-F238E27FC236}">
-                <a16:creationId xmlns:a16="http://schemas.microsoft.com/office/drawing/2014/main" id="{E89C330A-10E7-4B56-8826-2213918A706A}"/>
+                <a16:creationId xmlns:a16="http://schemas.microsoft.com/office/drawing/2014/main" id="{8CD5C18E-7E19-4643-A85E-BEDE2180BDF0}"/>
               </a:ext>
             </a:extLst>
           </p:cNvPr>
@@ -6953,7 +6953,7 @@
           <p:cNvPr id="2" name="">
             <a:extLst xmlns:a="http://schemas.openxmlformats.org/drawingml/2006/main">
               <a:ext uri="{FF2B5EF4-FFF2-40B4-BE49-F238E27FC236}">
-                <a16:creationId xmlns:a16="http://schemas.microsoft.com/office/drawing/2014/main" id="{A87BC61A-2081-485C-B627-5250B6BF5D90}"/>
+                <a16:creationId xmlns:a16="http://schemas.microsoft.com/office/drawing/2014/main" id="{405B7453-21E2-46C2-9B78-F710BBF5130D}"/>
               </a:ext>
             </a:extLst>
           </p:cNvPr>
@@ -7019,7 +7019,7 @@
           <p:cNvPr id="3" name="">
             <a:extLst xmlns:a="http://schemas.openxmlformats.org/drawingml/2006/main">
               <a:ext uri="{FF2B5EF4-FFF2-40B4-BE49-F238E27FC236}">
-                <a16:creationId xmlns:a16="http://schemas.microsoft.com/office/drawing/2014/main" id="{B3FD5A8C-4770-4AE6-9EB5-5D75E8EC5564}"/>
+                <a16:creationId xmlns:a16="http://schemas.microsoft.com/office/drawing/2014/main" id="{7945D001-4925-4F81-B0E6-D24ABCB8C764}"/>
               </a:ext>
             </a:extLst>
           </p:cNvPr>
@@ -7085,7 +7085,7 @@
           <p:cNvPr id="4" name="">
             <a:extLst xmlns:a="http://schemas.openxmlformats.org/drawingml/2006/main">
               <a:ext uri="{FF2B5EF4-FFF2-40B4-BE49-F238E27FC236}">
-                <a16:creationId xmlns:a16="http://schemas.microsoft.com/office/drawing/2014/main" id="{68EA55A0-DCF9-44CA-83F0-4D59E0EB609A}"/>
+                <a16:creationId xmlns:a16="http://schemas.microsoft.com/office/drawing/2014/main" id="{DBECC61D-EA64-4651-9827-A32BCCBE26FB}"/>
               </a:ext>
             </a:extLst>
           </p:cNvPr>
@@ -7151,7 +7151,7 @@
           <p:cNvPr id="5" name="">
             <a:extLst xmlns:a="http://schemas.openxmlformats.org/drawingml/2006/main">
               <a:ext uri="{FF2B5EF4-FFF2-40B4-BE49-F238E27FC236}">
-                <a16:creationId xmlns:a16="http://schemas.microsoft.com/office/drawing/2014/main" id="{5C15AB6B-84D6-4825-9AA7-AD8706FAB11E}"/>
+                <a16:creationId xmlns:a16="http://schemas.microsoft.com/office/drawing/2014/main" id="{C131113E-0371-4F49-95EA-733D3ECDD196}"/>
               </a:ext>
             </a:extLst>
           </p:cNvPr>
@@ -7849,7 +7849,7 @@
           <p:cNvPr id="6" name="">
             <a:extLst xmlns:a="http://schemas.openxmlformats.org/drawingml/2006/main">
               <a:ext uri="{FF2B5EF4-FFF2-40B4-BE49-F238E27FC236}">
-                <a16:creationId xmlns:a16="http://schemas.microsoft.com/office/drawing/2014/main" id="{0FF34829-377D-44F8-96DA-F6AB16421EDD}"/>
+                <a16:creationId xmlns:a16="http://schemas.microsoft.com/office/drawing/2014/main" id="{9720B675-E0C6-4EFF-9FF0-A498B782310F}"/>
               </a:ext>
             </a:extLst>
           </p:cNvPr>
@@ -7913,7 +7913,7 @@
     </p:spTree>
     <p:extLst>
       <p:ext uri="{BB962C8B-B14F-4D97-AF65-F5344CB8AC3E}">
-        <p14:creationId xmlns:p14="http://schemas.microsoft.com/office/powerpoint/2010/main" val="1571530152"/>
+        <p14:creationId xmlns:p14="http://schemas.microsoft.com/office/powerpoint/2010/main" val="187762285"/>
       </p:ext>
     </p:extLst>
   </p:cSld>
@@ -7944,7 +7944,7 @@
           <p:cNvPr id="12" name="">
             <a:extLst xmlns:a="http://schemas.openxmlformats.org/drawingml/2006/main">
               <a:ext uri="{FF2B5EF4-FFF2-40B4-BE49-F238E27FC236}">
-                <a16:creationId xmlns:a16="http://schemas.microsoft.com/office/drawing/2014/main" id="{37C72842-50A2-4892-93E7-373C9D03C855}"/>
+                <a16:creationId xmlns:a16="http://schemas.microsoft.com/office/drawing/2014/main" id="{76F3236E-8F14-4769-A0DB-8C1B8F0674A1}"/>
               </a:ext>
             </a:extLst>
           </p:cNvPr>
@@ -8010,7 +8010,7 @@
           <p:cNvPr id="2" name="">
             <a:extLst xmlns:a="http://schemas.openxmlformats.org/drawingml/2006/main">
               <a:ext uri="{FF2B5EF4-FFF2-40B4-BE49-F238E27FC236}">
-                <a16:creationId xmlns:a16="http://schemas.microsoft.com/office/drawing/2014/main" id="{30DBFB3F-E9F2-409E-9D68-DCBC8F945877}"/>
+                <a16:creationId xmlns:a16="http://schemas.microsoft.com/office/drawing/2014/main" id="{6A3D010F-1BCE-49EE-85D7-B1D4F6E277F7}"/>
               </a:ext>
             </a:extLst>
           </p:cNvPr>
@@ -8076,7 +8076,7 @@
           <p:cNvPr id="3" name="">
             <a:extLst xmlns:a="http://schemas.openxmlformats.org/drawingml/2006/main">
               <a:ext uri="{FF2B5EF4-FFF2-40B4-BE49-F238E27FC236}">
-                <a16:creationId xmlns:a16="http://schemas.microsoft.com/office/drawing/2014/main" id="{BE2E6FA8-1FA1-4C42-9B1C-74A74307F696}"/>
+                <a16:creationId xmlns:a16="http://schemas.microsoft.com/office/drawing/2014/main" id="{403757B5-FA44-47CD-9D7D-A10B61A530D4}"/>
               </a:ext>
             </a:extLst>
           </p:cNvPr>
@@ -8142,7 +8142,7 @@
           <p:cNvPr id="4" name="">
             <a:extLst xmlns:a="http://schemas.openxmlformats.org/drawingml/2006/main">
               <a:ext uri="{FF2B5EF4-FFF2-40B4-BE49-F238E27FC236}">
-                <a16:creationId xmlns:a16="http://schemas.microsoft.com/office/drawing/2014/main" id="{23816DBF-1127-4E4E-8ED1-078CE06ED40B}"/>
+                <a16:creationId xmlns:a16="http://schemas.microsoft.com/office/drawing/2014/main" id="{B162189E-8038-4688-A9F4-5FA926E95686}"/>
               </a:ext>
             </a:extLst>
           </p:cNvPr>
@@ -8208,7 +8208,7 @@
           <p:cNvPr id="5" name="">
             <a:extLst xmlns:a="http://schemas.openxmlformats.org/drawingml/2006/main">
               <a:ext uri="{FF2B5EF4-FFF2-40B4-BE49-F238E27FC236}">
-                <a16:creationId xmlns:a16="http://schemas.microsoft.com/office/drawing/2014/main" id="{BA4B3F65-834E-413B-B568-E7B63F4DEA42}"/>
+                <a16:creationId xmlns:a16="http://schemas.microsoft.com/office/drawing/2014/main" id="{9B9B80AE-E07D-48C1-992F-F26EFE2E3CAE}"/>
               </a:ext>
             </a:extLst>
           </p:cNvPr>
@@ -8274,7 +8274,7 @@
           <p:cNvPr id="6" name="">
             <a:extLst xmlns:a="http://schemas.openxmlformats.org/drawingml/2006/main">
               <a:ext uri="{FF2B5EF4-FFF2-40B4-BE49-F238E27FC236}">
-                <a16:creationId xmlns:a16="http://schemas.microsoft.com/office/drawing/2014/main" id="{A18BC4B3-6F6A-4909-97CA-3FF585A62C47}"/>
+                <a16:creationId xmlns:a16="http://schemas.microsoft.com/office/drawing/2014/main" id="{79BF18FA-1B3D-4F7A-9BA0-8431A398E46B}"/>
               </a:ext>
             </a:extLst>
           </p:cNvPr>
@@ -8340,7 +8340,7 @@
           <p:cNvPr id="7" name="">
             <a:extLst xmlns:a="http://schemas.openxmlformats.org/drawingml/2006/main">
               <a:ext uri="{FF2B5EF4-FFF2-40B4-BE49-F238E27FC236}">
-                <a16:creationId xmlns:a16="http://schemas.microsoft.com/office/drawing/2014/main" id="{CAC895BF-3035-4A89-B305-806CD65963FB}"/>
+                <a16:creationId xmlns:a16="http://schemas.microsoft.com/office/drawing/2014/main" id="{A8720C7E-CA87-4EEA-99C5-76DB604B7711}"/>
               </a:ext>
             </a:extLst>
           </p:cNvPr>
@@ -8406,7 +8406,7 @@
           <p:cNvPr id="8" name="">
             <a:extLst xmlns:a="http://schemas.openxmlformats.org/drawingml/2006/main">
               <a:ext uri="{FF2B5EF4-FFF2-40B4-BE49-F238E27FC236}">
-                <a16:creationId xmlns:a16="http://schemas.microsoft.com/office/drawing/2014/main" id="{DA0D2AD1-4F7D-4C0E-9756-68D6FCE6ABCF}"/>
+                <a16:creationId xmlns:a16="http://schemas.microsoft.com/office/drawing/2014/main" id="{9CF975E8-06C1-47C2-819F-B2DE867CD69D}"/>
               </a:ext>
             </a:extLst>
           </p:cNvPr>
@@ -8472,7 +8472,7 @@
           <p:cNvPr id="9" name="">
             <a:extLst xmlns:a="http://schemas.openxmlformats.org/drawingml/2006/main">
               <a:ext uri="{FF2B5EF4-FFF2-40B4-BE49-F238E27FC236}">
-                <a16:creationId xmlns:a16="http://schemas.microsoft.com/office/drawing/2014/main" id="{0634AFFB-9B0D-4FB2-BCFA-772B804801EF}"/>
+                <a16:creationId xmlns:a16="http://schemas.microsoft.com/office/drawing/2014/main" id="{F12C8C44-F34C-4504-8D45-A77D94D10CD7}"/>
               </a:ext>
             </a:extLst>
           </p:cNvPr>
@@ -8538,7 +8538,7 @@
           <p:cNvPr id="10" name="">
             <a:extLst xmlns:a="http://schemas.openxmlformats.org/drawingml/2006/main">
               <a:ext uri="{FF2B5EF4-FFF2-40B4-BE49-F238E27FC236}">
-                <a16:creationId xmlns:a16="http://schemas.microsoft.com/office/drawing/2014/main" id="{DF2F7FFD-1466-4774-8A6B-9F4C60660CB8}"/>
+                <a16:creationId xmlns:a16="http://schemas.microsoft.com/office/drawing/2014/main" id="{219AD209-992F-471A-B2DF-C0318061C344}"/>
               </a:ext>
             </a:extLst>
           </p:cNvPr>
@@ -8604,7 +8604,7 @@
           <p:cNvPr id="11" name="">
             <a:extLst xmlns:a="http://schemas.openxmlformats.org/drawingml/2006/main">
               <a:ext uri="{FF2B5EF4-FFF2-40B4-BE49-F238E27FC236}">
-                <a16:creationId xmlns:a16="http://schemas.microsoft.com/office/drawing/2014/main" id="{06072862-851F-44FB-AA1E-D64FAD833A51}"/>
+                <a16:creationId xmlns:a16="http://schemas.microsoft.com/office/drawing/2014/main" id="{492874E7-243E-4C97-AB8C-2C6AF33F6D7C}"/>
               </a:ext>
             </a:extLst>
           </p:cNvPr>
@@ -8691,7 +8691,7 @@
     </p:spTree>
     <p:extLst>
       <p:ext uri="{BB962C8B-B14F-4D97-AF65-F5344CB8AC3E}">
-        <p14:creationId xmlns:p14="http://schemas.microsoft.com/office/powerpoint/2010/main" val="1010739324"/>
+        <p14:creationId xmlns:p14="http://schemas.microsoft.com/office/powerpoint/2010/main" val="1635893515"/>
       </p:ext>
     </p:extLst>
   </p:cSld>
@@ -8719,10 +8719,10 @@
       </p:grpSpPr>
       <p:sp>
         <p:nvSpPr>
-          <p:cNvPr id="8" name="">
-            <a:extLst xmlns:a="http://schemas.openxmlformats.org/drawingml/2006/main">
-              <a:ext uri="{FF2B5EF4-FFF2-40B4-BE49-F238E27FC236}">
-                <a16:creationId xmlns:a16="http://schemas.microsoft.com/office/drawing/2014/main" id="{5F75C5D9-8795-47E8-B8E1-B4F4E2EA9116}"/>
+          <p:cNvPr id="10" name="">
+            <a:extLst xmlns:a="http://schemas.openxmlformats.org/drawingml/2006/main">
+              <a:ext uri="{FF2B5EF4-FFF2-40B4-BE49-F238E27FC236}">
+                <a16:creationId xmlns:a16="http://schemas.microsoft.com/office/drawing/2014/main" id="{225145D1-B1F8-499A-A6DF-FF86F753CF2A}"/>
               </a:ext>
             </a:extLst>
           </p:cNvPr>
@@ -8778,7 +8778,7 @@
                 <a:ea typeface="Arial"/>
                 <a:cs typeface="Arial"/>
               </a:rPr>
-              <a:t>DEMONSTRATION ACCESS</a:t>
+              <a:t>LIVE DEMONSTRATION ACCESS</a:t>
             </a:r>
           </a:p>
         </p:txBody>
@@ -8788,7 +8788,7 @@
           <p:cNvPr id="2" name="">
             <a:extLst xmlns:a="http://schemas.openxmlformats.org/drawingml/2006/main">
               <a:ext uri="{FF2B5EF4-FFF2-40B4-BE49-F238E27FC236}">
-                <a16:creationId xmlns:a16="http://schemas.microsoft.com/office/drawing/2014/main" id="{FCC43C81-3ED7-4E94-9622-28B39AFC978A}"/>
+                <a16:creationId xmlns:a16="http://schemas.microsoft.com/office/drawing/2014/main" id="{C1375F65-EFA4-4D67-9A31-50F9572C0949}"/>
               </a:ext>
             </a:extLst>
           </p:cNvPr>
@@ -8844,7 +8844,7 @@
                 <a:ea typeface="Georgia"/>
                 <a:cs typeface="Georgia"/>
               </a:rPr>
-              <a:t>Local demo login credentials</a:t>
+              <a:t>Live reviewer login</a:t>
             </a:r>
           </a:p>
         </p:txBody>
@@ -8854,7 +8854,7 @@
           <p:cNvPr id="3" name="">
             <a:extLst xmlns:a="http://schemas.openxmlformats.org/drawingml/2006/main">
               <a:ext uri="{FF2B5EF4-FFF2-40B4-BE49-F238E27FC236}">
-                <a16:creationId xmlns:a16="http://schemas.microsoft.com/office/drawing/2014/main" id="{ABF26330-E5B2-4B36-A851-C81F633B0729}"/>
+                <a16:creationId xmlns:a16="http://schemas.microsoft.com/office/drawing/2014/main" id="{CDD1DA97-AA43-473E-8C09-E64847F1A6CE}"/>
               </a:ext>
             </a:extLst>
           </p:cNvPr>
@@ -8920,7 +8920,7 @@
           <p:cNvPr id="4" name="">
             <a:extLst xmlns:a="http://schemas.openxmlformats.org/drawingml/2006/main">
               <a:ext uri="{FF2B5EF4-FFF2-40B4-BE49-F238E27FC236}">
-                <a16:creationId xmlns:a16="http://schemas.microsoft.com/office/drawing/2014/main" id="{17C82ED5-1D00-4E18-94CD-1F33E2E205E9}"/>
+                <a16:creationId xmlns:a16="http://schemas.microsoft.com/office/drawing/2014/main" id="{4C152040-F2E9-48B2-9981-0FFC043F31CA}"/>
               </a:ext>
             </a:extLst>
           </p:cNvPr>
@@ -8981,12 +8981,78 @@
           </a:p>
         </p:txBody>
       </p:sp>
+      <p:sp>
+        <p:nvSpPr>
+          <p:cNvPr id="5" name="">
+            <a:extLst xmlns:a="http://schemas.openxmlformats.org/drawingml/2006/main">
+              <a:ext uri="{FF2B5EF4-FFF2-40B4-BE49-F238E27FC236}">
+                <a16:creationId xmlns:a16="http://schemas.microsoft.com/office/drawing/2014/main" id="{26AEF386-7BA4-4FB0-BC3E-C94611B1A316}"/>
+              </a:ext>
+            </a:extLst>
+          </p:cNvPr>
+          <p:cNvSpPr>
+            <a:spLocks xmlns:a="http://schemas.openxmlformats.org/drawingml/2006/main" noGrp="1"/>
+          </p:cNvSpPr>
+          <p:nvPr/>
+        </p:nvSpPr>
+        <p:spPr>
+          <a:xfrm xmlns:a="http://schemas.openxmlformats.org/drawingml/2006/main">
+            <a:off x="609600" y="1657350"/>
+            <a:ext cx="10972800" cy="571500"/>
+          </a:xfrm>
+          <a:prstGeom xmlns:a="http://schemas.openxmlformats.org/drawingml/2006/main" prst="rect">
+            <a:avLst/>
+          </a:prstGeom>
+          <a:noFill xmlns:a="http://schemas.openxmlformats.org/drawingml/2006/main"/>
+          <a:ln xmlns:a="http://schemas.openxmlformats.org/drawingml/2006/main" w="0">
+            <a:noFill/>
+          </a:ln>
+        </p:spPr>
+        <p:txBody>
+          <a:bodyPr xmlns:a="http://schemas.openxmlformats.org/drawingml/2006/main"/>
+          <a:lstStyle xmlns:a="http://schemas.openxmlformats.org/drawingml/2006/main">
+            <a:defPPr>
+              <a:defRPr sz="2175" b="1">
+                <a:solidFill>
+                  <a:srgbClr val="AD583D"/>
+                </a:solidFill>
+                <a:latin typeface="Arial"/>
+                <a:ea typeface="Arial"/>
+                <a:cs typeface="Arial"/>
+              </a:defRPr>
+            </a:defPPr>
+          </a:lstStyle>
+          <a:p xmlns:a="http://schemas.openxmlformats.org/drawingml/2006/main">
+            <a:pPr>
+              <a:defRPr sz="2175" b="1">
+                <a:solidFill>
+                  <a:srgbClr val="AD583D"/>
+                </a:solidFill>
+                <a:latin typeface="Arial"/>
+                <a:ea typeface="Arial"/>
+                <a:cs typeface="Arial"/>
+              </a:defRPr>
+            </a:pPr>
+            <a:r>
+              <a:rPr sz="2175" b="1">
+                <a:solidFill>
+                  <a:srgbClr val="AD583D"/>
+                </a:solidFill>
+                <a:latin typeface="Arial"/>
+                <a:ea typeface="Arial"/>
+                <a:cs typeface="Arial"/>
+              </a:rPr>
+              <a:t>https://quiznova-muskanbuilds11.onrender.com</a:t>
+            </a:r>
+          </a:p>
+        </p:txBody>
+      </p:sp>
       <p:graphicFrame>
         <p:nvGraphicFramePr>
-          <p:cNvPr id="5" name="">
-            <a:extLst xmlns:a="http://schemas.openxmlformats.org/drawingml/2006/main">
-              <a:ext uri="{FF2B5EF4-FFF2-40B4-BE49-F238E27FC236}">
-                <a16:creationId xmlns:a16="http://schemas.microsoft.com/office/drawing/2014/main" id="{1EEDB10E-62B1-478F-B98E-5D8767AF1351}"/>
+          <p:cNvPr id="6" name="">
+            <a:extLst xmlns:a="http://schemas.openxmlformats.org/drawingml/2006/main">
+              <a:ext uri="{FF2B5EF4-FFF2-40B4-BE49-F238E27FC236}">
+                <a16:creationId xmlns:a16="http://schemas.microsoft.com/office/drawing/2014/main" id="{22C0E206-95BE-499B-B2A7-BE794051E46D}"/>
               </a:ext>
             </a:extLst>
           </p:cNvPr>
@@ -8994,25 +9060,26 @@
           <p:nvPr/>
         </p:nvGraphicFramePr>
         <p:xfrm>
-          <a:off xmlns:a="http://schemas.openxmlformats.org/drawingml/2006/main" x="609600" y="1743075"/>
-          <a:ext xmlns:a="http://schemas.openxmlformats.org/drawingml/2006/main" cx="10972800" cy="2857500"/>
+          <a:off xmlns:a="http://schemas.openxmlformats.org/drawingml/2006/main" x="609600" y="2514600"/>
+          <a:ext xmlns:a="http://schemas.openxmlformats.org/drawingml/2006/main" cx="10972800" cy="1809750"/>
         </p:xfrm>
         <a:graphic xmlns:a="http://schemas.openxmlformats.org/drawingml/2006/main">
           <a:graphicData uri="http://schemas.openxmlformats.org/drawingml/2006/table">
             <a:tbl>
               <a:tblPr/>
               <a:tblGrid>
-                <a:gridCol w="4000500"/>
-                <a:gridCol w="6972300"/>
+                <a:gridCol w="2190750"/>
+                <a:gridCol w="5238750"/>
+                <a:gridCol w="3543300"/>
               </a:tblGrid>
-              <a:tr h="714375">
+              <a:tr h="904875">
                 <a:tc>
                   <a:txBody>
                     <a:bodyPr/>
                     <a:lstStyle/>
                     <a:p>
                       <a:r>
-                        <a:rPr sz="2175" b="1">
+                        <a:rPr sz="1950" b="1">
                           <a:solidFill>
                             <a:srgbClr val="F5F2E9"/>
                           </a:solidFill>
@@ -9056,7 +9123,7 @@
                     <a:lstStyle/>
                     <a:p>
                       <a:r>
-                        <a:rPr sz="2175" b="1">
+                        <a:rPr sz="1950" b="1">
                           <a:solidFill>
                             <a:srgbClr val="F5F2E9"/>
                           </a:solidFill>
@@ -9089,62 +9156,21 @@
                     </a:solidFill>
                   </a:tcPr>
                 </a:tc>
-              </a:tr>
-              <a:tr h="714375">
                 <a:tc>
                   <a:txBody>
                     <a:bodyPr/>
                     <a:lstStyle/>
                     <a:p>
                       <a:r>
-                        <a:rPr sz="2175">
+                        <a:rPr sz="1950" b="1">
                           <a:solidFill>
-                            <a:srgbClr val="253F33"/>
+                            <a:srgbClr val="F5F2E9"/>
                           </a:solidFill>
                           <a:latin typeface="Arial"/>
                           <a:ea typeface="Arial"/>
                           <a:cs typeface="Arial"/>
                         </a:rPr>
-                        <a:t>Administrator</a:t>
-                      </a:r>
-                    </a:p>
-                  </a:txBody>
-                  <a:tcPr marL="171450" marR="171450" marT="161925" marB="161925">
-                    <a:lnL w="9525">
-                      <a:solidFill>
-                        <a:srgbClr val="BBC5B6"/>
-                      </a:solidFill>
-                    </a:lnL>
-                    <a:lnR w="9525">
-                      <a:solidFill>
-                        <a:srgbClr val="BBC5B6"/>
-                      </a:solidFill>
-                    </a:lnR>
-                    <a:lnB w="9525">
-                      <a:solidFill>
-                        <a:srgbClr val="BBC5B6"/>
-                      </a:solidFill>
-                    </a:lnB>
-                    <a:solidFill>
-                      <a:srgbClr val="F5F2E9"/>
-                    </a:solidFill>
-                  </a:tcPr>
-                </a:tc>
-                <a:tc>
-                  <a:txBody>
-                    <a:bodyPr/>
-                    <a:lstStyle/>
-                    <a:p>
-                      <a:r>
-                        <a:rPr sz="2175">
-                          <a:solidFill>
-                            <a:srgbClr val="253F33"/>
-                          </a:solidFill>
-                          <a:latin typeface="Arial"/>
-                          <a:ea typeface="Arial"/>
-                          <a:cs typeface="Arial"/>
-                        </a:rPr>
-                        <a:t>admin@quizcraft.dev</a:t>
+                        <a:t>Password</a:t>
                       </a:r>
                     </a:p>
                   </a:txBody>
@@ -9154,100 +9180,30 @@
                         <a:srgbClr val="BBC5B6"/>
                       </a:solidFill>
                     </a:lnR>
+                    <a:lnT w="9525">
+                      <a:solidFill>
+                        <a:srgbClr val="BBC5B6"/>
+                      </a:solidFill>
+                    </a:lnT>
                     <a:lnB w="9525">
                       <a:solidFill>
                         <a:srgbClr val="BBC5B6"/>
                       </a:solidFill>
                     </a:lnB>
                     <a:solidFill>
-                      <a:srgbClr val="F5F2E9"/>
+                      <a:srgbClr val="253F33"/>
                     </a:solidFill>
                   </a:tcPr>
                 </a:tc>
               </a:tr>
-              <a:tr h="714375">
+              <a:tr h="904875">
                 <a:tc>
                   <a:txBody>
                     <a:bodyPr/>
                     <a:lstStyle/>
                     <a:p>
                       <a:r>
-                        <a:rPr sz="2175">
-                          <a:solidFill>
-                            <a:srgbClr val="253F33"/>
-                          </a:solidFill>
-                          <a:latin typeface="Arial"/>
-                          <a:ea typeface="Arial"/>
-                          <a:cs typeface="Arial"/>
-                        </a:rPr>
-                        <a:t>Quiz creator</a:t>
-                      </a:r>
-                    </a:p>
-                  </a:txBody>
-                  <a:tcPr marL="171450" marR="171450" marT="161925" marB="161925">
-                    <a:lnL w="9525">
-                      <a:solidFill>
-                        <a:srgbClr val="BBC5B6"/>
-                      </a:solidFill>
-                    </a:lnL>
-                    <a:lnR w="9525">
-                      <a:solidFill>
-                        <a:srgbClr val="BBC5B6"/>
-                      </a:solidFill>
-                    </a:lnR>
-                    <a:lnB w="9525">
-                      <a:solidFill>
-                        <a:srgbClr val="BBC5B6"/>
-                      </a:solidFill>
-                    </a:lnB>
-                    <a:solidFill>
-                      <a:srgbClr val="F5F2E9"/>
-                    </a:solidFill>
-                  </a:tcPr>
-                </a:tc>
-                <a:tc>
-                  <a:txBody>
-                    <a:bodyPr/>
-                    <a:lstStyle/>
-                    <a:p>
-                      <a:r>
-                        <a:rPr sz="2175">
-                          <a:solidFill>
-                            <a:srgbClr val="253F33"/>
-                          </a:solidFill>
-                          <a:latin typeface="Arial"/>
-                          <a:ea typeface="Arial"/>
-                          <a:cs typeface="Arial"/>
-                        </a:rPr>
-                        <a:t>creator@quizcraft.dev</a:t>
-                      </a:r>
-                    </a:p>
-                  </a:txBody>
-                  <a:tcPr marL="171450" marR="171450" marT="161925" marB="161925">
-                    <a:lnR w="9525">
-                      <a:solidFill>
-                        <a:srgbClr val="BBC5B6"/>
-                      </a:solidFill>
-                    </a:lnR>
-                    <a:lnB w="9525">
-                      <a:solidFill>
-                        <a:srgbClr val="BBC5B6"/>
-                      </a:solidFill>
-                    </a:lnB>
-                    <a:solidFill>
-                      <a:srgbClr val="F5F2E9"/>
-                    </a:solidFill>
-                  </a:tcPr>
-                </a:tc>
-              </a:tr>
-              <a:tr h="714375">
-                <a:tc>
-                  <a:txBody>
-                    <a:bodyPr/>
-                    <a:lstStyle/>
-                    <a:p>
-                      <a:r>
-                        <a:rPr sz="2175">
+                        <a:rPr sz="1950">
                           <a:solidFill>
                             <a:srgbClr val="253F33"/>
                           </a:solidFill>
@@ -9286,7 +9242,7 @@
                     <a:lstStyle/>
                     <a:p>
                       <a:r>
-                        <a:rPr sz="2175">
+                        <a:rPr sz="1950">
                           <a:solidFill>
                             <a:srgbClr val="253F33"/>
                           </a:solidFill>
@@ -9294,7 +9250,41 @@
                           <a:ea typeface="Arial"/>
                           <a:cs typeface="Arial"/>
                         </a:rPr>
-                        <a:t>participant@quizcraft.dev</a:t>
+                        <a:t>reviewer@quiznova.test</a:t>
+                      </a:r>
+                    </a:p>
+                  </a:txBody>
+                  <a:tcPr marL="171450" marR="171450" marT="161925" marB="161925">
+                    <a:lnR w="9525">
+                      <a:solidFill>
+                        <a:srgbClr val="BBC5B6"/>
+                      </a:solidFill>
+                    </a:lnR>
+                    <a:lnB w="9525">
+                      <a:solidFill>
+                        <a:srgbClr val="BBC5B6"/>
+                      </a:solidFill>
+                    </a:lnB>
+                    <a:solidFill>
+                      <a:srgbClr val="F5F2E9"/>
+                    </a:solidFill>
+                  </a:tcPr>
+                </a:tc>
+                <a:tc>
+                  <a:txBody>
+                    <a:bodyPr/>
+                    <a:lstStyle/>
+                    <a:p>
+                      <a:r>
+                        <a:rPr sz="1950">
+                          <a:solidFill>
+                            <a:srgbClr val="253F33"/>
+                          </a:solidFill>
+                          <a:latin typeface="Arial"/>
+                          <a:ea typeface="Arial"/>
+                          <a:cs typeface="Arial"/>
+                        </a:rPr>
+                        <a:t>ReviewJava@2026</a:t>
                       </a:r>
                     </a:p>
                   </a:txBody>
@@ -9321,22 +9311,22 @@
       </p:graphicFrame>
       <p:sp>
         <p:nvSpPr>
-          <p:cNvPr id="6" name="">
-            <a:extLst xmlns:a="http://schemas.openxmlformats.org/drawingml/2006/main">
-              <a:ext uri="{FF2B5EF4-FFF2-40B4-BE49-F238E27FC236}">
-                <a16:creationId xmlns:a16="http://schemas.microsoft.com/office/drawing/2014/main" id="{52B1193B-9709-4728-AE8E-F7575011A3D5}"/>
-              </a:ext>
-            </a:extLst>
-          </p:cNvPr>
-          <p:cNvSpPr>
-            <a:spLocks xmlns:a="http://schemas.openxmlformats.org/drawingml/2006/main" noGrp="1"/>
-          </p:cNvSpPr>
-          <p:nvPr/>
-        </p:nvSpPr>
-        <p:spPr>
-          <a:xfrm xmlns:a="http://schemas.openxmlformats.org/drawingml/2006/main">
-            <a:off x="609600" y="4953000"/>
-            <a:ext cx="10668000" cy="571500"/>
+          <p:cNvPr id="7" name="">
+            <a:extLst xmlns:a="http://schemas.openxmlformats.org/drawingml/2006/main">
+              <a:ext uri="{FF2B5EF4-FFF2-40B4-BE49-F238E27FC236}">
+                <a16:creationId xmlns:a16="http://schemas.microsoft.com/office/drawing/2014/main" id="{67C154A4-8542-4C86-B4EB-A39247A35C56}"/>
+              </a:ext>
+            </a:extLst>
+          </p:cNvPr>
+          <p:cNvSpPr>
+            <a:spLocks xmlns:a="http://schemas.openxmlformats.org/drawingml/2006/main" noGrp="1"/>
+          </p:cNvSpPr>
+          <p:nvPr/>
+        </p:nvSpPr>
+        <p:spPr>
+          <a:xfrm xmlns:a="http://schemas.openxmlformats.org/drawingml/2006/main">
+            <a:off x="609600" y="4676775"/>
+            <a:ext cx="10972800" cy="571500"/>
           </a:xfrm>
           <a:prstGeom xmlns:a="http://schemas.openxmlformats.org/drawingml/2006/main" prst="rect">
             <a:avLst/>
@@ -9350,7 +9340,7 @@
           <a:bodyPr xmlns:a="http://schemas.openxmlformats.org/drawingml/2006/main"/>
           <a:lstStyle xmlns:a="http://schemas.openxmlformats.org/drawingml/2006/main">
             <a:defPPr>
-              <a:defRPr sz="2550" b="1">
+              <a:defRPr sz="2100" b="1">
                 <a:solidFill>
                   <a:srgbClr val="AD583D"/>
                 </a:solidFill>
@@ -9362,7 +9352,7 @@
           </a:lstStyle>
           <a:p xmlns:a="http://schemas.openxmlformats.org/drawingml/2006/main">
             <a:pPr>
-              <a:defRPr sz="2550" b="1">
+              <a:defRPr sz="2100" b="1">
                 <a:solidFill>
                   <a:srgbClr val="AD583D"/>
                 </a:solidFill>
@@ -9372,7 +9362,7 @@
               </a:defRPr>
             </a:pPr>
             <a:r>
-              <a:rPr sz="2550" b="1">
+              <a:rPr sz="2100" b="1">
                 <a:solidFill>
                   <a:srgbClr val="AD583D"/>
                 </a:solidFill>
@@ -9380,29 +9370,29 @@
                 <a:ea typeface="Arial"/>
                 <a:cs typeface="Arial"/>
               </a:rPr>
-              <a:t>Password for all three: JavaLab@123</a:t>
-            </a:r>
-          </a:p>
-        </p:txBody>
-      </p:sp>
-      <p:sp>
-        <p:nvSpPr>
-          <p:cNvPr id="7" name="">
-            <a:extLst xmlns:a="http://schemas.openxmlformats.org/drawingml/2006/main">
-              <a:ext uri="{FF2B5EF4-FFF2-40B4-BE49-F238E27FC236}">
-                <a16:creationId xmlns:a16="http://schemas.microsoft.com/office/drawing/2014/main" id="{FE65C4FB-34F7-4095-BD1B-CD976CEBA85C}"/>
-              </a:ext>
-            </a:extLst>
-          </p:cNvPr>
-          <p:cNvSpPr>
-            <a:spLocks xmlns:a="http://schemas.openxmlformats.org/drawingml/2006/main" noGrp="1"/>
-          </p:cNvSpPr>
-          <p:nvPr/>
-        </p:nvSpPr>
-        <p:spPr>
-          <a:xfrm xmlns:a="http://schemas.openxmlformats.org/drawingml/2006/main">
-            <a:off x="609600" y="5772150"/>
-            <a:ext cx="10763250" cy="457200"/>
+              <a:t>6 Java quizzes. 36 questions. Explanations after submission.</a:t>
+            </a:r>
+          </a:p>
+        </p:txBody>
+      </p:sp>
+      <p:sp>
+        <p:nvSpPr>
+          <p:cNvPr id="8" name="">
+            <a:extLst xmlns:a="http://schemas.openxmlformats.org/drawingml/2006/main">
+              <a:ext uri="{FF2B5EF4-FFF2-40B4-BE49-F238E27FC236}">
+                <a16:creationId xmlns:a16="http://schemas.microsoft.com/office/drawing/2014/main" id="{2C0C1458-D471-4F8E-B99B-E46875826480}"/>
+              </a:ext>
+            </a:extLst>
+          </p:cNvPr>
+          <p:cNvSpPr>
+            <a:spLocks xmlns:a="http://schemas.openxmlformats.org/drawingml/2006/main" noGrp="1"/>
+          </p:cNvSpPr>
+          <p:nvPr/>
+        </p:nvSpPr>
+        <p:spPr>
+          <a:xfrm xmlns:a="http://schemas.openxmlformats.org/drawingml/2006/main">
+            <a:off x="609600" y="5353050"/>
+            <a:ext cx="10972800" cy="457200"/>
           </a:xfrm>
           <a:prstGeom xmlns:a="http://schemas.openxmlformats.org/drawingml/2006/main" prst="rect">
             <a:avLst/>
@@ -9446,7 +9436,73 @@
                 <a:ea typeface="Arial"/>
                 <a:cs typeface="Arial"/>
               </a:rPr>
-              <a:t>Normal users create an account first. Admin creates creator accounts.</a:t>
+              <a:t>Shared demo account. Create your own account for separate quiz history.</a:t>
+            </a:r>
+          </a:p>
+        </p:txBody>
+      </p:sp>
+      <p:sp>
+        <p:nvSpPr>
+          <p:cNvPr id="9" name="">
+            <a:extLst xmlns:a="http://schemas.openxmlformats.org/drawingml/2006/main">
+              <a:ext uri="{FF2B5EF4-FFF2-40B4-BE49-F238E27FC236}">
+                <a16:creationId xmlns:a16="http://schemas.microsoft.com/office/drawing/2014/main" id="{28B55490-D3C1-4862-94DD-CE82743417F2}"/>
+              </a:ext>
+            </a:extLst>
+          </p:cNvPr>
+          <p:cNvSpPr>
+            <a:spLocks xmlns:a="http://schemas.openxmlformats.org/drawingml/2006/main" noGrp="1"/>
+          </p:cNvSpPr>
+          <p:nvPr/>
+        </p:nvSpPr>
+        <p:spPr>
+          <a:xfrm xmlns:a="http://schemas.openxmlformats.org/drawingml/2006/main">
+            <a:off x="609600" y="5848350"/>
+            <a:ext cx="10972800" cy="400050"/>
+          </a:xfrm>
+          <a:prstGeom xmlns:a="http://schemas.openxmlformats.org/drawingml/2006/main" prst="rect">
+            <a:avLst/>
+          </a:prstGeom>
+          <a:noFill xmlns:a="http://schemas.openxmlformats.org/drawingml/2006/main"/>
+          <a:ln xmlns:a="http://schemas.openxmlformats.org/drawingml/2006/main" w="0">
+            <a:noFill/>
+          </a:ln>
+        </p:spPr>
+        <p:txBody>
+          <a:bodyPr xmlns:a="http://schemas.openxmlformats.org/drawingml/2006/main"/>
+          <a:lstStyle xmlns:a="http://schemas.openxmlformats.org/drawingml/2006/main">
+            <a:defPPr>
+              <a:defRPr sz="1725" b="0">
+                <a:solidFill>
+                  <a:srgbClr val="253F33"/>
+                </a:solidFill>
+                <a:latin typeface="Arial"/>
+                <a:ea typeface="Arial"/>
+                <a:cs typeface="Arial"/>
+              </a:defRPr>
+            </a:defPPr>
+          </a:lstStyle>
+          <a:p xmlns:a="http://schemas.openxmlformats.org/drawingml/2006/main">
+            <a:pPr>
+              <a:defRPr sz="1725" b="0">
+                <a:solidFill>
+                  <a:srgbClr val="253F33"/>
+                </a:solidFill>
+                <a:latin typeface="Arial"/>
+                <a:ea typeface="Arial"/>
+                <a:cs typeface="Arial"/>
+              </a:defRPr>
+            </a:pPr>
+            <a:r>
+              <a:rPr sz="1725" b="0">
+                <a:solidFill>
+                  <a:srgbClr val="253F33"/>
+                </a:solidFill>
+                <a:latin typeface="Arial"/>
+                <a:ea typeface="Arial"/>
+                <a:cs typeface="Arial"/>
+              </a:rPr>
+              <a:t>Administrator and creator credentials are managed privately.</a:t>
             </a:r>
           </a:p>
         </p:txBody>
@@ -9454,7 +9510,7 @@
     </p:spTree>
     <p:extLst>
       <p:ext uri="{BB962C8B-B14F-4D97-AF65-F5344CB8AC3E}">
-        <p14:creationId xmlns:p14="http://schemas.microsoft.com/office/powerpoint/2010/main" val="1355623438"/>
+        <p14:creationId xmlns:p14="http://schemas.microsoft.com/office/powerpoint/2010/main" val="10506376"/>
       </p:ext>
     </p:extLst>
   </p:cSld>
@@ -9485,7 +9541,7 @@
           <p:cNvPr id="12" name="">
             <a:extLst xmlns:a="http://schemas.openxmlformats.org/drawingml/2006/main">
               <a:ext uri="{FF2B5EF4-FFF2-40B4-BE49-F238E27FC236}">
-                <a16:creationId xmlns:a16="http://schemas.microsoft.com/office/drawing/2014/main" id="{353B1A3A-A0E6-4039-A813-AB0D9FB28B3E}"/>
+                <a16:creationId xmlns:a16="http://schemas.microsoft.com/office/drawing/2014/main" id="{AEC551AD-2881-4C38-AAC2-390348167CC0}"/>
               </a:ext>
             </a:extLst>
           </p:cNvPr>
@@ -9551,7 +9607,7 @@
           <p:cNvPr id="2" name="">
             <a:extLst xmlns:a="http://schemas.openxmlformats.org/drawingml/2006/main">
               <a:ext uri="{FF2B5EF4-FFF2-40B4-BE49-F238E27FC236}">
-                <a16:creationId xmlns:a16="http://schemas.microsoft.com/office/drawing/2014/main" id="{D604AD7B-9EAB-48AD-B31C-BDCA4672CB23}"/>
+                <a16:creationId xmlns:a16="http://schemas.microsoft.com/office/drawing/2014/main" id="{5E84AB41-4C61-48C6-9930-16AABB6BE4E8}"/>
               </a:ext>
             </a:extLst>
           </p:cNvPr>
@@ -9617,7 +9673,7 @@
           <p:cNvPr id="3" name="">
             <a:extLst xmlns:a="http://schemas.openxmlformats.org/drawingml/2006/main">
               <a:ext uri="{FF2B5EF4-FFF2-40B4-BE49-F238E27FC236}">
-                <a16:creationId xmlns:a16="http://schemas.microsoft.com/office/drawing/2014/main" id="{5255E50A-E22A-4CFB-BFC9-2DFB7CCC3DB7}"/>
+                <a16:creationId xmlns:a16="http://schemas.microsoft.com/office/drawing/2014/main" id="{3C97D70E-CE3B-4FD8-8E8C-CD7DA14DD2A4}"/>
               </a:ext>
             </a:extLst>
           </p:cNvPr>
@@ -9683,7 +9739,7 @@
           <p:cNvPr id="4" name="">
             <a:extLst xmlns:a="http://schemas.openxmlformats.org/drawingml/2006/main">
               <a:ext uri="{FF2B5EF4-FFF2-40B4-BE49-F238E27FC236}">
-                <a16:creationId xmlns:a16="http://schemas.microsoft.com/office/drawing/2014/main" id="{8BB741FC-A07F-40D8-AD40-7593D8A67C7F}"/>
+                <a16:creationId xmlns:a16="http://schemas.microsoft.com/office/drawing/2014/main" id="{928FCFE4-5B30-479D-9B6A-9AAB58DDCCD5}"/>
               </a:ext>
             </a:extLst>
           </p:cNvPr>
@@ -9749,7 +9805,7 @@
           <p:cNvPr id="5" name="">
             <a:extLst xmlns:a="http://schemas.openxmlformats.org/drawingml/2006/main">
               <a:ext uri="{FF2B5EF4-FFF2-40B4-BE49-F238E27FC236}">
-                <a16:creationId xmlns:a16="http://schemas.microsoft.com/office/drawing/2014/main" id="{EF3B05EF-3A26-4814-AD84-89ACBBA86846}"/>
+                <a16:creationId xmlns:a16="http://schemas.microsoft.com/office/drawing/2014/main" id="{2A78E91A-769D-4285-94DB-C40A581B9DFB}"/>
               </a:ext>
             </a:extLst>
           </p:cNvPr>
@@ -9815,7 +9871,7 @@
           <p:cNvPr id="6" name="">
             <a:extLst xmlns:a="http://schemas.openxmlformats.org/drawingml/2006/main">
               <a:ext uri="{FF2B5EF4-FFF2-40B4-BE49-F238E27FC236}">
-                <a16:creationId xmlns:a16="http://schemas.microsoft.com/office/drawing/2014/main" id="{FBF13A5E-6A95-45ED-96B0-8B3CB9767829}"/>
+                <a16:creationId xmlns:a16="http://schemas.microsoft.com/office/drawing/2014/main" id="{6D92C023-5377-47F3-9B71-B850D40FAA27}"/>
               </a:ext>
             </a:extLst>
           </p:cNvPr>
@@ -9881,7 +9937,7 @@
           <p:cNvPr id="7" name="">
             <a:extLst xmlns:a="http://schemas.openxmlformats.org/drawingml/2006/main">
               <a:ext uri="{FF2B5EF4-FFF2-40B4-BE49-F238E27FC236}">
-                <a16:creationId xmlns:a16="http://schemas.microsoft.com/office/drawing/2014/main" id="{91712309-A384-4B57-8A70-FD3DF6E4F8BB}"/>
+                <a16:creationId xmlns:a16="http://schemas.microsoft.com/office/drawing/2014/main" id="{D870EB48-AB3D-4191-A971-59E6C7326466}"/>
               </a:ext>
             </a:extLst>
           </p:cNvPr>
@@ -9947,7 +10003,7 @@
           <p:cNvPr id="8" name="">
             <a:extLst xmlns:a="http://schemas.openxmlformats.org/drawingml/2006/main">
               <a:ext uri="{FF2B5EF4-FFF2-40B4-BE49-F238E27FC236}">
-                <a16:creationId xmlns:a16="http://schemas.microsoft.com/office/drawing/2014/main" id="{A0F390AF-4DED-4DD1-96BF-1B5CFB5FC37D}"/>
+                <a16:creationId xmlns:a16="http://schemas.microsoft.com/office/drawing/2014/main" id="{95D8D57E-C367-4530-B216-AC47D8AA29FA}"/>
               </a:ext>
             </a:extLst>
           </p:cNvPr>
@@ -10013,7 +10069,7 @@
           <p:cNvPr id="9" name="">
             <a:extLst xmlns:a="http://schemas.openxmlformats.org/drawingml/2006/main">
               <a:ext uri="{FF2B5EF4-FFF2-40B4-BE49-F238E27FC236}">
-                <a16:creationId xmlns:a16="http://schemas.microsoft.com/office/drawing/2014/main" id="{598A8E44-C627-41E2-9C70-06DCF6B4EE9A}"/>
+                <a16:creationId xmlns:a16="http://schemas.microsoft.com/office/drawing/2014/main" id="{5B3819EB-E47B-4405-91E7-09A537252F60}"/>
               </a:ext>
             </a:extLst>
           </p:cNvPr>
@@ -10079,7 +10135,7 @@
           <p:cNvPr id="10" name="">
             <a:extLst xmlns:a="http://schemas.openxmlformats.org/drawingml/2006/main">
               <a:ext uri="{FF2B5EF4-FFF2-40B4-BE49-F238E27FC236}">
-                <a16:creationId xmlns:a16="http://schemas.microsoft.com/office/drawing/2014/main" id="{B790AA26-A274-4220-A066-2F1F5EB9D9BE}"/>
+                <a16:creationId xmlns:a16="http://schemas.microsoft.com/office/drawing/2014/main" id="{07780AE5-ED3E-472D-8DAD-FF7D91623D4A}"/>
               </a:ext>
             </a:extLst>
           </p:cNvPr>
@@ -10145,7 +10201,7 @@
           <p:cNvPr id="11" name="">
             <a:extLst xmlns:a="http://schemas.openxmlformats.org/drawingml/2006/main">
               <a:ext uri="{FF2B5EF4-FFF2-40B4-BE49-F238E27FC236}">
-                <a16:creationId xmlns:a16="http://schemas.microsoft.com/office/drawing/2014/main" id="{C72F0374-BA83-459E-92BA-4DDA43FA176A}"/>
+                <a16:creationId xmlns:a16="http://schemas.microsoft.com/office/drawing/2014/main" id="{CFADC305-0C4D-43EE-92FE-D93ECAB37158}"/>
               </a:ext>
             </a:extLst>
           </p:cNvPr>
@@ -10209,7 +10265,7 @@
     </p:spTree>
     <p:extLst>
       <p:ext uri="{BB962C8B-B14F-4D97-AF65-F5344CB8AC3E}">
-        <p14:creationId xmlns:p14="http://schemas.microsoft.com/office/powerpoint/2010/main" val="1816796149"/>
+        <p14:creationId xmlns:p14="http://schemas.microsoft.com/office/powerpoint/2010/main" val="325817016"/>
       </p:ext>
     </p:extLst>
   </p:cSld>
@@ -10240,7 +10296,7 @@
           <p:cNvPr id="12" name="">
             <a:extLst xmlns:a="http://schemas.openxmlformats.org/drawingml/2006/main">
               <a:ext uri="{FF2B5EF4-FFF2-40B4-BE49-F238E27FC236}">
-                <a16:creationId xmlns:a16="http://schemas.microsoft.com/office/drawing/2014/main" id="{7EC57283-04F4-4C30-BE70-BA11A57B90A6}"/>
+                <a16:creationId xmlns:a16="http://schemas.microsoft.com/office/drawing/2014/main" id="{C2E865AC-3FCE-410E-8082-75234F0A5963}"/>
               </a:ext>
             </a:extLst>
           </p:cNvPr>
@@ -10306,7 +10362,7 @@
           <p:cNvPr id="2" name="">
             <a:extLst xmlns:a="http://schemas.openxmlformats.org/drawingml/2006/main">
               <a:ext uri="{FF2B5EF4-FFF2-40B4-BE49-F238E27FC236}">
-                <a16:creationId xmlns:a16="http://schemas.microsoft.com/office/drawing/2014/main" id="{8ACCB7F6-3AF4-44AC-B7AE-96494731127A}"/>
+                <a16:creationId xmlns:a16="http://schemas.microsoft.com/office/drawing/2014/main" id="{0A109569-66EA-4234-902C-D117E90B102E}"/>
               </a:ext>
             </a:extLst>
           </p:cNvPr>
@@ -10372,7 +10428,7 @@
           <p:cNvPr id="3" name="">
             <a:extLst xmlns:a="http://schemas.openxmlformats.org/drawingml/2006/main">
               <a:ext uri="{FF2B5EF4-FFF2-40B4-BE49-F238E27FC236}">
-                <a16:creationId xmlns:a16="http://schemas.microsoft.com/office/drawing/2014/main" id="{894EC7DC-FFB1-416E-A887-903F680F8CF8}"/>
+                <a16:creationId xmlns:a16="http://schemas.microsoft.com/office/drawing/2014/main" id="{B02577D0-0A7D-47C6-B0DA-307D2E8CD391}"/>
               </a:ext>
             </a:extLst>
           </p:cNvPr>
@@ -10438,7 +10494,7 @@
           <p:cNvPr id="4" name="">
             <a:extLst xmlns:a="http://schemas.openxmlformats.org/drawingml/2006/main">
               <a:ext uri="{FF2B5EF4-FFF2-40B4-BE49-F238E27FC236}">
-                <a16:creationId xmlns:a16="http://schemas.microsoft.com/office/drawing/2014/main" id="{4354C36E-1640-43F9-9732-D245FC2BBEAD}"/>
+                <a16:creationId xmlns:a16="http://schemas.microsoft.com/office/drawing/2014/main" id="{6D66DCC7-980A-4FB6-82EF-D2814B4387D0}"/>
               </a:ext>
             </a:extLst>
           </p:cNvPr>
@@ -10504,7 +10560,7 @@
           <p:cNvPr id="5" name="">
             <a:extLst xmlns:a="http://schemas.openxmlformats.org/drawingml/2006/main">
               <a:ext uri="{FF2B5EF4-FFF2-40B4-BE49-F238E27FC236}">
-                <a16:creationId xmlns:a16="http://schemas.microsoft.com/office/drawing/2014/main" id="{DEB32B90-5FB3-4FD5-87B6-B3F5C2BA3CC0}"/>
+                <a16:creationId xmlns:a16="http://schemas.microsoft.com/office/drawing/2014/main" id="{112CAE8E-0BCE-465F-B0C2-39192EE95EB0}"/>
               </a:ext>
             </a:extLst>
           </p:cNvPr>
@@ -10570,7 +10626,7 @@
           <p:cNvPr id="6" name="">
             <a:extLst xmlns:a="http://schemas.openxmlformats.org/drawingml/2006/main">
               <a:ext uri="{FF2B5EF4-FFF2-40B4-BE49-F238E27FC236}">
-                <a16:creationId xmlns:a16="http://schemas.microsoft.com/office/drawing/2014/main" id="{A4F206D0-DE1C-4C72-9374-9EB289D12D82}"/>
+                <a16:creationId xmlns:a16="http://schemas.microsoft.com/office/drawing/2014/main" id="{7C3E2058-C0E7-4E94-8497-C811E5F5F36A}"/>
               </a:ext>
             </a:extLst>
           </p:cNvPr>
@@ -10636,7 +10692,7 @@
           <p:cNvPr id="7" name="">
             <a:extLst xmlns:a="http://schemas.openxmlformats.org/drawingml/2006/main">
               <a:ext uri="{FF2B5EF4-FFF2-40B4-BE49-F238E27FC236}">
-                <a16:creationId xmlns:a16="http://schemas.microsoft.com/office/drawing/2014/main" id="{A5C53F2F-E025-49D6-BD47-A643397D8D94}"/>
+                <a16:creationId xmlns:a16="http://schemas.microsoft.com/office/drawing/2014/main" id="{6910DCBD-CF62-457A-8F48-81CD1F1A8B42}"/>
               </a:ext>
             </a:extLst>
           </p:cNvPr>
@@ -10702,7 +10758,7 @@
           <p:cNvPr id="8" name="">
             <a:extLst xmlns:a="http://schemas.openxmlformats.org/drawingml/2006/main">
               <a:ext uri="{FF2B5EF4-FFF2-40B4-BE49-F238E27FC236}">
-                <a16:creationId xmlns:a16="http://schemas.microsoft.com/office/drawing/2014/main" id="{DF95FF0C-C56E-433D-80F6-9AE0F6E8419F}"/>
+                <a16:creationId xmlns:a16="http://schemas.microsoft.com/office/drawing/2014/main" id="{F9CC3F04-67C9-4764-AF24-BD465F9150ED}"/>
               </a:ext>
             </a:extLst>
           </p:cNvPr>
@@ -10768,7 +10824,7 @@
           <p:cNvPr id="9" name="">
             <a:extLst xmlns:a="http://schemas.openxmlformats.org/drawingml/2006/main">
               <a:ext uri="{FF2B5EF4-FFF2-40B4-BE49-F238E27FC236}">
-                <a16:creationId xmlns:a16="http://schemas.microsoft.com/office/drawing/2014/main" id="{1D074E9E-F699-41F3-A6F3-B6C1C1BF3C66}"/>
+                <a16:creationId xmlns:a16="http://schemas.microsoft.com/office/drawing/2014/main" id="{1B3167B3-857B-451E-9E10-8AD69C897E24}"/>
               </a:ext>
             </a:extLst>
           </p:cNvPr>
@@ -10834,7 +10890,7 @@
           <p:cNvPr id="10" name="">
             <a:extLst xmlns:a="http://schemas.openxmlformats.org/drawingml/2006/main">
               <a:ext uri="{FF2B5EF4-FFF2-40B4-BE49-F238E27FC236}">
-                <a16:creationId xmlns:a16="http://schemas.microsoft.com/office/drawing/2014/main" id="{A13A16E0-55F3-4011-B96C-8AB77708589A}"/>
+                <a16:creationId xmlns:a16="http://schemas.microsoft.com/office/drawing/2014/main" id="{19190C49-48BD-4983-B720-D4799A79D6F0}"/>
               </a:ext>
             </a:extLst>
           </p:cNvPr>
@@ -10900,7 +10956,7 @@
           <p:cNvPr id="11" name="">
             <a:extLst xmlns:a="http://schemas.openxmlformats.org/drawingml/2006/main">
               <a:ext uri="{FF2B5EF4-FFF2-40B4-BE49-F238E27FC236}">
-                <a16:creationId xmlns:a16="http://schemas.microsoft.com/office/drawing/2014/main" id="{E36279AA-DDFB-4853-BEC0-B2D347BD2FED}"/>
+                <a16:creationId xmlns:a16="http://schemas.microsoft.com/office/drawing/2014/main" id="{5152B311-3125-47BA-BC5F-5375004C8AC6}"/>
               </a:ext>
             </a:extLst>
           </p:cNvPr>
@@ -10964,7 +11020,7 @@
     </p:spTree>
     <p:extLst>
       <p:ext uri="{BB962C8B-B14F-4D97-AF65-F5344CB8AC3E}">
-        <p14:creationId xmlns:p14="http://schemas.microsoft.com/office/powerpoint/2010/main" val="1010940883"/>
+        <p14:creationId xmlns:p14="http://schemas.microsoft.com/office/powerpoint/2010/main" val="1766506006"/>
       </p:ext>
     </p:extLst>
   </p:cSld>
@@ -10995,7 +11051,7 @@
           <p:cNvPr id="16" name="">
             <a:extLst xmlns:a="http://schemas.openxmlformats.org/drawingml/2006/main">
               <a:ext uri="{FF2B5EF4-FFF2-40B4-BE49-F238E27FC236}">
-                <a16:creationId xmlns:a16="http://schemas.microsoft.com/office/drawing/2014/main" id="{ECB4F049-E17E-4D9B-B10A-71F873B64778}"/>
+                <a16:creationId xmlns:a16="http://schemas.microsoft.com/office/drawing/2014/main" id="{80F721A1-11FF-4597-AB10-F618CEFD2A50}"/>
               </a:ext>
             </a:extLst>
           </p:cNvPr>
@@ -11026,7 +11082,7 @@
           <p:cNvPr id="15" name="">
             <a:extLst xmlns:a="http://schemas.openxmlformats.org/drawingml/2006/main">
               <a:ext uri="{FF2B5EF4-FFF2-40B4-BE49-F238E27FC236}">
-                <a16:creationId xmlns:a16="http://schemas.microsoft.com/office/drawing/2014/main" id="{6F4F54C7-03A3-42FE-9760-5310A7BB06E8}"/>
+                <a16:creationId xmlns:a16="http://schemas.microsoft.com/office/drawing/2014/main" id="{9F73893E-71BE-4C62-A103-A78E41E341D2}"/>
               </a:ext>
             </a:extLst>
           </p:cNvPr>
@@ -11057,7 +11113,7 @@
           <p:cNvPr id="14" name="">
             <a:extLst xmlns:a="http://schemas.openxmlformats.org/drawingml/2006/main">
               <a:ext uri="{FF2B5EF4-FFF2-40B4-BE49-F238E27FC236}">
-                <a16:creationId xmlns:a16="http://schemas.microsoft.com/office/drawing/2014/main" id="{7B12681F-59F1-4DA9-9F80-C83EEE2730D6}"/>
+                <a16:creationId xmlns:a16="http://schemas.microsoft.com/office/drawing/2014/main" id="{0E4244A3-9442-454C-8096-D25EEFA4104A}"/>
               </a:ext>
             </a:extLst>
           </p:cNvPr>
@@ -11088,7 +11144,7 @@
           <p:cNvPr id="13" name="">
             <a:extLst xmlns:a="http://schemas.openxmlformats.org/drawingml/2006/main">
               <a:ext uri="{FF2B5EF4-FFF2-40B4-BE49-F238E27FC236}">
-                <a16:creationId xmlns:a16="http://schemas.microsoft.com/office/drawing/2014/main" id="{74C5D578-A436-4435-BF12-5C06C2F99872}"/>
+                <a16:creationId xmlns:a16="http://schemas.microsoft.com/office/drawing/2014/main" id="{D47312A5-11FF-47B3-AFAF-E1F36CC2ED9B}"/>
               </a:ext>
             </a:extLst>
           </p:cNvPr>
@@ -11119,7 +11175,7 @@
           <p:cNvPr id="12" name="">
             <a:extLst xmlns:a="http://schemas.openxmlformats.org/drawingml/2006/main">
               <a:ext uri="{FF2B5EF4-FFF2-40B4-BE49-F238E27FC236}">
-                <a16:creationId xmlns:a16="http://schemas.microsoft.com/office/drawing/2014/main" id="{79E0937C-50E4-4F88-B570-6DD61F9A0082}"/>
+                <a16:creationId xmlns:a16="http://schemas.microsoft.com/office/drawing/2014/main" id="{0067A039-F557-4028-B840-7E7D5BAB22F3}"/>
               </a:ext>
             </a:extLst>
           </p:cNvPr>
@@ -11150,7 +11206,7 @@
           <p:cNvPr id="11" name="">
             <a:extLst xmlns:a="http://schemas.openxmlformats.org/drawingml/2006/main">
               <a:ext uri="{FF2B5EF4-FFF2-40B4-BE49-F238E27FC236}">
-                <a16:creationId xmlns:a16="http://schemas.microsoft.com/office/drawing/2014/main" id="{6BE8A253-9342-4F24-A00E-B9428E032597}"/>
+                <a16:creationId xmlns:a16="http://schemas.microsoft.com/office/drawing/2014/main" id="{719A3114-2C4F-4910-BBD5-52FB178E405E}"/>
               </a:ext>
             </a:extLst>
           </p:cNvPr>
@@ -11181,7 +11237,7 @@
           <p:cNvPr id="17" name="">
             <a:extLst xmlns:a="http://schemas.openxmlformats.org/drawingml/2006/main">
               <a:ext uri="{FF2B5EF4-FFF2-40B4-BE49-F238E27FC236}">
-                <a16:creationId xmlns:a16="http://schemas.microsoft.com/office/drawing/2014/main" id="{602E22E7-2571-4A88-9F7D-E69DB09718D3}"/>
+                <a16:creationId xmlns:a16="http://schemas.microsoft.com/office/drawing/2014/main" id="{E8B16964-1775-4845-AA01-374B5B8B5E00}"/>
               </a:ext>
             </a:extLst>
           </p:cNvPr>
@@ -11247,7 +11303,7 @@
           <p:cNvPr id="2" name="">
             <a:extLst xmlns:a="http://schemas.openxmlformats.org/drawingml/2006/main">
               <a:ext uri="{FF2B5EF4-FFF2-40B4-BE49-F238E27FC236}">
-                <a16:creationId xmlns:a16="http://schemas.microsoft.com/office/drawing/2014/main" id="{3467EA4E-6D4E-4D21-9B31-6AF1CB811A2B}"/>
+                <a16:creationId xmlns:a16="http://schemas.microsoft.com/office/drawing/2014/main" id="{AE2BAF90-892E-48B9-920E-0DFE507413CD}"/>
               </a:ext>
             </a:extLst>
           </p:cNvPr>
@@ -11313,7 +11369,7 @@
           <p:cNvPr id="3" name="">
             <a:extLst xmlns:a="http://schemas.openxmlformats.org/drawingml/2006/main">
               <a:ext uri="{FF2B5EF4-FFF2-40B4-BE49-F238E27FC236}">
-                <a16:creationId xmlns:a16="http://schemas.microsoft.com/office/drawing/2014/main" id="{A09BAB1A-EA9F-43FE-A835-3E69340778AB}"/>
+                <a16:creationId xmlns:a16="http://schemas.microsoft.com/office/drawing/2014/main" id="{E0F81296-585E-4334-81FC-335034154801}"/>
               </a:ext>
             </a:extLst>
           </p:cNvPr>
@@ -11379,7 +11435,7 @@
           <p:cNvPr id="4" name="">
             <a:extLst xmlns:a="http://schemas.openxmlformats.org/drawingml/2006/main">
               <a:ext uri="{FF2B5EF4-FFF2-40B4-BE49-F238E27FC236}">
-                <a16:creationId xmlns:a16="http://schemas.microsoft.com/office/drawing/2014/main" id="{68AA98C5-D54C-4DA0-989B-6B743BC81923}"/>
+                <a16:creationId xmlns:a16="http://schemas.microsoft.com/office/drawing/2014/main" id="{BC20C536-EA33-4317-AC00-BFCED6305882}"/>
               </a:ext>
             </a:extLst>
           </p:cNvPr>
@@ -11445,7 +11501,7 @@
           <p:cNvPr id="5" name="">
             <a:extLst xmlns:a="http://schemas.openxmlformats.org/drawingml/2006/main">
               <a:ext uri="{FF2B5EF4-FFF2-40B4-BE49-F238E27FC236}">
-                <a16:creationId xmlns:a16="http://schemas.microsoft.com/office/drawing/2014/main" id="{D2B7D90E-A96C-4A85-A324-D9B3F029C1AA}"/>
+                <a16:creationId xmlns:a16="http://schemas.microsoft.com/office/drawing/2014/main" id="{788B479D-5CF5-4753-A2DC-DCC13BB72DBC}"/>
               </a:ext>
             </a:extLst>
           </p:cNvPr>
@@ -11538,7 +11594,7 @@
           <p:cNvPr id="6" name="">
             <a:extLst xmlns:a="http://schemas.openxmlformats.org/drawingml/2006/main">
               <a:ext uri="{FF2B5EF4-FFF2-40B4-BE49-F238E27FC236}">
-                <a16:creationId xmlns:a16="http://schemas.microsoft.com/office/drawing/2014/main" id="{B4F3A3EE-A111-4FD2-9328-73B046A2BC4A}"/>
+                <a16:creationId xmlns:a16="http://schemas.microsoft.com/office/drawing/2014/main" id="{63F24696-4301-4AFB-8F8C-F04D0E16CD04}"/>
               </a:ext>
             </a:extLst>
           </p:cNvPr>
@@ -11631,7 +11687,7 @@
           <p:cNvPr id="7" name="">
             <a:extLst xmlns:a="http://schemas.openxmlformats.org/drawingml/2006/main">
               <a:ext uri="{FF2B5EF4-FFF2-40B4-BE49-F238E27FC236}">
-                <a16:creationId xmlns:a16="http://schemas.microsoft.com/office/drawing/2014/main" id="{C743ED02-4B5D-448F-AA56-1F0595EC500A}"/>
+                <a16:creationId xmlns:a16="http://schemas.microsoft.com/office/drawing/2014/main" id="{D40DB827-23D8-4D15-A749-45E7F0570D5D}"/>
               </a:ext>
             </a:extLst>
           </p:cNvPr>
@@ -11724,7 +11780,7 @@
           <p:cNvPr id="8" name="">
             <a:extLst xmlns:a="http://schemas.openxmlformats.org/drawingml/2006/main">
               <a:ext uri="{FF2B5EF4-FFF2-40B4-BE49-F238E27FC236}">
-                <a16:creationId xmlns:a16="http://schemas.microsoft.com/office/drawing/2014/main" id="{2EAB2326-1CBB-4CC9-94FC-C004F1C53E5F}"/>
+                <a16:creationId xmlns:a16="http://schemas.microsoft.com/office/drawing/2014/main" id="{2C29F740-F120-4281-9BBB-800924F1BDA1}"/>
               </a:ext>
             </a:extLst>
           </p:cNvPr>
@@ -11817,7 +11873,7 @@
           <p:cNvPr id="9" name="">
             <a:extLst xmlns:a="http://schemas.openxmlformats.org/drawingml/2006/main">
               <a:ext uri="{FF2B5EF4-FFF2-40B4-BE49-F238E27FC236}">
-                <a16:creationId xmlns:a16="http://schemas.microsoft.com/office/drawing/2014/main" id="{FF453E35-237B-46CB-9FEF-D3F011665BF9}"/>
+                <a16:creationId xmlns:a16="http://schemas.microsoft.com/office/drawing/2014/main" id="{311F13DD-CF70-4D9F-9C44-5779FD967DA8}"/>
               </a:ext>
             </a:extLst>
           </p:cNvPr>
@@ -11910,7 +11966,7 @@
           <p:cNvPr id="10" name="">
             <a:extLst xmlns:a="http://schemas.openxmlformats.org/drawingml/2006/main">
               <a:ext uri="{FF2B5EF4-FFF2-40B4-BE49-F238E27FC236}">
-                <a16:creationId xmlns:a16="http://schemas.microsoft.com/office/drawing/2014/main" id="{2F0263F5-4356-4090-BA38-A212659F305E}"/>
+                <a16:creationId xmlns:a16="http://schemas.microsoft.com/office/drawing/2014/main" id="{5B3FCF66-2E21-4658-AC2E-9AB1474583B7}"/>
               </a:ext>
             </a:extLst>
           </p:cNvPr>
@@ -12001,7 +12057,7 @@
     </p:spTree>
     <p:extLst>
       <p:ext uri="{BB962C8B-B14F-4D97-AF65-F5344CB8AC3E}">
-        <p14:creationId xmlns:p14="http://schemas.microsoft.com/office/powerpoint/2010/main" val="1447635965"/>
+        <p14:creationId xmlns:p14="http://schemas.microsoft.com/office/powerpoint/2010/main" val="1114459224"/>
       </p:ext>
     </p:extLst>
   </p:cSld>
@@ -12032,7 +12088,7 @@
           <p:cNvPr id="19" name="">
             <a:extLst xmlns:a="http://schemas.openxmlformats.org/drawingml/2006/main">
               <a:ext uri="{FF2B5EF4-FFF2-40B4-BE49-F238E27FC236}">
-                <a16:creationId xmlns:a16="http://schemas.microsoft.com/office/drawing/2014/main" id="{6BA5E1CF-3F43-4F54-8BA1-65566756C8CA}"/>
+                <a16:creationId xmlns:a16="http://schemas.microsoft.com/office/drawing/2014/main" id="{44242CBE-7326-4801-A2B3-A29C2E6B9F42}"/>
               </a:ext>
             </a:extLst>
           </p:cNvPr>
@@ -12063,7 +12119,7 @@
           <p:cNvPr id="18" name="">
             <a:extLst xmlns:a="http://schemas.openxmlformats.org/drawingml/2006/main">
               <a:ext uri="{FF2B5EF4-FFF2-40B4-BE49-F238E27FC236}">
-                <a16:creationId xmlns:a16="http://schemas.microsoft.com/office/drawing/2014/main" id="{B5079D49-3A42-4328-BD73-22E1F71073C4}"/>
+                <a16:creationId xmlns:a16="http://schemas.microsoft.com/office/drawing/2014/main" id="{E72DA74A-2BB6-482F-A7EB-E6D0C8D7575A}"/>
               </a:ext>
             </a:extLst>
           </p:cNvPr>
@@ -12094,7 +12150,7 @@
           <p:cNvPr id="17" name="">
             <a:extLst xmlns:a="http://schemas.openxmlformats.org/drawingml/2006/main">
               <a:ext uri="{FF2B5EF4-FFF2-40B4-BE49-F238E27FC236}">
-                <a16:creationId xmlns:a16="http://schemas.microsoft.com/office/drawing/2014/main" id="{6C753D2C-760C-448B-A37C-E4F4ED1E6A9C}"/>
+                <a16:creationId xmlns:a16="http://schemas.microsoft.com/office/drawing/2014/main" id="{3CA73431-29B8-4993-8B56-A073E261E951}"/>
               </a:ext>
             </a:extLst>
           </p:cNvPr>
@@ -12125,7 +12181,7 @@
           <p:cNvPr id="16" name="">
             <a:extLst xmlns:a="http://schemas.openxmlformats.org/drawingml/2006/main">
               <a:ext uri="{FF2B5EF4-FFF2-40B4-BE49-F238E27FC236}">
-                <a16:creationId xmlns:a16="http://schemas.microsoft.com/office/drawing/2014/main" id="{09B0F088-AC7C-4F13-A116-4543196AA5DF}"/>
+                <a16:creationId xmlns:a16="http://schemas.microsoft.com/office/drawing/2014/main" id="{4EDF44FE-4D17-458B-9F48-20FC5F535179}"/>
               </a:ext>
             </a:extLst>
           </p:cNvPr>
@@ -12156,7 +12212,7 @@
           <p:cNvPr id="15" name="">
             <a:extLst xmlns:a="http://schemas.openxmlformats.org/drawingml/2006/main">
               <a:ext uri="{FF2B5EF4-FFF2-40B4-BE49-F238E27FC236}">
-                <a16:creationId xmlns:a16="http://schemas.microsoft.com/office/drawing/2014/main" id="{D9E11230-69F5-462A-9F30-177B6EFB80AF}"/>
+                <a16:creationId xmlns:a16="http://schemas.microsoft.com/office/drawing/2014/main" id="{7F38DAD2-A2D7-4A65-8C1A-E88C0855702E}"/>
               </a:ext>
             </a:extLst>
           </p:cNvPr>
@@ -12187,7 +12243,7 @@
           <p:cNvPr id="14" name="">
             <a:extLst xmlns:a="http://schemas.openxmlformats.org/drawingml/2006/main">
               <a:ext uri="{FF2B5EF4-FFF2-40B4-BE49-F238E27FC236}">
-                <a16:creationId xmlns:a16="http://schemas.microsoft.com/office/drawing/2014/main" id="{59A919F6-AC5F-4930-B17C-B79265BC2575}"/>
+                <a16:creationId xmlns:a16="http://schemas.microsoft.com/office/drawing/2014/main" id="{28A6BC55-80B9-42FE-A31F-240FD39489E7}"/>
               </a:ext>
             </a:extLst>
           </p:cNvPr>
@@ -12218,7 +12274,7 @@
           <p:cNvPr id="13" name="">
             <a:extLst xmlns:a="http://schemas.openxmlformats.org/drawingml/2006/main">
               <a:ext uri="{FF2B5EF4-FFF2-40B4-BE49-F238E27FC236}">
-                <a16:creationId xmlns:a16="http://schemas.microsoft.com/office/drawing/2014/main" id="{026ACE20-F709-44DE-8C55-F138A28A1B1F}"/>
+                <a16:creationId xmlns:a16="http://schemas.microsoft.com/office/drawing/2014/main" id="{212CCED9-15AF-47B8-9355-DE160E635E0C}"/>
               </a:ext>
             </a:extLst>
           </p:cNvPr>
@@ -12249,7 +12305,7 @@
           <p:cNvPr id="21" name="">
             <a:extLst xmlns:a="http://schemas.openxmlformats.org/drawingml/2006/main">
               <a:ext uri="{FF2B5EF4-FFF2-40B4-BE49-F238E27FC236}">
-                <a16:creationId xmlns:a16="http://schemas.microsoft.com/office/drawing/2014/main" id="{7454FCB4-94FC-4549-BDE5-764E0DB74D48}"/>
+                <a16:creationId xmlns:a16="http://schemas.microsoft.com/office/drawing/2014/main" id="{1CBA6BF6-FB0A-47A7-B097-D3559E1A28E4}"/>
               </a:ext>
             </a:extLst>
           </p:cNvPr>
@@ -12315,7 +12371,7 @@
           <p:cNvPr id="2" name="">
             <a:extLst xmlns:a="http://schemas.openxmlformats.org/drawingml/2006/main">
               <a:ext uri="{FF2B5EF4-FFF2-40B4-BE49-F238E27FC236}">
-                <a16:creationId xmlns:a16="http://schemas.microsoft.com/office/drawing/2014/main" id="{63A3E537-2BD0-42A4-80E5-FA901CCCB39F}"/>
+                <a16:creationId xmlns:a16="http://schemas.microsoft.com/office/drawing/2014/main" id="{8F339478-6985-4B1E-901C-AFD5D46B6364}"/>
               </a:ext>
             </a:extLst>
           </p:cNvPr>
@@ -12381,7 +12437,7 @@
           <p:cNvPr id="3" name="">
             <a:extLst xmlns:a="http://schemas.openxmlformats.org/drawingml/2006/main">
               <a:ext uri="{FF2B5EF4-FFF2-40B4-BE49-F238E27FC236}">
-                <a16:creationId xmlns:a16="http://schemas.microsoft.com/office/drawing/2014/main" id="{C4736573-AC0D-4F66-A293-1E2B52F34008}"/>
+                <a16:creationId xmlns:a16="http://schemas.microsoft.com/office/drawing/2014/main" id="{9C3D75A5-17AC-441A-B829-384013508C32}"/>
               </a:ext>
             </a:extLst>
           </p:cNvPr>
@@ -12447,7 +12503,7 @@
           <p:cNvPr id="4" name="">
             <a:extLst xmlns:a="http://schemas.openxmlformats.org/drawingml/2006/main">
               <a:ext uri="{FF2B5EF4-FFF2-40B4-BE49-F238E27FC236}">
-                <a16:creationId xmlns:a16="http://schemas.microsoft.com/office/drawing/2014/main" id="{D209E5D9-43E1-4ADA-AD1F-D11B0F1C5E5E}"/>
+                <a16:creationId xmlns:a16="http://schemas.microsoft.com/office/drawing/2014/main" id="{AA0DE37A-93A8-4285-BA66-8A4B913B2EC4}"/>
               </a:ext>
             </a:extLst>
           </p:cNvPr>
@@ -12513,7 +12569,7 @@
           <p:cNvPr id="5" name="">
             <a:extLst xmlns:a="http://schemas.openxmlformats.org/drawingml/2006/main">
               <a:ext uri="{FF2B5EF4-FFF2-40B4-BE49-F238E27FC236}">
-                <a16:creationId xmlns:a16="http://schemas.microsoft.com/office/drawing/2014/main" id="{BCAB8A8E-11B0-4D42-B378-3624806E888D}"/>
+                <a16:creationId xmlns:a16="http://schemas.microsoft.com/office/drawing/2014/main" id="{99CF63E1-D639-450C-A446-A1A43F895C1D}"/>
               </a:ext>
             </a:extLst>
           </p:cNvPr>
@@ -12606,7 +12662,7 @@
           <p:cNvPr id="6" name="">
             <a:extLst xmlns:a="http://schemas.openxmlformats.org/drawingml/2006/main">
               <a:ext uri="{FF2B5EF4-FFF2-40B4-BE49-F238E27FC236}">
-                <a16:creationId xmlns:a16="http://schemas.microsoft.com/office/drawing/2014/main" id="{8E8C970B-3EE1-4997-AB71-79AE7CAB1414}"/>
+                <a16:creationId xmlns:a16="http://schemas.microsoft.com/office/drawing/2014/main" id="{92479422-2CFF-4E6B-BE61-1D8EE3673632}"/>
               </a:ext>
             </a:extLst>
           </p:cNvPr>
@@ -12699,7 +12755,7 @@
           <p:cNvPr id="7" name="">
             <a:extLst xmlns:a="http://schemas.openxmlformats.org/drawingml/2006/main">
               <a:ext uri="{FF2B5EF4-FFF2-40B4-BE49-F238E27FC236}">
-                <a16:creationId xmlns:a16="http://schemas.microsoft.com/office/drawing/2014/main" id="{0D8BC9A2-B405-40BE-B60E-0F2ED72608FD}"/>
+                <a16:creationId xmlns:a16="http://schemas.microsoft.com/office/drawing/2014/main" id="{46F0818A-9642-4DB3-B8A5-942EAD08EE89}"/>
               </a:ext>
             </a:extLst>
           </p:cNvPr>
@@ -12792,7 +12848,7 @@
           <p:cNvPr id="8" name="">
             <a:extLst xmlns:a="http://schemas.openxmlformats.org/drawingml/2006/main">
               <a:ext uri="{FF2B5EF4-FFF2-40B4-BE49-F238E27FC236}">
-                <a16:creationId xmlns:a16="http://schemas.microsoft.com/office/drawing/2014/main" id="{3CFA2E7A-57C5-47E0-9B3A-8FE351753904}"/>
+                <a16:creationId xmlns:a16="http://schemas.microsoft.com/office/drawing/2014/main" id="{2A67063E-C063-413F-941D-542EA4E5CF93}"/>
               </a:ext>
             </a:extLst>
           </p:cNvPr>
@@ -12885,7 +12941,7 @@
           <p:cNvPr id="9" name="">
             <a:extLst xmlns:a="http://schemas.openxmlformats.org/drawingml/2006/main">
               <a:ext uri="{FF2B5EF4-FFF2-40B4-BE49-F238E27FC236}">
-                <a16:creationId xmlns:a16="http://schemas.microsoft.com/office/drawing/2014/main" id="{D242F453-F958-4B5D-B682-F8EB2E144D08}"/>
+                <a16:creationId xmlns:a16="http://schemas.microsoft.com/office/drawing/2014/main" id="{14410A97-8B83-482A-9AEB-5EBFB9F270AB}"/>
               </a:ext>
             </a:extLst>
           </p:cNvPr>
@@ -12978,7 +13034,7 @@
           <p:cNvPr id="10" name="">
             <a:extLst xmlns:a="http://schemas.openxmlformats.org/drawingml/2006/main">
               <a:ext uri="{FF2B5EF4-FFF2-40B4-BE49-F238E27FC236}">
-                <a16:creationId xmlns:a16="http://schemas.microsoft.com/office/drawing/2014/main" id="{B9517BF6-07C5-49D8-972D-D6E2F15B9139}"/>
+                <a16:creationId xmlns:a16="http://schemas.microsoft.com/office/drawing/2014/main" id="{9169F02E-B703-43B7-B2DB-A9F022164C43}"/>
               </a:ext>
             </a:extLst>
           </p:cNvPr>
@@ -13071,7 +13127,7 @@
           <p:cNvPr id="11" name="">
             <a:extLst xmlns:a="http://schemas.openxmlformats.org/drawingml/2006/main">
               <a:ext uri="{FF2B5EF4-FFF2-40B4-BE49-F238E27FC236}">
-                <a16:creationId xmlns:a16="http://schemas.microsoft.com/office/drawing/2014/main" id="{135BBA48-C2E7-4401-9AB8-0DB0B319F4CF}"/>
+                <a16:creationId xmlns:a16="http://schemas.microsoft.com/office/drawing/2014/main" id="{7ED12FB9-7C58-424D-B229-CB79FDBBB34A}"/>
               </a:ext>
             </a:extLst>
           </p:cNvPr>
@@ -13164,7 +13220,7 @@
           <p:cNvPr id="12" name="">
             <a:extLst xmlns:a="http://schemas.openxmlformats.org/drawingml/2006/main">
               <a:ext uri="{FF2B5EF4-FFF2-40B4-BE49-F238E27FC236}">
-                <a16:creationId xmlns:a16="http://schemas.microsoft.com/office/drawing/2014/main" id="{FF74F7D6-3E9D-430B-BABE-178EB8B776F1}"/>
+                <a16:creationId xmlns:a16="http://schemas.microsoft.com/office/drawing/2014/main" id="{02E1ECE3-4421-4E9E-834B-E9C0D1A1007B}"/>
               </a:ext>
             </a:extLst>
           </p:cNvPr>
@@ -13257,7 +13313,7 @@
           <p:cNvPr id="20" name="">
             <a:extLst xmlns:a="http://schemas.openxmlformats.org/drawingml/2006/main">
               <a:ext uri="{FF2B5EF4-FFF2-40B4-BE49-F238E27FC236}">
-                <a16:creationId xmlns:a16="http://schemas.microsoft.com/office/drawing/2014/main" id="{FD53EE6B-9943-4223-BACD-D02CF7253FAC}"/>
+                <a16:creationId xmlns:a16="http://schemas.microsoft.com/office/drawing/2014/main" id="{1FE35F1F-292D-4038-8940-69C49B0FF5FA}"/>
               </a:ext>
             </a:extLst>
           </p:cNvPr>
@@ -13321,7 +13377,7 @@
     </p:spTree>
     <p:extLst>
       <p:ext uri="{BB962C8B-B14F-4D97-AF65-F5344CB8AC3E}">
-        <p14:creationId xmlns:p14="http://schemas.microsoft.com/office/powerpoint/2010/main" val="1725932056"/>
+        <p14:creationId xmlns:p14="http://schemas.microsoft.com/office/powerpoint/2010/main" val="487489900"/>
       </p:ext>
     </p:extLst>
   </p:cSld>
@@ -13352,7 +13408,7 @@
           <p:cNvPr id="11" name="">
             <a:extLst xmlns:a="http://schemas.openxmlformats.org/drawingml/2006/main">
               <a:ext uri="{FF2B5EF4-FFF2-40B4-BE49-F238E27FC236}">
-                <a16:creationId xmlns:a16="http://schemas.microsoft.com/office/drawing/2014/main" id="{04FAA4F7-692E-4FDF-A70B-B6654E42667E}"/>
+                <a16:creationId xmlns:a16="http://schemas.microsoft.com/office/drawing/2014/main" id="{1A633E49-BB1C-4597-A377-A40A099EE3D5}"/>
               </a:ext>
             </a:extLst>
           </p:cNvPr>
@@ -13418,7 +13474,7 @@
           <p:cNvPr id="2" name="">
             <a:extLst xmlns:a="http://schemas.openxmlformats.org/drawingml/2006/main">
               <a:ext uri="{FF2B5EF4-FFF2-40B4-BE49-F238E27FC236}">
-                <a16:creationId xmlns:a16="http://schemas.microsoft.com/office/drawing/2014/main" id="{D9602E98-87A2-4F8A-904F-87B8526C9C08}"/>
+                <a16:creationId xmlns:a16="http://schemas.microsoft.com/office/drawing/2014/main" id="{545A243C-8338-445B-BB33-1A2BC760D5B1}"/>
               </a:ext>
             </a:extLst>
           </p:cNvPr>
@@ -13484,7 +13540,7 @@
           <p:cNvPr id="3" name="">
             <a:extLst xmlns:a="http://schemas.openxmlformats.org/drawingml/2006/main">
               <a:ext uri="{FF2B5EF4-FFF2-40B4-BE49-F238E27FC236}">
-                <a16:creationId xmlns:a16="http://schemas.microsoft.com/office/drawing/2014/main" id="{69959912-4419-4072-9D35-9CC8615F2DF5}"/>
+                <a16:creationId xmlns:a16="http://schemas.microsoft.com/office/drawing/2014/main" id="{1C62AACA-9444-475E-B375-0FAFD5D7D0B5}"/>
               </a:ext>
             </a:extLst>
           </p:cNvPr>
@@ -13550,7 +13606,7 @@
           <p:cNvPr id="4" name="">
             <a:extLst xmlns:a="http://schemas.openxmlformats.org/drawingml/2006/main">
               <a:ext uri="{FF2B5EF4-FFF2-40B4-BE49-F238E27FC236}">
-                <a16:creationId xmlns:a16="http://schemas.microsoft.com/office/drawing/2014/main" id="{96579A74-101A-4B74-A233-196D43C7AAB3}"/>
+                <a16:creationId xmlns:a16="http://schemas.microsoft.com/office/drawing/2014/main" id="{8AE9802D-6221-4B2A-BA19-9E071EEBC7EA}"/>
               </a:ext>
             </a:extLst>
           </p:cNvPr>
@@ -13616,7 +13672,7 @@
           <p:cNvPr id="5" name="">
             <a:extLst xmlns:a="http://schemas.openxmlformats.org/drawingml/2006/main">
               <a:ext uri="{FF2B5EF4-FFF2-40B4-BE49-F238E27FC236}">
-                <a16:creationId xmlns:a16="http://schemas.microsoft.com/office/drawing/2014/main" id="{028478D7-87CC-49DE-800A-F8CA7A20BBA4}"/>
+                <a16:creationId xmlns:a16="http://schemas.microsoft.com/office/drawing/2014/main" id="{03FA6A14-85CC-4881-86A8-3FDAF687B868}"/>
               </a:ext>
             </a:extLst>
           </p:cNvPr>
@@ -13682,7 +13738,7 @@
           <p:cNvPr id="6" name="">
             <a:extLst xmlns:a="http://schemas.openxmlformats.org/drawingml/2006/main">
               <a:ext uri="{FF2B5EF4-FFF2-40B4-BE49-F238E27FC236}">
-                <a16:creationId xmlns:a16="http://schemas.microsoft.com/office/drawing/2014/main" id="{AADDBC94-3497-4E3A-A3A7-F1E8B1009CC3}"/>
+                <a16:creationId xmlns:a16="http://schemas.microsoft.com/office/drawing/2014/main" id="{67C44D0D-DF77-4336-9AC6-114D98CE8CA5}"/>
               </a:ext>
             </a:extLst>
           </p:cNvPr>
@@ -13799,7 +13855,7 @@
           <p:cNvPr id="7" name="">
             <a:extLst xmlns:a="http://schemas.openxmlformats.org/drawingml/2006/main">
               <a:ext uri="{FF2B5EF4-FFF2-40B4-BE49-F238E27FC236}">
-                <a16:creationId xmlns:a16="http://schemas.microsoft.com/office/drawing/2014/main" id="{BDE66234-10D8-47EA-806E-A3F8E9BB9AA5}"/>
+                <a16:creationId xmlns:a16="http://schemas.microsoft.com/office/drawing/2014/main" id="{458AAAFD-B05C-45DF-BBC9-B29BB0720124}"/>
               </a:ext>
             </a:extLst>
           </p:cNvPr>
@@ -13865,7 +13921,7 @@
           <p:cNvPr id="8" name="">
             <a:extLst xmlns:a="http://schemas.openxmlformats.org/drawingml/2006/main">
               <a:ext uri="{FF2B5EF4-FFF2-40B4-BE49-F238E27FC236}">
-                <a16:creationId xmlns:a16="http://schemas.microsoft.com/office/drawing/2014/main" id="{4041D0A9-E420-4ACC-BBA4-354AB23057F6}"/>
+                <a16:creationId xmlns:a16="http://schemas.microsoft.com/office/drawing/2014/main" id="{01DABFFD-216F-4ABA-989C-474A8A7A8204}"/>
               </a:ext>
             </a:extLst>
           </p:cNvPr>
@@ -13931,7 +13987,7 @@
           <p:cNvPr id="9" name="">
             <a:extLst xmlns:a="http://schemas.openxmlformats.org/drawingml/2006/main">
               <a:ext uri="{FF2B5EF4-FFF2-40B4-BE49-F238E27FC236}">
-                <a16:creationId xmlns:a16="http://schemas.microsoft.com/office/drawing/2014/main" id="{E4A3684C-CD77-472B-900E-96F58D091750}"/>
+                <a16:creationId xmlns:a16="http://schemas.microsoft.com/office/drawing/2014/main" id="{F46A0200-8E35-467F-B7EB-603FA4AEF2CA}"/>
               </a:ext>
             </a:extLst>
           </p:cNvPr>
@@ -13997,7 +14053,7 @@
           <p:cNvPr id="10" name="">
             <a:extLst xmlns:a="http://schemas.openxmlformats.org/drawingml/2006/main">
               <a:ext uri="{FF2B5EF4-FFF2-40B4-BE49-F238E27FC236}">
-                <a16:creationId xmlns:a16="http://schemas.microsoft.com/office/drawing/2014/main" id="{8DB7FA04-4113-465D-83FB-D7902712A2CB}"/>
+                <a16:creationId xmlns:a16="http://schemas.microsoft.com/office/drawing/2014/main" id="{0FF5255D-FB70-4E62-8463-AA5F826CDB39}"/>
               </a:ext>
             </a:extLst>
           </p:cNvPr>
@@ -14061,7 +14117,7 @@
     </p:spTree>
     <p:extLst>
       <p:ext uri="{BB962C8B-B14F-4D97-AF65-F5344CB8AC3E}">
-        <p14:creationId xmlns:p14="http://schemas.microsoft.com/office/powerpoint/2010/main" val="1362913730"/>
+        <p14:creationId xmlns:p14="http://schemas.microsoft.com/office/powerpoint/2010/main" val="75421878"/>
       </p:ext>
     </p:extLst>
   </p:cSld>
@@ -14092,7 +14148,7 @@
           <p:cNvPr id="13" name="">
             <a:extLst xmlns:a="http://schemas.openxmlformats.org/drawingml/2006/main">
               <a:ext uri="{FF2B5EF4-FFF2-40B4-BE49-F238E27FC236}">
-                <a16:creationId xmlns:a16="http://schemas.microsoft.com/office/drawing/2014/main" id="{A9152D53-E42B-47BC-B5AC-531D09EB7C80}"/>
+                <a16:creationId xmlns:a16="http://schemas.microsoft.com/office/drawing/2014/main" id="{19610592-3F49-4B20-8C15-39123347A194}"/>
               </a:ext>
             </a:extLst>
           </p:cNvPr>
@@ -14158,7 +14214,7 @@
           <p:cNvPr id="2" name="">
             <a:extLst xmlns:a="http://schemas.openxmlformats.org/drawingml/2006/main">
               <a:ext uri="{FF2B5EF4-FFF2-40B4-BE49-F238E27FC236}">
-                <a16:creationId xmlns:a16="http://schemas.microsoft.com/office/drawing/2014/main" id="{D38FCB1A-5A26-49B7-AFAB-2BCEDEEFDC90}"/>
+                <a16:creationId xmlns:a16="http://schemas.microsoft.com/office/drawing/2014/main" id="{82A242E2-00CF-4366-8BA0-6EEAB5A319B8}"/>
               </a:ext>
             </a:extLst>
           </p:cNvPr>
@@ -14224,7 +14280,7 @@
           <p:cNvPr id="3" name="">
             <a:extLst xmlns:a="http://schemas.openxmlformats.org/drawingml/2006/main">
               <a:ext uri="{FF2B5EF4-FFF2-40B4-BE49-F238E27FC236}">
-                <a16:creationId xmlns:a16="http://schemas.microsoft.com/office/drawing/2014/main" id="{ADE7BA50-47ED-46F1-9088-D5838E8EF046}"/>
+                <a16:creationId xmlns:a16="http://schemas.microsoft.com/office/drawing/2014/main" id="{A5BE053E-4F34-4CF2-BF38-D2D644A029C9}"/>
               </a:ext>
             </a:extLst>
           </p:cNvPr>
@@ -14290,7 +14346,7 @@
           <p:cNvPr id="4" name="">
             <a:extLst xmlns:a="http://schemas.openxmlformats.org/drawingml/2006/main">
               <a:ext uri="{FF2B5EF4-FFF2-40B4-BE49-F238E27FC236}">
-                <a16:creationId xmlns:a16="http://schemas.microsoft.com/office/drawing/2014/main" id="{70D79545-FDB3-4C6C-842A-7F1F3659D8D3}"/>
+                <a16:creationId xmlns:a16="http://schemas.microsoft.com/office/drawing/2014/main" id="{40BCB76B-B54C-4536-A54F-8615CCF47906}"/>
               </a:ext>
             </a:extLst>
           </p:cNvPr>
@@ -14356,7 +14412,7 @@
           <p:cNvPr id="5" name="">
             <a:extLst xmlns:a="http://schemas.openxmlformats.org/drawingml/2006/main">
               <a:ext uri="{FF2B5EF4-FFF2-40B4-BE49-F238E27FC236}">
-                <a16:creationId xmlns:a16="http://schemas.microsoft.com/office/drawing/2014/main" id="{4202AC86-C4FD-4E6B-B2B1-961EADE48C03}"/>
+                <a16:creationId xmlns:a16="http://schemas.microsoft.com/office/drawing/2014/main" id="{7B90F87C-1F2B-46DE-B1CA-A091DDFFF098}"/>
               </a:ext>
             </a:extLst>
           </p:cNvPr>
@@ -14422,7 +14478,7 @@
           <p:cNvPr id="6" name="">
             <a:extLst xmlns:a="http://schemas.openxmlformats.org/drawingml/2006/main">
               <a:ext uri="{FF2B5EF4-FFF2-40B4-BE49-F238E27FC236}">
-                <a16:creationId xmlns:a16="http://schemas.microsoft.com/office/drawing/2014/main" id="{5784319E-8B41-4FC3-9588-6C14F5669D0B}"/>
+                <a16:creationId xmlns:a16="http://schemas.microsoft.com/office/drawing/2014/main" id="{DC7CDF5B-E08E-4C0E-98E6-7F1A44451B50}"/>
               </a:ext>
             </a:extLst>
           </p:cNvPr>
@@ -14488,7 +14544,7 @@
           <p:cNvPr id="7" name="">
             <a:extLst xmlns:a="http://schemas.openxmlformats.org/drawingml/2006/main">
               <a:ext uri="{FF2B5EF4-FFF2-40B4-BE49-F238E27FC236}">
-                <a16:creationId xmlns:a16="http://schemas.microsoft.com/office/drawing/2014/main" id="{96B10287-BB84-4849-8BFF-F4B28BB3B576}"/>
+                <a16:creationId xmlns:a16="http://schemas.microsoft.com/office/drawing/2014/main" id="{0427982F-A1C3-4851-B227-A396BD1F6D43}"/>
               </a:ext>
             </a:extLst>
           </p:cNvPr>
@@ -14554,7 +14610,7 @@
           <p:cNvPr id="8" name="">
             <a:extLst xmlns:a="http://schemas.openxmlformats.org/drawingml/2006/main">
               <a:ext uri="{FF2B5EF4-FFF2-40B4-BE49-F238E27FC236}">
-                <a16:creationId xmlns:a16="http://schemas.microsoft.com/office/drawing/2014/main" id="{8044581C-657E-4431-8C59-AE7961169CD6}"/>
+                <a16:creationId xmlns:a16="http://schemas.microsoft.com/office/drawing/2014/main" id="{4B58E2BA-3C3C-47F4-A505-88E5629D594C}"/>
               </a:ext>
             </a:extLst>
           </p:cNvPr>
@@ -14620,7 +14676,7 @@
           <p:cNvPr id="9" name="">
             <a:extLst xmlns:a="http://schemas.openxmlformats.org/drawingml/2006/main">
               <a:ext uri="{FF2B5EF4-FFF2-40B4-BE49-F238E27FC236}">
-                <a16:creationId xmlns:a16="http://schemas.microsoft.com/office/drawing/2014/main" id="{E98F18F9-F5A0-4DC9-8576-0207EDA353B1}"/>
+                <a16:creationId xmlns:a16="http://schemas.microsoft.com/office/drawing/2014/main" id="{89736A82-B97F-4B57-88DC-59BDD99F671E}"/>
               </a:ext>
             </a:extLst>
           </p:cNvPr>
@@ -14686,7 +14742,7 @@
           <p:cNvPr id="10" name="">
             <a:extLst xmlns:a="http://schemas.openxmlformats.org/drawingml/2006/main">
               <a:ext uri="{FF2B5EF4-FFF2-40B4-BE49-F238E27FC236}">
-                <a16:creationId xmlns:a16="http://schemas.microsoft.com/office/drawing/2014/main" id="{86E15C1F-995B-4E2D-A751-99A016DA17E9}"/>
+                <a16:creationId xmlns:a16="http://schemas.microsoft.com/office/drawing/2014/main" id="{25D443FB-C770-4C77-8301-7FD0DA834BB5}"/>
               </a:ext>
             </a:extLst>
           </p:cNvPr>
@@ -14752,7 +14808,7 @@
           <p:cNvPr id="11" name="">
             <a:extLst xmlns:a="http://schemas.openxmlformats.org/drawingml/2006/main">
               <a:ext uri="{FF2B5EF4-FFF2-40B4-BE49-F238E27FC236}">
-                <a16:creationId xmlns:a16="http://schemas.microsoft.com/office/drawing/2014/main" id="{D4E6FA61-0590-41F2-B9A6-0F7855F33ED5}"/>
+                <a16:creationId xmlns:a16="http://schemas.microsoft.com/office/drawing/2014/main" id="{587CAF8C-2199-4ABD-8C0A-D7C0ADFA91E3}"/>
               </a:ext>
             </a:extLst>
           </p:cNvPr>
@@ -14818,7 +14874,7 @@
           <p:cNvPr id="12" name="">
             <a:extLst xmlns:a="http://schemas.openxmlformats.org/drawingml/2006/main">
               <a:ext uri="{FF2B5EF4-FFF2-40B4-BE49-F238E27FC236}">
-                <a16:creationId xmlns:a16="http://schemas.microsoft.com/office/drawing/2014/main" id="{A71EDCCD-7AFD-43C0-B33B-8516E136614B}"/>
+                <a16:creationId xmlns:a16="http://schemas.microsoft.com/office/drawing/2014/main" id="{2B4B1852-B4F2-4B7B-9984-3720D90074A7}"/>
               </a:ext>
             </a:extLst>
           </p:cNvPr>
@@ -14882,7 +14938,7 @@
     </p:spTree>
     <p:extLst>
       <p:ext uri="{BB962C8B-B14F-4D97-AF65-F5344CB8AC3E}">
-        <p14:creationId xmlns:p14="http://schemas.microsoft.com/office/powerpoint/2010/main" val="1982180738"/>
+        <p14:creationId xmlns:p14="http://schemas.microsoft.com/office/powerpoint/2010/main" val="39742006"/>
       </p:ext>
     </p:extLst>
   </p:cSld>
@@ -14913,7 +14969,7 @@
           <p:cNvPr id="8" name="">
             <a:extLst xmlns:a="http://schemas.openxmlformats.org/drawingml/2006/main">
               <a:ext uri="{FF2B5EF4-FFF2-40B4-BE49-F238E27FC236}">
-                <a16:creationId xmlns:a16="http://schemas.microsoft.com/office/drawing/2014/main" id="{63A1551E-D326-4516-BB8C-8CBCE5D258A8}"/>
+                <a16:creationId xmlns:a16="http://schemas.microsoft.com/office/drawing/2014/main" id="{FE701AB6-DB75-4002-98EA-2A6DF91630CE}"/>
               </a:ext>
             </a:extLst>
           </p:cNvPr>
@@ -14979,7 +15035,7 @@
           <p:cNvPr id="2" name="">
             <a:extLst xmlns:a="http://schemas.openxmlformats.org/drawingml/2006/main">
               <a:ext uri="{FF2B5EF4-FFF2-40B4-BE49-F238E27FC236}">
-                <a16:creationId xmlns:a16="http://schemas.microsoft.com/office/drawing/2014/main" id="{BC56D4B3-029E-4D36-A096-27EA8977ED71}"/>
+                <a16:creationId xmlns:a16="http://schemas.microsoft.com/office/drawing/2014/main" id="{57FB3461-F03B-47EA-B815-ECBE30317E5E}"/>
               </a:ext>
             </a:extLst>
           </p:cNvPr>
@@ -15045,7 +15101,7 @@
           <p:cNvPr id="3" name="">
             <a:extLst xmlns:a="http://schemas.openxmlformats.org/drawingml/2006/main">
               <a:ext uri="{FF2B5EF4-FFF2-40B4-BE49-F238E27FC236}">
-                <a16:creationId xmlns:a16="http://schemas.microsoft.com/office/drawing/2014/main" id="{F2AF8D57-933E-4478-962C-FC52F3AEC969}"/>
+                <a16:creationId xmlns:a16="http://schemas.microsoft.com/office/drawing/2014/main" id="{D8583B02-56DC-4800-B32F-E11FF663AF1E}"/>
               </a:ext>
             </a:extLst>
           </p:cNvPr>
@@ -15111,7 +15167,7 @@
           <p:cNvPr id="4" name="">
             <a:extLst xmlns:a="http://schemas.openxmlformats.org/drawingml/2006/main">
               <a:ext uri="{FF2B5EF4-FFF2-40B4-BE49-F238E27FC236}">
-                <a16:creationId xmlns:a16="http://schemas.microsoft.com/office/drawing/2014/main" id="{6DDDE0B7-4D5F-403F-AF48-E6E93FEC5F74}"/>
+                <a16:creationId xmlns:a16="http://schemas.microsoft.com/office/drawing/2014/main" id="{21925DCC-C60F-428A-910D-88FD39E18407}"/>
               </a:ext>
             </a:extLst>
           </p:cNvPr>
@@ -15177,7 +15233,7 @@
           <p:cNvPr id="5" name="">
             <a:extLst xmlns:a="http://schemas.openxmlformats.org/drawingml/2006/main">
               <a:ext uri="{FF2B5EF4-FFF2-40B4-BE49-F238E27FC236}">
-                <a16:creationId xmlns:a16="http://schemas.microsoft.com/office/drawing/2014/main" id="{703877D2-973C-48D4-96D9-2BF711862CAB}"/>
+                <a16:creationId xmlns:a16="http://schemas.microsoft.com/office/drawing/2014/main" id="{463B0A30-4D3A-46F5-A166-75A77F392A0A}"/>
               </a:ext>
             </a:extLst>
           </p:cNvPr>
@@ -15243,7 +15299,7 @@
           <p:cNvPr id="6" name="">
             <a:extLst xmlns:a="http://schemas.openxmlformats.org/drawingml/2006/main">
               <a:ext uri="{FF2B5EF4-FFF2-40B4-BE49-F238E27FC236}">
-                <a16:creationId xmlns:a16="http://schemas.microsoft.com/office/drawing/2014/main" id="{F2EE7ED1-5E3F-4D62-9CB7-03BE0C757F34}"/>
+                <a16:creationId xmlns:a16="http://schemas.microsoft.com/office/drawing/2014/main" id="{C25F696E-052A-4E52-B6BC-0DD76AE343B7}"/>
               </a:ext>
             </a:extLst>
           </p:cNvPr>
@@ -15393,7 +15449,7 @@
           <p:cNvPr id="7" name="">
             <a:extLst xmlns:a="http://schemas.openxmlformats.org/drawingml/2006/main">
               <a:ext uri="{FF2B5EF4-FFF2-40B4-BE49-F238E27FC236}">
-                <a16:creationId xmlns:a16="http://schemas.microsoft.com/office/drawing/2014/main" id="{B3042F9C-A74B-49B0-86A3-91CFA4700CDC}"/>
+                <a16:creationId xmlns:a16="http://schemas.microsoft.com/office/drawing/2014/main" id="{A1B722CD-0027-4511-A383-A56F5FB4D6E2}"/>
               </a:ext>
             </a:extLst>
           </p:cNvPr>
@@ -15403,7 +15459,7 @@
           <p:nvPr/>
         </p:nvPicPr>
         <p:blipFill>
-          <a:blip xmlns:r="http://schemas.openxmlformats.org/officeDocument/2006/relationships" xmlns:a="http://schemas.openxmlformats.org/drawingml/2006/main" r:embed="R6e41881ede3940bf"/>
+          <a:blip xmlns:r="http://schemas.openxmlformats.org/officeDocument/2006/relationships" xmlns:a="http://schemas.openxmlformats.org/drawingml/2006/main" r:embed="R55c17f38e52f4704"/>
           <a:stretch xmlns:a="http://schemas.openxmlformats.org/drawingml/2006/main"/>
         </p:blipFill>
         <p:spPr>
@@ -15419,7 +15475,7 @@
     </p:spTree>
     <p:extLst>
       <p:ext uri="{BB962C8B-B14F-4D97-AF65-F5344CB8AC3E}">
-        <p14:creationId xmlns:p14="http://schemas.microsoft.com/office/powerpoint/2010/main" val="1170944965"/>
+        <p14:creationId xmlns:p14="http://schemas.microsoft.com/office/powerpoint/2010/main" val="1215634844"/>
       </p:ext>
     </p:extLst>
   </p:cSld>
@@ -15450,7 +15506,7 @@
           <p:cNvPr id="8" name="">
             <a:extLst xmlns:a="http://schemas.openxmlformats.org/drawingml/2006/main">
               <a:ext uri="{FF2B5EF4-FFF2-40B4-BE49-F238E27FC236}">
-                <a16:creationId xmlns:a16="http://schemas.microsoft.com/office/drawing/2014/main" id="{13BF33EF-33D8-46EF-AA8A-3F949A16D1AF}"/>
+                <a16:creationId xmlns:a16="http://schemas.microsoft.com/office/drawing/2014/main" id="{79C6F8DD-FF4B-4C01-9F38-4F728F64EB4D}"/>
               </a:ext>
             </a:extLst>
           </p:cNvPr>
@@ -15516,7 +15572,7 @@
           <p:cNvPr id="2" name="">
             <a:extLst xmlns:a="http://schemas.openxmlformats.org/drawingml/2006/main">
               <a:ext uri="{FF2B5EF4-FFF2-40B4-BE49-F238E27FC236}">
-                <a16:creationId xmlns:a16="http://schemas.microsoft.com/office/drawing/2014/main" id="{DCB1A01F-B26C-4077-BC25-1670D90E1BD8}"/>
+                <a16:creationId xmlns:a16="http://schemas.microsoft.com/office/drawing/2014/main" id="{391716FE-73C7-47E3-8267-EE0703000636}"/>
               </a:ext>
             </a:extLst>
           </p:cNvPr>
@@ -15582,7 +15638,7 @@
           <p:cNvPr id="3" name="">
             <a:extLst xmlns:a="http://schemas.openxmlformats.org/drawingml/2006/main">
               <a:ext uri="{FF2B5EF4-FFF2-40B4-BE49-F238E27FC236}">
-                <a16:creationId xmlns:a16="http://schemas.microsoft.com/office/drawing/2014/main" id="{5C1F3D4B-8529-4559-9651-7864271901D5}"/>
+                <a16:creationId xmlns:a16="http://schemas.microsoft.com/office/drawing/2014/main" id="{F7693C79-19CD-4552-884C-67A4A1BFB7F9}"/>
               </a:ext>
             </a:extLst>
           </p:cNvPr>
@@ -15648,7 +15704,7 @@
           <p:cNvPr id="4" name="">
             <a:extLst xmlns:a="http://schemas.openxmlformats.org/drawingml/2006/main">
               <a:ext uri="{FF2B5EF4-FFF2-40B4-BE49-F238E27FC236}">
-                <a16:creationId xmlns:a16="http://schemas.microsoft.com/office/drawing/2014/main" id="{80D64C62-3AD2-4C3A-8DDF-76C1D84FA641}"/>
+                <a16:creationId xmlns:a16="http://schemas.microsoft.com/office/drawing/2014/main" id="{767296DE-4D18-4A86-94F8-5B50FF7EFE79}"/>
               </a:ext>
             </a:extLst>
           </p:cNvPr>
@@ -15714,7 +15770,7 @@
           <p:cNvPr id="5" name="">
             <a:extLst xmlns:a="http://schemas.openxmlformats.org/drawingml/2006/main">
               <a:ext uri="{FF2B5EF4-FFF2-40B4-BE49-F238E27FC236}">
-                <a16:creationId xmlns:a16="http://schemas.microsoft.com/office/drawing/2014/main" id="{BC83C81A-3729-435D-97FD-FAF39E97ED7F}"/>
+                <a16:creationId xmlns:a16="http://schemas.microsoft.com/office/drawing/2014/main" id="{B7954C27-AC0F-4D84-B3C0-9DF36464731B}"/>
               </a:ext>
             </a:extLst>
           </p:cNvPr>
@@ -15724,7 +15780,7 @@
           <p:nvPr/>
         </p:nvPicPr>
         <p:blipFill>
-          <a:blip xmlns:r="http://schemas.openxmlformats.org/officeDocument/2006/relationships" xmlns:a="http://schemas.openxmlformats.org/drawingml/2006/main" r:embed="Ra0ccbf1734554dd8"/>
+          <a:blip xmlns:r="http://schemas.openxmlformats.org/officeDocument/2006/relationships" xmlns:a="http://schemas.openxmlformats.org/drawingml/2006/main" r:embed="R827b614a2ceb47ba"/>
           <a:stretch xmlns:a="http://schemas.openxmlformats.org/drawingml/2006/main"/>
         </p:blipFill>
         <p:spPr>
@@ -15742,7 +15798,7 @@
           <p:cNvPr id="6" name="">
             <a:extLst xmlns:a="http://schemas.openxmlformats.org/drawingml/2006/main">
               <a:ext uri="{FF2B5EF4-FFF2-40B4-BE49-F238E27FC236}">
-                <a16:creationId xmlns:a16="http://schemas.microsoft.com/office/drawing/2014/main" id="{8063D66C-E577-4C4E-849C-6BF3A357D367}"/>
+                <a16:creationId xmlns:a16="http://schemas.microsoft.com/office/drawing/2014/main" id="{D459142A-682B-41DC-BEAC-659D9C659B50}"/>
               </a:ext>
             </a:extLst>
           </p:cNvPr>
@@ -15752,7 +15808,7 @@
           <p:nvPr/>
         </p:nvPicPr>
         <p:blipFill>
-          <a:blip xmlns:r="http://schemas.openxmlformats.org/officeDocument/2006/relationships" xmlns:a="http://schemas.openxmlformats.org/drawingml/2006/main" r:embed="Re2d738a83e5b41a6"/>
+          <a:blip xmlns:r="http://schemas.openxmlformats.org/officeDocument/2006/relationships" xmlns:a="http://schemas.openxmlformats.org/drawingml/2006/main" r:embed="R33b8390e42e24ae2"/>
           <a:stretch xmlns:a="http://schemas.openxmlformats.org/drawingml/2006/main"/>
         </p:blipFill>
         <p:spPr>
@@ -15770,7 +15826,7 @@
           <p:cNvPr id="7" name="">
             <a:extLst xmlns:a="http://schemas.openxmlformats.org/drawingml/2006/main">
               <a:ext uri="{FF2B5EF4-FFF2-40B4-BE49-F238E27FC236}">
-                <a16:creationId xmlns:a16="http://schemas.microsoft.com/office/drawing/2014/main" id="{4112D853-B39B-42BB-8CE0-E1516893A8BA}"/>
+                <a16:creationId xmlns:a16="http://schemas.microsoft.com/office/drawing/2014/main" id="{40E48DAB-7E15-40FB-9C0C-F5AD78D6B61C}"/>
               </a:ext>
             </a:extLst>
           </p:cNvPr>
@@ -15834,7 +15890,7 @@
     </p:spTree>
     <p:extLst>
       <p:ext uri="{BB962C8B-B14F-4D97-AF65-F5344CB8AC3E}">
-        <p14:creationId xmlns:p14="http://schemas.microsoft.com/office/powerpoint/2010/main" val="148508790"/>
+        <p14:creationId xmlns:p14="http://schemas.microsoft.com/office/powerpoint/2010/main" val="1101490454"/>
       </p:ext>
     </p:extLst>
   </p:cSld>
@@ -15865,7 +15921,7 @@
           <p:cNvPr id="8" name="">
             <a:extLst xmlns:a="http://schemas.openxmlformats.org/drawingml/2006/main">
               <a:ext uri="{FF2B5EF4-FFF2-40B4-BE49-F238E27FC236}">
-                <a16:creationId xmlns:a16="http://schemas.microsoft.com/office/drawing/2014/main" id="{CD53D4C1-D427-4023-B83D-4C749B795ECE}"/>
+                <a16:creationId xmlns:a16="http://schemas.microsoft.com/office/drawing/2014/main" id="{10320A34-E818-4099-BCE3-EF59AEFA8EC3}"/>
               </a:ext>
             </a:extLst>
           </p:cNvPr>
@@ -15931,7 +15987,7 @@
           <p:cNvPr id="2" name="">
             <a:extLst xmlns:a="http://schemas.openxmlformats.org/drawingml/2006/main">
               <a:ext uri="{FF2B5EF4-FFF2-40B4-BE49-F238E27FC236}">
-                <a16:creationId xmlns:a16="http://schemas.microsoft.com/office/drawing/2014/main" id="{2FCCB202-5370-4F0E-A74D-763C8E8BCE89}"/>
+                <a16:creationId xmlns:a16="http://schemas.microsoft.com/office/drawing/2014/main" id="{C9BF168F-FA91-45B5-9599-5D1751317DE6}"/>
               </a:ext>
             </a:extLst>
           </p:cNvPr>
@@ -15997,7 +16053,7 @@
           <p:cNvPr id="3" name="">
             <a:extLst xmlns:a="http://schemas.openxmlformats.org/drawingml/2006/main">
               <a:ext uri="{FF2B5EF4-FFF2-40B4-BE49-F238E27FC236}">
-                <a16:creationId xmlns:a16="http://schemas.microsoft.com/office/drawing/2014/main" id="{49DA53A5-3E28-41F6-818A-31377AC252C0}"/>
+                <a16:creationId xmlns:a16="http://schemas.microsoft.com/office/drawing/2014/main" id="{05E2CD01-686D-4973-B931-7D5600110B41}"/>
               </a:ext>
             </a:extLst>
           </p:cNvPr>
@@ -16063,7 +16119,7 @@
           <p:cNvPr id="4" name="">
             <a:extLst xmlns:a="http://schemas.openxmlformats.org/drawingml/2006/main">
               <a:ext uri="{FF2B5EF4-FFF2-40B4-BE49-F238E27FC236}">
-                <a16:creationId xmlns:a16="http://schemas.microsoft.com/office/drawing/2014/main" id="{6593A6DF-FD07-459B-BC1B-440BBEA253E5}"/>
+                <a16:creationId xmlns:a16="http://schemas.microsoft.com/office/drawing/2014/main" id="{0BFC4824-EA7D-4443-A890-05C8D81CA774}"/>
               </a:ext>
             </a:extLst>
           </p:cNvPr>
@@ -16129,7 +16185,7 @@
           <p:cNvPr id="5" name="">
             <a:extLst xmlns:a="http://schemas.openxmlformats.org/drawingml/2006/main">
               <a:ext uri="{FF2B5EF4-FFF2-40B4-BE49-F238E27FC236}">
-                <a16:creationId xmlns:a16="http://schemas.microsoft.com/office/drawing/2014/main" id="{BAB372DA-C7BF-42B9-B203-579548395987}"/>
+                <a16:creationId xmlns:a16="http://schemas.microsoft.com/office/drawing/2014/main" id="{2EC5E3A1-18A7-4933-8F4A-81F35776B5C4}"/>
               </a:ext>
             </a:extLst>
           </p:cNvPr>
@@ -16139,7 +16195,7 @@
           <p:nvPr/>
         </p:nvPicPr>
         <p:blipFill>
-          <a:blip xmlns:r="http://schemas.openxmlformats.org/officeDocument/2006/relationships" xmlns:a="http://schemas.openxmlformats.org/drawingml/2006/main" r:embed="R9a4d604e6c054ddf"/>
+          <a:blip xmlns:r="http://schemas.openxmlformats.org/officeDocument/2006/relationships" xmlns:a="http://schemas.openxmlformats.org/drawingml/2006/main" r:embed="Rd9e5aa1194c44d63"/>
           <a:stretch xmlns:a="http://schemas.openxmlformats.org/drawingml/2006/main"/>
         </p:blipFill>
         <p:spPr>
@@ -16157,7 +16213,7 @@
           <p:cNvPr id="6" name="">
             <a:extLst xmlns:a="http://schemas.openxmlformats.org/drawingml/2006/main">
               <a:ext uri="{FF2B5EF4-FFF2-40B4-BE49-F238E27FC236}">
-                <a16:creationId xmlns:a16="http://schemas.microsoft.com/office/drawing/2014/main" id="{5C3FDA54-2ECC-419A-B6CA-8FBCF971A230}"/>
+                <a16:creationId xmlns:a16="http://schemas.microsoft.com/office/drawing/2014/main" id="{253E5E63-6165-4649-AFDF-24AB47601042}"/>
               </a:ext>
             </a:extLst>
           </p:cNvPr>
@@ -16167,7 +16223,7 @@
           <p:nvPr/>
         </p:nvPicPr>
         <p:blipFill>
-          <a:blip xmlns:r="http://schemas.openxmlformats.org/officeDocument/2006/relationships" xmlns:a="http://schemas.openxmlformats.org/drawingml/2006/main" r:embed="R5c66a171a68d463a"/>
+          <a:blip xmlns:r="http://schemas.openxmlformats.org/officeDocument/2006/relationships" xmlns:a="http://schemas.openxmlformats.org/drawingml/2006/main" r:embed="R54b856c8f3f24402"/>
           <a:stretch xmlns:a="http://schemas.openxmlformats.org/drawingml/2006/main"/>
         </p:blipFill>
         <p:spPr>
@@ -16185,7 +16241,7 @@
           <p:cNvPr id="7" name="">
             <a:extLst xmlns:a="http://schemas.openxmlformats.org/drawingml/2006/main">
               <a:ext uri="{FF2B5EF4-FFF2-40B4-BE49-F238E27FC236}">
-                <a16:creationId xmlns:a16="http://schemas.microsoft.com/office/drawing/2014/main" id="{15E32786-AC06-445C-AC2A-F3ACC575EA08}"/>
+                <a16:creationId xmlns:a16="http://schemas.microsoft.com/office/drawing/2014/main" id="{2699E43E-D6B1-4D72-8939-0CABAF7014CD}"/>
               </a:ext>
             </a:extLst>
           </p:cNvPr>
@@ -16249,7 +16305,7 @@
     </p:spTree>
     <p:extLst>
       <p:ext uri="{BB962C8B-B14F-4D97-AF65-F5344CB8AC3E}">
-        <p14:creationId xmlns:p14="http://schemas.microsoft.com/office/powerpoint/2010/main" val="417577643"/>
+        <p14:creationId xmlns:p14="http://schemas.microsoft.com/office/powerpoint/2010/main" val="648525406"/>
       </p:ext>
     </p:extLst>
   </p:cSld>

</xml_diff>

<commit_message>
Document live creator approval workflow and keep privileged review logins private
</commit_message>
<xml_diff>
--- a/docs/presentation/QuizNova-Review-1.pptx
+++ b/docs/presentation/QuizNova-Review-1.pptx
@@ -2,29 +2,29 @@
 <file path=ppt/presentation.xml><?xml version="1.0" encoding="utf-8"?>
 <p:presentation xmlns:p="http://schemas.openxmlformats.org/presentationml/2006/main">
   <p:sldMasterIdLst>
-    <p:sldMasterId xmlns:r="http://schemas.openxmlformats.org/officeDocument/2006/relationships" id="2147483648" r:id="R288e8331c87e470f"/>
+    <p:sldMasterId xmlns:r="http://schemas.openxmlformats.org/officeDocument/2006/relationships" id="2147483648" r:id="R0918485833a64fe8"/>
   </p:sldMasterIdLst>
   <p:notesMasterIdLst>
-    <p:notesMasterId xmlns:r="http://schemas.openxmlformats.org/officeDocument/2006/relationships" r:id="R431247f8026649aa"/>
+    <p:notesMasterId xmlns:r="http://schemas.openxmlformats.org/officeDocument/2006/relationships" r:id="R55557c1414104073"/>
   </p:notesMasterIdLst>
   <p:sldIdLst>
-    <p:sldId xmlns:r="http://schemas.openxmlformats.org/officeDocument/2006/relationships" id="256" r:id="R4566e76028514856"/>
-    <p:sldId xmlns:r="http://schemas.openxmlformats.org/officeDocument/2006/relationships" id="257" r:id="Re9bb7d56884144e3"/>
-    <p:sldId xmlns:r="http://schemas.openxmlformats.org/officeDocument/2006/relationships" id="258" r:id="R3967a5a1d65b452d"/>
-    <p:sldId xmlns:r="http://schemas.openxmlformats.org/officeDocument/2006/relationships" id="259" r:id="R77ed05f6cbf14ce6"/>
-    <p:sldId xmlns:r="http://schemas.openxmlformats.org/officeDocument/2006/relationships" id="260" r:id="R125b4839811f48a3"/>
-    <p:sldId xmlns:r="http://schemas.openxmlformats.org/officeDocument/2006/relationships" id="261" r:id="R04b332bd40d24d33"/>
-    <p:sldId xmlns:r="http://schemas.openxmlformats.org/officeDocument/2006/relationships" id="262" r:id="R66ccb1eabaaa4872"/>
-    <p:sldId xmlns:r="http://schemas.openxmlformats.org/officeDocument/2006/relationships" id="263" r:id="R8a46711dedcc4fe2"/>
-    <p:sldId xmlns:r="http://schemas.openxmlformats.org/officeDocument/2006/relationships" id="264" r:id="Rb2b78e6c80bf4e51"/>
-    <p:sldId xmlns:r="http://schemas.openxmlformats.org/officeDocument/2006/relationships" id="265" r:id="Rf03ffa88b1864724"/>
-    <p:sldId xmlns:r="http://schemas.openxmlformats.org/officeDocument/2006/relationships" id="266" r:id="R64fb20f1d8f24c35"/>
-    <p:sldId xmlns:r="http://schemas.openxmlformats.org/officeDocument/2006/relationships" id="267" r:id="R26f4ff2ea42d445e"/>
-    <p:sldId xmlns:r="http://schemas.openxmlformats.org/officeDocument/2006/relationships" id="268" r:id="R00ffae7f9c5c403d"/>
-    <p:sldId xmlns:r="http://schemas.openxmlformats.org/officeDocument/2006/relationships" id="269" r:id="R5d6912bfb7d940dc"/>
-    <p:sldId xmlns:r="http://schemas.openxmlformats.org/officeDocument/2006/relationships" id="270" r:id="Rf85d45dc5d384a8a"/>
-    <p:sldId xmlns:r="http://schemas.openxmlformats.org/officeDocument/2006/relationships" id="271" r:id="Rad66677759db480f"/>
-    <p:sldId xmlns:r="http://schemas.openxmlformats.org/officeDocument/2006/relationships" id="272" r:id="Rae7b357c580a4637"/>
+    <p:sldId xmlns:r="http://schemas.openxmlformats.org/officeDocument/2006/relationships" id="256" r:id="Rc0f28486494d4d37"/>
+    <p:sldId xmlns:r="http://schemas.openxmlformats.org/officeDocument/2006/relationships" id="257" r:id="Rd808760193434cc6"/>
+    <p:sldId xmlns:r="http://schemas.openxmlformats.org/officeDocument/2006/relationships" id="258" r:id="R64524b900a204b51"/>
+    <p:sldId xmlns:r="http://schemas.openxmlformats.org/officeDocument/2006/relationships" id="259" r:id="R0c9c225cba4c475b"/>
+    <p:sldId xmlns:r="http://schemas.openxmlformats.org/officeDocument/2006/relationships" id="260" r:id="R5a16345c952e40cb"/>
+    <p:sldId xmlns:r="http://schemas.openxmlformats.org/officeDocument/2006/relationships" id="261" r:id="Rd95ed6dac7e74e4e"/>
+    <p:sldId xmlns:r="http://schemas.openxmlformats.org/officeDocument/2006/relationships" id="262" r:id="R5f15976222f24e5b"/>
+    <p:sldId xmlns:r="http://schemas.openxmlformats.org/officeDocument/2006/relationships" id="263" r:id="R80c703a7c7474d01"/>
+    <p:sldId xmlns:r="http://schemas.openxmlformats.org/officeDocument/2006/relationships" id="264" r:id="R6cf98a4feac245f0"/>
+    <p:sldId xmlns:r="http://schemas.openxmlformats.org/officeDocument/2006/relationships" id="265" r:id="R395b66dce372452e"/>
+    <p:sldId xmlns:r="http://schemas.openxmlformats.org/officeDocument/2006/relationships" id="266" r:id="R682e0ca6c43b4ebc"/>
+    <p:sldId xmlns:r="http://schemas.openxmlformats.org/officeDocument/2006/relationships" id="267" r:id="R8380fdb462e04705"/>
+    <p:sldId xmlns:r="http://schemas.openxmlformats.org/officeDocument/2006/relationships" id="268" r:id="Rd01aa889805d44b4"/>
+    <p:sldId xmlns:r="http://schemas.openxmlformats.org/officeDocument/2006/relationships" id="269" r:id="R70a2bf0a945646e3"/>
+    <p:sldId xmlns:r="http://schemas.openxmlformats.org/officeDocument/2006/relationships" id="270" r:id="R52a6dcc370ce4c3e"/>
+    <p:sldId xmlns:r="http://schemas.openxmlformats.org/officeDocument/2006/relationships" id="271" r:id="Rb1b6401f038e49bb"/>
+    <p:sldId xmlns:r="http://schemas.openxmlformats.org/officeDocument/2006/relationships" id="272" r:id="Re662a1c04ebc4e8e"/>
   </p:sldIdLst>
   <p:sldSz cx="12192000" cy="6858000"/>
   <p:notesSz cx="6858000" cy="9144000"/>
@@ -948,7 +948,7 @@
           <a:lstStyle xmlns:a="http://schemas.openxmlformats.org/drawingml/2006/main"/>
           <a:p xmlns:a="http://schemas.openxmlformats.org/drawingml/2006/main">
             <a:r>
-              <a:t>Live participant reviewer account on https://quiznova-muskanbuilds11.onrender.com . This is a shared demonstration login with Participant permissions. Reviewers can instead register their own participant account for independent history. The live database contains six approved quizzes with six questions each. The private administrator password and database credentials are not included. The local-only sample logins have been replaced on this access slide.</a:t>
+              <a:t>Live participant reviewer account on https://quiznova-muskanbuilds11.onrender.com . This is a shared demonstration login with Participant permissions. Reviewers can instead register their own participant account for independent history. The live database contains seven approved quizzes with forty questions in total. The private administrator password and database credentials are not included. The local-only sample logins have been replaced on this access slide.</a:t>
             </a:r>
           </a:p>
         </p:txBody>
@@ -1625,7 +1625,7 @@
           <p:cNvPr id="3" name="Title">
             <a:extLst xmlns:a="http://schemas.openxmlformats.org/drawingml/2006/main">
               <a:ext uri="{FF2B5EF4-FFF2-40B4-BE49-F238E27FC236}">
-                <a16:creationId xmlns:a16="http://schemas.microsoft.com/office/drawing/2014/main" id="{D5913389-0334-4D36-B97C-A3318C06EEA4}"/>
+                <a16:creationId xmlns:a16="http://schemas.microsoft.com/office/drawing/2014/main" id="{5AB98AC6-A92E-4B64-8B1C-43E2A5E9DF86}"/>
               </a:ext>
             </a:extLst>
           </p:cNvPr>
@@ -1782,7 +1782,7 @@
           <p:cNvPr id="2" name="Subtitle">
             <a:extLst xmlns:a="http://schemas.openxmlformats.org/drawingml/2006/main">
               <a:ext uri="{FF2B5EF4-FFF2-40B4-BE49-F238E27FC236}">
-                <a16:creationId xmlns:a16="http://schemas.microsoft.com/office/drawing/2014/main" id="{B7ED4327-0EA0-4AE1-968D-20F8413F2B85}"/>
+                <a16:creationId xmlns:a16="http://schemas.microsoft.com/office/drawing/2014/main" id="{B83F0B7B-91A1-41AB-9D46-05F12627B590}"/>
               </a:ext>
             </a:extLst>
           </p:cNvPr>
@@ -1956,7 +1956,7 @@
           <p:cNvPr id="2" name="Section title">
             <a:extLst xmlns:a="http://schemas.openxmlformats.org/drawingml/2006/main">
               <a:ext uri="{FF2B5EF4-FFF2-40B4-BE49-F238E27FC236}">
-                <a16:creationId xmlns:a16="http://schemas.microsoft.com/office/drawing/2014/main" id="{7ABE9A62-6648-497F-9D8B-00E540E7F97C}"/>
+                <a16:creationId xmlns:a16="http://schemas.microsoft.com/office/drawing/2014/main" id="{71D6948A-80CA-43F9-9D55-C1BADEF46B30}"/>
               </a:ext>
             </a:extLst>
           </p:cNvPr>
@@ -2130,7 +2130,7 @@
           <p:cNvPr id="3" name="Title">
             <a:extLst xmlns:a="http://schemas.openxmlformats.org/drawingml/2006/main">
               <a:ext uri="{FF2B5EF4-FFF2-40B4-BE49-F238E27FC236}">
-                <a16:creationId xmlns:a16="http://schemas.microsoft.com/office/drawing/2014/main" id="{3D62B2D3-B723-42D8-A787-0847FC611125}"/>
+                <a16:creationId xmlns:a16="http://schemas.microsoft.com/office/drawing/2014/main" id="{D78A970F-E947-417B-B6D5-B03A3D61261E}"/>
               </a:ext>
             </a:extLst>
           </p:cNvPr>
@@ -2287,7 +2287,7 @@
           <p:cNvPr id="2" name="Body">
             <a:extLst xmlns:a="http://schemas.openxmlformats.org/drawingml/2006/main">
               <a:ext uri="{FF2B5EF4-FFF2-40B4-BE49-F238E27FC236}">
-                <a16:creationId xmlns:a16="http://schemas.microsoft.com/office/drawing/2014/main" id="{A47A654F-AFC2-4E3E-825C-179D3046AAEA}"/>
+                <a16:creationId xmlns:a16="http://schemas.microsoft.com/office/drawing/2014/main" id="{DEA4229D-6A62-43F4-8506-B27062365B34}"/>
               </a:ext>
             </a:extLst>
           </p:cNvPr>
@@ -2461,7 +2461,7 @@
           <p:cNvPr id="4" name="Title">
             <a:extLst xmlns:a="http://schemas.openxmlformats.org/drawingml/2006/main">
               <a:ext uri="{FF2B5EF4-FFF2-40B4-BE49-F238E27FC236}">
-                <a16:creationId xmlns:a16="http://schemas.microsoft.com/office/drawing/2014/main" id="{52A0D7D7-184A-44B9-9F2E-8F9BD6EA49FA}"/>
+                <a16:creationId xmlns:a16="http://schemas.microsoft.com/office/drawing/2014/main" id="{F81E1730-0A71-4B65-836C-2C871120D847}"/>
               </a:ext>
             </a:extLst>
           </p:cNvPr>
@@ -2618,7 +2618,7 @@
           <p:cNvPr id="2" name="Left column">
             <a:extLst xmlns:a="http://schemas.openxmlformats.org/drawingml/2006/main">
               <a:ext uri="{FF2B5EF4-FFF2-40B4-BE49-F238E27FC236}">
-                <a16:creationId xmlns:a16="http://schemas.microsoft.com/office/drawing/2014/main" id="{579F1165-F0ED-415D-A456-10B12E3CC482}"/>
+                <a16:creationId xmlns:a16="http://schemas.microsoft.com/office/drawing/2014/main" id="{D2E2C55D-815E-46E1-B781-22E223C24B5A}"/>
               </a:ext>
             </a:extLst>
           </p:cNvPr>
@@ -2775,7 +2775,7 @@
           <p:cNvPr id="3" name="Right column">
             <a:extLst xmlns:a="http://schemas.openxmlformats.org/drawingml/2006/main">
               <a:ext uri="{FF2B5EF4-FFF2-40B4-BE49-F238E27FC236}">
-                <a16:creationId xmlns:a16="http://schemas.microsoft.com/office/drawing/2014/main" id="{02A3B431-B49C-49B4-BB14-409F48A96190}"/>
+                <a16:creationId xmlns:a16="http://schemas.microsoft.com/office/drawing/2014/main" id="{C2A2D875-B3F8-4637-A704-E5E2370086AC}"/>
               </a:ext>
             </a:extLst>
           </p:cNvPr>
@@ -2949,7 +2949,7 @@
           <p:cNvPr id="3" name="Title">
             <a:extLst xmlns:a="http://schemas.openxmlformats.org/drawingml/2006/main">
               <a:ext uri="{FF2B5EF4-FFF2-40B4-BE49-F238E27FC236}">
-                <a16:creationId xmlns:a16="http://schemas.microsoft.com/office/drawing/2014/main" id="{420CF134-3117-4A22-8707-766733449F87}"/>
+                <a16:creationId xmlns:a16="http://schemas.microsoft.com/office/drawing/2014/main" id="{2B02491F-0502-4BA1-8691-0AFA22CE1001}"/>
               </a:ext>
             </a:extLst>
           </p:cNvPr>
@@ -3106,7 +3106,7 @@
           <p:cNvPr id="2" name="Left column">
             <a:extLst xmlns:a="http://schemas.openxmlformats.org/drawingml/2006/main">
               <a:ext uri="{FF2B5EF4-FFF2-40B4-BE49-F238E27FC236}">
-                <a16:creationId xmlns:a16="http://schemas.microsoft.com/office/drawing/2014/main" id="{68BCB4EF-CA12-4785-9BB6-161D0F756A68}"/>
+                <a16:creationId xmlns:a16="http://schemas.microsoft.com/office/drawing/2014/main" id="{A5A426E6-B779-4665-83EC-96FD2CDEB550}"/>
               </a:ext>
             </a:extLst>
           </p:cNvPr>
@@ -3301,12 +3301,12 @@
   </p:cSld>
   <p:clrMap bg1="lt1" tx1="dk1" bg2="lt2" tx2="dk2" accent1="accent1" accent2="accent2" accent3="accent3" accent4="accent4" accent5="accent5" accent6="accent6" hlink="hlink" folHlink="folHlink"/>
   <p:sldLayoutIdLst>
-    <p:sldLayoutId xmlns:r="http://schemas.openxmlformats.org/officeDocument/2006/relationships" id="2147483649" r:id="Re16ef79a633e4a05"/>
-    <p:sldLayoutId xmlns:r="http://schemas.openxmlformats.org/officeDocument/2006/relationships" id="2147483650" r:id="R65583c4bc4c547f7"/>
-    <p:sldLayoutId xmlns:r="http://schemas.openxmlformats.org/officeDocument/2006/relationships" id="2147483651" r:id="R30b3839a589e45ed"/>
-    <p:sldLayoutId xmlns:r="http://schemas.openxmlformats.org/officeDocument/2006/relationships" id="2147483652" r:id="Rab5fda82924b47e2"/>
-    <p:sldLayoutId xmlns:r="http://schemas.openxmlformats.org/officeDocument/2006/relationships" id="2147483653" r:id="Ra8e83730e23043b8"/>
-    <p:sldLayoutId xmlns:r="http://schemas.openxmlformats.org/officeDocument/2006/relationships" id="2147483654" r:id="R752a0b8e10ec4811"/>
+    <p:sldLayoutId xmlns:r="http://schemas.openxmlformats.org/officeDocument/2006/relationships" id="2147483649" r:id="Ra5a3080409c44ea8"/>
+    <p:sldLayoutId xmlns:r="http://schemas.openxmlformats.org/officeDocument/2006/relationships" id="2147483650" r:id="R770db6d3856443c7"/>
+    <p:sldLayoutId xmlns:r="http://schemas.openxmlformats.org/officeDocument/2006/relationships" id="2147483651" r:id="R2590ac09c74a4ab2"/>
+    <p:sldLayoutId xmlns:r="http://schemas.openxmlformats.org/officeDocument/2006/relationships" id="2147483652" r:id="R7ae48ddf27f94966"/>
+    <p:sldLayoutId xmlns:r="http://schemas.openxmlformats.org/officeDocument/2006/relationships" id="2147483653" r:id="R503db75bf6a84993"/>
+    <p:sldLayoutId xmlns:r="http://schemas.openxmlformats.org/officeDocument/2006/relationships" id="2147483654" r:id="R55f008f24d27411d"/>
   </p:sldLayoutIdLst>
   <p:txStyles>
     <p:titleStyle>
@@ -3857,7 +3857,7 @@
           <p:cNvPr id="9" name="">
             <a:extLst xmlns:a="http://schemas.openxmlformats.org/drawingml/2006/main">
               <a:ext uri="{FF2B5EF4-FFF2-40B4-BE49-F238E27FC236}">
-                <a16:creationId xmlns:a16="http://schemas.microsoft.com/office/drawing/2014/main" id="{0B33FF4D-7DD1-4EDF-A968-359CE6FDC11E}"/>
+                <a16:creationId xmlns:a16="http://schemas.microsoft.com/office/drawing/2014/main" id="{6BAF28BE-3C5F-4261-B298-25D11A0258FF}"/>
               </a:ext>
             </a:extLst>
           </p:cNvPr>
@@ -3923,7 +3923,7 @@
           <p:cNvPr id="2" name="">
             <a:extLst xmlns:a="http://schemas.openxmlformats.org/drawingml/2006/main">
               <a:ext uri="{FF2B5EF4-FFF2-40B4-BE49-F238E27FC236}">
-                <a16:creationId xmlns:a16="http://schemas.microsoft.com/office/drawing/2014/main" id="{AEB854E7-5A4D-4784-ADA2-45960B5F29E8}"/>
+                <a16:creationId xmlns:a16="http://schemas.microsoft.com/office/drawing/2014/main" id="{C9DDEDAD-A7A2-48A9-9D6C-CA0CDC615AD5}"/>
               </a:ext>
             </a:extLst>
           </p:cNvPr>
@@ -3989,7 +3989,7 @@
           <p:cNvPr id="3" name="">
             <a:extLst xmlns:a="http://schemas.openxmlformats.org/drawingml/2006/main">
               <a:ext uri="{FF2B5EF4-FFF2-40B4-BE49-F238E27FC236}">
-                <a16:creationId xmlns:a16="http://schemas.microsoft.com/office/drawing/2014/main" id="{8C070406-749F-41CE-90C7-D567C2C96967}"/>
+                <a16:creationId xmlns:a16="http://schemas.microsoft.com/office/drawing/2014/main" id="{36946838-2964-43C3-9F12-B8398EA11284}"/>
               </a:ext>
             </a:extLst>
           </p:cNvPr>
@@ -4055,7 +4055,7 @@
           <p:cNvPr id="4" name="">
             <a:extLst xmlns:a="http://schemas.openxmlformats.org/drawingml/2006/main">
               <a:ext uri="{FF2B5EF4-FFF2-40B4-BE49-F238E27FC236}">
-                <a16:creationId xmlns:a16="http://schemas.microsoft.com/office/drawing/2014/main" id="{FC2825E5-0D0E-47A5-BAC8-9A2BFB813723}"/>
+                <a16:creationId xmlns:a16="http://schemas.microsoft.com/office/drawing/2014/main" id="{4DBAB8A7-5447-458C-B08F-28E3EAD65927}"/>
               </a:ext>
             </a:extLst>
           </p:cNvPr>
@@ -4121,7 +4121,7 @@
           <p:cNvPr id="5" name="">
             <a:extLst xmlns:a="http://schemas.openxmlformats.org/drawingml/2006/main">
               <a:ext uri="{FF2B5EF4-FFF2-40B4-BE49-F238E27FC236}">
-                <a16:creationId xmlns:a16="http://schemas.microsoft.com/office/drawing/2014/main" id="{861422A5-4616-4FB0-AAE8-DCBCC6C36104}"/>
+                <a16:creationId xmlns:a16="http://schemas.microsoft.com/office/drawing/2014/main" id="{4F5B5D2E-54D0-439D-A6EB-240625E1CAE7}"/>
               </a:ext>
             </a:extLst>
           </p:cNvPr>
@@ -4210,7 +4210,7 @@
           <p:cNvPr id="6" name="">
             <a:extLst xmlns:a="http://schemas.openxmlformats.org/drawingml/2006/main">
               <a:ext uri="{FF2B5EF4-FFF2-40B4-BE49-F238E27FC236}">
-                <a16:creationId xmlns:a16="http://schemas.microsoft.com/office/drawing/2014/main" id="{59F1872D-3FC7-4363-AD96-01D6448BF612}"/>
+                <a16:creationId xmlns:a16="http://schemas.microsoft.com/office/drawing/2014/main" id="{2ABEB3A3-4429-4237-8E16-BA7A68F3E000}"/>
               </a:ext>
             </a:extLst>
           </p:cNvPr>
@@ -4276,7 +4276,7 @@
           <p:cNvPr id="7" name="">
             <a:extLst xmlns:a="http://schemas.openxmlformats.org/drawingml/2006/main">
               <a:ext uri="{FF2B5EF4-FFF2-40B4-BE49-F238E27FC236}">
-                <a16:creationId xmlns:a16="http://schemas.microsoft.com/office/drawing/2014/main" id="{1FDC43B7-9DCC-461C-8F12-C12001BE5E78}"/>
+                <a16:creationId xmlns:a16="http://schemas.microsoft.com/office/drawing/2014/main" id="{8069CFA1-DC8E-45CA-ADD1-A32B5697C477}"/>
               </a:ext>
             </a:extLst>
           </p:cNvPr>
@@ -4342,7 +4342,7 @@
           <p:cNvPr id="8" name="">
             <a:extLst xmlns:a="http://schemas.openxmlformats.org/drawingml/2006/main">
               <a:ext uri="{FF2B5EF4-FFF2-40B4-BE49-F238E27FC236}">
-                <a16:creationId xmlns:a16="http://schemas.microsoft.com/office/drawing/2014/main" id="{CA1706E3-44FC-487C-B3A0-EE9BF687C2E1}"/>
+                <a16:creationId xmlns:a16="http://schemas.microsoft.com/office/drawing/2014/main" id="{480D201E-5317-4588-8A8F-2119EA934A11}"/>
               </a:ext>
             </a:extLst>
           </p:cNvPr>
@@ -4406,7 +4406,7 @@
     </p:spTree>
     <p:extLst>
       <p:ext uri="{BB962C8B-B14F-4D97-AF65-F5344CB8AC3E}">
-        <p14:creationId xmlns:p14="http://schemas.microsoft.com/office/powerpoint/2010/main" val="126208355"/>
+        <p14:creationId xmlns:p14="http://schemas.microsoft.com/office/powerpoint/2010/main" val="1703235561"/>
       </p:ext>
     </p:extLst>
   </p:cSld>
@@ -4437,7 +4437,7 @@
           <p:cNvPr id="8" name="">
             <a:extLst xmlns:a="http://schemas.openxmlformats.org/drawingml/2006/main">
               <a:ext uri="{FF2B5EF4-FFF2-40B4-BE49-F238E27FC236}">
-                <a16:creationId xmlns:a16="http://schemas.microsoft.com/office/drawing/2014/main" id="{1D4B0FE0-E811-4D3F-A3D1-7F0CFA443229}"/>
+                <a16:creationId xmlns:a16="http://schemas.microsoft.com/office/drawing/2014/main" id="{678C769E-A578-4F52-B926-04F9DFAAC463}"/>
               </a:ext>
             </a:extLst>
           </p:cNvPr>
@@ -4503,7 +4503,7 @@
           <p:cNvPr id="2" name="">
             <a:extLst xmlns:a="http://schemas.openxmlformats.org/drawingml/2006/main">
               <a:ext uri="{FF2B5EF4-FFF2-40B4-BE49-F238E27FC236}">
-                <a16:creationId xmlns:a16="http://schemas.microsoft.com/office/drawing/2014/main" id="{4C5F2C88-98C2-4AD2-B3C3-8016E82B0665}"/>
+                <a16:creationId xmlns:a16="http://schemas.microsoft.com/office/drawing/2014/main" id="{9E9FA129-D72D-4DF5-B6DB-09141AEFA838}"/>
               </a:ext>
             </a:extLst>
           </p:cNvPr>
@@ -4569,7 +4569,7 @@
           <p:cNvPr id="3" name="">
             <a:extLst xmlns:a="http://schemas.openxmlformats.org/drawingml/2006/main">
               <a:ext uri="{FF2B5EF4-FFF2-40B4-BE49-F238E27FC236}">
-                <a16:creationId xmlns:a16="http://schemas.microsoft.com/office/drawing/2014/main" id="{A87B96A3-E6A3-4B4A-8498-874B45908C63}"/>
+                <a16:creationId xmlns:a16="http://schemas.microsoft.com/office/drawing/2014/main" id="{999F186C-8709-4FB2-8BE2-8C4F0194457D}"/>
               </a:ext>
             </a:extLst>
           </p:cNvPr>
@@ -4635,7 +4635,7 @@
           <p:cNvPr id="4" name="">
             <a:extLst xmlns:a="http://schemas.openxmlformats.org/drawingml/2006/main">
               <a:ext uri="{FF2B5EF4-FFF2-40B4-BE49-F238E27FC236}">
-                <a16:creationId xmlns:a16="http://schemas.microsoft.com/office/drawing/2014/main" id="{42F479A6-580E-47F7-9521-066FA4956121}"/>
+                <a16:creationId xmlns:a16="http://schemas.microsoft.com/office/drawing/2014/main" id="{550C309A-5A3D-4554-A288-868A681726FC}"/>
               </a:ext>
             </a:extLst>
           </p:cNvPr>
@@ -4701,7 +4701,7 @@
           <p:cNvPr id="5" name="">
             <a:extLst xmlns:a="http://schemas.openxmlformats.org/drawingml/2006/main">
               <a:ext uri="{FF2B5EF4-FFF2-40B4-BE49-F238E27FC236}">
-                <a16:creationId xmlns:a16="http://schemas.microsoft.com/office/drawing/2014/main" id="{35CD215E-C6C7-4A76-9816-E887EDB3CA65}"/>
+                <a16:creationId xmlns:a16="http://schemas.microsoft.com/office/drawing/2014/main" id="{4605BA4F-E4A6-4BE6-88AF-BCAD058BD8CE}"/>
               </a:ext>
             </a:extLst>
           </p:cNvPr>
@@ -4711,7 +4711,7 @@
           <p:nvPr/>
         </p:nvPicPr>
         <p:blipFill>
-          <a:blip xmlns:r="http://schemas.openxmlformats.org/officeDocument/2006/relationships" xmlns:a="http://schemas.openxmlformats.org/drawingml/2006/main" r:embed="Rf434958cac2b4f90"/>
+          <a:blip xmlns:r="http://schemas.openxmlformats.org/officeDocument/2006/relationships" xmlns:a="http://schemas.openxmlformats.org/drawingml/2006/main" r:embed="R890d19a635804b5b"/>
           <a:stretch xmlns:a="http://schemas.openxmlformats.org/drawingml/2006/main"/>
         </p:blipFill>
         <p:spPr>
@@ -4729,7 +4729,7 @@
           <p:cNvPr id="6" name="">
             <a:extLst xmlns:a="http://schemas.openxmlformats.org/drawingml/2006/main">
               <a:ext uri="{FF2B5EF4-FFF2-40B4-BE49-F238E27FC236}">
-                <a16:creationId xmlns:a16="http://schemas.microsoft.com/office/drawing/2014/main" id="{9E39597C-A1DC-4346-B823-5F146677CCF8}"/>
+                <a16:creationId xmlns:a16="http://schemas.microsoft.com/office/drawing/2014/main" id="{C6665F72-90FF-4884-98D5-405341C5C5E7}"/>
               </a:ext>
             </a:extLst>
           </p:cNvPr>
@@ -4887,7 +4887,7 @@
           <p:cNvPr id="7" name="">
             <a:extLst xmlns:a="http://schemas.openxmlformats.org/drawingml/2006/main">
               <a:ext uri="{FF2B5EF4-FFF2-40B4-BE49-F238E27FC236}">
-                <a16:creationId xmlns:a16="http://schemas.microsoft.com/office/drawing/2014/main" id="{7AD45F27-3B51-4C41-9DB1-414B8D7F7D55}"/>
+                <a16:creationId xmlns:a16="http://schemas.microsoft.com/office/drawing/2014/main" id="{7EA078D7-94BD-4D36-B7F7-6799CFACF410}"/>
               </a:ext>
             </a:extLst>
           </p:cNvPr>
@@ -4951,7 +4951,7 @@
     </p:spTree>
     <p:extLst>
       <p:ext uri="{BB962C8B-B14F-4D97-AF65-F5344CB8AC3E}">
-        <p14:creationId xmlns:p14="http://schemas.microsoft.com/office/powerpoint/2010/main" val="744470422"/>
+        <p14:creationId xmlns:p14="http://schemas.microsoft.com/office/powerpoint/2010/main" val="98239387"/>
       </p:ext>
     </p:extLst>
   </p:cSld>
@@ -4982,7 +4982,7 @@
           <p:cNvPr id="10" name="">
             <a:extLst xmlns:a="http://schemas.openxmlformats.org/drawingml/2006/main">
               <a:ext uri="{FF2B5EF4-FFF2-40B4-BE49-F238E27FC236}">
-                <a16:creationId xmlns:a16="http://schemas.microsoft.com/office/drawing/2014/main" id="{9D00A86D-232F-4218-A314-12801E370F05}"/>
+                <a16:creationId xmlns:a16="http://schemas.microsoft.com/office/drawing/2014/main" id="{CF665914-FE01-49BC-8ECC-109FDF852B77}"/>
               </a:ext>
             </a:extLst>
           </p:cNvPr>
@@ -5048,7 +5048,7 @@
           <p:cNvPr id="2" name="">
             <a:extLst xmlns:a="http://schemas.openxmlformats.org/drawingml/2006/main">
               <a:ext uri="{FF2B5EF4-FFF2-40B4-BE49-F238E27FC236}">
-                <a16:creationId xmlns:a16="http://schemas.microsoft.com/office/drawing/2014/main" id="{CF7EBBF6-53F0-4BF8-9FEE-E2E6922BB717}"/>
+                <a16:creationId xmlns:a16="http://schemas.microsoft.com/office/drawing/2014/main" id="{3116BDEA-5D3B-400B-A818-ABF41D2BF512}"/>
               </a:ext>
             </a:extLst>
           </p:cNvPr>
@@ -5114,7 +5114,7 @@
           <p:cNvPr id="3" name="">
             <a:extLst xmlns:a="http://schemas.openxmlformats.org/drawingml/2006/main">
               <a:ext uri="{FF2B5EF4-FFF2-40B4-BE49-F238E27FC236}">
-                <a16:creationId xmlns:a16="http://schemas.microsoft.com/office/drawing/2014/main" id="{AA6C98CA-D310-463D-891D-72054058911C}"/>
+                <a16:creationId xmlns:a16="http://schemas.microsoft.com/office/drawing/2014/main" id="{3EBE686B-F42E-40A6-AFBE-603407D8FDAC}"/>
               </a:ext>
             </a:extLst>
           </p:cNvPr>
@@ -5180,7 +5180,7 @@
           <p:cNvPr id="4" name="">
             <a:extLst xmlns:a="http://schemas.openxmlformats.org/drawingml/2006/main">
               <a:ext uri="{FF2B5EF4-FFF2-40B4-BE49-F238E27FC236}">
-                <a16:creationId xmlns:a16="http://schemas.microsoft.com/office/drawing/2014/main" id="{6F053C87-BD0F-4FA3-BDD4-7EAFDD75F7D5}"/>
+                <a16:creationId xmlns:a16="http://schemas.microsoft.com/office/drawing/2014/main" id="{95097041-8F88-4C27-9104-CFE297D6D128}"/>
               </a:ext>
             </a:extLst>
           </p:cNvPr>
@@ -5246,7 +5246,7 @@
           <p:cNvPr id="5" name="">
             <a:extLst xmlns:a="http://schemas.openxmlformats.org/drawingml/2006/main">
               <a:ext uri="{FF2B5EF4-FFF2-40B4-BE49-F238E27FC236}">
-                <a16:creationId xmlns:a16="http://schemas.microsoft.com/office/drawing/2014/main" id="{87D35437-A266-4E16-828E-8C4F79AC0A37}"/>
+                <a16:creationId xmlns:a16="http://schemas.microsoft.com/office/drawing/2014/main" id="{4E6DD394-011A-4699-9D62-384301D02A69}"/>
               </a:ext>
             </a:extLst>
           </p:cNvPr>
@@ -5256,7 +5256,7 @@
           <p:nvPr/>
         </p:nvPicPr>
         <p:blipFill>
-          <a:blip xmlns:r="http://schemas.openxmlformats.org/officeDocument/2006/relationships" xmlns:a="http://schemas.openxmlformats.org/drawingml/2006/main" r:embed="Rd05da8484b744344"/>
+          <a:blip xmlns:r="http://schemas.openxmlformats.org/officeDocument/2006/relationships" xmlns:a="http://schemas.openxmlformats.org/drawingml/2006/main" r:embed="R9dbec35471e74298"/>
           <a:stretch xmlns:a="http://schemas.openxmlformats.org/drawingml/2006/main"/>
         </p:blipFill>
         <p:spPr>
@@ -5274,7 +5274,7 @@
           <p:cNvPr id="6" name="">
             <a:extLst xmlns:a="http://schemas.openxmlformats.org/drawingml/2006/main">
               <a:ext uri="{FF2B5EF4-FFF2-40B4-BE49-F238E27FC236}">
-                <a16:creationId xmlns:a16="http://schemas.microsoft.com/office/drawing/2014/main" id="{86A82145-0CF5-436A-AD0B-48CB24F1BEFF}"/>
+                <a16:creationId xmlns:a16="http://schemas.microsoft.com/office/drawing/2014/main" id="{81D674EF-8643-471D-B02B-74D6235B82EF}"/>
               </a:ext>
             </a:extLst>
           </p:cNvPr>
@@ -5340,7 +5340,7 @@
           <p:cNvPr id="7" name="">
             <a:extLst xmlns:a="http://schemas.openxmlformats.org/drawingml/2006/main">
               <a:ext uri="{FF2B5EF4-FFF2-40B4-BE49-F238E27FC236}">
-                <a16:creationId xmlns:a16="http://schemas.microsoft.com/office/drawing/2014/main" id="{03E89C19-E075-46BA-A750-53DA87FEE1AC}"/>
+                <a16:creationId xmlns:a16="http://schemas.microsoft.com/office/drawing/2014/main" id="{A1EFC476-3321-482C-A924-7D6919215811}"/>
               </a:ext>
             </a:extLst>
           </p:cNvPr>
@@ -5406,7 +5406,7 @@
           <p:cNvPr id="8" name="">
             <a:extLst xmlns:a="http://schemas.openxmlformats.org/drawingml/2006/main">
               <a:ext uri="{FF2B5EF4-FFF2-40B4-BE49-F238E27FC236}">
-                <a16:creationId xmlns:a16="http://schemas.microsoft.com/office/drawing/2014/main" id="{86AA87D0-2A92-4F36-A9C8-510078AD9D7A}"/>
+                <a16:creationId xmlns:a16="http://schemas.microsoft.com/office/drawing/2014/main" id="{18D451FF-782F-4ED0-BF90-8ECCBF4A7F34}"/>
               </a:ext>
             </a:extLst>
           </p:cNvPr>
@@ -5472,7 +5472,7 @@
           <p:cNvPr id="9" name="">
             <a:extLst xmlns:a="http://schemas.openxmlformats.org/drawingml/2006/main">
               <a:ext uri="{FF2B5EF4-FFF2-40B4-BE49-F238E27FC236}">
-                <a16:creationId xmlns:a16="http://schemas.microsoft.com/office/drawing/2014/main" id="{880A2560-EF36-4900-B1BD-019E35DD35B1}"/>
+                <a16:creationId xmlns:a16="http://schemas.microsoft.com/office/drawing/2014/main" id="{88498C11-C540-43F4-AA6B-9AB6BCCD23AA}"/>
               </a:ext>
             </a:extLst>
           </p:cNvPr>
@@ -5536,7 +5536,7 @@
     </p:spTree>
     <p:extLst>
       <p:ext uri="{BB962C8B-B14F-4D97-AF65-F5344CB8AC3E}">
-        <p14:creationId xmlns:p14="http://schemas.microsoft.com/office/powerpoint/2010/main" val="2037342438"/>
+        <p14:creationId xmlns:p14="http://schemas.microsoft.com/office/powerpoint/2010/main" val="1195773876"/>
       </p:ext>
     </p:extLst>
   </p:cSld>
@@ -5567,7 +5567,7 @@
           <p:cNvPr id="7" name="">
             <a:extLst xmlns:a="http://schemas.openxmlformats.org/drawingml/2006/main">
               <a:ext uri="{FF2B5EF4-FFF2-40B4-BE49-F238E27FC236}">
-                <a16:creationId xmlns:a16="http://schemas.microsoft.com/office/drawing/2014/main" id="{7D91943D-F696-4B8D-8598-3736A4719F91}"/>
+                <a16:creationId xmlns:a16="http://schemas.microsoft.com/office/drawing/2014/main" id="{5B84D7DF-4F36-4E9B-8FFC-0A57A2644F8D}"/>
               </a:ext>
             </a:extLst>
           </p:cNvPr>
@@ -5633,7 +5633,7 @@
           <p:cNvPr id="2" name="">
             <a:extLst xmlns:a="http://schemas.openxmlformats.org/drawingml/2006/main">
               <a:ext uri="{FF2B5EF4-FFF2-40B4-BE49-F238E27FC236}">
-                <a16:creationId xmlns:a16="http://schemas.microsoft.com/office/drawing/2014/main" id="{4639AFCB-20D6-49BB-B969-9D5B5DF95508}"/>
+                <a16:creationId xmlns:a16="http://schemas.microsoft.com/office/drawing/2014/main" id="{8F709A2B-86D8-4541-A0BD-44FCB36C70AB}"/>
               </a:ext>
             </a:extLst>
           </p:cNvPr>
@@ -5699,7 +5699,7 @@
           <p:cNvPr id="3" name="">
             <a:extLst xmlns:a="http://schemas.openxmlformats.org/drawingml/2006/main">
               <a:ext uri="{FF2B5EF4-FFF2-40B4-BE49-F238E27FC236}">
-                <a16:creationId xmlns:a16="http://schemas.microsoft.com/office/drawing/2014/main" id="{141B3037-AE8D-40E0-BFA5-A378963C8EB0}"/>
+                <a16:creationId xmlns:a16="http://schemas.microsoft.com/office/drawing/2014/main" id="{94926AA3-4919-4422-9BED-774D64C7BED0}"/>
               </a:ext>
             </a:extLst>
           </p:cNvPr>
@@ -5765,7 +5765,7 @@
           <p:cNvPr id="4" name="">
             <a:extLst xmlns:a="http://schemas.openxmlformats.org/drawingml/2006/main">
               <a:ext uri="{FF2B5EF4-FFF2-40B4-BE49-F238E27FC236}">
-                <a16:creationId xmlns:a16="http://schemas.microsoft.com/office/drawing/2014/main" id="{7FB0BA8B-1E55-4899-AB29-A211E8BF6BDC}"/>
+                <a16:creationId xmlns:a16="http://schemas.microsoft.com/office/drawing/2014/main" id="{95121BA8-690E-466B-9021-34AF84D8EB78}"/>
               </a:ext>
             </a:extLst>
           </p:cNvPr>
@@ -5831,7 +5831,7 @@
           <p:cNvPr id="5" name="">
             <a:extLst xmlns:a="http://schemas.openxmlformats.org/drawingml/2006/main">
               <a:ext uri="{FF2B5EF4-FFF2-40B4-BE49-F238E27FC236}">
-                <a16:creationId xmlns:a16="http://schemas.microsoft.com/office/drawing/2014/main" id="{30F63B44-48F5-42B3-A2B3-85ADB199B8BA}"/>
+                <a16:creationId xmlns:a16="http://schemas.microsoft.com/office/drawing/2014/main" id="{50D898ED-0304-4B3A-A22D-235EDD5D3C2E}"/>
               </a:ext>
             </a:extLst>
           </p:cNvPr>
@@ -5841,7 +5841,7 @@
           <p:nvPr/>
         </p:nvPicPr>
         <p:blipFill>
-          <a:blip xmlns:r="http://schemas.openxmlformats.org/officeDocument/2006/relationships" xmlns:a="http://schemas.openxmlformats.org/drawingml/2006/main" r:embed="R16bc5d5e554a4cf5"/>
+          <a:blip xmlns:r="http://schemas.openxmlformats.org/officeDocument/2006/relationships" xmlns:a="http://schemas.openxmlformats.org/drawingml/2006/main" r:embed="R78ec3538a1ac4811"/>
           <a:stretch xmlns:a="http://schemas.openxmlformats.org/drawingml/2006/main"/>
         </p:blipFill>
         <p:spPr>
@@ -5859,7 +5859,7 @@
           <p:cNvPr id="6" name="">
             <a:extLst xmlns:a="http://schemas.openxmlformats.org/drawingml/2006/main">
               <a:ext uri="{FF2B5EF4-FFF2-40B4-BE49-F238E27FC236}">
-                <a16:creationId xmlns:a16="http://schemas.microsoft.com/office/drawing/2014/main" id="{BB96F312-2580-4253-84CB-E5E58CDC9459}"/>
+                <a16:creationId xmlns:a16="http://schemas.microsoft.com/office/drawing/2014/main" id="{B28EAFBB-91D1-4349-B473-805C42A66E91}"/>
               </a:ext>
             </a:extLst>
           </p:cNvPr>
@@ -6035,7 +6035,7 @@
     </p:spTree>
     <p:extLst>
       <p:ext uri="{BB962C8B-B14F-4D97-AF65-F5344CB8AC3E}">
-        <p14:creationId xmlns:p14="http://schemas.microsoft.com/office/powerpoint/2010/main" val="1364022024"/>
+        <p14:creationId xmlns:p14="http://schemas.microsoft.com/office/powerpoint/2010/main" val="527172539"/>
       </p:ext>
     </p:extLst>
   </p:cSld>
@@ -6066,7 +6066,7 @@
           <p:cNvPr id="13" name="">
             <a:extLst xmlns:a="http://schemas.openxmlformats.org/drawingml/2006/main">
               <a:ext uri="{FF2B5EF4-FFF2-40B4-BE49-F238E27FC236}">
-                <a16:creationId xmlns:a16="http://schemas.microsoft.com/office/drawing/2014/main" id="{A1537DB9-9620-48B7-8884-C483E5113ED1}"/>
+                <a16:creationId xmlns:a16="http://schemas.microsoft.com/office/drawing/2014/main" id="{6F94BCC2-09EB-43B6-9FF9-A7C992DCAE7B}"/>
               </a:ext>
             </a:extLst>
           </p:cNvPr>
@@ -6132,7 +6132,7 @@
           <p:cNvPr id="2" name="">
             <a:extLst xmlns:a="http://schemas.openxmlformats.org/drawingml/2006/main">
               <a:ext uri="{FF2B5EF4-FFF2-40B4-BE49-F238E27FC236}">
-                <a16:creationId xmlns:a16="http://schemas.microsoft.com/office/drawing/2014/main" id="{98E6FBCD-38F2-437F-9604-0A93777B41D7}"/>
+                <a16:creationId xmlns:a16="http://schemas.microsoft.com/office/drawing/2014/main" id="{C3D76FA3-FD56-441B-83CF-73C7BA278997}"/>
               </a:ext>
             </a:extLst>
           </p:cNvPr>
@@ -6198,7 +6198,7 @@
           <p:cNvPr id="3" name="">
             <a:extLst xmlns:a="http://schemas.openxmlformats.org/drawingml/2006/main">
               <a:ext uri="{FF2B5EF4-FFF2-40B4-BE49-F238E27FC236}">
-                <a16:creationId xmlns:a16="http://schemas.microsoft.com/office/drawing/2014/main" id="{92A65F0F-AF49-4B5D-8CE3-3EA2EDCB86E9}"/>
+                <a16:creationId xmlns:a16="http://schemas.microsoft.com/office/drawing/2014/main" id="{B0C179CC-DF8C-4FDF-8894-28BDD9070BA4}"/>
               </a:ext>
             </a:extLst>
           </p:cNvPr>
@@ -6264,7 +6264,7 @@
           <p:cNvPr id="4" name="">
             <a:extLst xmlns:a="http://schemas.openxmlformats.org/drawingml/2006/main">
               <a:ext uri="{FF2B5EF4-FFF2-40B4-BE49-F238E27FC236}">
-                <a16:creationId xmlns:a16="http://schemas.microsoft.com/office/drawing/2014/main" id="{DA93D888-4956-4307-86A9-AD798CFBCBCF}"/>
+                <a16:creationId xmlns:a16="http://schemas.microsoft.com/office/drawing/2014/main" id="{ED723B06-86DD-4FD7-918E-827F76037AC8}"/>
               </a:ext>
             </a:extLst>
           </p:cNvPr>
@@ -6330,7 +6330,7 @@
           <p:cNvPr id="5" name="">
             <a:extLst xmlns:a="http://schemas.openxmlformats.org/drawingml/2006/main">
               <a:ext uri="{FF2B5EF4-FFF2-40B4-BE49-F238E27FC236}">
-                <a16:creationId xmlns:a16="http://schemas.microsoft.com/office/drawing/2014/main" id="{C4803E62-0BAB-495B-9DA0-381C7B4AE892}"/>
+                <a16:creationId xmlns:a16="http://schemas.microsoft.com/office/drawing/2014/main" id="{A48EA63E-0830-4F38-9A29-9FD46045DDD0}"/>
               </a:ext>
             </a:extLst>
           </p:cNvPr>
@@ -6396,7 +6396,7 @@
           <p:cNvPr id="6" name="">
             <a:extLst xmlns:a="http://schemas.openxmlformats.org/drawingml/2006/main">
               <a:ext uri="{FF2B5EF4-FFF2-40B4-BE49-F238E27FC236}">
-                <a16:creationId xmlns:a16="http://schemas.microsoft.com/office/drawing/2014/main" id="{86094195-4FD4-428A-B4EA-5C60C2E00AEF}"/>
+                <a16:creationId xmlns:a16="http://schemas.microsoft.com/office/drawing/2014/main" id="{512C9E6D-4D6F-475F-B7D8-ED216897829C}"/>
               </a:ext>
             </a:extLst>
           </p:cNvPr>
@@ -6462,7 +6462,7 @@
           <p:cNvPr id="7" name="">
             <a:extLst xmlns:a="http://schemas.openxmlformats.org/drawingml/2006/main">
               <a:ext uri="{FF2B5EF4-FFF2-40B4-BE49-F238E27FC236}">
-                <a16:creationId xmlns:a16="http://schemas.microsoft.com/office/drawing/2014/main" id="{8065139C-38B8-49A1-B2B5-AFA3A7B53AEA}"/>
+                <a16:creationId xmlns:a16="http://schemas.microsoft.com/office/drawing/2014/main" id="{A41C5DF8-2C4E-4942-A5FF-ED2BB9171B53}"/>
               </a:ext>
             </a:extLst>
           </p:cNvPr>
@@ -6528,7 +6528,7 @@
           <p:cNvPr id="8" name="">
             <a:extLst xmlns:a="http://schemas.openxmlformats.org/drawingml/2006/main">
               <a:ext uri="{FF2B5EF4-FFF2-40B4-BE49-F238E27FC236}">
-                <a16:creationId xmlns:a16="http://schemas.microsoft.com/office/drawing/2014/main" id="{C58D9F01-5B4A-4000-9C76-11D6928FFF2C}"/>
+                <a16:creationId xmlns:a16="http://schemas.microsoft.com/office/drawing/2014/main" id="{5580D32D-B731-4D03-A21F-EE8A661D6350}"/>
               </a:ext>
             </a:extLst>
           </p:cNvPr>
@@ -6594,7 +6594,7 @@
           <p:cNvPr id="9" name="">
             <a:extLst xmlns:a="http://schemas.openxmlformats.org/drawingml/2006/main">
               <a:ext uri="{FF2B5EF4-FFF2-40B4-BE49-F238E27FC236}">
-                <a16:creationId xmlns:a16="http://schemas.microsoft.com/office/drawing/2014/main" id="{4CC9CC86-0A54-4BC5-970C-A9D9DD0F1D28}"/>
+                <a16:creationId xmlns:a16="http://schemas.microsoft.com/office/drawing/2014/main" id="{B94990F6-4811-47C6-9AC7-2D1F4BF2522A}"/>
               </a:ext>
             </a:extLst>
           </p:cNvPr>
@@ -6660,7 +6660,7 @@
           <p:cNvPr id="10" name="">
             <a:extLst xmlns:a="http://schemas.openxmlformats.org/drawingml/2006/main">
               <a:ext uri="{FF2B5EF4-FFF2-40B4-BE49-F238E27FC236}">
-                <a16:creationId xmlns:a16="http://schemas.microsoft.com/office/drawing/2014/main" id="{38C0B4C3-5491-4BE8-BFFC-B3751FF430CD}"/>
+                <a16:creationId xmlns:a16="http://schemas.microsoft.com/office/drawing/2014/main" id="{3AF896A2-ECE6-402D-AD49-85D9B335C4D8}"/>
               </a:ext>
             </a:extLst>
           </p:cNvPr>
@@ -6726,7 +6726,7 @@
           <p:cNvPr id="11" name="">
             <a:extLst xmlns:a="http://schemas.openxmlformats.org/drawingml/2006/main">
               <a:ext uri="{FF2B5EF4-FFF2-40B4-BE49-F238E27FC236}">
-                <a16:creationId xmlns:a16="http://schemas.microsoft.com/office/drawing/2014/main" id="{06194F0C-7BBC-4E75-85C6-5AD07A7826D9}"/>
+                <a16:creationId xmlns:a16="http://schemas.microsoft.com/office/drawing/2014/main" id="{EB5B7754-1F8E-4616-A555-21AEB6A7AACF}"/>
               </a:ext>
             </a:extLst>
           </p:cNvPr>
@@ -6792,7 +6792,7 @@
           <p:cNvPr id="12" name="">
             <a:extLst xmlns:a="http://schemas.openxmlformats.org/drawingml/2006/main">
               <a:ext uri="{FF2B5EF4-FFF2-40B4-BE49-F238E27FC236}">
-                <a16:creationId xmlns:a16="http://schemas.microsoft.com/office/drawing/2014/main" id="{24F2746A-605B-4AB4-883D-26C0852DEA3F}"/>
+                <a16:creationId xmlns:a16="http://schemas.microsoft.com/office/drawing/2014/main" id="{E4408BFB-5964-46E0-91DC-24CF80837279}"/>
               </a:ext>
             </a:extLst>
           </p:cNvPr>
@@ -6856,7 +6856,7 @@
     </p:spTree>
     <p:extLst>
       <p:ext uri="{BB962C8B-B14F-4D97-AF65-F5344CB8AC3E}">
-        <p14:creationId xmlns:p14="http://schemas.microsoft.com/office/powerpoint/2010/main" val="1825684873"/>
+        <p14:creationId xmlns:p14="http://schemas.microsoft.com/office/powerpoint/2010/main" val="897599962"/>
       </p:ext>
     </p:extLst>
   </p:cSld>
@@ -6887,7 +6887,7 @@
           <p:cNvPr id="7" name="">
             <a:extLst xmlns:a="http://schemas.openxmlformats.org/drawingml/2006/main">
               <a:ext uri="{FF2B5EF4-FFF2-40B4-BE49-F238E27FC236}">
-                <a16:creationId xmlns:a16="http://schemas.microsoft.com/office/drawing/2014/main" id="{8CD5C18E-7E19-4643-A85E-BEDE2180BDF0}"/>
+                <a16:creationId xmlns:a16="http://schemas.microsoft.com/office/drawing/2014/main" id="{6DFA1CBF-7464-46C9-81E3-EF2D67711739}"/>
               </a:ext>
             </a:extLst>
           </p:cNvPr>
@@ -6953,7 +6953,7 @@
           <p:cNvPr id="2" name="">
             <a:extLst xmlns:a="http://schemas.openxmlformats.org/drawingml/2006/main">
               <a:ext uri="{FF2B5EF4-FFF2-40B4-BE49-F238E27FC236}">
-                <a16:creationId xmlns:a16="http://schemas.microsoft.com/office/drawing/2014/main" id="{405B7453-21E2-46C2-9B78-F710BBF5130D}"/>
+                <a16:creationId xmlns:a16="http://schemas.microsoft.com/office/drawing/2014/main" id="{D2FD5C54-42F7-436D-B02A-C887B2B73E59}"/>
               </a:ext>
             </a:extLst>
           </p:cNvPr>
@@ -7019,7 +7019,7 @@
           <p:cNvPr id="3" name="">
             <a:extLst xmlns:a="http://schemas.openxmlformats.org/drawingml/2006/main">
               <a:ext uri="{FF2B5EF4-FFF2-40B4-BE49-F238E27FC236}">
-                <a16:creationId xmlns:a16="http://schemas.microsoft.com/office/drawing/2014/main" id="{7945D001-4925-4F81-B0E6-D24ABCB8C764}"/>
+                <a16:creationId xmlns:a16="http://schemas.microsoft.com/office/drawing/2014/main" id="{30CA3A5E-A15E-4D9F-9E35-4B4CBC116DA6}"/>
               </a:ext>
             </a:extLst>
           </p:cNvPr>
@@ -7085,7 +7085,7 @@
           <p:cNvPr id="4" name="">
             <a:extLst xmlns:a="http://schemas.openxmlformats.org/drawingml/2006/main">
               <a:ext uri="{FF2B5EF4-FFF2-40B4-BE49-F238E27FC236}">
-                <a16:creationId xmlns:a16="http://schemas.microsoft.com/office/drawing/2014/main" id="{DBECC61D-EA64-4651-9827-A32BCCBE26FB}"/>
+                <a16:creationId xmlns:a16="http://schemas.microsoft.com/office/drawing/2014/main" id="{1E78B3C0-5DD3-4705-BF37-4740DE817DD8}"/>
               </a:ext>
             </a:extLst>
           </p:cNvPr>
@@ -7151,7 +7151,7 @@
           <p:cNvPr id="5" name="">
             <a:extLst xmlns:a="http://schemas.openxmlformats.org/drawingml/2006/main">
               <a:ext uri="{FF2B5EF4-FFF2-40B4-BE49-F238E27FC236}">
-                <a16:creationId xmlns:a16="http://schemas.microsoft.com/office/drawing/2014/main" id="{C131113E-0371-4F49-95EA-733D3ECDD196}"/>
+                <a16:creationId xmlns:a16="http://schemas.microsoft.com/office/drawing/2014/main" id="{5166100C-66D7-4913-AB43-7AB22188728C}"/>
               </a:ext>
             </a:extLst>
           </p:cNvPr>
@@ -7849,7 +7849,7 @@
           <p:cNvPr id="6" name="">
             <a:extLst xmlns:a="http://schemas.openxmlformats.org/drawingml/2006/main">
               <a:ext uri="{FF2B5EF4-FFF2-40B4-BE49-F238E27FC236}">
-                <a16:creationId xmlns:a16="http://schemas.microsoft.com/office/drawing/2014/main" id="{9720B675-E0C6-4EFF-9FF0-A498B782310F}"/>
+                <a16:creationId xmlns:a16="http://schemas.microsoft.com/office/drawing/2014/main" id="{B158B481-7C55-4DE1-94DD-126216F5F1F7}"/>
               </a:ext>
             </a:extLst>
           </p:cNvPr>
@@ -7913,7 +7913,7 @@
     </p:spTree>
     <p:extLst>
       <p:ext uri="{BB962C8B-B14F-4D97-AF65-F5344CB8AC3E}">
-        <p14:creationId xmlns:p14="http://schemas.microsoft.com/office/powerpoint/2010/main" val="187762285"/>
+        <p14:creationId xmlns:p14="http://schemas.microsoft.com/office/powerpoint/2010/main" val="1128978386"/>
       </p:ext>
     </p:extLst>
   </p:cSld>
@@ -7944,7 +7944,7 @@
           <p:cNvPr id="12" name="">
             <a:extLst xmlns:a="http://schemas.openxmlformats.org/drawingml/2006/main">
               <a:ext uri="{FF2B5EF4-FFF2-40B4-BE49-F238E27FC236}">
-                <a16:creationId xmlns:a16="http://schemas.microsoft.com/office/drawing/2014/main" id="{76F3236E-8F14-4769-A0DB-8C1B8F0674A1}"/>
+                <a16:creationId xmlns:a16="http://schemas.microsoft.com/office/drawing/2014/main" id="{B577C355-024D-42D4-AADC-2BCCC6947792}"/>
               </a:ext>
             </a:extLst>
           </p:cNvPr>
@@ -8010,7 +8010,7 @@
           <p:cNvPr id="2" name="">
             <a:extLst xmlns:a="http://schemas.openxmlformats.org/drawingml/2006/main">
               <a:ext uri="{FF2B5EF4-FFF2-40B4-BE49-F238E27FC236}">
-                <a16:creationId xmlns:a16="http://schemas.microsoft.com/office/drawing/2014/main" id="{6A3D010F-1BCE-49EE-85D7-B1D4F6E277F7}"/>
+                <a16:creationId xmlns:a16="http://schemas.microsoft.com/office/drawing/2014/main" id="{1906124B-F196-42BF-BC09-2FCB69204A32}"/>
               </a:ext>
             </a:extLst>
           </p:cNvPr>
@@ -8076,7 +8076,7 @@
           <p:cNvPr id="3" name="">
             <a:extLst xmlns:a="http://schemas.openxmlformats.org/drawingml/2006/main">
               <a:ext uri="{FF2B5EF4-FFF2-40B4-BE49-F238E27FC236}">
-                <a16:creationId xmlns:a16="http://schemas.microsoft.com/office/drawing/2014/main" id="{403757B5-FA44-47CD-9D7D-A10B61A530D4}"/>
+                <a16:creationId xmlns:a16="http://schemas.microsoft.com/office/drawing/2014/main" id="{5C0CD7F5-8756-43BF-846D-8CCDFE335096}"/>
               </a:ext>
             </a:extLst>
           </p:cNvPr>
@@ -8142,7 +8142,7 @@
           <p:cNvPr id="4" name="">
             <a:extLst xmlns:a="http://schemas.openxmlformats.org/drawingml/2006/main">
               <a:ext uri="{FF2B5EF4-FFF2-40B4-BE49-F238E27FC236}">
-                <a16:creationId xmlns:a16="http://schemas.microsoft.com/office/drawing/2014/main" id="{B162189E-8038-4688-A9F4-5FA926E95686}"/>
+                <a16:creationId xmlns:a16="http://schemas.microsoft.com/office/drawing/2014/main" id="{4FF2EE56-F8BD-48CA-B957-C6CBA1C0F106}"/>
               </a:ext>
             </a:extLst>
           </p:cNvPr>
@@ -8208,7 +8208,7 @@
           <p:cNvPr id="5" name="">
             <a:extLst xmlns:a="http://schemas.openxmlformats.org/drawingml/2006/main">
               <a:ext uri="{FF2B5EF4-FFF2-40B4-BE49-F238E27FC236}">
-                <a16:creationId xmlns:a16="http://schemas.microsoft.com/office/drawing/2014/main" id="{9B9B80AE-E07D-48C1-992F-F26EFE2E3CAE}"/>
+                <a16:creationId xmlns:a16="http://schemas.microsoft.com/office/drawing/2014/main" id="{CA006F96-D938-4965-B694-EBF6FDAB5C52}"/>
               </a:ext>
             </a:extLst>
           </p:cNvPr>
@@ -8274,7 +8274,7 @@
           <p:cNvPr id="6" name="">
             <a:extLst xmlns:a="http://schemas.openxmlformats.org/drawingml/2006/main">
               <a:ext uri="{FF2B5EF4-FFF2-40B4-BE49-F238E27FC236}">
-                <a16:creationId xmlns:a16="http://schemas.microsoft.com/office/drawing/2014/main" id="{79BF18FA-1B3D-4F7A-9BA0-8431A398E46B}"/>
+                <a16:creationId xmlns:a16="http://schemas.microsoft.com/office/drawing/2014/main" id="{6D77F290-1DAA-4D43-B27A-623CD2053C12}"/>
               </a:ext>
             </a:extLst>
           </p:cNvPr>
@@ -8340,7 +8340,7 @@
           <p:cNvPr id="7" name="">
             <a:extLst xmlns:a="http://schemas.openxmlformats.org/drawingml/2006/main">
               <a:ext uri="{FF2B5EF4-FFF2-40B4-BE49-F238E27FC236}">
-                <a16:creationId xmlns:a16="http://schemas.microsoft.com/office/drawing/2014/main" id="{A8720C7E-CA87-4EEA-99C5-76DB604B7711}"/>
+                <a16:creationId xmlns:a16="http://schemas.microsoft.com/office/drawing/2014/main" id="{3546D338-3EA9-475B-B057-5442CA1D9BB6}"/>
               </a:ext>
             </a:extLst>
           </p:cNvPr>
@@ -8406,7 +8406,7 @@
           <p:cNvPr id="8" name="">
             <a:extLst xmlns:a="http://schemas.openxmlformats.org/drawingml/2006/main">
               <a:ext uri="{FF2B5EF4-FFF2-40B4-BE49-F238E27FC236}">
-                <a16:creationId xmlns:a16="http://schemas.microsoft.com/office/drawing/2014/main" id="{9CF975E8-06C1-47C2-819F-B2DE867CD69D}"/>
+                <a16:creationId xmlns:a16="http://schemas.microsoft.com/office/drawing/2014/main" id="{90420E13-4C1E-42BA-BF6B-AFC8206B3125}"/>
               </a:ext>
             </a:extLst>
           </p:cNvPr>
@@ -8472,7 +8472,7 @@
           <p:cNvPr id="9" name="">
             <a:extLst xmlns:a="http://schemas.openxmlformats.org/drawingml/2006/main">
               <a:ext uri="{FF2B5EF4-FFF2-40B4-BE49-F238E27FC236}">
-                <a16:creationId xmlns:a16="http://schemas.microsoft.com/office/drawing/2014/main" id="{F12C8C44-F34C-4504-8D45-A77D94D10CD7}"/>
+                <a16:creationId xmlns:a16="http://schemas.microsoft.com/office/drawing/2014/main" id="{BCB8D46C-840A-4C30-929E-F21B6590D9F1}"/>
               </a:ext>
             </a:extLst>
           </p:cNvPr>
@@ -8538,7 +8538,7 @@
           <p:cNvPr id="10" name="">
             <a:extLst xmlns:a="http://schemas.openxmlformats.org/drawingml/2006/main">
               <a:ext uri="{FF2B5EF4-FFF2-40B4-BE49-F238E27FC236}">
-                <a16:creationId xmlns:a16="http://schemas.microsoft.com/office/drawing/2014/main" id="{219AD209-992F-471A-B2DF-C0318061C344}"/>
+                <a16:creationId xmlns:a16="http://schemas.microsoft.com/office/drawing/2014/main" id="{4AE4C176-D4A2-4BE2-AD35-413352B102E0}"/>
               </a:ext>
             </a:extLst>
           </p:cNvPr>
@@ -8604,7 +8604,7 @@
           <p:cNvPr id="11" name="">
             <a:extLst xmlns:a="http://schemas.openxmlformats.org/drawingml/2006/main">
               <a:ext uri="{FF2B5EF4-FFF2-40B4-BE49-F238E27FC236}">
-                <a16:creationId xmlns:a16="http://schemas.microsoft.com/office/drawing/2014/main" id="{492874E7-243E-4C97-AB8C-2C6AF33F6D7C}"/>
+                <a16:creationId xmlns:a16="http://schemas.microsoft.com/office/drawing/2014/main" id="{963C0D20-95C0-4D98-ADBF-E48BD031FCDA}"/>
               </a:ext>
             </a:extLst>
           </p:cNvPr>
@@ -8691,7 +8691,7 @@
     </p:spTree>
     <p:extLst>
       <p:ext uri="{BB962C8B-B14F-4D97-AF65-F5344CB8AC3E}">
-        <p14:creationId xmlns:p14="http://schemas.microsoft.com/office/powerpoint/2010/main" val="1635893515"/>
+        <p14:creationId xmlns:p14="http://schemas.microsoft.com/office/powerpoint/2010/main" val="31973870"/>
       </p:ext>
     </p:extLst>
   </p:cSld>
@@ -8722,7 +8722,7 @@
           <p:cNvPr id="10" name="">
             <a:extLst xmlns:a="http://schemas.openxmlformats.org/drawingml/2006/main">
               <a:ext uri="{FF2B5EF4-FFF2-40B4-BE49-F238E27FC236}">
-                <a16:creationId xmlns:a16="http://schemas.microsoft.com/office/drawing/2014/main" id="{225145D1-B1F8-499A-A6DF-FF86F753CF2A}"/>
+                <a16:creationId xmlns:a16="http://schemas.microsoft.com/office/drawing/2014/main" id="{B7305DA8-1105-4CE5-8AF7-B01651CE6CC5}"/>
               </a:ext>
             </a:extLst>
           </p:cNvPr>
@@ -8788,7 +8788,7 @@
           <p:cNvPr id="2" name="">
             <a:extLst xmlns:a="http://schemas.openxmlformats.org/drawingml/2006/main">
               <a:ext uri="{FF2B5EF4-FFF2-40B4-BE49-F238E27FC236}">
-                <a16:creationId xmlns:a16="http://schemas.microsoft.com/office/drawing/2014/main" id="{C1375F65-EFA4-4D67-9A31-50F9572C0949}"/>
+                <a16:creationId xmlns:a16="http://schemas.microsoft.com/office/drawing/2014/main" id="{4B0E4AE1-533D-48CC-ACCF-270E9B8BC5D0}"/>
               </a:ext>
             </a:extLst>
           </p:cNvPr>
@@ -8854,7 +8854,7 @@
           <p:cNvPr id="3" name="">
             <a:extLst xmlns:a="http://schemas.openxmlformats.org/drawingml/2006/main">
               <a:ext uri="{FF2B5EF4-FFF2-40B4-BE49-F238E27FC236}">
-                <a16:creationId xmlns:a16="http://schemas.microsoft.com/office/drawing/2014/main" id="{CDD1DA97-AA43-473E-8C09-E64847F1A6CE}"/>
+                <a16:creationId xmlns:a16="http://schemas.microsoft.com/office/drawing/2014/main" id="{83040BE9-1AFD-4944-8BBC-34DB0C927F5E}"/>
               </a:ext>
             </a:extLst>
           </p:cNvPr>
@@ -8920,7 +8920,7 @@
           <p:cNvPr id="4" name="">
             <a:extLst xmlns:a="http://schemas.openxmlformats.org/drawingml/2006/main">
               <a:ext uri="{FF2B5EF4-FFF2-40B4-BE49-F238E27FC236}">
-                <a16:creationId xmlns:a16="http://schemas.microsoft.com/office/drawing/2014/main" id="{4C152040-F2E9-48B2-9981-0FFC043F31CA}"/>
+                <a16:creationId xmlns:a16="http://schemas.microsoft.com/office/drawing/2014/main" id="{1602F406-A5C3-4805-8898-DAE467A2933C}"/>
               </a:ext>
             </a:extLst>
           </p:cNvPr>
@@ -8986,7 +8986,7 @@
           <p:cNvPr id="5" name="">
             <a:extLst xmlns:a="http://schemas.openxmlformats.org/drawingml/2006/main">
               <a:ext uri="{FF2B5EF4-FFF2-40B4-BE49-F238E27FC236}">
-                <a16:creationId xmlns:a16="http://schemas.microsoft.com/office/drawing/2014/main" id="{26AEF386-7BA4-4FB0-BC3E-C94611B1A316}"/>
+                <a16:creationId xmlns:a16="http://schemas.microsoft.com/office/drawing/2014/main" id="{0F9C20A6-E24D-4581-B124-B7CBD7FC4E67}"/>
               </a:ext>
             </a:extLst>
           </p:cNvPr>
@@ -9052,7 +9052,7 @@
           <p:cNvPr id="6" name="">
             <a:extLst xmlns:a="http://schemas.openxmlformats.org/drawingml/2006/main">
               <a:ext uri="{FF2B5EF4-FFF2-40B4-BE49-F238E27FC236}">
-                <a16:creationId xmlns:a16="http://schemas.microsoft.com/office/drawing/2014/main" id="{22C0E206-95BE-499B-B2A7-BE794051E46D}"/>
+                <a16:creationId xmlns:a16="http://schemas.microsoft.com/office/drawing/2014/main" id="{D7FF406E-ACB2-4BBB-B45F-88C68AD88BB7}"/>
               </a:ext>
             </a:extLst>
           </p:cNvPr>
@@ -9314,7 +9314,7 @@
           <p:cNvPr id="7" name="">
             <a:extLst xmlns:a="http://schemas.openxmlformats.org/drawingml/2006/main">
               <a:ext uri="{FF2B5EF4-FFF2-40B4-BE49-F238E27FC236}">
-                <a16:creationId xmlns:a16="http://schemas.microsoft.com/office/drawing/2014/main" id="{67C154A4-8542-4C86-B4EB-A39247A35C56}"/>
+                <a16:creationId xmlns:a16="http://schemas.microsoft.com/office/drawing/2014/main" id="{C8EF3346-783D-4946-A72A-D5EF835B649C}"/>
               </a:ext>
             </a:extLst>
           </p:cNvPr>
@@ -9370,7 +9370,7 @@
                 <a:ea typeface="Arial"/>
                 <a:cs typeface="Arial"/>
               </a:rPr>
-              <a:t>6 Java quizzes. 36 questions. Explanations after submission.</a:t>
+              <a:t>7 Java quizzes. 40 questions. Explanations after submission.</a:t>
             </a:r>
           </a:p>
         </p:txBody>
@@ -9380,7 +9380,7 @@
           <p:cNvPr id="8" name="">
             <a:extLst xmlns:a="http://schemas.openxmlformats.org/drawingml/2006/main">
               <a:ext uri="{FF2B5EF4-FFF2-40B4-BE49-F238E27FC236}">
-                <a16:creationId xmlns:a16="http://schemas.microsoft.com/office/drawing/2014/main" id="{2C0C1458-D471-4F8E-B99B-E46875826480}"/>
+                <a16:creationId xmlns:a16="http://schemas.microsoft.com/office/drawing/2014/main" id="{7F127049-02A9-4BF7-B0C5-C36ABD22557A}"/>
               </a:ext>
             </a:extLst>
           </p:cNvPr>
@@ -9446,7 +9446,7 @@
           <p:cNvPr id="9" name="">
             <a:extLst xmlns:a="http://schemas.openxmlformats.org/drawingml/2006/main">
               <a:ext uri="{FF2B5EF4-FFF2-40B4-BE49-F238E27FC236}">
-                <a16:creationId xmlns:a16="http://schemas.microsoft.com/office/drawing/2014/main" id="{28B55490-D3C1-4862-94DD-CE82743417F2}"/>
+                <a16:creationId xmlns:a16="http://schemas.microsoft.com/office/drawing/2014/main" id="{9EE821E5-2218-4F79-8DBD-E9A50AF84109}"/>
               </a:ext>
             </a:extLst>
           </p:cNvPr>
@@ -9510,7 +9510,7 @@
     </p:spTree>
     <p:extLst>
       <p:ext uri="{BB962C8B-B14F-4D97-AF65-F5344CB8AC3E}">
-        <p14:creationId xmlns:p14="http://schemas.microsoft.com/office/powerpoint/2010/main" val="10506376"/>
+        <p14:creationId xmlns:p14="http://schemas.microsoft.com/office/powerpoint/2010/main" val="184711935"/>
       </p:ext>
     </p:extLst>
   </p:cSld>
@@ -9541,7 +9541,7 @@
           <p:cNvPr id="12" name="">
             <a:extLst xmlns:a="http://schemas.openxmlformats.org/drawingml/2006/main">
               <a:ext uri="{FF2B5EF4-FFF2-40B4-BE49-F238E27FC236}">
-                <a16:creationId xmlns:a16="http://schemas.microsoft.com/office/drawing/2014/main" id="{AEC551AD-2881-4C38-AAC2-390348167CC0}"/>
+                <a16:creationId xmlns:a16="http://schemas.microsoft.com/office/drawing/2014/main" id="{EC6E5071-0317-4EA8-8398-AD30789D8D28}"/>
               </a:ext>
             </a:extLst>
           </p:cNvPr>
@@ -9607,7 +9607,7 @@
           <p:cNvPr id="2" name="">
             <a:extLst xmlns:a="http://schemas.openxmlformats.org/drawingml/2006/main">
               <a:ext uri="{FF2B5EF4-FFF2-40B4-BE49-F238E27FC236}">
-                <a16:creationId xmlns:a16="http://schemas.microsoft.com/office/drawing/2014/main" id="{5E84AB41-4C61-48C6-9930-16AABB6BE4E8}"/>
+                <a16:creationId xmlns:a16="http://schemas.microsoft.com/office/drawing/2014/main" id="{7A5CD9BF-7561-42AF-8D07-F7BB8C594B1C}"/>
               </a:ext>
             </a:extLst>
           </p:cNvPr>
@@ -9673,7 +9673,7 @@
           <p:cNvPr id="3" name="">
             <a:extLst xmlns:a="http://schemas.openxmlformats.org/drawingml/2006/main">
               <a:ext uri="{FF2B5EF4-FFF2-40B4-BE49-F238E27FC236}">
-                <a16:creationId xmlns:a16="http://schemas.microsoft.com/office/drawing/2014/main" id="{3C97D70E-CE3B-4FD8-8E8C-CD7DA14DD2A4}"/>
+                <a16:creationId xmlns:a16="http://schemas.microsoft.com/office/drawing/2014/main" id="{67E6BE8E-F843-4055-9875-F0A7E4A62226}"/>
               </a:ext>
             </a:extLst>
           </p:cNvPr>
@@ -9739,7 +9739,7 @@
           <p:cNvPr id="4" name="">
             <a:extLst xmlns:a="http://schemas.openxmlformats.org/drawingml/2006/main">
               <a:ext uri="{FF2B5EF4-FFF2-40B4-BE49-F238E27FC236}">
-                <a16:creationId xmlns:a16="http://schemas.microsoft.com/office/drawing/2014/main" id="{928FCFE4-5B30-479D-9B6A-9AAB58DDCCD5}"/>
+                <a16:creationId xmlns:a16="http://schemas.microsoft.com/office/drawing/2014/main" id="{27CADAF2-E4B6-4726-B8B7-67B6415932E0}"/>
               </a:ext>
             </a:extLst>
           </p:cNvPr>
@@ -9805,7 +9805,7 @@
           <p:cNvPr id="5" name="">
             <a:extLst xmlns:a="http://schemas.openxmlformats.org/drawingml/2006/main">
               <a:ext uri="{FF2B5EF4-FFF2-40B4-BE49-F238E27FC236}">
-                <a16:creationId xmlns:a16="http://schemas.microsoft.com/office/drawing/2014/main" id="{2A78E91A-769D-4285-94DB-C40A581B9DFB}"/>
+                <a16:creationId xmlns:a16="http://schemas.microsoft.com/office/drawing/2014/main" id="{E2D635E5-C83A-493B-8ED0-B4197E172B8F}"/>
               </a:ext>
             </a:extLst>
           </p:cNvPr>
@@ -9871,7 +9871,7 @@
           <p:cNvPr id="6" name="">
             <a:extLst xmlns:a="http://schemas.openxmlformats.org/drawingml/2006/main">
               <a:ext uri="{FF2B5EF4-FFF2-40B4-BE49-F238E27FC236}">
-                <a16:creationId xmlns:a16="http://schemas.microsoft.com/office/drawing/2014/main" id="{6D92C023-5377-47F3-9B71-B850D40FAA27}"/>
+                <a16:creationId xmlns:a16="http://schemas.microsoft.com/office/drawing/2014/main" id="{6FE47D89-81CB-4127-AE30-C32DAAE43B72}"/>
               </a:ext>
             </a:extLst>
           </p:cNvPr>
@@ -9937,7 +9937,7 @@
           <p:cNvPr id="7" name="">
             <a:extLst xmlns:a="http://schemas.openxmlformats.org/drawingml/2006/main">
               <a:ext uri="{FF2B5EF4-FFF2-40B4-BE49-F238E27FC236}">
-                <a16:creationId xmlns:a16="http://schemas.microsoft.com/office/drawing/2014/main" id="{D870EB48-AB3D-4191-A971-59E6C7326466}"/>
+                <a16:creationId xmlns:a16="http://schemas.microsoft.com/office/drawing/2014/main" id="{2D790297-EDCF-4401-930E-2DDA0407F5D6}"/>
               </a:ext>
             </a:extLst>
           </p:cNvPr>
@@ -10003,7 +10003,7 @@
           <p:cNvPr id="8" name="">
             <a:extLst xmlns:a="http://schemas.openxmlformats.org/drawingml/2006/main">
               <a:ext uri="{FF2B5EF4-FFF2-40B4-BE49-F238E27FC236}">
-                <a16:creationId xmlns:a16="http://schemas.microsoft.com/office/drawing/2014/main" id="{95D8D57E-C367-4530-B216-AC47D8AA29FA}"/>
+                <a16:creationId xmlns:a16="http://schemas.microsoft.com/office/drawing/2014/main" id="{D735733B-95F5-46B3-A645-AB2B84A5CE3F}"/>
               </a:ext>
             </a:extLst>
           </p:cNvPr>
@@ -10069,7 +10069,7 @@
           <p:cNvPr id="9" name="">
             <a:extLst xmlns:a="http://schemas.openxmlformats.org/drawingml/2006/main">
               <a:ext uri="{FF2B5EF4-FFF2-40B4-BE49-F238E27FC236}">
-                <a16:creationId xmlns:a16="http://schemas.microsoft.com/office/drawing/2014/main" id="{5B3819EB-E47B-4405-91E7-09A537252F60}"/>
+                <a16:creationId xmlns:a16="http://schemas.microsoft.com/office/drawing/2014/main" id="{72C5C215-4D23-4BC7-84CA-ECAF3E8B8833}"/>
               </a:ext>
             </a:extLst>
           </p:cNvPr>
@@ -10135,7 +10135,7 @@
           <p:cNvPr id="10" name="">
             <a:extLst xmlns:a="http://schemas.openxmlformats.org/drawingml/2006/main">
               <a:ext uri="{FF2B5EF4-FFF2-40B4-BE49-F238E27FC236}">
-                <a16:creationId xmlns:a16="http://schemas.microsoft.com/office/drawing/2014/main" id="{07780AE5-ED3E-472D-8DAD-FF7D91623D4A}"/>
+                <a16:creationId xmlns:a16="http://schemas.microsoft.com/office/drawing/2014/main" id="{07098CCE-7D3C-4F3F-9397-33666374619A}"/>
               </a:ext>
             </a:extLst>
           </p:cNvPr>
@@ -10201,7 +10201,7 @@
           <p:cNvPr id="11" name="">
             <a:extLst xmlns:a="http://schemas.openxmlformats.org/drawingml/2006/main">
               <a:ext uri="{FF2B5EF4-FFF2-40B4-BE49-F238E27FC236}">
-                <a16:creationId xmlns:a16="http://schemas.microsoft.com/office/drawing/2014/main" id="{CFADC305-0C4D-43EE-92FE-D93ECAB37158}"/>
+                <a16:creationId xmlns:a16="http://schemas.microsoft.com/office/drawing/2014/main" id="{1A065867-1FE8-4CFF-9EEE-013A7FD4BBE8}"/>
               </a:ext>
             </a:extLst>
           </p:cNvPr>
@@ -10265,7 +10265,7 @@
     </p:spTree>
     <p:extLst>
       <p:ext uri="{BB962C8B-B14F-4D97-AF65-F5344CB8AC3E}">
-        <p14:creationId xmlns:p14="http://schemas.microsoft.com/office/powerpoint/2010/main" val="325817016"/>
+        <p14:creationId xmlns:p14="http://schemas.microsoft.com/office/powerpoint/2010/main" val="365024769"/>
       </p:ext>
     </p:extLst>
   </p:cSld>
@@ -10296,7 +10296,7 @@
           <p:cNvPr id="12" name="">
             <a:extLst xmlns:a="http://schemas.openxmlformats.org/drawingml/2006/main">
               <a:ext uri="{FF2B5EF4-FFF2-40B4-BE49-F238E27FC236}">
-                <a16:creationId xmlns:a16="http://schemas.microsoft.com/office/drawing/2014/main" id="{C2E865AC-3FCE-410E-8082-75234F0A5963}"/>
+                <a16:creationId xmlns:a16="http://schemas.microsoft.com/office/drawing/2014/main" id="{9270180B-4A00-4E22-834B-A81803E7A44C}"/>
               </a:ext>
             </a:extLst>
           </p:cNvPr>
@@ -10362,7 +10362,7 @@
           <p:cNvPr id="2" name="">
             <a:extLst xmlns:a="http://schemas.openxmlformats.org/drawingml/2006/main">
               <a:ext uri="{FF2B5EF4-FFF2-40B4-BE49-F238E27FC236}">
-                <a16:creationId xmlns:a16="http://schemas.microsoft.com/office/drawing/2014/main" id="{0A109569-66EA-4234-902C-D117E90B102E}"/>
+                <a16:creationId xmlns:a16="http://schemas.microsoft.com/office/drawing/2014/main" id="{7AF68833-4ED2-4501-A1BA-32E5552574A5}"/>
               </a:ext>
             </a:extLst>
           </p:cNvPr>
@@ -10428,7 +10428,7 @@
           <p:cNvPr id="3" name="">
             <a:extLst xmlns:a="http://schemas.openxmlformats.org/drawingml/2006/main">
               <a:ext uri="{FF2B5EF4-FFF2-40B4-BE49-F238E27FC236}">
-                <a16:creationId xmlns:a16="http://schemas.microsoft.com/office/drawing/2014/main" id="{B02577D0-0A7D-47C6-B0DA-307D2E8CD391}"/>
+                <a16:creationId xmlns:a16="http://schemas.microsoft.com/office/drawing/2014/main" id="{512514B3-7E46-4E89-BDB1-3ED34D9BD5F0}"/>
               </a:ext>
             </a:extLst>
           </p:cNvPr>
@@ -10494,7 +10494,7 @@
           <p:cNvPr id="4" name="">
             <a:extLst xmlns:a="http://schemas.openxmlformats.org/drawingml/2006/main">
               <a:ext uri="{FF2B5EF4-FFF2-40B4-BE49-F238E27FC236}">
-                <a16:creationId xmlns:a16="http://schemas.microsoft.com/office/drawing/2014/main" id="{6D66DCC7-980A-4FB6-82EF-D2814B4387D0}"/>
+                <a16:creationId xmlns:a16="http://schemas.microsoft.com/office/drawing/2014/main" id="{BCE0AB4E-D14E-4A6B-A05D-77D46DD2502C}"/>
               </a:ext>
             </a:extLst>
           </p:cNvPr>
@@ -10560,7 +10560,7 @@
           <p:cNvPr id="5" name="">
             <a:extLst xmlns:a="http://schemas.openxmlformats.org/drawingml/2006/main">
               <a:ext uri="{FF2B5EF4-FFF2-40B4-BE49-F238E27FC236}">
-                <a16:creationId xmlns:a16="http://schemas.microsoft.com/office/drawing/2014/main" id="{112CAE8E-0BCE-465F-B0C2-39192EE95EB0}"/>
+                <a16:creationId xmlns:a16="http://schemas.microsoft.com/office/drawing/2014/main" id="{0D6315A8-E1F2-47D0-AD2D-EF644D6B6FB7}"/>
               </a:ext>
             </a:extLst>
           </p:cNvPr>
@@ -10626,7 +10626,7 @@
           <p:cNvPr id="6" name="">
             <a:extLst xmlns:a="http://schemas.openxmlformats.org/drawingml/2006/main">
               <a:ext uri="{FF2B5EF4-FFF2-40B4-BE49-F238E27FC236}">
-                <a16:creationId xmlns:a16="http://schemas.microsoft.com/office/drawing/2014/main" id="{7C3E2058-C0E7-4E94-8497-C811E5F5F36A}"/>
+                <a16:creationId xmlns:a16="http://schemas.microsoft.com/office/drawing/2014/main" id="{65E58F60-7973-44F1-873F-DDD2A0D88DA6}"/>
               </a:ext>
             </a:extLst>
           </p:cNvPr>
@@ -10692,7 +10692,7 @@
           <p:cNvPr id="7" name="">
             <a:extLst xmlns:a="http://schemas.openxmlformats.org/drawingml/2006/main">
               <a:ext uri="{FF2B5EF4-FFF2-40B4-BE49-F238E27FC236}">
-                <a16:creationId xmlns:a16="http://schemas.microsoft.com/office/drawing/2014/main" id="{6910DCBD-CF62-457A-8F48-81CD1F1A8B42}"/>
+                <a16:creationId xmlns:a16="http://schemas.microsoft.com/office/drawing/2014/main" id="{AC480AD2-1DA1-4ED4-AE41-42A9139FF571}"/>
               </a:ext>
             </a:extLst>
           </p:cNvPr>
@@ -10758,7 +10758,7 @@
           <p:cNvPr id="8" name="">
             <a:extLst xmlns:a="http://schemas.openxmlformats.org/drawingml/2006/main">
               <a:ext uri="{FF2B5EF4-FFF2-40B4-BE49-F238E27FC236}">
-                <a16:creationId xmlns:a16="http://schemas.microsoft.com/office/drawing/2014/main" id="{F9CC3F04-67C9-4764-AF24-BD465F9150ED}"/>
+                <a16:creationId xmlns:a16="http://schemas.microsoft.com/office/drawing/2014/main" id="{D9135368-276E-41BC-ACE0-7E668E5E8CD2}"/>
               </a:ext>
             </a:extLst>
           </p:cNvPr>
@@ -10824,7 +10824,7 @@
           <p:cNvPr id="9" name="">
             <a:extLst xmlns:a="http://schemas.openxmlformats.org/drawingml/2006/main">
               <a:ext uri="{FF2B5EF4-FFF2-40B4-BE49-F238E27FC236}">
-                <a16:creationId xmlns:a16="http://schemas.microsoft.com/office/drawing/2014/main" id="{1B3167B3-857B-451E-9E10-8AD69C897E24}"/>
+                <a16:creationId xmlns:a16="http://schemas.microsoft.com/office/drawing/2014/main" id="{77832FD1-86DA-4EC2-A775-870EB725485C}"/>
               </a:ext>
             </a:extLst>
           </p:cNvPr>
@@ -10890,7 +10890,7 @@
           <p:cNvPr id="10" name="">
             <a:extLst xmlns:a="http://schemas.openxmlformats.org/drawingml/2006/main">
               <a:ext uri="{FF2B5EF4-FFF2-40B4-BE49-F238E27FC236}">
-                <a16:creationId xmlns:a16="http://schemas.microsoft.com/office/drawing/2014/main" id="{19190C49-48BD-4983-B720-D4799A79D6F0}"/>
+                <a16:creationId xmlns:a16="http://schemas.microsoft.com/office/drawing/2014/main" id="{F4C01B57-68D9-4340-A2D7-C780C38047E8}"/>
               </a:ext>
             </a:extLst>
           </p:cNvPr>
@@ -10956,7 +10956,7 @@
           <p:cNvPr id="11" name="">
             <a:extLst xmlns:a="http://schemas.openxmlformats.org/drawingml/2006/main">
               <a:ext uri="{FF2B5EF4-FFF2-40B4-BE49-F238E27FC236}">
-                <a16:creationId xmlns:a16="http://schemas.microsoft.com/office/drawing/2014/main" id="{5152B311-3125-47BA-BC5F-5375004C8AC6}"/>
+                <a16:creationId xmlns:a16="http://schemas.microsoft.com/office/drawing/2014/main" id="{BDD87274-9D08-405F-BF3B-56EC06085815}"/>
               </a:ext>
             </a:extLst>
           </p:cNvPr>
@@ -11020,7 +11020,7 @@
     </p:spTree>
     <p:extLst>
       <p:ext uri="{BB962C8B-B14F-4D97-AF65-F5344CB8AC3E}">
-        <p14:creationId xmlns:p14="http://schemas.microsoft.com/office/powerpoint/2010/main" val="1766506006"/>
+        <p14:creationId xmlns:p14="http://schemas.microsoft.com/office/powerpoint/2010/main" val="1230952093"/>
       </p:ext>
     </p:extLst>
   </p:cSld>
@@ -11051,7 +11051,7 @@
           <p:cNvPr id="16" name="">
             <a:extLst xmlns:a="http://schemas.openxmlformats.org/drawingml/2006/main">
               <a:ext uri="{FF2B5EF4-FFF2-40B4-BE49-F238E27FC236}">
-                <a16:creationId xmlns:a16="http://schemas.microsoft.com/office/drawing/2014/main" id="{80F721A1-11FF-4597-AB10-F618CEFD2A50}"/>
+                <a16:creationId xmlns:a16="http://schemas.microsoft.com/office/drawing/2014/main" id="{EDA8F83F-A7BB-4010-9AF9-F7CF33370555}"/>
               </a:ext>
             </a:extLst>
           </p:cNvPr>
@@ -11082,7 +11082,7 @@
           <p:cNvPr id="15" name="">
             <a:extLst xmlns:a="http://schemas.openxmlformats.org/drawingml/2006/main">
               <a:ext uri="{FF2B5EF4-FFF2-40B4-BE49-F238E27FC236}">
-                <a16:creationId xmlns:a16="http://schemas.microsoft.com/office/drawing/2014/main" id="{9F73893E-71BE-4C62-A103-A78E41E341D2}"/>
+                <a16:creationId xmlns:a16="http://schemas.microsoft.com/office/drawing/2014/main" id="{7C56C25D-6C30-4042-8F5F-5F13035FC03E}"/>
               </a:ext>
             </a:extLst>
           </p:cNvPr>
@@ -11113,7 +11113,7 @@
           <p:cNvPr id="14" name="">
             <a:extLst xmlns:a="http://schemas.openxmlformats.org/drawingml/2006/main">
               <a:ext uri="{FF2B5EF4-FFF2-40B4-BE49-F238E27FC236}">
-                <a16:creationId xmlns:a16="http://schemas.microsoft.com/office/drawing/2014/main" id="{0E4244A3-9442-454C-8096-D25EEFA4104A}"/>
+                <a16:creationId xmlns:a16="http://schemas.microsoft.com/office/drawing/2014/main" id="{2056E0CC-0EA0-4FD7-9AEA-2868171BE8DF}"/>
               </a:ext>
             </a:extLst>
           </p:cNvPr>
@@ -11144,7 +11144,7 @@
           <p:cNvPr id="13" name="">
             <a:extLst xmlns:a="http://schemas.openxmlformats.org/drawingml/2006/main">
               <a:ext uri="{FF2B5EF4-FFF2-40B4-BE49-F238E27FC236}">
-                <a16:creationId xmlns:a16="http://schemas.microsoft.com/office/drawing/2014/main" id="{D47312A5-11FF-47B3-AFAF-E1F36CC2ED9B}"/>
+                <a16:creationId xmlns:a16="http://schemas.microsoft.com/office/drawing/2014/main" id="{AD7178B1-1D9A-45EC-9BA0-082768723E5D}"/>
               </a:ext>
             </a:extLst>
           </p:cNvPr>
@@ -11175,7 +11175,7 @@
           <p:cNvPr id="12" name="">
             <a:extLst xmlns:a="http://schemas.openxmlformats.org/drawingml/2006/main">
               <a:ext uri="{FF2B5EF4-FFF2-40B4-BE49-F238E27FC236}">
-                <a16:creationId xmlns:a16="http://schemas.microsoft.com/office/drawing/2014/main" id="{0067A039-F557-4028-B840-7E7D5BAB22F3}"/>
+                <a16:creationId xmlns:a16="http://schemas.microsoft.com/office/drawing/2014/main" id="{43D7F9B3-8DE9-40E8-9081-FF7F1F5FF0A1}"/>
               </a:ext>
             </a:extLst>
           </p:cNvPr>
@@ -11206,7 +11206,7 @@
           <p:cNvPr id="11" name="">
             <a:extLst xmlns:a="http://schemas.openxmlformats.org/drawingml/2006/main">
               <a:ext uri="{FF2B5EF4-FFF2-40B4-BE49-F238E27FC236}">
-                <a16:creationId xmlns:a16="http://schemas.microsoft.com/office/drawing/2014/main" id="{719A3114-2C4F-4910-BBD5-52FB178E405E}"/>
+                <a16:creationId xmlns:a16="http://schemas.microsoft.com/office/drawing/2014/main" id="{10AF5EC9-133F-4343-81BF-875CEEF07E8E}"/>
               </a:ext>
             </a:extLst>
           </p:cNvPr>
@@ -11237,7 +11237,7 @@
           <p:cNvPr id="17" name="">
             <a:extLst xmlns:a="http://schemas.openxmlformats.org/drawingml/2006/main">
               <a:ext uri="{FF2B5EF4-FFF2-40B4-BE49-F238E27FC236}">
-                <a16:creationId xmlns:a16="http://schemas.microsoft.com/office/drawing/2014/main" id="{E8B16964-1775-4845-AA01-374B5B8B5E00}"/>
+                <a16:creationId xmlns:a16="http://schemas.microsoft.com/office/drawing/2014/main" id="{AE6EAF71-01A1-487E-B2BD-2E463AC4C7CC}"/>
               </a:ext>
             </a:extLst>
           </p:cNvPr>
@@ -11303,7 +11303,7 @@
           <p:cNvPr id="2" name="">
             <a:extLst xmlns:a="http://schemas.openxmlformats.org/drawingml/2006/main">
               <a:ext uri="{FF2B5EF4-FFF2-40B4-BE49-F238E27FC236}">
-                <a16:creationId xmlns:a16="http://schemas.microsoft.com/office/drawing/2014/main" id="{AE2BAF90-892E-48B9-920E-0DFE507413CD}"/>
+                <a16:creationId xmlns:a16="http://schemas.microsoft.com/office/drawing/2014/main" id="{8678EC0C-3015-4148-AF4D-2D0C76605DAC}"/>
               </a:ext>
             </a:extLst>
           </p:cNvPr>
@@ -11369,7 +11369,7 @@
           <p:cNvPr id="3" name="">
             <a:extLst xmlns:a="http://schemas.openxmlformats.org/drawingml/2006/main">
               <a:ext uri="{FF2B5EF4-FFF2-40B4-BE49-F238E27FC236}">
-                <a16:creationId xmlns:a16="http://schemas.microsoft.com/office/drawing/2014/main" id="{E0F81296-585E-4334-81FC-335034154801}"/>
+                <a16:creationId xmlns:a16="http://schemas.microsoft.com/office/drawing/2014/main" id="{924B87FA-FC85-490E-B5E0-DF83E241ACAA}"/>
               </a:ext>
             </a:extLst>
           </p:cNvPr>
@@ -11435,7 +11435,7 @@
           <p:cNvPr id="4" name="">
             <a:extLst xmlns:a="http://schemas.openxmlformats.org/drawingml/2006/main">
               <a:ext uri="{FF2B5EF4-FFF2-40B4-BE49-F238E27FC236}">
-                <a16:creationId xmlns:a16="http://schemas.microsoft.com/office/drawing/2014/main" id="{BC20C536-EA33-4317-AC00-BFCED6305882}"/>
+                <a16:creationId xmlns:a16="http://schemas.microsoft.com/office/drawing/2014/main" id="{63AE9E1F-AF27-495B-8648-261C061F1CBB}"/>
               </a:ext>
             </a:extLst>
           </p:cNvPr>
@@ -11501,7 +11501,7 @@
           <p:cNvPr id="5" name="">
             <a:extLst xmlns:a="http://schemas.openxmlformats.org/drawingml/2006/main">
               <a:ext uri="{FF2B5EF4-FFF2-40B4-BE49-F238E27FC236}">
-                <a16:creationId xmlns:a16="http://schemas.microsoft.com/office/drawing/2014/main" id="{788B479D-5CF5-4753-A2DC-DCC13BB72DBC}"/>
+                <a16:creationId xmlns:a16="http://schemas.microsoft.com/office/drawing/2014/main" id="{6240F7E2-14C3-4D22-96CF-CF8C4690676F}"/>
               </a:ext>
             </a:extLst>
           </p:cNvPr>
@@ -11594,7 +11594,7 @@
           <p:cNvPr id="6" name="">
             <a:extLst xmlns:a="http://schemas.openxmlformats.org/drawingml/2006/main">
               <a:ext uri="{FF2B5EF4-FFF2-40B4-BE49-F238E27FC236}">
-                <a16:creationId xmlns:a16="http://schemas.microsoft.com/office/drawing/2014/main" id="{63F24696-4301-4AFB-8F8C-F04D0E16CD04}"/>
+                <a16:creationId xmlns:a16="http://schemas.microsoft.com/office/drawing/2014/main" id="{05CD6C05-5346-4830-B964-82BD385C4BF3}"/>
               </a:ext>
             </a:extLst>
           </p:cNvPr>
@@ -11687,7 +11687,7 @@
           <p:cNvPr id="7" name="">
             <a:extLst xmlns:a="http://schemas.openxmlformats.org/drawingml/2006/main">
               <a:ext uri="{FF2B5EF4-FFF2-40B4-BE49-F238E27FC236}">
-                <a16:creationId xmlns:a16="http://schemas.microsoft.com/office/drawing/2014/main" id="{D40DB827-23D8-4D15-A749-45E7F0570D5D}"/>
+                <a16:creationId xmlns:a16="http://schemas.microsoft.com/office/drawing/2014/main" id="{BD846E7F-A62C-4CA4-9E57-83969A046644}"/>
               </a:ext>
             </a:extLst>
           </p:cNvPr>
@@ -11780,7 +11780,7 @@
           <p:cNvPr id="8" name="">
             <a:extLst xmlns:a="http://schemas.openxmlformats.org/drawingml/2006/main">
               <a:ext uri="{FF2B5EF4-FFF2-40B4-BE49-F238E27FC236}">
-                <a16:creationId xmlns:a16="http://schemas.microsoft.com/office/drawing/2014/main" id="{2C29F740-F120-4281-9BBB-800924F1BDA1}"/>
+                <a16:creationId xmlns:a16="http://schemas.microsoft.com/office/drawing/2014/main" id="{404BBA03-3762-4332-8D6F-5108760B83A7}"/>
               </a:ext>
             </a:extLst>
           </p:cNvPr>
@@ -11873,7 +11873,7 @@
           <p:cNvPr id="9" name="">
             <a:extLst xmlns:a="http://schemas.openxmlformats.org/drawingml/2006/main">
               <a:ext uri="{FF2B5EF4-FFF2-40B4-BE49-F238E27FC236}">
-                <a16:creationId xmlns:a16="http://schemas.microsoft.com/office/drawing/2014/main" id="{311F13DD-CF70-4D9F-9C44-5779FD967DA8}"/>
+                <a16:creationId xmlns:a16="http://schemas.microsoft.com/office/drawing/2014/main" id="{7450F11E-37D4-437D-B317-61859B6859A3}"/>
               </a:ext>
             </a:extLst>
           </p:cNvPr>
@@ -11966,7 +11966,7 @@
           <p:cNvPr id="10" name="">
             <a:extLst xmlns:a="http://schemas.openxmlformats.org/drawingml/2006/main">
               <a:ext uri="{FF2B5EF4-FFF2-40B4-BE49-F238E27FC236}">
-                <a16:creationId xmlns:a16="http://schemas.microsoft.com/office/drawing/2014/main" id="{5B3FCF66-2E21-4658-AC2E-9AB1474583B7}"/>
+                <a16:creationId xmlns:a16="http://schemas.microsoft.com/office/drawing/2014/main" id="{F8407EE4-BD10-45FE-AE87-CF84971064DD}"/>
               </a:ext>
             </a:extLst>
           </p:cNvPr>
@@ -12057,7 +12057,7 @@
     </p:spTree>
     <p:extLst>
       <p:ext uri="{BB962C8B-B14F-4D97-AF65-F5344CB8AC3E}">
-        <p14:creationId xmlns:p14="http://schemas.microsoft.com/office/powerpoint/2010/main" val="1114459224"/>
+        <p14:creationId xmlns:p14="http://schemas.microsoft.com/office/powerpoint/2010/main" val="1603686885"/>
       </p:ext>
     </p:extLst>
   </p:cSld>
@@ -12088,7 +12088,7 @@
           <p:cNvPr id="19" name="">
             <a:extLst xmlns:a="http://schemas.openxmlformats.org/drawingml/2006/main">
               <a:ext uri="{FF2B5EF4-FFF2-40B4-BE49-F238E27FC236}">
-                <a16:creationId xmlns:a16="http://schemas.microsoft.com/office/drawing/2014/main" id="{44242CBE-7326-4801-A2B3-A29C2E6B9F42}"/>
+                <a16:creationId xmlns:a16="http://schemas.microsoft.com/office/drawing/2014/main" id="{23BD1C30-A3AB-493A-A4E8-1E97029B126C}"/>
               </a:ext>
             </a:extLst>
           </p:cNvPr>
@@ -12119,7 +12119,7 @@
           <p:cNvPr id="18" name="">
             <a:extLst xmlns:a="http://schemas.openxmlformats.org/drawingml/2006/main">
               <a:ext uri="{FF2B5EF4-FFF2-40B4-BE49-F238E27FC236}">
-                <a16:creationId xmlns:a16="http://schemas.microsoft.com/office/drawing/2014/main" id="{E72DA74A-2BB6-482F-A7EB-E6D0C8D7575A}"/>
+                <a16:creationId xmlns:a16="http://schemas.microsoft.com/office/drawing/2014/main" id="{367BBE94-CCCE-492A-B89F-ACB2B520D3BB}"/>
               </a:ext>
             </a:extLst>
           </p:cNvPr>
@@ -12150,7 +12150,7 @@
           <p:cNvPr id="17" name="">
             <a:extLst xmlns:a="http://schemas.openxmlformats.org/drawingml/2006/main">
               <a:ext uri="{FF2B5EF4-FFF2-40B4-BE49-F238E27FC236}">
-                <a16:creationId xmlns:a16="http://schemas.microsoft.com/office/drawing/2014/main" id="{3CA73431-29B8-4993-8B56-A073E261E951}"/>
+                <a16:creationId xmlns:a16="http://schemas.microsoft.com/office/drawing/2014/main" id="{3B2E0EE0-4DF7-4C26-8037-8803FB7045B6}"/>
               </a:ext>
             </a:extLst>
           </p:cNvPr>
@@ -12181,7 +12181,7 @@
           <p:cNvPr id="16" name="">
             <a:extLst xmlns:a="http://schemas.openxmlformats.org/drawingml/2006/main">
               <a:ext uri="{FF2B5EF4-FFF2-40B4-BE49-F238E27FC236}">
-                <a16:creationId xmlns:a16="http://schemas.microsoft.com/office/drawing/2014/main" id="{4EDF44FE-4D17-458B-9F48-20FC5F535179}"/>
+                <a16:creationId xmlns:a16="http://schemas.microsoft.com/office/drawing/2014/main" id="{80C6A629-C1F6-434A-A030-6E301AF7FDEF}"/>
               </a:ext>
             </a:extLst>
           </p:cNvPr>
@@ -12212,7 +12212,7 @@
           <p:cNvPr id="15" name="">
             <a:extLst xmlns:a="http://schemas.openxmlformats.org/drawingml/2006/main">
               <a:ext uri="{FF2B5EF4-FFF2-40B4-BE49-F238E27FC236}">
-                <a16:creationId xmlns:a16="http://schemas.microsoft.com/office/drawing/2014/main" id="{7F38DAD2-A2D7-4A65-8C1A-E88C0855702E}"/>
+                <a16:creationId xmlns:a16="http://schemas.microsoft.com/office/drawing/2014/main" id="{955AB6B4-3FDD-4A80-BAA2-B7A76F56BF7C}"/>
               </a:ext>
             </a:extLst>
           </p:cNvPr>
@@ -12243,7 +12243,7 @@
           <p:cNvPr id="14" name="">
             <a:extLst xmlns:a="http://schemas.openxmlformats.org/drawingml/2006/main">
               <a:ext uri="{FF2B5EF4-FFF2-40B4-BE49-F238E27FC236}">
-                <a16:creationId xmlns:a16="http://schemas.microsoft.com/office/drawing/2014/main" id="{28A6BC55-80B9-42FE-A31F-240FD39489E7}"/>
+                <a16:creationId xmlns:a16="http://schemas.microsoft.com/office/drawing/2014/main" id="{3F0FBEFF-2AE0-4AE2-943E-48C8A1AB259E}"/>
               </a:ext>
             </a:extLst>
           </p:cNvPr>
@@ -12274,7 +12274,7 @@
           <p:cNvPr id="13" name="">
             <a:extLst xmlns:a="http://schemas.openxmlformats.org/drawingml/2006/main">
               <a:ext uri="{FF2B5EF4-FFF2-40B4-BE49-F238E27FC236}">
-                <a16:creationId xmlns:a16="http://schemas.microsoft.com/office/drawing/2014/main" id="{212CCED9-15AF-47B8-9355-DE160E635E0C}"/>
+                <a16:creationId xmlns:a16="http://schemas.microsoft.com/office/drawing/2014/main" id="{ADF3DB21-C6EA-4246-99A9-7E66C9C073FB}"/>
               </a:ext>
             </a:extLst>
           </p:cNvPr>
@@ -12305,7 +12305,7 @@
           <p:cNvPr id="21" name="">
             <a:extLst xmlns:a="http://schemas.openxmlformats.org/drawingml/2006/main">
               <a:ext uri="{FF2B5EF4-FFF2-40B4-BE49-F238E27FC236}">
-                <a16:creationId xmlns:a16="http://schemas.microsoft.com/office/drawing/2014/main" id="{1CBA6BF6-FB0A-47A7-B097-D3559E1A28E4}"/>
+                <a16:creationId xmlns:a16="http://schemas.microsoft.com/office/drawing/2014/main" id="{A07F9CE6-9F89-4471-A785-DBDDF04008D3}"/>
               </a:ext>
             </a:extLst>
           </p:cNvPr>
@@ -12371,7 +12371,7 @@
           <p:cNvPr id="2" name="">
             <a:extLst xmlns:a="http://schemas.openxmlformats.org/drawingml/2006/main">
               <a:ext uri="{FF2B5EF4-FFF2-40B4-BE49-F238E27FC236}">
-                <a16:creationId xmlns:a16="http://schemas.microsoft.com/office/drawing/2014/main" id="{8F339478-6985-4B1E-901C-AFD5D46B6364}"/>
+                <a16:creationId xmlns:a16="http://schemas.microsoft.com/office/drawing/2014/main" id="{186D25BD-13C5-4F3A-9E1A-B8813C07116F}"/>
               </a:ext>
             </a:extLst>
           </p:cNvPr>
@@ -12437,7 +12437,7 @@
           <p:cNvPr id="3" name="">
             <a:extLst xmlns:a="http://schemas.openxmlformats.org/drawingml/2006/main">
               <a:ext uri="{FF2B5EF4-FFF2-40B4-BE49-F238E27FC236}">
-                <a16:creationId xmlns:a16="http://schemas.microsoft.com/office/drawing/2014/main" id="{9C3D75A5-17AC-441A-B829-384013508C32}"/>
+                <a16:creationId xmlns:a16="http://schemas.microsoft.com/office/drawing/2014/main" id="{61C12719-561D-4908-996C-2FCF20C1425E}"/>
               </a:ext>
             </a:extLst>
           </p:cNvPr>
@@ -12503,7 +12503,7 @@
           <p:cNvPr id="4" name="">
             <a:extLst xmlns:a="http://schemas.openxmlformats.org/drawingml/2006/main">
               <a:ext uri="{FF2B5EF4-FFF2-40B4-BE49-F238E27FC236}">
-                <a16:creationId xmlns:a16="http://schemas.microsoft.com/office/drawing/2014/main" id="{AA0DE37A-93A8-4285-BA66-8A4B913B2EC4}"/>
+                <a16:creationId xmlns:a16="http://schemas.microsoft.com/office/drawing/2014/main" id="{F1FEC627-E441-4F85-89CD-6F415BFB7CC9}"/>
               </a:ext>
             </a:extLst>
           </p:cNvPr>
@@ -12569,7 +12569,7 @@
           <p:cNvPr id="5" name="">
             <a:extLst xmlns:a="http://schemas.openxmlformats.org/drawingml/2006/main">
               <a:ext uri="{FF2B5EF4-FFF2-40B4-BE49-F238E27FC236}">
-                <a16:creationId xmlns:a16="http://schemas.microsoft.com/office/drawing/2014/main" id="{99CF63E1-D639-450C-A446-A1A43F895C1D}"/>
+                <a16:creationId xmlns:a16="http://schemas.microsoft.com/office/drawing/2014/main" id="{EDE984E0-FB7B-42D1-A04A-C70DE1A90486}"/>
               </a:ext>
             </a:extLst>
           </p:cNvPr>
@@ -12662,7 +12662,7 @@
           <p:cNvPr id="6" name="">
             <a:extLst xmlns:a="http://schemas.openxmlformats.org/drawingml/2006/main">
               <a:ext uri="{FF2B5EF4-FFF2-40B4-BE49-F238E27FC236}">
-                <a16:creationId xmlns:a16="http://schemas.microsoft.com/office/drawing/2014/main" id="{92479422-2CFF-4E6B-BE61-1D8EE3673632}"/>
+                <a16:creationId xmlns:a16="http://schemas.microsoft.com/office/drawing/2014/main" id="{723C2AD1-7743-4148-AB98-DB5CE36E1211}"/>
               </a:ext>
             </a:extLst>
           </p:cNvPr>
@@ -12755,7 +12755,7 @@
           <p:cNvPr id="7" name="">
             <a:extLst xmlns:a="http://schemas.openxmlformats.org/drawingml/2006/main">
               <a:ext uri="{FF2B5EF4-FFF2-40B4-BE49-F238E27FC236}">
-                <a16:creationId xmlns:a16="http://schemas.microsoft.com/office/drawing/2014/main" id="{46F0818A-9642-4DB3-B8A5-942EAD08EE89}"/>
+                <a16:creationId xmlns:a16="http://schemas.microsoft.com/office/drawing/2014/main" id="{AB3B8D84-A869-41DD-B5C8-50E31733C770}"/>
               </a:ext>
             </a:extLst>
           </p:cNvPr>
@@ -12848,7 +12848,7 @@
           <p:cNvPr id="8" name="">
             <a:extLst xmlns:a="http://schemas.openxmlformats.org/drawingml/2006/main">
               <a:ext uri="{FF2B5EF4-FFF2-40B4-BE49-F238E27FC236}">
-                <a16:creationId xmlns:a16="http://schemas.microsoft.com/office/drawing/2014/main" id="{2A67063E-C063-413F-941D-542EA4E5CF93}"/>
+                <a16:creationId xmlns:a16="http://schemas.microsoft.com/office/drawing/2014/main" id="{82C8B35A-2F43-4982-A11E-754B62F00517}"/>
               </a:ext>
             </a:extLst>
           </p:cNvPr>
@@ -12941,7 +12941,7 @@
           <p:cNvPr id="9" name="">
             <a:extLst xmlns:a="http://schemas.openxmlformats.org/drawingml/2006/main">
               <a:ext uri="{FF2B5EF4-FFF2-40B4-BE49-F238E27FC236}">
-                <a16:creationId xmlns:a16="http://schemas.microsoft.com/office/drawing/2014/main" id="{14410A97-8B83-482A-9AEB-5EBFB9F270AB}"/>
+                <a16:creationId xmlns:a16="http://schemas.microsoft.com/office/drawing/2014/main" id="{CFA9550D-C8C9-41E0-97E8-FE75DFBEF9AA}"/>
               </a:ext>
             </a:extLst>
           </p:cNvPr>
@@ -13034,7 +13034,7 @@
           <p:cNvPr id="10" name="">
             <a:extLst xmlns:a="http://schemas.openxmlformats.org/drawingml/2006/main">
               <a:ext uri="{FF2B5EF4-FFF2-40B4-BE49-F238E27FC236}">
-                <a16:creationId xmlns:a16="http://schemas.microsoft.com/office/drawing/2014/main" id="{9169F02E-B703-43B7-B2DB-A9F022164C43}"/>
+                <a16:creationId xmlns:a16="http://schemas.microsoft.com/office/drawing/2014/main" id="{C61B62DC-1221-486C-B997-10CBE720AC94}"/>
               </a:ext>
             </a:extLst>
           </p:cNvPr>
@@ -13127,7 +13127,7 @@
           <p:cNvPr id="11" name="">
             <a:extLst xmlns:a="http://schemas.openxmlformats.org/drawingml/2006/main">
               <a:ext uri="{FF2B5EF4-FFF2-40B4-BE49-F238E27FC236}">
-                <a16:creationId xmlns:a16="http://schemas.microsoft.com/office/drawing/2014/main" id="{7ED12FB9-7C58-424D-B229-CB79FDBBB34A}"/>
+                <a16:creationId xmlns:a16="http://schemas.microsoft.com/office/drawing/2014/main" id="{3682FEC9-106C-47BE-A8A6-13D2148ABB34}"/>
               </a:ext>
             </a:extLst>
           </p:cNvPr>
@@ -13220,7 +13220,7 @@
           <p:cNvPr id="12" name="">
             <a:extLst xmlns:a="http://schemas.openxmlformats.org/drawingml/2006/main">
               <a:ext uri="{FF2B5EF4-FFF2-40B4-BE49-F238E27FC236}">
-                <a16:creationId xmlns:a16="http://schemas.microsoft.com/office/drawing/2014/main" id="{02E1ECE3-4421-4E9E-834B-E9C0D1A1007B}"/>
+                <a16:creationId xmlns:a16="http://schemas.microsoft.com/office/drawing/2014/main" id="{3814DED6-E7DB-42AD-A9A9-5284323E2FF5}"/>
               </a:ext>
             </a:extLst>
           </p:cNvPr>
@@ -13313,7 +13313,7 @@
           <p:cNvPr id="20" name="">
             <a:extLst xmlns:a="http://schemas.openxmlformats.org/drawingml/2006/main">
               <a:ext uri="{FF2B5EF4-FFF2-40B4-BE49-F238E27FC236}">
-                <a16:creationId xmlns:a16="http://schemas.microsoft.com/office/drawing/2014/main" id="{1FE35F1F-292D-4038-8940-69C49B0FF5FA}"/>
+                <a16:creationId xmlns:a16="http://schemas.microsoft.com/office/drawing/2014/main" id="{186FE829-D45A-47AE-BA1A-582FA7A9FD5E}"/>
               </a:ext>
             </a:extLst>
           </p:cNvPr>
@@ -13377,7 +13377,7 @@
     </p:spTree>
     <p:extLst>
       <p:ext uri="{BB962C8B-B14F-4D97-AF65-F5344CB8AC3E}">
-        <p14:creationId xmlns:p14="http://schemas.microsoft.com/office/powerpoint/2010/main" val="487489900"/>
+        <p14:creationId xmlns:p14="http://schemas.microsoft.com/office/powerpoint/2010/main" val="1617379564"/>
       </p:ext>
     </p:extLst>
   </p:cSld>
@@ -13408,7 +13408,7 @@
           <p:cNvPr id="11" name="">
             <a:extLst xmlns:a="http://schemas.openxmlformats.org/drawingml/2006/main">
               <a:ext uri="{FF2B5EF4-FFF2-40B4-BE49-F238E27FC236}">
-                <a16:creationId xmlns:a16="http://schemas.microsoft.com/office/drawing/2014/main" id="{1A633E49-BB1C-4597-A377-A40A099EE3D5}"/>
+                <a16:creationId xmlns:a16="http://schemas.microsoft.com/office/drawing/2014/main" id="{A5E8F535-3ACC-4ABC-BFE5-FF6FFAAF3895}"/>
               </a:ext>
             </a:extLst>
           </p:cNvPr>
@@ -13474,7 +13474,7 @@
           <p:cNvPr id="2" name="">
             <a:extLst xmlns:a="http://schemas.openxmlformats.org/drawingml/2006/main">
               <a:ext uri="{FF2B5EF4-FFF2-40B4-BE49-F238E27FC236}">
-                <a16:creationId xmlns:a16="http://schemas.microsoft.com/office/drawing/2014/main" id="{545A243C-8338-445B-BB33-1A2BC760D5B1}"/>
+                <a16:creationId xmlns:a16="http://schemas.microsoft.com/office/drawing/2014/main" id="{80604FCF-031D-4759-8BF4-D1B23049A08A}"/>
               </a:ext>
             </a:extLst>
           </p:cNvPr>
@@ -13540,7 +13540,7 @@
           <p:cNvPr id="3" name="">
             <a:extLst xmlns:a="http://schemas.openxmlformats.org/drawingml/2006/main">
               <a:ext uri="{FF2B5EF4-FFF2-40B4-BE49-F238E27FC236}">
-                <a16:creationId xmlns:a16="http://schemas.microsoft.com/office/drawing/2014/main" id="{1C62AACA-9444-475E-B375-0FAFD5D7D0B5}"/>
+                <a16:creationId xmlns:a16="http://schemas.microsoft.com/office/drawing/2014/main" id="{69A9FE81-8502-4142-9CE7-9FA8AE874DF8}"/>
               </a:ext>
             </a:extLst>
           </p:cNvPr>
@@ -13606,7 +13606,7 @@
           <p:cNvPr id="4" name="">
             <a:extLst xmlns:a="http://schemas.openxmlformats.org/drawingml/2006/main">
               <a:ext uri="{FF2B5EF4-FFF2-40B4-BE49-F238E27FC236}">
-                <a16:creationId xmlns:a16="http://schemas.microsoft.com/office/drawing/2014/main" id="{8AE9802D-6221-4B2A-BA19-9E071EEBC7EA}"/>
+                <a16:creationId xmlns:a16="http://schemas.microsoft.com/office/drawing/2014/main" id="{4B204C47-F7F6-43C1-AC6B-FF24B8DB9AE7}"/>
               </a:ext>
             </a:extLst>
           </p:cNvPr>
@@ -13672,7 +13672,7 @@
           <p:cNvPr id="5" name="">
             <a:extLst xmlns:a="http://schemas.openxmlformats.org/drawingml/2006/main">
               <a:ext uri="{FF2B5EF4-FFF2-40B4-BE49-F238E27FC236}">
-                <a16:creationId xmlns:a16="http://schemas.microsoft.com/office/drawing/2014/main" id="{03FA6A14-85CC-4881-86A8-3FDAF687B868}"/>
+                <a16:creationId xmlns:a16="http://schemas.microsoft.com/office/drawing/2014/main" id="{629F26AD-981F-46EF-BDBA-7E9526C20C16}"/>
               </a:ext>
             </a:extLst>
           </p:cNvPr>
@@ -13738,7 +13738,7 @@
           <p:cNvPr id="6" name="">
             <a:extLst xmlns:a="http://schemas.openxmlformats.org/drawingml/2006/main">
               <a:ext uri="{FF2B5EF4-FFF2-40B4-BE49-F238E27FC236}">
-                <a16:creationId xmlns:a16="http://schemas.microsoft.com/office/drawing/2014/main" id="{67C44D0D-DF77-4336-9AC6-114D98CE8CA5}"/>
+                <a16:creationId xmlns:a16="http://schemas.microsoft.com/office/drawing/2014/main" id="{93B0EAE9-EC53-4D1D-B039-AE253F4702A9}"/>
               </a:ext>
             </a:extLst>
           </p:cNvPr>
@@ -13855,7 +13855,7 @@
           <p:cNvPr id="7" name="">
             <a:extLst xmlns:a="http://schemas.openxmlformats.org/drawingml/2006/main">
               <a:ext uri="{FF2B5EF4-FFF2-40B4-BE49-F238E27FC236}">
-                <a16:creationId xmlns:a16="http://schemas.microsoft.com/office/drawing/2014/main" id="{458AAAFD-B05C-45DF-BBC9-B29BB0720124}"/>
+                <a16:creationId xmlns:a16="http://schemas.microsoft.com/office/drawing/2014/main" id="{4A982B26-798C-4ABB-86AC-0D747201DE51}"/>
               </a:ext>
             </a:extLst>
           </p:cNvPr>
@@ -13921,7 +13921,7 @@
           <p:cNvPr id="8" name="">
             <a:extLst xmlns:a="http://schemas.openxmlformats.org/drawingml/2006/main">
               <a:ext uri="{FF2B5EF4-FFF2-40B4-BE49-F238E27FC236}">
-                <a16:creationId xmlns:a16="http://schemas.microsoft.com/office/drawing/2014/main" id="{01DABFFD-216F-4ABA-989C-474A8A7A8204}"/>
+                <a16:creationId xmlns:a16="http://schemas.microsoft.com/office/drawing/2014/main" id="{713146E9-6603-4582-AACC-F5FD7C71FA3E}"/>
               </a:ext>
             </a:extLst>
           </p:cNvPr>
@@ -13987,7 +13987,7 @@
           <p:cNvPr id="9" name="">
             <a:extLst xmlns:a="http://schemas.openxmlformats.org/drawingml/2006/main">
               <a:ext uri="{FF2B5EF4-FFF2-40B4-BE49-F238E27FC236}">
-                <a16:creationId xmlns:a16="http://schemas.microsoft.com/office/drawing/2014/main" id="{F46A0200-8E35-467F-B7EB-603FA4AEF2CA}"/>
+                <a16:creationId xmlns:a16="http://schemas.microsoft.com/office/drawing/2014/main" id="{43454F06-18F3-4902-8194-220BF487C639}"/>
               </a:ext>
             </a:extLst>
           </p:cNvPr>
@@ -14053,7 +14053,7 @@
           <p:cNvPr id="10" name="">
             <a:extLst xmlns:a="http://schemas.openxmlformats.org/drawingml/2006/main">
               <a:ext uri="{FF2B5EF4-FFF2-40B4-BE49-F238E27FC236}">
-                <a16:creationId xmlns:a16="http://schemas.microsoft.com/office/drawing/2014/main" id="{0FF5255D-FB70-4E62-8463-AA5F826CDB39}"/>
+                <a16:creationId xmlns:a16="http://schemas.microsoft.com/office/drawing/2014/main" id="{8DD8CE54-AEED-49A9-A02B-A9F7A7E5F6C8}"/>
               </a:ext>
             </a:extLst>
           </p:cNvPr>
@@ -14117,7 +14117,7 @@
     </p:spTree>
     <p:extLst>
       <p:ext uri="{BB962C8B-B14F-4D97-AF65-F5344CB8AC3E}">
-        <p14:creationId xmlns:p14="http://schemas.microsoft.com/office/powerpoint/2010/main" val="75421878"/>
+        <p14:creationId xmlns:p14="http://schemas.microsoft.com/office/powerpoint/2010/main" val="708292139"/>
       </p:ext>
     </p:extLst>
   </p:cSld>
@@ -14148,7 +14148,7 @@
           <p:cNvPr id="13" name="">
             <a:extLst xmlns:a="http://schemas.openxmlformats.org/drawingml/2006/main">
               <a:ext uri="{FF2B5EF4-FFF2-40B4-BE49-F238E27FC236}">
-                <a16:creationId xmlns:a16="http://schemas.microsoft.com/office/drawing/2014/main" id="{19610592-3F49-4B20-8C15-39123347A194}"/>
+                <a16:creationId xmlns:a16="http://schemas.microsoft.com/office/drawing/2014/main" id="{35E082B2-463F-4BF0-B7BA-C94DCA39C054}"/>
               </a:ext>
             </a:extLst>
           </p:cNvPr>
@@ -14214,7 +14214,7 @@
           <p:cNvPr id="2" name="">
             <a:extLst xmlns:a="http://schemas.openxmlformats.org/drawingml/2006/main">
               <a:ext uri="{FF2B5EF4-FFF2-40B4-BE49-F238E27FC236}">
-                <a16:creationId xmlns:a16="http://schemas.microsoft.com/office/drawing/2014/main" id="{82A242E2-00CF-4366-8BA0-6EEAB5A319B8}"/>
+                <a16:creationId xmlns:a16="http://schemas.microsoft.com/office/drawing/2014/main" id="{8A9FA362-FDE9-42D4-9FDC-636DA9AB80A5}"/>
               </a:ext>
             </a:extLst>
           </p:cNvPr>
@@ -14280,7 +14280,7 @@
           <p:cNvPr id="3" name="">
             <a:extLst xmlns:a="http://schemas.openxmlformats.org/drawingml/2006/main">
               <a:ext uri="{FF2B5EF4-FFF2-40B4-BE49-F238E27FC236}">
-                <a16:creationId xmlns:a16="http://schemas.microsoft.com/office/drawing/2014/main" id="{A5BE053E-4F34-4CF2-BF38-D2D644A029C9}"/>
+                <a16:creationId xmlns:a16="http://schemas.microsoft.com/office/drawing/2014/main" id="{01EFAB66-5D09-44E4-BF09-2067CC82E4AA}"/>
               </a:ext>
             </a:extLst>
           </p:cNvPr>
@@ -14346,7 +14346,7 @@
           <p:cNvPr id="4" name="">
             <a:extLst xmlns:a="http://schemas.openxmlformats.org/drawingml/2006/main">
               <a:ext uri="{FF2B5EF4-FFF2-40B4-BE49-F238E27FC236}">
-                <a16:creationId xmlns:a16="http://schemas.microsoft.com/office/drawing/2014/main" id="{40BCB76B-B54C-4536-A54F-8615CCF47906}"/>
+                <a16:creationId xmlns:a16="http://schemas.microsoft.com/office/drawing/2014/main" id="{57C9565B-5307-463F-B7DC-4112FC1BE634}"/>
               </a:ext>
             </a:extLst>
           </p:cNvPr>
@@ -14412,7 +14412,7 @@
           <p:cNvPr id="5" name="">
             <a:extLst xmlns:a="http://schemas.openxmlformats.org/drawingml/2006/main">
               <a:ext uri="{FF2B5EF4-FFF2-40B4-BE49-F238E27FC236}">
-                <a16:creationId xmlns:a16="http://schemas.microsoft.com/office/drawing/2014/main" id="{7B90F87C-1F2B-46DE-B1CA-A091DDFFF098}"/>
+                <a16:creationId xmlns:a16="http://schemas.microsoft.com/office/drawing/2014/main" id="{49C3500F-5A96-41EA-9DE1-DDB5C5E4F929}"/>
               </a:ext>
             </a:extLst>
           </p:cNvPr>
@@ -14478,7 +14478,7 @@
           <p:cNvPr id="6" name="">
             <a:extLst xmlns:a="http://schemas.openxmlformats.org/drawingml/2006/main">
               <a:ext uri="{FF2B5EF4-FFF2-40B4-BE49-F238E27FC236}">
-                <a16:creationId xmlns:a16="http://schemas.microsoft.com/office/drawing/2014/main" id="{DC7CDF5B-E08E-4C0E-98E6-7F1A44451B50}"/>
+                <a16:creationId xmlns:a16="http://schemas.microsoft.com/office/drawing/2014/main" id="{5D4AD5BF-6938-4288-A490-9DB7AD67BCEA}"/>
               </a:ext>
             </a:extLst>
           </p:cNvPr>
@@ -14544,7 +14544,7 @@
           <p:cNvPr id="7" name="">
             <a:extLst xmlns:a="http://schemas.openxmlformats.org/drawingml/2006/main">
               <a:ext uri="{FF2B5EF4-FFF2-40B4-BE49-F238E27FC236}">
-                <a16:creationId xmlns:a16="http://schemas.microsoft.com/office/drawing/2014/main" id="{0427982F-A1C3-4851-B227-A396BD1F6D43}"/>
+                <a16:creationId xmlns:a16="http://schemas.microsoft.com/office/drawing/2014/main" id="{320FDA78-0607-43BE-A0EC-7D580F2E3BD4}"/>
               </a:ext>
             </a:extLst>
           </p:cNvPr>
@@ -14610,7 +14610,7 @@
           <p:cNvPr id="8" name="">
             <a:extLst xmlns:a="http://schemas.openxmlformats.org/drawingml/2006/main">
               <a:ext uri="{FF2B5EF4-FFF2-40B4-BE49-F238E27FC236}">
-                <a16:creationId xmlns:a16="http://schemas.microsoft.com/office/drawing/2014/main" id="{4B58E2BA-3C3C-47F4-A505-88E5629D594C}"/>
+                <a16:creationId xmlns:a16="http://schemas.microsoft.com/office/drawing/2014/main" id="{3EC0F777-E270-4FF9-B33A-2681DE620D1C}"/>
               </a:ext>
             </a:extLst>
           </p:cNvPr>
@@ -14676,7 +14676,7 @@
           <p:cNvPr id="9" name="">
             <a:extLst xmlns:a="http://schemas.openxmlformats.org/drawingml/2006/main">
               <a:ext uri="{FF2B5EF4-FFF2-40B4-BE49-F238E27FC236}">
-                <a16:creationId xmlns:a16="http://schemas.microsoft.com/office/drawing/2014/main" id="{89736A82-B97F-4B57-88DC-59BDD99F671E}"/>
+                <a16:creationId xmlns:a16="http://schemas.microsoft.com/office/drawing/2014/main" id="{6C8D7FA6-8FFF-44E0-9540-E7867ECAA78B}"/>
               </a:ext>
             </a:extLst>
           </p:cNvPr>
@@ -14742,7 +14742,7 @@
           <p:cNvPr id="10" name="">
             <a:extLst xmlns:a="http://schemas.openxmlformats.org/drawingml/2006/main">
               <a:ext uri="{FF2B5EF4-FFF2-40B4-BE49-F238E27FC236}">
-                <a16:creationId xmlns:a16="http://schemas.microsoft.com/office/drawing/2014/main" id="{25D443FB-C770-4C77-8301-7FD0DA834BB5}"/>
+                <a16:creationId xmlns:a16="http://schemas.microsoft.com/office/drawing/2014/main" id="{E93F21C2-A162-4DB9-9B38-16C80FC5B485}"/>
               </a:ext>
             </a:extLst>
           </p:cNvPr>
@@ -14808,7 +14808,7 @@
           <p:cNvPr id="11" name="">
             <a:extLst xmlns:a="http://schemas.openxmlformats.org/drawingml/2006/main">
               <a:ext uri="{FF2B5EF4-FFF2-40B4-BE49-F238E27FC236}">
-                <a16:creationId xmlns:a16="http://schemas.microsoft.com/office/drawing/2014/main" id="{587CAF8C-2199-4ABD-8C0A-D7C0ADFA91E3}"/>
+                <a16:creationId xmlns:a16="http://schemas.microsoft.com/office/drawing/2014/main" id="{B6F289D1-757E-4279-98BE-1A828671EC6D}"/>
               </a:ext>
             </a:extLst>
           </p:cNvPr>
@@ -14874,7 +14874,7 @@
           <p:cNvPr id="12" name="">
             <a:extLst xmlns:a="http://schemas.openxmlformats.org/drawingml/2006/main">
               <a:ext uri="{FF2B5EF4-FFF2-40B4-BE49-F238E27FC236}">
-                <a16:creationId xmlns:a16="http://schemas.microsoft.com/office/drawing/2014/main" id="{2B4B1852-B4F2-4B7B-9984-3720D90074A7}"/>
+                <a16:creationId xmlns:a16="http://schemas.microsoft.com/office/drawing/2014/main" id="{FC2912BD-6709-459B-B342-08D3199382A0}"/>
               </a:ext>
             </a:extLst>
           </p:cNvPr>
@@ -14938,7 +14938,7 @@
     </p:spTree>
     <p:extLst>
       <p:ext uri="{BB962C8B-B14F-4D97-AF65-F5344CB8AC3E}">
-        <p14:creationId xmlns:p14="http://schemas.microsoft.com/office/powerpoint/2010/main" val="39742006"/>
+        <p14:creationId xmlns:p14="http://schemas.microsoft.com/office/powerpoint/2010/main" val="1323477768"/>
       </p:ext>
     </p:extLst>
   </p:cSld>
@@ -14969,7 +14969,7 @@
           <p:cNvPr id="8" name="">
             <a:extLst xmlns:a="http://schemas.openxmlformats.org/drawingml/2006/main">
               <a:ext uri="{FF2B5EF4-FFF2-40B4-BE49-F238E27FC236}">
-                <a16:creationId xmlns:a16="http://schemas.microsoft.com/office/drawing/2014/main" id="{FE701AB6-DB75-4002-98EA-2A6DF91630CE}"/>
+                <a16:creationId xmlns:a16="http://schemas.microsoft.com/office/drawing/2014/main" id="{E1CCBB0E-9AFE-4DCF-B6E4-BFE6FF5B0BCF}"/>
               </a:ext>
             </a:extLst>
           </p:cNvPr>
@@ -15035,7 +15035,7 @@
           <p:cNvPr id="2" name="">
             <a:extLst xmlns:a="http://schemas.openxmlformats.org/drawingml/2006/main">
               <a:ext uri="{FF2B5EF4-FFF2-40B4-BE49-F238E27FC236}">
-                <a16:creationId xmlns:a16="http://schemas.microsoft.com/office/drawing/2014/main" id="{57FB3461-F03B-47EA-B815-ECBE30317E5E}"/>
+                <a16:creationId xmlns:a16="http://schemas.microsoft.com/office/drawing/2014/main" id="{FA085B64-0BA0-4D09-AD23-EEC3513FC60B}"/>
               </a:ext>
             </a:extLst>
           </p:cNvPr>
@@ -15101,7 +15101,7 @@
           <p:cNvPr id="3" name="">
             <a:extLst xmlns:a="http://schemas.openxmlformats.org/drawingml/2006/main">
               <a:ext uri="{FF2B5EF4-FFF2-40B4-BE49-F238E27FC236}">
-                <a16:creationId xmlns:a16="http://schemas.microsoft.com/office/drawing/2014/main" id="{D8583B02-56DC-4800-B32F-E11FF663AF1E}"/>
+                <a16:creationId xmlns:a16="http://schemas.microsoft.com/office/drawing/2014/main" id="{63CE5EEB-D9CB-4024-B920-6E5CCB4DD655}"/>
               </a:ext>
             </a:extLst>
           </p:cNvPr>
@@ -15167,7 +15167,7 @@
           <p:cNvPr id="4" name="">
             <a:extLst xmlns:a="http://schemas.openxmlformats.org/drawingml/2006/main">
               <a:ext uri="{FF2B5EF4-FFF2-40B4-BE49-F238E27FC236}">
-                <a16:creationId xmlns:a16="http://schemas.microsoft.com/office/drawing/2014/main" id="{21925DCC-C60F-428A-910D-88FD39E18407}"/>
+                <a16:creationId xmlns:a16="http://schemas.microsoft.com/office/drawing/2014/main" id="{5AA7FE5A-5F5F-40F3-BD79-D16B4EAD9EED}"/>
               </a:ext>
             </a:extLst>
           </p:cNvPr>
@@ -15233,7 +15233,7 @@
           <p:cNvPr id="5" name="">
             <a:extLst xmlns:a="http://schemas.openxmlformats.org/drawingml/2006/main">
               <a:ext uri="{FF2B5EF4-FFF2-40B4-BE49-F238E27FC236}">
-                <a16:creationId xmlns:a16="http://schemas.microsoft.com/office/drawing/2014/main" id="{463B0A30-4D3A-46F5-A166-75A77F392A0A}"/>
+                <a16:creationId xmlns:a16="http://schemas.microsoft.com/office/drawing/2014/main" id="{6EC01E41-19CF-4792-A243-C2BA6A8EFFCA}"/>
               </a:ext>
             </a:extLst>
           </p:cNvPr>
@@ -15299,7 +15299,7 @@
           <p:cNvPr id="6" name="">
             <a:extLst xmlns:a="http://schemas.openxmlformats.org/drawingml/2006/main">
               <a:ext uri="{FF2B5EF4-FFF2-40B4-BE49-F238E27FC236}">
-                <a16:creationId xmlns:a16="http://schemas.microsoft.com/office/drawing/2014/main" id="{C25F696E-052A-4E52-B6BC-0DD76AE343B7}"/>
+                <a16:creationId xmlns:a16="http://schemas.microsoft.com/office/drawing/2014/main" id="{CCC87246-ABE5-4787-A899-45D4C92CECF5}"/>
               </a:ext>
             </a:extLst>
           </p:cNvPr>
@@ -15449,7 +15449,7 @@
           <p:cNvPr id="7" name="">
             <a:extLst xmlns:a="http://schemas.openxmlformats.org/drawingml/2006/main">
               <a:ext uri="{FF2B5EF4-FFF2-40B4-BE49-F238E27FC236}">
-                <a16:creationId xmlns:a16="http://schemas.microsoft.com/office/drawing/2014/main" id="{A1B722CD-0027-4511-A383-A56F5FB4D6E2}"/>
+                <a16:creationId xmlns:a16="http://schemas.microsoft.com/office/drawing/2014/main" id="{B545A9FD-C7E7-4017-B15E-1ED49116CFDC}"/>
               </a:ext>
             </a:extLst>
           </p:cNvPr>
@@ -15459,7 +15459,7 @@
           <p:nvPr/>
         </p:nvPicPr>
         <p:blipFill>
-          <a:blip xmlns:r="http://schemas.openxmlformats.org/officeDocument/2006/relationships" xmlns:a="http://schemas.openxmlformats.org/drawingml/2006/main" r:embed="R55c17f38e52f4704"/>
+          <a:blip xmlns:r="http://schemas.openxmlformats.org/officeDocument/2006/relationships" xmlns:a="http://schemas.openxmlformats.org/drawingml/2006/main" r:embed="Rafb7a666e6bd42b1"/>
           <a:stretch xmlns:a="http://schemas.openxmlformats.org/drawingml/2006/main"/>
         </p:blipFill>
         <p:spPr>
@@ -15475,7 +15475,7 @@
     </p:spTree>
     <p:extLst>
       <p:ext uri="{BB962C8B-B14F-4D97-AF65-F5344CB8AC3E}">
-        <p14:creationId xmlns:p14="http://schemas.microsoft.com/office/powerpoint/2010/main" val="1215634844"/>
+        <p14:creationId xmlns:p14="http://schemas.microsoft.com/office/powerpoint/2010/main" val="372389093"/>
       </p:ext>
     </p:extLst>
   </p:cSld>
@@ -15506,7 +15506,7 @@
           <p:cNvPr id="8" name="">
             <a:extLst xmlns:a="http://schemas.openxmlformats.org/drawingml/2006/main">
               <a:ext uri="{FF2B5EF4-FFF2-40B4-BE49-F238E27FC236}">
-                <a16:creationId xmlns:a16="http://schemas.microsoft.com/office/drawing/2014/main" id="{79C6F8DD-FF4B-4C01-9F38-4F728F64EB4D}"/>
+                <a16:creationId xmlns:a16="http://schemas.microsoft.com/office/drawing/2014/main" id="{15FC29C9-F61C-4555-9458-3B4C47A1F4DA}"/>
               </a:ext>
             </a:extLst>
           </p:cNvPr>
@@ -15572,7 +15572,7 @@
           <p:cNvPr id="2" name="">
             <a:extLst xmlns:a="http://schemas.openxmlformats.org/drawingml/2006/main">
               <a:ext uri="{FF2B5EF4-FFF2-40B4-BE49-F238E27FC236}">
-                <a16:creationId xmlns:a16="http://schemas.microsoft.com/office/drawing/2014/main" id="{391716FE-73C7-47E3-8267-EE0703000636}"/>
+                <a16:creationId xmlns:a16="http://schemas.microsoft.com/office/drawing/2014/main" id="{DDB56186-7EA1-48BD-B2BB-BEDC17E2F533}"/>
               </a:ext>
             </a:extLst>
           </p:cNvPr>
@@ -15638,7 +15638,7 @@
           <p:cNvPr id="3" name="">
             <a:extLst xmlns:a="http://schemas.openxmlformats.org/drawingml/2006/main">
               <a:ext uri="{FF2B5EF4-FFF2-40B4-BE49-F238E27FC236}">
-                <a16:creationId xmlns:a16="http://schemas.microsoft.com/office/drawing/2014/main" id="{F7693C79-19CD-4552-884C-67A4A1BFB7F9}"/>
+                <a16:creationId xmlns:a16="http://schemas.microsoft.com/office/drawing/2014/main" id="{B13EC58A-8951-4747-B940-72FF83934C11}"/>
               </a:ext>
             </a:extLst>
           </p:cNvPr>
@@ -15704,7 +15704,7 @@
           <p:cNvPr id="4" name="">
             <a:extLst xmlns:a="http://schemas.openxmlformats.org/drawingml/2006/main">
               <a:ext uri="{FF2B5EF4-FFF2-40B4-BE49-F238E27FC236}">
-                <a16:creationId xmlns:a16="http://schemas.microsoft.com/office/drawing/2014/main" id="{767296DE-4D18-4A86-94F8-5B50FF7EFE79}"/>
+                <a16:creationId xmlns:a16="http://schemas.microsoft.com/office/drawing/2014/main" id="{0F386C09-1576-441F-906A-4CE9A559BF6F}"/>
               </a:ext>
             </a:extLst>
           </p:cNvPr>
@@ -15770,7 +15770,7 @@
           <p:cNvPr id="5" name="">
             <a:extLst xmlns:a="http://schemas.openxmlformats.org/drawingml/2006/main">
               <a:ext uri="{FF2B5EF4-FFF2-40B4-BE49-F238E27FC236}">
-                <a16:creationId xmlns:a16="http://schemas.microsoft.com/office/drawing/2014/main" id="{B7954C27-AC0F-4D84-B3C0-9DF36464731B}"/>
+                <a16:creationId xmlns:a16="http://schemas.microsoft.com/office/drawing/2014/main" id="{CDEBD81F-D827-45C0-978A-E6F89DFE6BD3}"/>
               </a:ext>
             </a:extLst>
           </p:cNvPr>
@@ -15780,7 +15780,7 @@
           <p:nvPr/>
         </p:nvPicPr>
         <p:blipFill>
-          <a:blip xmlns:r="http://schemas.openxmlformats.org/officeDocument/2006/relationships" xmlns:a="http://schemas.openxmlformats.org/drawingml/2006/main" r:embed="R827b614a2ceb47ba"/>
+          <a:blip xmlns:r="http://schemas.openxmlformats.org/officeDocument/2006/relationships" xmlns:a="http://schemas.openxmlformats.org/drawingml/2006/main" r:embed="Re8e0b6cabf7641ec"/>
           <a:stretch xmlns:a="http://schemas.openxmlformats.org/drawingml/2006/main"/>
         </p:blipFill>
         <p:spPr>
@@ -15798,7 +15798,7 @@
           <p:cNvPr id="6" name="">
             <a:extLst xmlns:a="http://schemas.openxmlformats.org/drawingml/2006/main">
               <a:ext uri="{FF2B5EF4-FFF2-40B4-BE49-F238E27FC236}">
-                <a16:creationId xmlns:a16="http://schemas.microsoft.com/office/drawing/2014/main" id="{D459142A-682B-41DC-BEAC-659D9C659B50}"/>
+                <a16:creationId xmlns:a16="http://schemas.microsoft.com/office/drawing/2014/main" id="{5A184895-F11C-466D-A812-71B7B67E0F90}"/>
               </a:ext>
             </a:extLst>
           </p:cNvPr>
@@ -15808,7 +15808,7 @@
           <p:nvPr/>
         </p:nvPicPr>
         <p:blipFill>
-          <a:blip xmlns:r="http://schemas.openxmlformats.org/officeDocument/2006/relationships" xmlns:a="http://schemas.openxmlformats.org/drawingml/2006/main" r:embed="R33b8390e42e24ae2"/>
+          <a:blip xmlns:r="http://schemas.openxmlformats.org/officeDocument/2006/relationships" xmlns:a="http://schemas.openxmlformats.org/drawingml/2006/main" r:embed="R58c146f31e8340f0"/>
           <a:stretch xmlns:a="http://schemas.openxmlformats.org/drawingml/2006/main"/>
         </p:blipFill>
         <p:spPr>
@@ -15826,7 +15826,7 @@
           <p:cNvPr id="7" name="">
             <a:extLst xmlns:a="http://schemas.openxmlformats.org/drawingml/2006/main">
               <a:ext uri="{FF2B5EF4-FFF2-40B4-BE49-F238E27FC236}">
-                <a16:creationId xmlns:a16="http://schemas.microsoft.com/office/drawing/2014/main" id="{40E48DAB-7E15-40FB-9C0C-F5AD78D6B61C}"/>
+                <a16:creationId xmlns:a16="http://schemas.microsoft.com/office/drawing/2014/main" id="{FC712203-8A0B-4873-A1E8-D38BB3733B40}"/>
               </a:ext>
             </a:extLst>
           </p:cNvPr>
@@ -15890,7 +15890,7 @@
     </p:spTree>
     <p:extLst>
       <p:ext uri="{BB962C8B-B14F-4D97-AF65-F5344CB8AC3E}">
-        <p14:creationId xmlns:p14="http://schemas.microsoft.com/office/powerpoint/2010/main" val="1101490454"/>
+        <p14:creationId xmlns:p14="http://schemas.microsoft.com/office/powerpoint/2010/main" val="1349498384"/>
       </p:ext>
     </p:extLst>
   </p:cSld>
@@ -15921,7 +15921,7 @@
           <p:cNvPr id="8" name="">
             <a:extLst xmlns:a="http://schemas.openxmlformats.org/drawingml/2006/main">
               <a:ext uri="{FF2B5EF4-FFF2-40B4-BE49-F238E27FC236}">
-                <a16:creationId xmlns:a16="http://schemas.microsoft.com/office/drawing/2014/main" id="{10320A34-E818-4099-BCE3-EF59AEFA8EC3}"/>
+                <a16:creationId xmlns:a16="http://schemas.microsoft.com/office/drawing/2014/main" id="{87E6625D-68EE-465D-A4D1-B41E6D290F28}"/>
               </a:ext>
             </a:extLst>
           </p:cNvPr>
@@ -15987,7 +15987,7 @@
           <p:cNvPr id="2" name="">
             <a:extLst xmlns:a="http://schemas.openxmlformats.org/drawingml/2006/main">
               <a:ext uri="{FF2B5EF4-FFF2-40B4-BE49-F238E27FC236}">
-                <a16:creationId xmlns:a16="http://schemas.microsoft.com/office/drawing/2014/main" id="{C9BF168F-FA91-45B5-9599-5D1751317DE6}"/>
+                <a16:creationId xmlns:a16="http://schemas.microsoft.com/office/drawing/2014/main" id="{408C65F0-2B4F-431B-93F0-3F878D2A6339}"/>
               </a:ext>
             </a:extLst>
           </p:cNvPr>
@@ -16053,7 +16053,7 @@
           <p:cNvPr id="3" name="">
             <a:extLst xmlns:a="http://schemas.openxmlformats.org/drawingml/2006/main">
               <a:ext uri="{FF2B5EF4-FFF2-40B4-BE49-F238E27FC236}">
-                <a16:creationId xmlns:a16="http://schemas.microsoft.com/office/drawing/2014/main" id="{05E2CD01-686D-4973-B931-7D5600110B41}"/>
+                <a16:creationId xmlns:a16="http://schemas.microsoft.com/office/drawing/2014/main" id="{E5E673AE-AB8E-49B7-A85C-BB22D0C1AF87}"/>
               </a:ext>
             </a:extLst>
           </p:cNvPr>
@@ -16119,7 +16119,7 @@
           <p:cNvPr id="4" name="">
             <a:extLst xmlns:a="http://schemas.openxmlformats.org/drawingml/2006/main">
               <a:ext uri="{FF2B5EF4-FFF2-40B4-BE49-F238E27FC236}">
-                <a16:creationId xmlns:a16="http://schemas.microsoft.com/office/drawing/2014/main" id="{0BFC4824-EA7D-4443-A890-05C8D81CA774}"/>
+                <a16:creationId xmlns:a16="http://schemas.microsoft.com/office/drawing/2014/main" id="{B4798BD6-2122-4C5C-9909-8AC6A2B4E3D4}"/>
               </a:ext>
             </a:extLst>
           </p:cNvPr>
@@ -16185,7 +16185,7 @@
           <p:cNvPr id="5" name="">
             <a:extLst xmlns:a="http://schemas.openxmlformats.org/drawingml/2006/main">
               <a:ext uri="{FF2B5EF4-FFF2-40B4-BE49-F238E27FC236}">
-                <a16:creationId xmlns:a16="http://schemas.microsoft.com/office/drawing/2014/main" id="{2EC5E3A1-18A7-4933-8F4A-81F35776B5C4}"/>
+                <a16:creationId xmlns:a16="http://schemas.microsoft.com/office/drawing/2014/main" id="{850A1577-7ACD-4DFA-BFD7-E1D64B359115}"/>
               </a:ext>
             </a:extLst>
           </p:cNvPr>
@@ -16195,7 +16195,7 @@
           <p:nvPr/>
         </p:nvPicPr>
         <p:blipFill>
-          <a:blip xmlns:r="http://schemas.openxmlformats.org/officeDocument/2006/relationships" xmlns:a="http://schemas.openxmlformats.org/drawingml/2006/main" r:embed="Rd9e5aa1194c44d63"/>
+          <a:blip xmlns:r="http://schemas.openxmlformats.org/officeDocument/2006/relationships" xmlns:a="http://schemas.openxmlformats.org/drawingml/2006/main" r:embed="Rd0295945fb9f4af3"/>
           <a:stretch xmlns:a="http://schemas.openxmlformats.org/drawingml/2006/main"/>
         </p:blipFill>
         <p:spPr>
@@ -16213,7 +16213,7 @@
           <p:cNvPr id="6" name="">
             <a:extLst xmlns:a="http://schemas.openxmlformats.org/drawingml/2006/main">
               <a:ext uri="{FF2B5EF4-FFF2-40B4-BE49-F238E27FC236}">
-                <a16:creationId xmlns:a16="http://schemas.microsoft.com/office/drawing/2014/main" id="{253E5E63-6165-4649-AFDF-24AB47601042}"/>
+                <a16:creationId xmlns:a16="http://schemas.microsoft.com/office/drawing/2014/main" id="{6ABBEC52-ACA2-4AE2-B60B-3DD0CEA49E98}"/>
               </a:ext>
             </a:extLst>
           </p:cNvPr>
@@ -16223,7 +16223,7 @@
           <p:nvPr/>
         </p:nvPicPr>
         <p:blipFill>
-          <a:blip xmlns:r="http://schemas.openxmlformats.org/officeDocument/2006/relationships" xmlns:a="http://schemas.openxmlformats.org/drawingml/2006/main" r:embed="R54b856c8f3f24402"/>
+          <a:blip xmlns:r="http://schemas.openxmlformats.org/officeDocument/2006/relationships" xmlns:a="http://schemas.openxmlformats.org/drawingml/2006/main" r:embed="R1f0ebde69ef14494"/>
           <a:stretch xmlns:a="http://schemas.openxmlformats.org/drawingml/2006/main"/>
         </p:blipFill>
         <p:spPr>
@@ -16241,7 +16241,7 @@
           <p:cNvPr id="7" name="">
             <a:extLst xmlns:a="http://schemas.openxmlformats.org/drawingml/2006/main">
               <a:ext uri="{FF2B5EF4-FFF2-40B4-BE49-F238E27FC236}">
-                <a16:creationId xmlns:a16="http://schemas.microsoft.com/office/drawing/2014/main" id="{2699E43E-D6B1-4D72-8939-0CABAF7014CD}"/>
+                <a16:creationId xmlns:a16="http://schemas.microsoft.com/office/drawing/2014/main" id="{7C7DBBB0-59E1-4BB4-9478-2EDFBAC63B05}"/>
               </a:ext>
             </a:extLst>
           </p:cNvPr>
@@ -16305,7 +16305,7 @@
     </p:spTree>
     <p:extLst>
       <p:ext uri="{BB962C8B-B14F-4D97-AF65-F5344CB8AC3E}">
-        <p14:creationId xmlns:p14="http://schemas.microsoft.com/office/powerpoint/2010/main" val="648525406"/>
+        <p14:creationId xmlns:p14="http://schemas.microsoft.com/office/powerpoint/2010/main" val="404062908"/>
       </p:ext>
     </p:extLst>
   </p:cSld>

</xml_diff>